<commit_message>
Sunum: platform ve indirme bilgileri v1.0.0 icin guncellendi
- Kapak ve kapanis slaytlarindaki platform satiri Windows 10/11 (x64) + macOS (Apple Silicon) olarak guncellendi
- Yeni 'Platforms & Download' slayti eklendi: GitHub Releases v1.0.0 indirme bilgisi (ozel repo notu), Windows + macOS zip paketleri ve macOS arm64 / notarize dipnotu (TR/EN/RU)
- Uretici betik (tmp/presentation/build-deck.mjs) depoya eklendi; PPTX yeniden uretildi, PDF PowerPoint ile yeniden disari aktarildi

Co-Authored-By: Claude Fable 5 <noreply@anthropic.com>
</commit_message>
<xml_diff>
--- a/docs/presentation/Russian-Course-AI-Trilingual.pptx
+++ b/docs/presentation/Russian-Course-AI-Trilingual.pptx
@@ -2,19 +2,20 @@
 <file path=ppt/presentation.xml><?xml version="1.0" encoding="utf-8"?>
 <p:presentation xmlns:p="http://schemas.openxmlformats.org/presentationml/2006/main">
   <p:sldMasterIdLst>
-    <p:sldMasterId xmlns:r="http://schemas.openxmlformats.org/officeDocument/2006/relationships" id="2147483648" r:id="Re664efd07f814b73"/>
+    <p:sldMasterId xmlns:r="http://schemas.openxmlformats.org/officeDocument/2006/relationships" id="2147483648" r:id="Rb1638df790e24309"/>
   </p:sldMasterIdLst>
   <p:notesMasterIdLst>
-    <p:notesMasterId xmlns:r="http://schemas.openxmlformats.org/officeDocument/2006/relationships" r:id="R968355976f94430f"/>
+    <p:notesMasterId xmlns:r="http://schemas.openxmlformats.org/officeDocument/2006/relationships" r:id="R99115881d6d740b0"/>
   </p:notesMasterIdLst>
   <p:sldIdLst>
-    <p:sldId xmlns:r="http://schemas.openxmlformats.org/officeDocument/2006/relationships" id="256" r:id="R4df127e5a9d74a27"/>
-    <p:sldId xmlns:r="http://schemas.openxmlformats.org/officeDocument/2006/relationships" id="257" r:id="Rf8895ee476cc46ac"/>
-    <p:sldId xmlns:r="http://schemas.openxmlformats.org/officeDocument/2006/relationships" id="258" r:id="Rb824058817ca4224"/>
-    <p:sldId xmlns:r="http://schemas.openxmlformats.org/officeDocument/2006/relationships" id="259" r:id="R49b72196cfde4cf3"/>
-    <p:sldId xmlns:r="http://schemas.openxmlformats.org/officeDocument/2006/relationships" id="260" r:id="R391e3edd6cf74ef4"/>
-    <p:sldId xmlns:r="http://schemas.openxmlformats.org/officeDocument/2006/relationships" id="261" r:id="Re49672be77cc4a57"/>
-    <p:sldId xmlns:r="http://schemas.openxmlformats.org/officeDocument/2006/relationships" id="262" r:id="R7f0f8c17acde48d8"/>
+    <p:sldId xmlns:r="http://schemas.openxmlformats.org/officeDocument/2006/relationships" id="256" r:id="R4dce43551a9e4ec5"/>
+    <p:sldId xmlns:r="http://schemas.openxmlformats.org/officeDocument/2006/relationships" id="257" r:id="Rd5d8eb9b4cce4859"/>
+    <p:sldId xmlns:r="http://schemas.openxmlformats.org/officeDocument/2006/relationships" id="258" r:id="Rd0c22b7f66304e00"/>
+    <p:sldId xmlns:r="http://schemas.openxmlformats.org/officeDocument/2006/relationships" id="259" r:id="R3a35e0a5d1f54d41"/>
+    <p:sldId xmlns:r="http://schemas.openxmlformats.org/officeDocument/2006/relationships" id="260" r:id="R45d394c5428a49bb"/>
+    <p:sldId xmlns:r="http://schemas.openxmlformats.org/officeDocument/2006/relationships" id="261" r:id="Re664ec9617cb45f7"/>
+    <p:sldId xmlns:r="http://schemas.openxmlformats.org/officeDocument/2006/relationships" id="262" r:id="R23f6bafabb9a467d"/>
+    <p:sldId xmlns:r="http://schemas.openxmlformats.org/officeDocument/2006/relationships" id="263" r:id="R096aaaceb2074dc9"/>
   </p:sldIdLst>
   <p:sldSz cx="12192000" cy="6858000"/>
   <p:notesSz cx="6858000" cy="9144000"/>
@@ -928,6 +929,81 @@
           </a:p>
           <a:p xmlns:a="http://schemas.openxmlformats.org/drawingml/2006/main">
             <a:r>
+              <a:t>- https://github.com/Azizsekerdil/RussianCourseAI/releases/tag/v1.0.0 (v1.0.0 release with Windows and macOS zip assets; private repository)</a:t>
+            </a:r>
+          </a:p>
+        </p:txBody>
+      </p:sp>
+      <p:sp>
+        <p:nvSpPr>
+          <p:cNvPr id="4" name="Slide Number Placeholder 3"/>
+          <p:cNvSpPr>
+            <a:spLocks xmlns:a="http://schemas.openxmlformats.org/drawingml/2006/main" noGrp="1"/>
+          </p:cNvSpPr>
+          <p:nvPr>
+            <p:ph type="sldNum" idx="5"/>
+          </p:nvPr>
+        </p:nvSpPr>
+        <p:spPr/>
+        <p:txBody>
+          <a:bodyPr xmlns:a="http://schemas.openxmlformats.org/drawingml/2006/main"/>
+          <a:lstStyle xmlns:a="http://schemas.openxmlformats.org/drawingml/2006/main"/>
+          <a:p xmlns:a="http://schemas.openxmlformats.org/drawingml/2006/main"/>
+        </p:txBody>
+      </p:sp>
+    </p:spTree>
+  </p:cSld>
+  <p:clrMapOvr>
+    <a:masterClrMapping xmlns:a="http://schemas.openxmlformats.org/drawingml/2006/main"/>
+  </p:clrMapOvr>
+</p:notes>
+</file>
+
+<file path=ppt/notesSlides/notesSlide8.xml><?xml version="1.0" encoding="utf-8"?>
+<p:notes xmlns:p="http://schemas.openxmlformats.org/presentationml/2006/main">
+  <p:cSld>
+    <p:spTree>
+      <p:nvGrpSpPr>
+        <p:cNvPr id="1" name=""/>
+        <p:cNvGrpSpPr/>
+        <p:nvPr/>
+      </p:nvGrpSpPr>
+      <p:grpSpPr>
+        <a:xfrm xmlns:a="http://schemas.openxmlformats.org/drawingml/2006/main"/>
+      </p:grpSpPr>
+      <p:sp>
+        <p:nvSpPr>
+          <p:cNvPr id="2" name="Slide Image Placeholder 1"/>
+          <p:cNvSpPr>
+            <a:spLocks xmlns:a="http://schemas.openxmlformats.org/drawingml/2006/main" noGrp="1"/>
+          </p:cNvSpPr>
+          <p:nvPr>
+            <p:ph type="sldImg" idx="0"/>
+          </p:nvPr>
+        </p:nvSpPr>
+        <p:spPr/>
+      </p:sp>
+      <p:sp>
+        <p:nvSpPr>
+          <p:cNvPr id="3" name="Notes Placeholder 2"/>
+          <p:cNvSpPr>
+            <a:spLocks xmlns:a="http://schemas.openxmlformats.org/drawingml/2006/main" noGrp="1"/>
+          </p:cNvSpPr>
+          <p:nvPr>
+            <p:ph type="body" idx="1"/>
+          </p:nvPr>
+        </p:nvSpPr>
+        <p:spPr/>
+        <p:txBody>
+          <a:bodyPr xmlns:a="http://schemas.openxmlformats.org/drawingml/2006/main"/>
+          <a:lstStyle xmlns:a="http://schemas.openxmlformats.org/drawingml/2006/main"/>
+          <a:p xmlns:a="http://schemas.openxmlformats.org/drawingml/2006/main">
+            <a:r>
+              <a:t>[Sources]</a:t>
+            </a:r>
+          </a:p>
+          <a:p xmlns:a="http://schemas.openxmlformats.org/drawingml/2006/main">
+            <a:r>
               <a:t>- D:/Russian/README.md (installation, learning levels, and feature overview)</a:t>
             </a:r>
           </a:p>
@@ -996,7 +1072,7 @@
   </p:cSld>
   <p:clrMap bg1="lt1" tx1="dk1" bg2="lt2" tx2="dk2" accent1="accent1" accent2="accent2" accent3="accent3" accent4="accent4" accent5="accent5" accent6="accent6" hlink="hlink" folHlink="folHlink"/>
   <p:sldLayoutIdLst>
-    <p:sldLayoutId xmlns:r="http://schemas.openxmlformats.org/officeDocument/2006/relationships" id="2147483649" r:id="R7c9eb1f732a24ff7"/>
+    <p:sldLayoutId xmlns:r="http://schemas.openxmlformats.org/officeDocument/2006/relationships" id="2147483649" r:id="Rb55103f2539e407c"/>
   </p:sldLayoutIdLst>
   <p:txStyles>
     <p:titleStyle>
@@ -1547,7 +1623,7 @@
           <p:cNvPr id="11" name="cover-kicker">
             <a:extLst xmlns:a="http://schemas.openxmlformats.org/drawingml/2006/main">
               <a:ext uri="{FF2B5EF4-FFF2-40B4-BE49-F238E27FC236}">
-                <a16:creationId xmlns:a16="http://schemas.microsoft.com/office/drawing/2014/main" id="{86510257-2F26-4285-9E8E-22D7B2738511}"/>
+                <a16:creationId xmlns:a16="http://schemas.microsoft.com/office/drawing/2014/main" id="{A6DAB9C9-410C-4146-9515-F1741EC913BC}"/>
               </a:ext>
             </a:extLst>
           </p:cNvPr>
@@ -1603,7 +1679,7 @@
           <p:cNvPr id="2" name="cover-title">
             <a:extLst xmlns:a="http://schemas.openxmlformats.org/drawingml/2006/main">
               <a:ext uri="{FF2B5EF4-FFF2-40B4-BE49-F238E27FC236}">
-                <a16:creationId xmlns:a16="http://schemas.microsoft.com/office/drawing/2014/main" id="{B26B7086-75B2-4C8C-B10B-85CB05291EC3}"/>
+                <a16:creationId xmlns:a16="http://schemas.microsoft.com/office/drawing/2014/main" id="{5565546F-D62F-4953-B4CE-49782A4825FA}"/>
               </a:ext>
             </a:extLst>
           </p:cNvPr>
@@ -1682,7 +1758,7 @@
           <p:cNvPr id="3" name="cover-rule">
             <a:extLst xmlns:a="http://schemas.openxmlformats.org/drawingml/2006/main">
               <a:ext uri="{FF2B5EF4-FFF2-40B4-BE49-F238E27FC236}">
-                <a16:creationId xmlns:a16="http://schemas.microsoft.com/office/drawing/2014/main" id="{23D9AE5F-16D2-45FB-B663-48846BFC6180}"/>
+                <a16:creationId xmlns:a16="http://schemas.microsoft.com/office/drawing/2014/main" id="{186941BB-993C-427D-AEAF-83ACFB4BBC85}"/>
               </a:ext>
             </a:extLst>
           </p:cNvPr>
@@ -1713,7 +1789,7 @@
           <p:cNvPr id="4" name="cover-tr">
             <a:extLst xmlns:a="http://schemas.openxmlformats.org/drawingml/2006/main">
               <a:ext uri="{FF2B5EF4-FFF2-40B4-BE49-F238E27FC236}">
-                <a16:creationId xmlns:a16="http://schemas.microsoft.com/office/drawing/2014/main" id="{D454D454-B6F6-435C-9669-4DE43D24434E}"/>
+                <a16:creationId xmlns:a16="http://schemas.microsoft.com/office/drawing/2014/main" id="{F28779AF-F2E9-422A-8559-61F433701CEA}"/>
               </a:ext>
             </a:extLst>
           </p:cNvPr>
@@ -1769,7 +1845,7 @@
           <p:cNvPr id="5" name="cover-en">
             <a:extLst xmlns:a="http://schemas.openxmlformats.org/drawingml/2006/main">
               <a:ext uri="{FF2B5EF4-FFF2-40B4-BE49-F238E27FC236}">
-                <a16:creationId xmlns:a16="http://schemas.microsoft.com/office/drawing/2014/main" id="{EB4C8AB0-8E50-4089-B3DC-773226E37023}"/>
+                <a16:creationId xmlns:a16="http://schemas.microsoft.com/office/drawing/2014/main" id="{38BABDD1-0AC3-4BD9-B2FB-F690C163B9A0}"/>
               </a:ext>
             </a:extLst>
           </p:cNvPr>
@@ -1825,7 +1901,7 @@
           <p:cNvPr id="6" name="cover-ru">
             <a:extLst xmlns:a="http://schemas.openxmlformats.org/drawingml/2006/main">
               <a:ext uri="{FF2B5EF4-FFF2-40B4-BE49-F238E27FC236}">
-                <a16:creationId xmlns:a16="http://schemas.microsoft.com/office/drawing/2014/main" id="{C13AF158-64C2-48D9-918A-FD3D69E5F640}"/>
+                <a16:creationId xmlns:a16="http://schemas.microsoft.com/office/drawing/2014/main" id="{1C98D64D-8C53-4D12-BC23-16CD763B612D}"/>
               </a:ext>
             </a:extLst>
           </p:cNvPr>
@@ -1881,7 +1957,7 @@
           <p:cNvPr id="7" name="cover-meta">
             <a:extLst xmlns:a="http://schemas.openxmlformats.org/drawingml/2006/main">
               <a:ext uri="{FF2B5EF4-FFF2-40B4-BE49-F238E27FC236}">
-                <a16:creationId xmlns:a16="http://schemas.microsoft.com/office/drawing/2014/main" id="{D73DE977-35E7-45AA-88B5-689C6F01BC4A}"/>
+                <a16:creationId xmlns:a16="http://schemas.microsoft.com/office/drawing/2014/main" id="{B0B32552-CA12-4D9A-A9BA-22876A2CC05E}"/>
               </a:ext>
             </a:extLst>
           </p:cNvPr>
@@ -1893,41 +1969,41 @@
         <p:spPr>
           <a:xfrm xmlns:a="http://schemas.openxmlformats.org/drawingml/2006/main">
             <a:off x="400050" y="5619750"/>
-            <a:ext cx="5334000" cy="266700"/>
-          </a:xfrm>
-          <a:prstGeom xmlns:a="http://schemas.openxmlformats.org/drawingml/2006/main" prst="rect">
-            <a:avLst/>
-          </a:prstGeom>
-          <a:noFill xmlns:a="http://schemas.openxmlformats.org/drawingml/2006/main"/>
-          <a:ln xmlns:a="http://schemas.openxmlformats.org/drawingml/2006/main" w="0">
-            <a:noFill/>
-            <a:prstDash val="solid"/>
-          </a:ln>
-        </p:spPr>
-        <p:txBody>
-          <a:bodyPr xmlns:a="http://schemas.openxmlformats.org/drawingml/2006/main" anchor="t"/>
-          <a:lstStyle xmlns:a="http://schemas.openxmlformats.org/drawingml/2006/main"/>
-          <a:p xmlns:a="http://schemas.openxmlformats.org/drawingml/2006/main">
-            <a:pPr algn="l">
-              <a:defRPr sz="1275" b="0">
-                <a:solidFill>
-                  <a:srgbClr val="5F6675"/>
-                </a:solidFill>
-                <a:latin typeface="Arial"/>
-                <a:ea typeface="Arial"/>
-                <a:cs typeface="Arial"/>
-              </a:defRPr>
-            </a:pPr>
-            <a:r>
-              <a:rPr sz="1275" b="0">
-                <a:solidFill>
-                  <a:srgbClr val="5F6675"/>
-                </a:solidFill>
-                <a:latin typeface="Arial"/>
-                <a:ea typeface="Arial"/>
-                <a:cs typeface="Arial"/>
-              </a:rPr>
-              <a:t>Windows  •  A1-C1  •  Türkçe / English / Русский</a:t>
+            <a:ext cx="5524500" cy="266700"/>
+          </a:xfrm>
+          <a:prstGeom xmlns:a="http://schemas.openxmlformats.org/drawingml/2006/main" prst="rect">
+            <a:avLst/>
+          </a:prstGeom>
+          <a:noFill xmlns:a="http://schemas.openxmlformats.org/drawingml/2006/main"/>
+          <a:ln xmlns:a="http://schemas.openxmlformats.org/drawingml/2006/main" w="0">
+            <a:noFill/>
+            <a:prstDash val="solid"/>
+          </a:ln>
+        </p:spPr>
+        <p:txBody>
+          <a:bodyPr xmlns:a="http://schemas.openxmlformats.org/drawingml/2006/main" anchor="t"/>
+          <a:lstStyle xmlns:a="http://schemas.openxmlformats.org/drawingml/2006/main"/>
+          <a:p xmlns:a="http://schemas.openxmlformats.org/drawingml/2006/main">
+            <a:pPr algn="l">
+              <a:defRPr sz="1125" b="0">
+                <a:solidFill>
+                  <a:srgbClr val="5F6675"/>
+                </a:solidFill>
+                <a:latin typeface="Arial"/>
+                <a:ea typeface="Arial"/>
+                <a:cs typeface="Arial"/>
+              </a:defRPr>
+            </a:pPr>
+            <a:r>
+              <a:rPr sz="1125" b="0">
+                <a:solidFill>
+                  <a:srgbClr val="5F6675"/>
+                </a:solidFill>
+                <a:latin typeface="Arial"/>
+                <a:ea typeface="Arial"/>
+                <a:cs typeface="Arial"/>
+              </a:rPr>
+              <a:t>Windows 10/11 (x64) + macOS (Apple Silicon)  •  A1-C1  •  TR / EN / RU</a:t>
             </a:r>
           </a:p>
         </p:txBody>
@@ -1937,7 +2013,7 @@
           <p:cNvPr id="8" name="hero-backing">
             <a:extLst xmlns:a="http://schemas.openxmlformats.org/drawingml/2006/main">
               <a:ext uri="{FF2B5EF4-FFF2-40B4-BE49-F238E27FC236}">
-                <a16:creationId xmlns:a16="http://schemas.microsoft.com/office/drawing/2014/main" id="{2CBBED24-A25C-4CA0-9AC2-B652563F3E0A}"/>
+                <a16:creationId xmlns:a16="http://schemas.microsoft.com/office/drawing/2014/main" id="{AC54D068-798B-4ACF-B644-E5192879E370}"/>
               </a:ext>
             </a:extLst>
           </p:cNvPr>
@@ -1974,7 +2050,7 @@
           <p:nvPr/>
         </p:nvPicPr>
         <p:blipFill>
-          <a:blip xmlns:r="http://schemas.openxmlformats.org/officeDocument/2006/relationships" xmlns:a="http://schemas.openxmlformats.org/drawingml/2006/main" r:embed="R5be20aa6722e448d"/>
+          <a:blip xmlns:r="http://schemas.openxmlformats.org/officeDocument/2006/relationships" xmlns:a="http://schemas.openxmlformats.org/drawingml/2006/main" r:embed="Rde624540c4d945a7"/>
           <a:srcRect xmlns:a="http://schemas.openxmlformats.org/drawingml/2006/main" l="510" t="0" r="510" b="0"/>
           <a:stretch xmlns:a="http://schemas.openxmlformats.org/drawingml/2006/main">
             <a:fillRect l="0" t="0" r="0" b="0"/>
@@ -1997,7 +2073,7 @@
           <p:cNvPr id="10" name="footer-1">
             <a:extLst xmlns:a="http://schemas.openxmlformats.org/drawingml/2006/main">
               <a:ext uri="{FF2B5EF4-FFF2-40B4-BE49-F238E27FC236}">
-                <a16:creationId xmlns:a16="http://schemas.microsoft.com/office/drawing/2014/main" id="{0D109E68-F875-4797-AF0B-2B6976402333}"/>
+                <a16:creationId xmlns:a16="http://schemas.microsoft.com/office/drawing/2014/main" id="{584EF786-102C-4364-976B-4C5864ED75D7}"/>
               </a:ext>
             </a:extLst>
           </p:cNvPr>
@@ -2051,7 +2127,7 @@
     </p:spTree>
     <p:extLst>
       <p:ext uri="{BB962C8B-B14F-4D97-AF65-F5344CB8AC3E}">
-        <p14:creationId xmlns:p14="http://schemas.microsoft.com/office/powerpoint/2010/main" val="1614675909"/>
+        <p14:creationId xmlns:p14="http://schemas.microsoft.com/office/powerpoint/2010/main" val="529797362"/>
       </p:ext>
     </p:extLst>
   </p:cSld>
@@ -2082,7 +2158,7 @@
           <p:cNvPr id="6" name="screen-title">
             <a:extLst xmlns:a="http://schemas.openxmlformats.org/drawingml/2006/main">
               <a:ext uri="{FF2B5EF4-FFF2-40B4-BE49-F238E27FC236}">
-                <a16:creationId xmlns:a16="http://schemas.microsoft.com/office/drawing/2014/main" id="{809E6FF9-DCF1-4213-BA89-635255386732}"/>
+                <a16:creationId xmlns:a16="http://schemas.microsoft.com/office/drawing/2014/main" id="{8191CE98-EEE6-4765-A884-84B857E79415}"/>
               </a:ext>
             </a:extLst>
           </p:cNvPr>
@@ -2138,7 +2214,7 @@
           <p:cNvPr id="2" name="screen-subtitle">
             <a:extLst xmlns:a="http://schemas.openxmlformats.org/drawingml/2006/main">
               <a:ext uri="{FF2B5EF4-FFF2-40B4-BE49-F238E27FC236}">
-                <a16:creationId xmlns:a16="http://schemas.microsoft.com/office/drawing/2014/main" id="{6CA81B22-351E-4EE6-AE4B-7DF051C13A70}"/>
+                <a16:creationId xmlns:a16="http://schemas.microsoft.com/office/drawing/2014/main" id="{9A3B5228-AE7F-407D-8045-3253368AA3CC}"/>
               </a:ext>
             </a:extLst>
           </p:cNvPr>
@@ -2194,7 +2270,7 @@
           <p:cNvPr id="3" name="screen-frame">
             <a:extLst xmlns:a="http://schemas.openxmlformats.org/drawingml/2006/main">
               <a:ext uri="{FF2B5EF4-FFF2-40B4-BE49-F238E27FC236}">
-                <a16:creationId xmlns:a16="http://schemas.microsoft.com/office/drawing/2014/main" id="{E89FDF22-754A-422B-8795-E02822E8F597}"/>
+                <a16:creationId xmlns:a16="http://schemas.microsoft.com/office/drawing/2014/main" id="{679B8401-2944-44E4-9DF2-939570C9C36B}"/>
               </a:ext>
             </a:extLst>
           </p:cNvPr>
@@ -2231,7 +2307,7 @@
           <p:nvPr/>
         </p:nvPicPr>
         <p:blipFill>
-          <a:blip xmlns:r="http://schemas.openxmlformats.org/officeDocument/2006/relationships" xmlns:a="http://schemas.openxmlformats.org/drawingml/2006/main" r:embed="R4f64eabc3ca949bb"/>
+          <a:blip xmlns:r="http://schemas.openxmlformats.org/officeDocument/2006/relationships" xmlns:a="http://schemas.openxmlformats.org/drawingml/2006/main" r:embed="Ra9a5bd89dd8b4b12"/>
           <a:stretch xmlns:a="http://schemas.openxmlformats.org/drawingml/2006/main"/>
         </p:blipFill>
         <p:spPr>
@@ -2251,7 +2327,7 @@
           <p:cNvPr id="5" name="screen-footer">
             <a:extLst xmlns:a="http://schemas.openxmlformats.org/drawingml/2006/main">
               <a:ext uri="{FF2B5EF4-FFF2-40B4-BE49-F238E27FC236}">
-                <a16:creationId xmlns:a16="http://schemas.microsoft.com/office/drawing/2014/main" id="{78CF2799-06AA-47E0-9BBA-A1E912B956A5}"/>
+                <a16:creationId xmlns:a16="http://schemas.microsoft.com/office/drawing/2014/main" id="{4D16A4A2-E284-4139-A68D-3DC8FC9C6EDF}"/>
               </a:ext>
             </a:extLst>
           </p:cNvPr>
@@ -2305,7 +2381,7 @@
     </p:spTree>
     <p:extLst>
       <p:ext uri="{BB962C8B-B14F-4D97-AF65-F5344CB8AC3E}">
-        <p14:creationId xmlns:p14="http://schemas.microsoft.com/office/powerpoint/2010/main" val="1321002865"/>
+        <p14:creationId xmlns:p14="http://schemas.microsoft.com/office/powerpoint/2010/main" val="1206458966"/>
       </p:ext>
     </p:extLst>
   </p:cSld>
@@ -2336,7 +2412,7 @@
           <p:cNvPr id="17" name="language-title">
             <a:extLst xmlns:a="http://schemas.openxmlformats.org/drawingml/2006/main">
               <a:ext uri="{FF2B5EF4-FFF2-40B4-BE49-F238E27FC236}">
-                <a16:creationId xmlns:a16="http://schemas.microsoft.com/office/drawing/2014/main" id="{1F90C4AF-269E-4641-826C-9335896F214C}"/>
+                <a16:creationId xmlns:a16="http://schemas.microsoft.com/office/drawing/2014/main" id="{E115A905-5AE8-4E59-A233-E765474B970D}"/>
               </a:ext>
             </a:extLst>
           </p:cNvPr>
@@ -2392,7 +2468,7 @@
           <p:cNvPr id="2" name="language-subtitle">
             <a:extLst xmlns:a="http://schemas.openxmlformats.org/drawingml/2006/main">
               <a:ext uri="{FF2B5EF4-FFF2-40B4-BE49-F238E27FC236}">
-                <a16:creationId xmlns:a16="http://schemas.microsoft.com/office/drawing/2014/main" id="{F66C4026-AC46-4CE7-BDC7-5831AAAE34B5}"/>
+                <a16:creationId xmlns:a16="http://schemas.microsoft.com/office/drawing/2014/main" id="{C3A796B8-CABE-492E-982B-AB789403749D}"/>
               </a:ext>
             </a:extLst>
           </p:cNvPr>
@@ -2448,7 +2524,7 @@
           <p:cNvPr id="3" name="language-rule">
             <a:extLst xmlns:a="http://schemas.openxmlformats.org/drawingml/2006/main">
               <a:ext uri="{FF2B5EF4-FFF2-40B4-BE49-F238E27FC236}">
-                <a16:creationId xmlns:a16="http://schemas.microsoft.com/office/drawing/2014/main" id="{B42BE569-3ED7-4123-A427-679D7877F53E}"/>
+                <a16:creationId xmlns:a16="http://schemas.microsoft.com/office/drawing/2014/main" id="{543574EE-9F55-48A4-99D4-8069B54F92B3}"/>
               </a:ext>
             </a:extLst>
           </p:cNvPr>
@@ -2479,7 +2555,7 @@
           <p:cNvPr id="4" name="language-label-0">
             <a:extLst xmlns:a="http://schemas.openxmlformats.org/drawingml/2006/main">
               <a:ext uri="{FF2B5EF4-FFF2-40B4-BE49-F238E27FC236}">
-                <a16:creationId xmlns:a16="http://schemas.microsoft.com/office/drawing/2014/main" id="{29C2C41A-2202-4B53-925D-0A09C06FC6D1}"/>
+                <a16:creationId xmlns:a16="http://schemas.microsoft.com/office/drawing/2014/main" id="{0B8F16DE-1D40-4990-B724-3683A00486C1}"/>
               </a:ext>
             </a:extLst>
           </p:cNvPr>
@@ -2535,7 +2611,7 @@
           <p:cNvPr id="5" name="language-head-0">
             <a:extLst xmlns:a="http://schemas.openxmlformats.org/drawingml/2006/main">
               <a:ext uri="{FF2B5EF4-FFF2-40B4-BE49-F238E27FC236}">
-                <a16:creationId xmlns:a16="http://schemas.microsoft.com/office/drawing/2014/main" id="{A71FA71F-0BAF-4882-8EA7-9C7E1CF48C2A}"/>
+                <a16:creationId xmlns:a16="http://schemas.microsoft.com/office/drawing/2014/main" id="{3E144B33-D62B-4ADF-A64E-7B03EA4883F5}"/>
               </a:ext>
             </a:extLst>
           </p:cNvPr>
@@ -2591,7 +2667,7 @@
           <p:cNvPr id="6" name="language-body-0">
             <a:extLst xmlns:a="http://schemas.openxmlformats.org/drawingml/2006/main">
               <a:ext uri="{FF2B5EF4-FFF2-40B4-BE49-F238E27FC236}">
-                <a16:creationId xmlns:a16="http://schemas.microsoft.com/office/drawing/2014/main" id="{A045C52A-E69F-4814-8EAA-7B2F93D74742}"/>
+                <a16:creationId xmlns:a16="http://schemas.microsoft.com/office/drawing/2014/main" id="{8626BC2B-4BE9-41D6-A539-C0D627C96973}"/>
               </a:ext>
             </a:extLst>
           </p:cNvPr>
@@ -2647,7 +2723,7 @@
           <p:cNvPr id="7" name="language-accent-0">
             <a:extLst xmlns:a="http://schemas.openxmlformats.org/drawingml/2006/main">
               <a:ext uri="{FF2B5EF4-FFF2-40B4-BE49-F238E27FC236}">
-                <a16:creationId xmlns:a16="http://schemas.microsoft.com/office/drawing/2014/main" id="{28F0C614-9F86-41F6-B56C-05FFE5ACA57F}"/>
+                <a16:creationId xmlns:a16="http://schemas.microsoft.com/office/drawing/2014/main" id="{1A44738F-ACC2-4824-80C6-9F0C445F9C16}"/>
               </a:ext>
             </a:extLst>
           </p:cNvPr>
@@ -2678,7 +2754,7 @@
           <p:cNvPr id="8" name="language-label-1">
             <a:extLst xmlns:a="http://schemas.openxmlformats.org/drawingml/2006/main">
               <a:ext uri="{FF2B5EF4-FFF2-40B4-BE49-F238E27FC236}">
-                <a16:creationId xmlns:a16="http://schemas.microsoft.com/office/drawing/2014/main" id="{C2AD4D3B-C543-4AC0-BB3F-74CE5E4C58F9}"/>
+                <a16:creationId xmlns:a16="http://schemas.microsoft.com/office/drawing/2014/main" id="{C0F9AB4E-E50E-4E6C-B8ED-D06E868E48EE}"/>
               </a:ext>
             </a:extLst>
           </p:cNvPr>
@@ -2734,7 +2810,7 @@
           <p:cNvPr id="9" name="language-head-1">
             <a:extLst xmlns:a="http://schemas.openxmlformats.org/drawingml/2006/main">
               <a:ext uri="{FF2B5EF4-FFF2-40B4-BE49-F238E27FC236}">
-                <a16:creationId xmlns:a16="http://schemas.microsoft.com/office/drawing/2014/main" id="{7BACEA20-5705-4B7B-B6AD-D23C6AEDE378}"/>
+                <a16:creationId xmlns:a16="http://schemas.microsoft.com/office/drawing/2014/main" id="{52019F9D-FDFE-4891-A102-5B0487D3DD4A}"/>
               </a:ext>
             </a:extLst>
           </p:cNvPr>
@@ -2790,7 +2866,7 @@
           <p:cNvPr id="10" name="language-body-1">
             <a:extLst xmlns:a="http://schemas.openxmlformats.org/drawingml/2006/main">
               <a:ext uri="{FF2B5EF4-FFF2-40B4-BE49-F238E27FC236}">
-                <a16:creationId xmlns:a16="http://schemas.microsoft.com/office/drawing/2014/main" id="{19DFF8C7-5723-40CF-9607-8D546A89D112}"/>
+                <a16:creationId xmlns:a16="http://schemas.microsoft.com/office/drawing/2014/main" id="{DC34904C-694C-458A-ACA6-7B9474D459C8}"/>
               </a:ext>
             </a:extLst>
           </p:cNvPr>
@@ -2846,7 +2922,7 @@
           <p:cNvPr id="11" name="language-accent-1">
             <a:extLst xmlns:a="http://schemas.openxmlformats.org/drawingml/2006/main">
               <a:ext uri="{FF2B5EF4-FFF2-40B4-BE49-F238E27FC236}">
-                <a16:creationId xmlns:a16="http://schemas.microsoft.com/office/drawing/2014/main" id="{FC46E218-A3BC-4EF0-8727-BFB852DE11B2}"/>
+                <a16:creationId xmlns:a16="http://schemas.microsoft.com/office/drawing/2014/main" id="{4B87AD09-8E70-47A0-955B-520788DCE585}"/>
               </a:ext>
             </a:extLst>
           </p:cNvPr>
@@ -2877,7 +2953,7 @@
           <p:cNvPr id="12" name="language-label-2">
             <a:extLst xmlns:a="http://schemas.openxmlformats.org/drawingml/2006/main">
               <a:ext uri="{FF2B5EF4-FFF2-40B4-BE49-F238E27FC236}">
-                <a16:creationId xmlns:a16="http://schemas.microsoft.com/office/drawing/2014/main" id="{EF7A8B74-C096-49B7-A7DA-93A8EC57D97D}"/>
+                <a16:creationId xmlns:a16="http://schemas.microsoft.com/office/drawing/2014/main" id="{B00AFB45-0294-4C80-A089-6A61C028814A}"/>
               </a:ext>
             </a:extLst>
           </p:cNvPr>
@@ -2933,7 +3009,7 @@
           <p:cNvPr id="13" name="language-head-2">
             <a:extLst xmlns:a="http://schemas.openxmlformats.org/drawingml/2006/main">
               <a:ext uri="{FF2B5EF4-FFF2-40B4-BE49-F238E27FC236}">
-                <a16:creationId xmlns:a16="http://schemas.microsoft.com/office/drawing/2014/main" id="{EDA8C0E2-FD7B-4EF9-94BD-D51C114E5075}"/>
+                <a16:creationId xmlns:a16="http://schemas.microsoft.com/office/drawing/2014/main" id="{A9A6E262-5286-4AC0-9F83-F5FAC71A23B4}"/>
               </a:ext>
             </a:extLst>
           </p:cNvPr>
@@ -2989,7 +3065,7 @@
           <p:cNvPr id="14" name="language-body-2">
             <a:extLst xmlns:a="http://schemas.openxmlformats.org/drawingml/2006/main">
               <a:ext uri="{FF2B5EF4-FFF2-40B4-BE49-F238E27FC236}">
-                <a16:creationId xmlns:a16="http://schemas.microsoft.com/office/drawing/2014/main" id="{D659C35E-E903-461E-A57A-C53C242AB475}"/>
+                <a16:creationId xmlns:a16="http://schemas.microsoft.com/office/drawing/2014/main" id="{C10E56FC-91B1-4BD1-9B59-C89FDC64C302}"/>
               </a:ext>
             </a:extLst>
           </p:cNvPr>
@@ -3045,7 +3121,7 @@
           <p:cNvPr id="15" name="language-accent-2">
             <a:extLst xmlns:a="http://schemas.openxmlformats.org/drawingml/2006/main">
               <a:ext uri="{FF2B5EF4-FFF2-40B4-BE49-F238E27FC236}">
-                <a16:creationId xmlns:a16="http://schemas.microsoft.com/office/drawing/2014/main" id="{7A66F3CA-1C21-43DD-904F-250B401B53C7}"/>
+                <a16:creationId xmlns:a16="http://schemas.microsoft.com/office/drawing/2014/main" id="{57B3DFAC-10D6-4A8A-862D-4D9A2A67F139}"/>
               </a:ext>
             </a:extLst>
           </p:cNvPr>
@@ -3076,7 +3152,7 @@
           <p:cNvPr id="16" name="footer-3">
             <a:extLst xmlns:a="http://schemas.openxmlformats.org/drawingml/2006/main">
               <a:ext uri="{FF2B5EF4-FFF2-40B4-BE49-F238E27FC236}">
-                <a16:creationId xmlns:a16="http://schemas.microsoft.com/office/drawing/2014/main" id="{CAE9B77E-EEDB-4F8A-BBF1-A6DEF896B413}"/>
+                <a16:creationId xmlns:a16="http://schemas.microsoft.com/office/drawing/2014/main" id="{F47596F4-D04A-4BB4-A5C0-E8631A2E7342}"/>
               </a:ext>
             </a:extLst>
           </p:cNvPr>
@@ -3130,7 +3206,7 @@
     </p:spTree>
     <p:extLst>
       <p:ext uri="{BB962C8B-B14F-4D97-AF65-F5344CB8AC3E}">
-        <p14:creationId xmlns:p14="http://schemas.microsoft.com/office/powerpoint/2010/main" val="544684829"/>
+        <p14:creationId xmlns:p14="http://schemas.microsoft.com/office/powerpoint/2010/main" val="221122730"/>
       </p:ext>
     </p:extLst>
   </p:cSld>
@@ -3161,7 +3237,7 @@
           <p:cNvPr id="23" name="loop-title">
             <a:extLst xmlns:a="http://schemas.openxmlformats.org/drawingml/2006/main">
               <a:ext uri="{FF2B5EF4-FFF2-40B4-BE49-F238E27FC236}">
-                <a16:creationId xmlns:a16="http://schemas.microsoft.com/office/drawing/2014/main" id="{D2B844B8-A3BA-4F40-A2D2-7E51E310746E}"/>
+                <a16:creationId xmlns:a16="http://schemas.microsoft.com/office/drawing/2014/main" id="{255E7022-10F5-483A-BC2A-5BE86474A177}"/>
               </a:ext>
             </a:extLst>
           </p:cNvPr>
@@ -3217,7 +3293,7 @@
           <p:cNvPr id="2" name="loop-subtitle">
             <a:extLst xmlns:a="http://schemas.openxmlformats.org/drawingml/2006/main">
               <a:ext uri="{FF2B5EF4-FFF2-40B4-BE49-F238E27FC236}">
-                <a16:creationId xmlns:a16="http://schemas.microsoft.com/office/drawing/2014/main" id="{14B8B205-91B4-4169-9F9D-99A3E0B1D871}"/>
+                <a16:creationId xmlns:a16="http://schemas.microsoft.com/office/drawing/2014/main" id="{2145E1D4-F7A4-493F-A8BD-61AF4EC03AC4}"/>
               </a:ext>
             </a:extLst>
           </p:cNvPr>
@@ -3273,7 +3349,7 @@
           <p:cNvPr id="3" name="loop-track">
             <a:extLst xmlns:a="http://schemas.openxmlformats.org/drawingml/2006/main">
               <a:ext uri="{FF2B5EF4-FFF2-40B4-BE49-F238E27FC236}">
-                <a16:creationId xmlns:a16="http://schemas.microsoft.com/office/drawing/2014/main" id="{AEF94EB4-A663-4485-A408-08CEC32A56DC}"/>
+                <a16:creationId xmlns:a16="http://schemas.microsoft.com/office/drawing/2014/main" id="{C493E2B2-28DB-482A-BCF1-D04EC8882DB6}"/>
               </a:ext>
             </a:extLst>
           </p:cNvPr>
@@ -3304,7 +3380,7 @@
           <p:cNvPr id="4" name="loop-node-0">
             <a:extLst xmlns:a="http://schemas.openxmlformats.org/drawingml/2006/main">
               <a:ext uri="{FF2B5EF4-FFF2-40B4-BE49-F238E27FC236}">
-                <a16:creationId xmlns:a16="http://schemas.microsoft.com/office/drawing/2014/main" id="{FBF4EF35-0D7D-4271-8A84-AD1B58BE0D23}"/>
+                <a16:creationId xmlns:a16="http://schemas.microsoft.com/office/drawing/2014/main" id="{9DAA1747-5F55-4FCD-BAFB-A3099AB35AE2}"/>
               </a:ext>
             </a:extLst>
           </p:cNvPr>
@@ -3337,7 +3413,7 @@
           <p:cNvPr id="5" name="loop-number-0">
             <a:extLst xmlns:a="http://schemas.openxmlformats.org/drawingml/2006/main">
               <a:ext uri="{FF2B5EF4-FFF2-40B4-BE49-F238E27FC236}">
-                <a16:creationId xmlns:a16="http://schemas.microsoft.com/office/drawing/2014/main" id="{87E9521F-9155-406A-9F52-2635593C1A8F}"/>
+                <a16:creationId xmlns:a16="http://schemas.microsoft.com/office/drawing/2014/main" id="{66992E49-DC49-4E6F-ADDE-56F3BC1A42D2}"/>
               </a:ext>
             </a:extLst>
           </p:cNvPr>
@@ -3393,7 +3469,7 @@
           <p:cNvPr id="6" name="loop-en-0">
             <a:extLst xmlns:a="http://schemas.openxmlformats.org/drawingml/2006/main">
               <a:ext uri="{FF2B5EF4-FFF2-40B4-BE49-F238E27FC236}">
-                <a16:creationId xmlns:a16="http://schemas.microsoft.com/office/drawing/2014/main" id="{71AFA280-A481-4781-AD82-2BA62DA42662}"/>
+                <a16:creationId xmlns:a16="http://schemas.microsoft.com/office/drawing/2014/main" id="{EF8473DB-D165-457F-AAE6-43DACA71C047}"/>
               </a:ext>
             </a:extLst>
           </p:cNvPr>
@@ -3449,7 +3525,7 @@
           <p:cNvPr id="7" name="loop-tr-0">
             <a:extLst xmlns:a="http://schemas.openxmlformats.org/drawingml/2006/main">
               <a:ext uri="{FF2B5EF4-FFF2-40B4-BE49-F238E27FC236}">
-                <a16:creationId xmlns:a16="http://schemas.microsoft.com/office/drawing/2014/main" id="{47C7E4B3-5707-4CB2-95AD-01880B0687E6}"/>
+                <a16:creationId xmlns:a16="http://schemas.microsoft.com/office/drawing/2014/main" id="{9CB65CB5-D354-4DC7-89FA-CB64887ED410}"/>
               </a:ext>
             </a:extLst>
           </p:cNvPr>
@@ -3505,7 +3581,7 @@
           <p:cNvPr id="8" name="loop-ru-0">
             <a:extLst xmlns:a="http://schemas.openxmlformats.org/drawingml/2006/main">
               <a:ext uri="{FF2B5EF4-FFF2-40B4-BE49-F238E27FC236}">
-                <a16:creationId xmlns:a16="http://schemas.microsoft.com/office/drawing/2014/main" id="{64525873-8194-4319-895E-469EA690D261}"/>
+                <a16:creationId xmlns:a16="http://schemas.microsoft.com/office/drawing/2014/main" id="{20069654-FB0D-452A-8CF6-7D1F21A01469}"/>
               </a:ext>
             </a:extLst>
           </p:cNvPr>
@@ -3561,7 +3637,7 @@
           <p:cNvPr id="9" name="loop-detail-0">
             <a:extLst xmlns:a="http://schemas.openxmlformats.org/drawingml/2006/main">
               <a:ext uri="{FF2B5EF4-FFF2-40B4-BE49-F238E27FC236}">
-                <a16:creationId xmlns:a16="http://schemas.microsoft.com/office/drawing/2014/main" id="{4C779C39-B844-4549-ACF2-AD4775786E7F}"/>
+                <a16:creationId xmlns:a16="http://schemas.microsoft.com/office/drawing/2014/main" id="{C58DB755-EB05-4FF6-985A-BCFA835D455C}"/>
               </a:ext>
             </a:extLst>
           </p:cNvPr>
@@ -3617,7 +3693,7 @@
           <p:cNvPr id="10" name="loop-node-1">
             <a:extLst xmlns:a="http://schemas.openxmlformats.org/drawingml/2006/main">
               <a:ext uri="{FF2B5EF4-FFF2-40B4-BE49-F238E27FC236}">
-                <a16:creationId xmlns:a16="http://schemas.microsoft.com/office/drawing/2014/main" id="{87D5917D-C62B-4366-BE64-D26E8CE14B6C}"/>
+                <a16:creationId xmlns:a16="http://schemas.microsoft.com/office/drawing/2014/main" id="{55380504-F5FE-4C22-BBE9-3D8982432B00}"/>
               </a:ext>
             </a:extLst>
           </p:cNvPr>
@@ -3650,7 +3726,7 @@
           <p:cNvPr id="11" name="loop-number-1">
             <a:extLst xmlns:a="http://schemas.openxmlformats.org/drawingml/2006/main">
               <a:ext uri="{FF2B5EF4-FFF2-40B4-BE49-F238E27FC236}">
-                <a16:creationId xmlns:a16="http://schemas.microsoft.com/office/drawing/2014/main" id="{568BD2FA-47B6-4F0E-AB5C-A4C3BE84BAB9}"/>
+                <a16:creationId xmlns:a16="http://schemas.microsoft.com/office/drawing/2014/main" id="{082A3E46-CD91-4C97-9C10-66CC8A17FC2D}"/>
               </a:ext>
             </a:extLst>
           </p:cNvPr>
@@ -3706,7 +3782,7 @@
           <p:cNvPr id="12" name="loop-en-1">
             <a:extLst xmlns:a="http://schemas.openxmlformats.org/drawingml/2006/main">
               <a:ext uri="{FF2B5EF4-FFF2-40B4-BE49-F238E27FC236}">
-                <a16:creationId xmlns:a16="http://schemas.microsoft.com/office/drawing/2014/main" id="{5B270218-24CD-4119-89B6-C777AEFBA295}"/>
+                <a16:creationId xmlns:a16="http://schemas.microsoft.com/office/drawing/2014/main" id="{C27A80AC-7270-4B59-AA7C-82C941BD722E}"/>
               </a:ext>
             </a:extLst>
           </p:cNvPr>
@@ -3762,7 +3838,7 @@
           <p:cNvPr id="13" name="loop-tr-1">
             <a:extLst xmlns:a="http://schemas.openxmlformats.org/drawingml/2006/main">
               <a:ext uri="{FF2B5EF4-FFF2-40B4-BE49-F238E27FC236}">
-                <a16:creationId xmlns:a16="http://schemas.microsoft.com/office/drawing/2014/main" id="{E21D80C1-81D5-4E23-B0DB-45A09DB5D78C}"/>
+                <a16:creationId xmlns:a16="http://schemas.microsoft.com/office/drawing/2014/main" id="{7647A533-AE97-4979-83E1-CB7C20483374}"/>
               </a:ext>
             </a:extLst>
           </p:cNvPr>
@@ -3818,7 +3894,7 @@
           <p:cNvPr id="14" name="loop-ru-1">
             <a:extLst xmlns:a="http://schemas.openxmlformats.org/drawingml/2006/main">
               <a:ext uri="{FF2B5EF4-FFF2-40B4-BE49-F238E27FC236}">
-                <a16:creationId xmlns:a16="http://schemas.microsoft.com/office/drawing/2014/main" id="{644037C0-64F2-44E7-AA19-762969DBE841}"/>
+                <a16:creationId xmlns:a16="http://schemas.microsoft.com/office/drawing/2014/main" id="{06410452-0AD5-4291-9DB3-204F46E0D20E}"/>
               </a:ext>
             </a:extLst>
           </p:cNvPr>
@@ -3874,7 +3950,7 @@
           <p:cNvPr id="15" name="loop-detail-1">
             <a:extLst xmlns:a="http://schemas.openxmlformats.org/drawingml/2006/main">
               <a:ext uri="{FF2B5EF4-FFF2-40B4-BE49-F238E27FC236}">
-                <a16:creationId xmlns:a16="http://schemas.microsoft.com/office/drawing/2014/main" id="{64686C18-C70B-4152-A0FC-0B9C4714E600}"/>
+                <a16:creationId xmlns:a16="http://schemas.microsoft.com/office/drawing/2014/main" id="{E9CAB811-C7E7-478C-9B78-98C8DFC8D092}"/>
               </a:ext>
             </a:extLst>
           </p:cNvPr>
@@ -3930,7 +4006,7 @@
           <p:cNvPr id="16" name="loop-node-2">
             <a:extLst xmlns:a="http://schemas.openxmlformats.org/drawingml/2006/main">
               <a:ext uri="{FF2B5EF4-FFF2-40B4-BE49-F238E27FC236}">
-                <a16:creationId xmlns:a16="http://schemas.microsoft.com/office/drawing/2014/main" id="{DD0D2DDF-1752-4ACD-A01A-016823CAD17E}"/>
+                <a16:creationId xmlns:a16="http://schemas.microsoft.com/office/drawing/2014/main" id="{F4774B87-1662-440E-92DB-8587FEB506C6}"/>
               </a:ext>
             </a:extLst>
           </p:cNvPr>
@@ -3963,7 +4039,7 @@
           <p:cNvPr id="17" name="loop-number-2">
             <a:extLst xmlns:a="http://schemas.openxmlformats.org/drawingml/2006/main">
               <a:ext uri="{FF2B5EF4-FFF2-40B4-BE49-F238E27FC236}">
-                <a16:creationId xmlns:a16="http://schemas.microsoft.com/office/drawing/2014/main" id="{286DBB46-2748-4138-B184-3177F3918C08}"/>
+                <a16:creationId xmlns:a16="http://schemas.microsoft.com/office/drawing/2014/main" id="{51B4121D-AD49-420D-BAB2-1D828383D6FB}"/>
               </a:ext>
             </a:extLst>
           </p:cNvPr>
@@ -4019,7 +4095,7 @@
           <p:cNvPr id="18" name="loop-en-2">
             <a:extLst xmlns:a="http://schemas.openxmlformats.org/drawingml/2006/main">
               <a:ext uri="{FF2B5EF4-FFF2-40B4-BE49-F238E27FC236}">
-                <a16:creationId xmlns:a16="http://schemas.microsoft.com/office/drawing/2014/main" id="{03AF0227-A8AA-4C56-B920-01F765A1064A}"/>
+                <a16:creationId xmlns:a16="http://schemas.microsoft.com/office/drawing/2014/main" id="{AFFDDA26-778A-4747-AF2B-A7E5CD80AAFD}"/>
               </a:ext>
             </a:extLst>
           </p:cNvPr>
@@ -4075,7 +4151,7 @@
           <p:cNvPr id="19" name="loop-tr-2">
             <a:extLst xmlns:a="http://schemas.openxmlformats.org/drawingml/2006/main">
               <a:ext uri="{FF2B5EF4-FFF2-40B4-BE49-F238E27FC236}">
-                <a16:creationId xmlns:a16="http://schemas.microsoft.com/office/drawing/2014/main" id="{28ECF146-50D0-4AD8-A36F-F5B005B7F4C5}"/>
+                <a16:creationId xmlns:a16="http://schemas.microsoft.com/office/drawing/2014/main" id="{5B5AB784-C001-42A3-97C0-29806E681782}"/>
               </a:ext>
             </a:extLst>
           </p:cNvPr>
@@ -4131,7 +4207,7 @@
           <p:cNvPr id="20" name="loop-ru-2">
             <a:extLst xmlns:a="http://schemas.openxmlformats.org/drawingml/2006/main">
               <a:ext uri="{FF2B5EF4-FFF2-40B4-BE49-F238E27FC236}">
-                <a16:creationId xmlns:a16="http://schemas.microsoft.com/office/drawing/2014/main" id="{E713A6B6-458D-48C8-904A-C1AA3A242804}"/>
+                <a16:creationId xmlns:a16="http://schemas.microsoft.com/office/drawing/2014/main" id="{B1A2A4C0-9B8E-4BEE-942A-91DA8C6C6E4E}"/>
               </a:ext>
             </a:extLst>
           </p:cNvPr>
@@ -4187,7 +4263,7 @@
           <p:cNvPr id="21" name="loop-detail-2">
             <a:extLst xmlns:a="http://schemas.openxmlformats.org/drawingml/2006/main">
               <a:ext uri="{FF2B5EF4-FFF2-40B4-BE49-F238E27FC236}">
-                <a16:creationId xmlns:a16="http://schemas.microsoft.com/office/drawing/2014/main" id="{5E58B6B5-EE16-4CD7-93E1-3150AC115344}"/>
+                <a16:creationId xmlns:a16="http://schemas.microsoft.com/office/drawing/2014/main" id="{75B9FA2F-1D23-44B8-A008-3E99CEAEFCD2}"/>
               </a:ext>
             </a:extLst>
           </p:cNvPr>
@@ -4243,7 +4319,7 @@
           <p:cNvPr id="22" name="footer-4">
             <a:extLst xmlns:a="http://schemas.openxmlformats.org/drawingml/2006/main">
               <a:ext uri="{FF2B5EF4-FFF2-40B4-BE49-F238E27FC236}">
-                <a16:creationId xmlns:a16="http://schemas.microsoft.com/office/drawing/2014/main" id="{2F2775CD-F227-46E6-B21A-7103F7ADA19E}"/>
+                <a16:creationId xmlns:a16="http://schemas.microsoft.com/office/drawing/2014/main" id="{DAC7DEAE-DF96-4FA9-BAF1-999167B71824}"/>
               </a:ext>
             </a:extLst>
           </p:cNvPr>
@@ -4297,7 +4373,7 @@
     </p:spTree>
     <p:extLst>
       <p:ext uri="{BB962C8B-B14F-4D97-AF65-F5344CB8AC3E}">
-        <p14:creationId xmlns:p14="http://schemas.microsoft.com/office/powerpoint/2010/main" val="857017787"/>
+        <p14:creationId xmlns:p14="http://schemas.microsoft.com/office/powerpoint/2010/main" val="1648552272"/>
       </p:ext>
     </p:extLst>
   </p:cSld>
@@ -4328,7 +4404,7 @@
           <p:cNvPr id="21" name="breadth-title">
             <a:extLst xmlns:a="http://schemas.openxmlformats.org/drawingml/2006/main">
               <a:ext uri="{FF2B5EF4-FFF2-40B4-BE49-F238E27FC236}">
-                <a16:creationId xmlns:a16="http://schemas.microsoft.com/office/drawing/2014/main" id="{E5264E20-C098-4923-8412-0A898EFC4CCB}"/>
+                <a16:creationId xmlns:a16="http://schemas.microsoft.com/office/drawing/2014/main" id="{7F6372B3-C494-4B24-A3FE-EEECDFE381FF}"/>
               </a:ext>
             </a:extLst>
           </p:cNvPr>
@@ -4384,7 +4460,7 @@
           <p:cNvPr id="2" name="breadth-triple">
             <a:extLst xmlns:a="http://schemas.openxmlformats.org/drawingml/2006/main">
               <a:ext uri="{FF2B5EF4-FFF2-40B4-BE49-F238E27FC236}">
-                <a16:creationId xmlns:a16="http://schemas.microsoft.com/office/drawing/2014/main" id="{97358284-7AF4-42AD-832D-62FCE03BAE9B}"/>
+                <a16:creationId xmlns:a16="http://schemas.microsoft.com/office/drawing/2014/main" id="{74DC8C2D-0F9F-4CF9-BC6A-933F55122570}"/>
               </a:ext>
             </a:extLst>
           </p:cNvPr>
@@ -4440,7 +4516,7 @@
           <p:cNvPr id="3" name="breadth-number">
             <a:extLst xmlns:a="http://schemas.openxmlformats.org/drawingml/2006/main">
               <a:ext uri="{FF2B5EF4-FFF2-40B4-BE49-F238E27FC236}">
-                <a16:creationId xmlns:a16="http://schemas.microsoft.com/office/drawing/2014/main" id="{897DB089-EEBE-4C9B-973F-FC6996C3BB8F}"/>
+                <a16:creationId xmlns:a16="http://schemas.microsoft.com/office/drawing/2014/main" id="{5FEB13A1-D785-4DAC-9D1D-1BE68E2E78AD}"/>
               </a:ext>
             </a:extLst>
           </p:cNvPr>
@@ -4496,7 +4572,7 @@
           <p:cNvPr id="4" name="breadth-caption">
             <a:extLst xmlns:a="http://schemas.openxmlformats.org/drawingml/2006/main">
               <a:ext uri="{FF2B5EF4-FFF2-40B4-BE49-F238E27FC236}">
-                <a16:creationId xmlns:a16="http://schemas.microsoft.com/office/drawing/2014/main" id="{8F9899BB-DCB7-42F3-94A0-2FB34FA5AFF5}"/>
+                <a16:creationId xmlns:a16="http://schemas.microsoft.com/office/drawing/2014/main" id="{68CAF65B-3EDE-41E8-A530-A84D6A678EC3}"/>
               </a:ext>
             </a:extLst>
           </p:cNvPr>
@@ -4598,7 +4674,7 @@
           <p:cNvPr id="5" name="breadth-divider">
             <a:extLst xmlns:a="http://schemas.openxmlformats.org/drawingml/2006/main">
               <a:ext uri="{FF2B5EF4-FFF2-40B4-BE49-F238E27FC236}">
-                <a16:creationId xmlns:a16="http://schemas.microsoft.com/office/drawing/2014/main" id="{8C31E0BD-72D8-48D9-BE7E-53273F4DF5A5}"/>
+                <a16:creationId xmlns:a16="http://schemas.microsoft.com/office/drawing/2014/main" id="{4F3ADE46-BA98-4C85-97F2-AC6DCC1C5D34}"/>
               </a:ext>
             </a:extLst>
           </p:cNvPr>
@@ -4629,7 +4705,7 @@
           <p:cNvPr id="6" name="breadth-item-rule-0">
             <a:extLst xmlns:a="http://schemas.openxmlformats.org/drawingml/2006/main">
               <a:ext uri="{FF2B5EF4-FFF2-40B4-BE49-F238E27FC236}">
-                <a16:creationId xmlns:a16="http://schemas.microsoft.com/office/drawing/2014/main" id="{79E464FE-034A-4E16-A1BC-448BA91E49BF}"/>
+                <a16:creationId xmlns:a16="http://schemas.microsoft.com/office/drawing/2014/main" id="{0BF48DA9-DB50-4A11-AA09-14BCEB8F3B51}"/>
               </a:ext>
             </a:extLst>
           </p:cNvPr>
@@ -4660,7 +4736,7 @@
           <p:cNvPr id="7" name="breadth-item-0">
             <a:extLst xmlns:a="http://schemas.openxmlformats.org/drawingml/2006/main">
               <a:ext uri="{FF2B5EF4-FFF2-40B4-BE49-F238E27FC236}">
-                <a16:creationId xmlns:a16="http://schemas.microsoft.com/office/drawing/2014/main" id="{C009B1DD-F4FF-4DE1-B019-AEF165825350}"/>
+                <a16:creationId xmlns:a16="http://schemas.microsoft.com/office/drawing/2014/main" id="{4A0DDE89-6668-4D81-9F6C-60C599F0D0D5}"/>
               </a:ext>
             </a:extLst>
           </p:cNvPr>
@@ -4716,7 +4792,7 @@
           <p:cNvPr id="8" name="breadth-item-rule-1">
             <a:extLst xmlns:a="http://schemas.openxmlformats.org/drawingml/2006/main">
               <a:ext uri="{FF2B5EF4-FFF2-40B4-BE49-F238E27FC236}">
-                <a16:creationId xmlns:a16="http://schemas.microsoft.com/office/drawing/2014/main" id="{00F0A5C0-F805-4F66-8FB9-F85E660C8388}"/>
+                <a16:creationId xmlns:a16="http://schemas.microsoft.com/office/drawing/2014/main" id="{0C79F47D-575C-4306-8AFB-C7F977419981}"/>
               </a:ext>
             </a:extLst>
           </p:cNvPr>
@@ -4747,7 +4823,7 @@
           <p:cNvPr id="9" name="breadth-item-1">
             <a:extLst xmlns:a="http://schemas.openxmlformats.org/drawingml/2006/main">
               <a:ext uri="{FF2B5EF4-FFF2-40B4-BE49-F238E27FC236}">
-                <a16:creationId xmlns:a16="http://schemas.microsoft.com/office/drawing/2014/main" id="{7336A383-8413-47F3-886B-317EF1108F99}"/>
+                <a16:creationId xmlns:a16="http://schemas.microsoft.com/office/drawing/2014/main" id="{7723828C-5B62-4757-966F-B8DFFD9790A3}"/>
               </a:ext>
             </a:extLst>
           </p:cNvPr>
@@ -4803,7 +4879,7 @@
           <p:cNvPr id="10" name="breadth-item-rule-2">
             <a:extLst xmlns:a="http://schemas.openxmlformats.org/drawingml/2006/main">
               <a:ext uri="{FF2B5EF4-FFF2-40B4-BE49-F238E27FC236}">
-                <a16:creationId xmlns:a16="http://schemas.microsoft.com/office/drawing/2014/main" id="{91B54514-B85C-420A-BF6C-EDF4292BDA3F}"/>
+                <a16:creationId xmlns:a16="http://schemas.microsoft.com/office/drawing/2014/main" id="{83093D72-19B5-4CF8-9463-EF9C7BD4969B}"/>
               </a:ext>
             </a:extLst>
           </p:cNvPr>
@@ -4834,7 +4910,7 @@
           <p:cNvPr id="11" name="breadth-item-2">
             <a:extLst xmlns:a="http://schemas.openxmlformats.org/drawingml/2006/main">
               <a:ext uri="{FF2B5EF4-FFF2-40B4-BE49-F238E27FC236}">
-                <a16:creationId xmlns:a16="http://schemas.microsoft.com/office/drawing/2014/main" id="{74F2F957-EC53-4709-914E-CE081CCF08D9}"/>
+                <a16:creationId xmlns:a16="http://schemas.microsoft.com/office/drawing/2014/main" id="{9C4F229C-E22D-4840-A7B8-279EF7E8D130}"/>
               </a:ext>
             </a:extLst>
           </p:cNvPr>
@@ -4890,7 +4966,7 @@
           <p:cNvPr id="12" name="breadth-item-rule-3">
             <a:extLst xmlns:a="http://schemas.openxmlformats.org/drawingml/2006/main">
               <a:ext uri="{FF2B5EF4-FFF2-40B4-BE49-F238E27FC236}">
-                <a16:creationId xmlns:a16="http://schemas.microsoft.com/office/drawing/2014/main" id="{62D3CFB6-F051-4199-9EB1-CF4FD001188E}"/>
+                <a16:creationId xmlns:a16="http://schemas.microsoft.com/office/drawing/2014/main" id="{7C53DC3E-20FB-41E7-9DCC-1C6FAB2A2BD5}"/>
               </a:ext>
             </a:extLst>
           </p:cNvPr>
@@ -4921,7 +4997,7 @@
           <p:cNvPr id="13" name="breadth-item-3">
             <a:extLst xmlns:a="http://schemas.openxmlformats.org/drawingml/2006/main">
               <a:ext uri="{FF2B5EF4-FFF2-40B4-BE49-F238E27FC236}">
-                <a16:creationId xmlns:a16="http://schemas.microsoft.com/office/drawing/2014/main" id="{EDBEA7AD-4604-4397-A837-6686B10D6D92}"/>
+                <a16:creationId xmlns:a16="http://schemas.microsoft.com/office/drawing/2014/main" id="{B99A28C3-5186-4CBA-8950-06A5E2613A0B}"/>
               </a:ext>
             </a:extLst>
           </p:cNvPr>
@@ -4977,7 +5053,7 @@
           <p:cNvPr id="14" name="breadth-item-rule-4">
             <a:extLst xmlns:a="http://schemas.openxmlformats.org/drawingml/2006/main">
               <a:ext uri="{FF2B5EF4-FFF2-40B4-BE49-F238E27FC236}">
-                <a16:creationId xmlns:a16="http://schemas.microsoft.com/office/drawing/2014/main" id="{07D4968F-ABA7-4A5F-91E2-12DC332F57EF}"/>
+                <a16:creationId xmlns:a16="http://schemas.microsoft.com/office/drawing/2014/main" id="{718F0F8D-9350-4051-981C-2513B6066485}"/>
               </a:ext>
             </a:extLst>
           </p:cNvPr>
@@ -5008,7 +5084,7 @@
           <p:cNvPr id="15" name="breadth-item-4">
             <a:extLst xmlns:a="http://schemas.openxmlformats.org/drawingml/2006/main">
               <a:ext uri="{FF2B5EF4-FFF2-40B4-BE49-F238E27FC236}">
-                <a16:creationId xmlns:a16="http://schemas.microsoft.com/office/drawing/2014/main" id="{C05839A5-8C15-4FE6-891B-2DA4CA3309A4}"/>
+                <a16:creationId xmlns:a16="http://schemas.microsoft.com/office/drawing/2014/main" id="{A25B442C-ADCC-4E19-A55C-81CDB2E88C8B}"/>
               </a:ext>
             </a:extLst>
           </p:cNvPr>
@@ -5064,7 +5140,7 @@
           <p:cNvPr id="16" name="breadth-item-rule-5">
             <a:extLst xmlns:a="http://schemas.openxmlformats.org/drawingml/2006/main">
               <a:ext uri="{FF2B5EF4-FFF2-40B4-BE49-F238E27FC236}">
-                <a16:creationId xmlns:a16="http://schemas.microsoft.com/office/drawing/2014/main" id="{71F9651A-F64A-4A39-B195-E0ABF9A56062}"/>
+                <a16:creationId xmlns:a16="http://schemas.microsoft.com/office/drawing/2014/main" id="{143AFB30-C781-466E-A65E-D9B054DB1805}"/>
               </a:ext>
             </a:extLst>
           </p:cNvPr>
@@ -5095,7 +5171,7 @@
           <p:cNvPr id="17" name="breadth-item-5">
             <a:extLst xmlns:a="http://schemas.openxmlformats.org/drawingml/2006/main">
               <a:ext uri="{FF2B5EF4-FFF2-40B4-BE49-F238E27FC236}">
-                <a16:creationId xmlns:a16="http://schemas.microsoft.com/office/drawing/2014/main" id="{303FA82B-59F0-4291-9A22-A68368D23B87}"/>
+                <a16:creationId xmlns:a16="http://schemas.microsoft.com/office/drawing/2014/main" id="{0F836236-7C42-4E33-A5F4-0A54B173EAB9}"/>
               </a:ext>
             </a:extLst>
           </p:cNvPr>
@@ -5151,7 +5227,7 @@
           <p:cNvPr id="18" name="breadth-item-rule-6">
             <a:extLst xmlns:a="http://schemas.openxmlformats.org/drawingml/2006/main">
               <a:ext uri="{FF2B5EF4-FFF2-40B4-BE49-F238E27FC236}">
-                <a16:creationId xmlns:a16="http://schemas.microsoft.com/office/drawing/2014/main" id="{A7CE26D3-6F2E-4B04-8243-C248F010E29B}"/>
+                <a16:creationId xmlns:a16="http://schemas.microsoft.com/office/drawing/2014/main" id="{8B8F4AE9-06CF-42A5-B384-6F8648C946A3}"/>
               </a:ext>
             </a:extLst>
           </p:cNvPr>
@@ -5182,7 +5258,7 @@
           <p:cNvPr id="19" name="breadth-item-6">
             <a:extLst xmlns:a="http://schemas.openxmlformats.org/drawingml/2006/main">
               <a:ext uri="{FF2B5EF4-FFF2-40B4-BE49-F238E27FC236}">
-                <a16:creationId xmlns:a16="http://schemas.microsoft.com/office/drawing/2014/main" id="{6774811F-148C-45E4-A59E-D1F5D6CCB120}"/>
+                <a16:creationId xmlns:a16="http://schemas.microsoft.com/office/drawing/2014/main" id="{D99DACF6-067E-41D4-B6AC-6521039E78CE}"/>
               </a:ext>
             </a:extLst>
           </p:cNvPr>
@@ -5238,7 +5314,7 @@
           <p:cNvPr id="20" name="footer-5">
             <a:extLst xmlns:a="http://schemas.openxmlformats.org/drawingml/2006/main">
               <a:ext uri="{FF2B5EF4-FFF2-40B4-BE49-F238E27FC236}">
-                <a16:creationId xmlns:a16="http://schemas.microsoft.com/office/drawing/2014/main" id="{BC148480-84B1-4427-86B3-8174E4D575BB}"/>
+                <a16:creationId xmlns:a16="http://schemas.microsoft.com/office/drawing/2014/main" id="{B0B2F394-0AA0-4315-B169-2A0CE2C9B9EA}"/>
               </a:ext>
             </a:extLst>
           </p:cNvPr>
@@ -5292,7 +5368,7 @@
     </p:spTree>
     <p:extLst>
       <p:ext uri="{BB962C8B-B14F-4D97-AF65-F5344CB8AC3E}">
-        <p14:creationId xmlns:p14="http://schemas.microsoft.com/office/powerpoint/2010/main" val="365693453"/>
+        <p14:creationId xmlns:p14="http://schemas.microsoft.com/office/powerpoint/2010/main" val="223721156"/>
       </p:ext>
     </p:extLst>
   </p:cSld>
@@ -5323,7 +5399,7 @@
           <p:cNvPr id="12" name="privacy-title">
             <a:extLst xmlns:a="http://schemas.openxmlformats.org/drawingml/2006/main">
               <a:ext uri="{FF2B5EF4-FFF2-40B4-BE49-F238E27FC236}">
-                <a16:creationId xmlns:a16="http://schemas.microsoft.com/office/drawing/2014/main" id="{36E0722C-6F40-4926-A8BA-1A5A92A3708D}"/>
+                <a16:creationId xmlns:a16="http://schemas.microsoft.com/office/drawing/2014/main" id="{5722DF48-0B98-4E24-B2BE-4844BD4C7E06}"/>
               </a:ext>
             </a:extLst>
           </p:cNvPr>
@@ -5379,7 +5455,7 @@
           <p:cNvPr id="2" name="privacy-tr">
             <a:extLst xmlns:a="http://schemas.openxmlformats.org/drawingml/2006/main">
               <a:ext uri="{FF2B5EF4-FFF2-40B4-BE49-F238E27FC236}">
-                <a16:creationId xmlns:a16="http://schemas.microsoft.com/office/drawing/2014/main" id="{63E0D95D-6E5A-44AE-BCCC-96C5ABFC506F}"/>
+                <a16:creationId xmlns:a16="http://schemas.microsoft.com/office/drawing/2014/main" id="{4DD94E00-5700-4E79-AECB-B826AB4E60A2}"/>
               </a:ext>
             </a:extLst>
           </p:cNvPr>
@@ -5435,7 +5511,7 @@
           <p:cNvPr id="3" name="privacy-ru">
             <a:extLst xmlns:a="http://schemas.openxmlformats.org/drawingml/2006/main">
               <a:ext uri="{FF2B5EF4-FFF2-40B4-BE49-F238E27FC236}">
-                <a16:creationId xmlns:a16="http://schemas.microsoft.com/office/drawing/2014/main" id="{94A1D7CA-2E95-4981-87B4-FB803B8D76B7}"/>
+                <a16:creationId xmlns:a16="http://schemas.microsoft.com/office/drawing/2014/main" id="{CA2CE190-6A7C-490D-9335-9F5F6B5F02B7}"/>
               </a:ext>
             </a:extLst>
           </p:cNvPr>
@@ -5491,7 +5567,7 @@
           <p:cNvPr id="4" name="privacy-divider">
             <a:extLst xmlns:a="http://schemas.openxmlformats.org/drawingml/2006/main">
               <a:ext uri="{FF2B5EF4-FFF2-40B4-BE49-F238E27FC236}">
-                <a16:creationId xmlns:a16="http://schemas.microsoft.com/office/drawing/2014/main" id="{13FFE2E8-D8C6-41A6-806C-F428173E1A29}"/>
+                <a16:creationId xmlns:a16="http://schemas.microsoft.com/office/drawing/2014/main" id="{25E236AB-756D-444F-8C04-6B2E34666350}"/>
               </a:ext>
             </a:extLst>
           </p:cNvPr>
@@ -5522,7 +5598,7 @@
           <p:cNvPr id="5" name="local-label">
             <a:extLst xmlns:a="http://schemas.openxmlformats.org/drawingml/2006/main">
               <a:ext uri="{FF2B5EF4-FFF2-40B4-BE49-F238E27FC236}">
-                <a16:creationId xmlns:a16="http://schemas.microsoft.com/office/drawing/2014/main" id="{1FD221DB-B6AA-41C2-B064-F2CFFFA377F5}"/>
+                <a16:creationId xmlns:a16="http://schemas.microsoft.com/office/drawing/2014/main" id="{5B70D2B8-FEAA-49B1-8562-484D08840A88}"/>
               </a:ext>
             </a:extLst>
           </p:cNvPr>
@@ -5578,7 +5654,7 @@
           <p:cNvPr id="6" name="local-head">
             <a:extLst xmlns:a="http://schemas.openxmlformats.org/drawingml/2006/main">
               <a:ext uri="{FF2B5EF4-FFF2-40B4-BE49-F238E27FC236}">
-                <a16:creationId xmlns:a16="http://schemas.microsoft.com/office/drawing/2014/main" id="{8D9523C8-5CE2-45F1-ACEE-3C3C05271E54}"/>
+                <a16:creationId xmlns:a16="http://schemas.microsoft.com/office/drawing/2014/main" id="{EFD14CD2-D0E4-4FE6-BBFB-BCDBFB91D8AD}"/>
               </a:ext>
             </a:extLst>
           </p:cNvPr>
@@ -5634,7 +5710,7 @@
           <p:cNvPr id="7" name="local-copy">
             <a:extLst xmlns:a="http://schemas.openxmlformats.org/drawingml/2006/main">
               <a:ext uri="{FF2B5EF4-FFF2-40B4-BE49-F238E27FC236}">
-                <a16:creationId xmlns:a16="http://schemas.microsoft.com/office/drawing/2014/main" id="{BEA3703B-6911-4861-9D14-D6CC45D644D1}"/>
+                <a16:creationId xmlns:a16="http://schemas.microsoft.com/office/drawing/2014/main" id="{BD32B1FC-E8AA-475A-B109-A536D2434249}"/>
               </a:ext>
             </a:extLst>
           </p:cNvPr>
@@ -5764,7 +5840,7 @@
           <p:cNvPr id="8" name="optional-label">
             <a:extLst xmlns:a="http://schemas.openxmlformats.org/drawingml/2006/main">
               <a:ext uri="{FF2B5EF4-FFF2-40B4-BE49-F238E27FC236}">
-                <a16:creationId xmlns:a16="http://schemas.microsoft.com/office/drawing/2014/main" id="{D3A55105-6C76-48C3-81A9-D81CD4EBD708}"/>
+                <a16:creationId xmlns:a16="http://schemas.microsoft.com/office/drawing/2014/main" id="{8E456682-CC31-4A33-95F3-70C66A3F5823}"/>
               </a:ext>
             </a:extLst>
           </p:cNvPr>
@@ -5820,7 +5896,7 @@
           <p:cNvPr id="9" name="optional-head">
             <a:extLst xmlns:a="http://schemas.openxmlformats.org/drawingml/2006/main">
               <a:ext uri="{FF2B5EF4-FFF2-40B4-BE49-F238E27FC236}">
-                <a16:creationId xmlns:a16="http://schemas.microsoft.com/office/drawing/2014/main" id="{1DF12856-5854-4ED7-9711-92CD12D19F48}"/>
+                <a16:creationId xmlns:a16="http://schemas.microsoft.com/office/drawing/2014/main" id="{1E854F30-7CD0-4655-B638-C1053F86E7DD}"/>
               </a:ext>
             </a:extLst>
           </p:cNvPr>
@@ -5876,7 +5952,7 @@
           <p:cNvPr id="10" name="optional-copy">
             <a:extLst xmlns:a="http://schemas.openxmlformats.org/drawingml/2006/main">
               <a:ext uri="{FF2B5EF4-FFF2-40B4-BE49-F238E27FC236}">
-                <a16:creationId xmlns:a16="http://schemas.microsoft.com/office/drawing/2014/main" id="{671F3D9E-C1FB-4DBD-9F8B-60DCC63939C3}"/>
+                <a16:creationId xmlns:a16="http://schemas.microsoft.com/office/drawing/2014/main" id="{29FAF81E-F393-4281-97A5-3CA5462E3574}"/>
               </a:ext>
             </a:extLst>
           </p:cNvPr>
@@ -6006,7 +6082,7 @@
           <p:cNvPr id="11" name="footer-6">
             <a:extLst xmlns:a="http://schemas.openxmlformats.org/drawingml/2006/main">
               <a:ext uri="{FF2B5EF4-FFF2-40B4-BE49-F238E27FC236}">
-                <a16:creationId xmlns:a16="http://schemas.microsoft.com/office/drawing/2014/main" id="{701E80FE-3449-400D-889C-597DCBC3B0A0}"/>
+                <a16:creationId xmlns:a16="http://schemas.microsoft.com/office/drawing/2014/main" id="{3F5EB684-3C35-43E9-9302-7D6958E566B9}"/>
               </a:ext>
             </a:extLst>
           </p:cNvPr>
@@ -6060,7 +6136,7 @@
     </p:spTree>
     <p:extLst>
       <p:ext uri="{BB962C8B-B14F-4D97-AF65-F5344CB8AC3E}">
-        <p14:creationId xmlns:p14="http://schemas.microsoft.com/office/powerpoint/2010/main" val="1564406263"/>
+        <p14:creationId xmlns:p14="http://schemas.microsoft.com/office/powerpoint/2010/main" val="283387903"/>
       </p:ext>
     </p:extLst>
   </p:cSld>
@@ -6088,94 +6164,38 @@
       </p:grpSpPr>
       <p:sp>
         <p:nvSpPr>
-          <p:cNvPr id="9" name="close-kicker">
-            <a:extLst xmlns:a="http://schemas.openxmlformats.org/drawingml/2006/main">
-              <a:ext uri="{FF2B5EF4-FFF2-40B4-BE49-F238E27FC236}">
-                <a16:creationId xmlns:a16="http://schemas.microsoft.com/office/drawing/2014/main" id="{57CCA191-3BB3-4CC8-9D71-A7803BA13F67}"/>
-              </a:ext>
-            </a:extLst>
-          </p:cNvPr>
-          <p:cNvSpPr>
-            <a:spLocks xmlns:a="http://schemas.openxmlformats.org/drawingml/2006/main" noGrp="1"/>
-          </p:cNvSpPr>
-          <p:nvPr/>
-        </p:nvSpPr>
-        <p:spPr>
-          <a:xfrm xmlns:a="http://schemas.openxmlformats.org/drawingml/2006/main">
-            <a:off x="400050" y="400050"/>
-            <a:ext cx="4000500" cy="228600"/>
-          </a:xfrm>
-          <a:prstGeom xmlns:a="http://schemas.openxmlformats.org/drawingml/2006/main" prst="rect">
-            <a:avLst/>
-          </a:prstGeom>
-          <a:noFill xmlns:a="http://schemas.openxmlformats.org/drawingml/2006/main"/>
-          <a:ln xmlns:a="http://schemas.openxmlformats.org/drawingml/2006/main" w="0">
-            <a:noFill/>
-            <a:prstDash val="solid"/>
-          </a:ln>
-        </p:spPr>
-        <p:txBody>
-          <a:bodyPr xmlns:a="http://schemas.openxmlformats.org/drawingml/2006/main" anchor="t"/>
-          <a:lstStyle xmlns:a="http://schemas.openxmlformats.org/drawingml/2006/main"/>
-          <a:p xmlns:a="http://schemas.openxmlformats.org/drawingml/2006/main">
-            <a:pPr algn="l">
-              <a:defRPr sz="1050" b="1">
-                <a:solidFill>
-                  <a:srgbClr val="3D8DFF"/>
-                </a:solidFill>
-                <a:latin typeface="Arial"/>
-                <a:ea typeface="Arial"/>
-                <a:cs typeface="Arial"/>
-              </a:defRPr>
-            </a:pPr>
-            <a:r>
-              <a:rPr sz="1050" b="1">
-                <a:solidFill>
-                  <a:srgbClr val="3D8DFF"/>
-                </a:solidFill>
-                <a:latin typeface="Arial"/>
-                <a:ea typeface="Arial"/>
-                <a:cs typeface="Arial"/>
-              </a:rPr>
-              <a:t>START YOUR NEXT SESSION</a:t>
-            </a:r>
-          </a:p>
-        </p:txBody>
-      </p:sp>
-      <p:sp>
-        <p:nvSpPr>
-          <p:cNvPr id="2" name="close-title">
-            <a:extLst xmlns:a="http://schemas.openxmlformats.org/drawingml/2006/main">
-              <a:ext uri="{FF2B5EF4-FFF2-40B4-BE49-F238E27FC236}">
-                <a16:creationId xmlns:a16="http://schemas.microsoft.com/office/drawing/2014/main" id="{3C72C30B-3688-4F15-90BF-C9A1FE5B60C8}"/>
-              </a:ext>
-            </a:extLst>
-          </p:cNvPr>
-          <p:cNvSpPr>
-            <a:spLocks xmlns:a="http://schemas.openxmlformats.org/drawingml/2006/main" noGrp="1"/>
-          </p:cNvSpPr>
-          <p:nvPr/>
-        </p:nvSpPr>
-        <p:spPr>
-          <a:xfrm xmlns:a="http://schemas.openxmlformats.org/drawingml/2006/main">
-            <a:off x="400050" y="1657350"/>
-            <a:ext cx="10001250" cy="1714500"/>
-          </a:xfrm>
-          <a:prstGeom xmlns:a="http://schemas.openxmlformats.org/drawingml/2006/main" prst="rect">
-            <a:avLst/>
-          </a:prstGeom>
-          <a:noFill xmlns:a="http://schemas.openxmlformats.org/drawingml/2006/main"/>
-          <a:ln xmlns:a="http://schemas.openxmlformats.org/drawingml/2006/main" w="0">
-            <a:noFill/>
-            <a:prstDash val="solid"/>
-          </a:ln>
-        </p:spPr>
-        <p:txBody>
-          <a:bodyPr xmlns:a="http://schemas.openxmlformats.org/drawingml/2006/main" anchor="t"/>
-          <a:lstStyle xmlns:a="http://schemas.openxmlformats.org/drawingml/2006/main"/>
-          <a:p xmlns:a="http://schemas.openxmlformats.org/drawingml/2006/main">
-            <a:pPr algn="l">
-              <a:defRPr sz="4650" b="1">
+          <p:cNvPr id="13" name="platform-title">
+            <a:extLst xmlns:a="http://schemas.openxmlformats.org/drawingml/2006/main">
+              <a:ext uri="{FF2B5EF4-FFF2-40B4-BE49-F238E27FC236}">
+                <a16:creationId xmlns:a16="http://schemas.microsoft.com/office/drawing/2014/main" id="{910C6908-AC17-4190-8351-FA648495865C}"/>
+              </a:ext>
+            </a:extLst>
+          </p:cNvPr>
+          <p:cNvSpPr>
+            <a:spLocks xmlns:a="http://schemas.openxmlformats.org/drawingml/2006/main" noGrp="1"/>
+          </p:cNvSpPr>
+          <p:nvPr/>
+        </p:nvSpPr>
+        <p:spPr>
+          <a:xfrm xmlns:a="http://schemas.openxmlformats.org/drawingml/2006/main">
+            <a:off x="400050" y="342900"/>
+            <a:ext cx="9525000" cy="571500"/>
+          </a:xfrm>
+          <a:prstGeom xmlns:a="http://schemas.openxmlformats.org/drawingml/2006/main" prst="rect">
+            <a:avLst/>
+          </a:prstGeom>
+          <a:noFill xmlns:a="http://schemas.openxmlformats.org/drawingml/2006/main"/>
+          <a:ln xmlns:a="http://schemas.openxmlformats.org/drawingml/2006/main" w="0">
+            <a:noFill/>
+            <a:prstDash val="solid"/>
+          </a:ln>
+        </p:spPr>
+        <p:txBody>
+          <a:bodyPr xmlns:a="http://schemas.openxmlformats.org/drawingml/2006/main" anchor="t"/>
+          <a:lstStyle xmlns:a="http://schemas.openxmlformats.org/drawingml/2006/main"/>
+          <a:p xmlns:a="http://schemas.openxmlformats.org/drawingml/2006/main">
+            <a:pPr algn="l">
+              <a:defRPr sz="3450" b="1">
                 <a:solidFill>
                   <a:srgbClr val="10131A"/>
                 </a:solidFill>
@@ -6185,7 +6205,7 @@
               </a:defRPr>
             </a:pPr>
             <a:r>
-              <a:rPr sz="4650" b="1">
+              <a:rPr sz="3450" b="1">
                 <a:solidFill>
                   <a:srgbClr val="10131A"/>
                 </a:solidFill>
@@ -6193,163 +6213,84 @@
                 <a:ea typeface="Arial"/>
                 <a:cs typeface="Arial"/>
               </a:rPr>
-              <a:t>Build a Russian routine</a:t>
-            </a:r>
-          </a:p>
-          <a:p xmlns:a="http://schemas.openxmlformats.org/drawingml/2006/main">
-            <a:pPr algn="l">
-              <a:defRPr sz="4650" b="1">
-                <a:solidFill>
-                  <a:srgbClr val="10131A"/>
-                </a:solidFill>
-                <a:latin typeface="Arial"/>
-                <a:ea typeface="Arial"/>
-                <a:cs typeface="Arial"/>
-              </a:defRPr>
-            </a:pPr>
-            <a:r>
-              <a:rPr sz="4650" b="1">
-                <a:solidFill>
-                  <a:srgbClr val="10131A"/>
-                </a:solidFill>
-                <a:latin typeface="Arial"/>
-                <a:ea typeface="Arial"/>
-                <a:cs typeface="Arial"/>
-              </a:rPr>
-              <a:t>that belongs to you.</a:t>
-            </a:r>
-          </a:p>
-        </p:txBody>
-      </p:sp>
-      <p:sp>
-        <p:nvSpPr>
-          <p:cNvPr id="3" name="close-tr">
-            <a:extLst xmlns:a="http://schemas.openxmlformats.org/drawingml/2006/main">
-              <a:ext uri="{FF2B5EF4-FFF2-40B4-BE49-F238E27FC236}">
-                <a16:creationId xmlns:a16="http://schemas.microsoft.com/office/drawing/2014/main" id="{E70AE877-0B21-434D-9DFA-D3414FCD962C}"/>
-              </a:ext>
-            </a:extLst>
-          </p:cNvPr>
-          <p:cNvSpPr>
-            <a:spLocks xmlns:a="http://schemas.openxmlformats.org/drawingml/2006/main" noGrp="1"/>
-          </p:cNvSpPr>
-          <p:nvPr/>
-        </p:nvSpPr>
-        <p:spPr>
-          <a:xfrm xmlns:a="http://schemas.openxmlformats.org/drawingml/2006/main">
-            <a:off x="400050" y="4324350"/>
-            <a:ext cx="6858000" cy="323850"/>
-          </a:xfrm>
-          <a:prstGeom xmlns:a="http://schemas.openxmlformats.org/drawingml/2006/main" prst="rect">
-            <a:avLst/>
-          </a:prstGeom>
-          <a:noFill xmlns:a="http://schemas.openxmlformats.org/drawingml/2006/main"/>
-          <a:ln xmlns:a="http://schemas.openxmlformats.org/drawingml/2006/main" w="0">
-            <a:noFill/>
-            <a:prstDash val="solid"/>
-          </a:ln>
-        </p:spPr>
-        <p:txBody>
-          <a:bodyPr xmlns:a="http://schemas.openxmlformats.org/drawingml/2006/main" anchor="t"/>
-          <a:lstStyle xmlns:a="http://schemas.openxmlformats.org/drawingml/2006/main"/>
-          <a:p xmlns:a="http://schemas.openxmlformats.org/drawingml/2006/main">
-            <a:pPr algn="l">
-              <a:defRPr sz="1725" b="1">
-                <a:solidFill>
-                  <a:srgbClr val="10131A"/>
-                </a:solidFill>
-                <a:latin typeface="Arial"/>
-                <a:ea typeface="Arial"/>
-                <a:cs typeface="Arial"/>
-              </a:defRPr>
-            </a:pPr>
-            <a:r>
-              <a:rPr sz="1725" b="1">
-                <a:solidFill>
-                  <a:srgbClr val="10131A"/>
-                </a:solidFill>
-                <a:latin typeface="Arial"/>
-                <a:ea typeface="Arial"/>
-                <a:cs typeface="Arial"/>
-              </a:rPr>
-              <a:t>Size ait bir Rusça rutini oluşturun.</a:t>
-            </a:r>
-          </a:p>
-        </p:txBody>
-      </p:sp>
-      <p:sp>
-        <p:nvSpPr>
-          <p:cNvPr id="4" name="close-ru">
-            <a:extLst xmlns:a="http://schemas.openxmlformats.org/drawingml/2006/main">
-              <a:ext uri="{FF2B5EF4-FFF2-40B4-BE49-F238E27FC236}">
-                <a16:creationId xmlns:a16="http://schemas.microsoft.com/office/drawing/2014/main" id="{AD21F1FB-F68F-4895-B91F-E95F754CFCF0}"/>
-              </a:ext>
-            </a:extLst>
-          </p:cNvPr>
-          <p:cNvSpPr>
-            <a:spLocks xmlns:a="http://schemas.openxmlformats.org/drawingml/2006/main" noGrp="1"/>
-          </p:cNvSpPr>
-          <p:nvPr/>
-        </p:nvSpPr>
-        <p:spPr>
-          <a:xfrm xmlns:a="http://schemas.openxmlformats.org/drawingml/2006/main">
-            <a:off x="400050" y="4800600"/>
-            <a:ext cx="7239000" cy="323850"/>
-          </a:xfrm>
-          <a:prstGeom xmlns:a="http://schemas.openxmlformats.org/drawingml/2006/main" prst="rect">
-            <a:avLst/>
-          </a:prstGeom>
-          <a:noFill xmlns:a="http://schemas.openxmlformats.org/drawingml/2006/main"/>
-          <a:ln xmlns:a="http://schemas.openxmlformats.org/drawingml/2006/main" w="0">
-            <a:noFill/>
-            <a:prstDash val="solid"/>
-          </a:ln>
-        </p:spPr>
-        <p:txBody>
-          <a:bodyPr xmlns:a="http://schemas.openxmlformats.org/drawingml/2006/main" anchor="t"/>
-          <a:lstStyle xmlns:a="http://schemas.openxmlformats.org/drawingml/2006/main"/>
-          <a:p xmlns:a="http://schemas.openxmlformats.org/drawingml/2006/main">
-            <a:pPr algn="l">
-              <a:defRPr sz="1725" b="1">
-                <a:solidFill>
-                  <a:srgbClr val="5F6675"/>
-                </a:solidFill>
-                <a:latin typeface="Arial"/>
-                <a:ea typeface="Arial"/>
-                <a:cs typeface="Arial"/>
-              </a:defRPr>
-            </a:pPr>
-            <a:r>
-              <a:rPr sz="1725" b="1">
-                <a:solidFill>
-                  <a:srgbClr val="5F6675"/>
-                </a:solidFill>
-                <a:latin typeface="Arial"/>
-                <a:ea typeface="Arial"/>
-                <a:cs typeface="Arial"/>
-              </a:rPr>
-              <a:t>Создайте свой ритм изучения русского.</a:t>
-            </a:r>
-          </a:p>
-        </p:txBody>
-      </p:sp>
-      <p:sp>
-        <p:nvSpPr>
-          <p:cNvPr id="5" name="close-rule">
-            <a:extLst xmlns:a="http://schemas.openxmlformats.org/drawingml/2006/main">
-              <a:ext uri="{FF2B5EF4-FFF2-40B4-BE49-F238E27FC236}">
-                <a16:creationId xmlns:a16="http://schemas.microsoft.com/office/drawing/2014/main" id="{AAD85EC3-A229-4738-8D4C-A0BE9BD859F6}"/>
-              </a:ext>
-            </a:extLst>
-          </p:cNvPr>
-          <p:cNvSpPr>
-            <a:spLocks xmlns:a="http://schemas.openxmlformats.org/drawingml/2006/main" noGrp="1"/>
-          </p:cNvSpPr>
-          <p:nvPr/>
-        </p:nvSpPr>
-        <p:spPr>
-          <a:xfrm xmlns:a="http://schemas.openxmlformats.org/drawingml/2006/main">
-            <a:off x="400050" y="5524500"/>
+              <a:t>Platforms &amp; Download</a:t>
+            </a:r>
+          </a:p>
+        </p:txBody>
+      </p:sp>
+      <p:sp>
+        <p:nvSpPr>
+          <p:cNvPr id="2" name="platform-subtitle">
+            <a:extLst xmlns:a="http://schemas.openxmlformats.org/drawingml/2006/main">
+              <a:ext uri="{FF2B5EF4-FFF2-40B4-BE49-F238E27FC236}">
+                <a16:creationId xmlns:a16="http://schemas.microsoft.com/office/drawing/2014/main" id="{7B8D01AF-F43D-4A39-AD7D-41D1D642B688}"/>
+              </a:ext>
+            </a:extLst>
+          </p:cNvPr>
+          <p:cNvSpPr>
+            <a:spLocks xmlns:a="http://schemas.openxmlformats.org/drawingml/2006/main" noGrp="1"/>
+          </p:cNvSpPr>
+          <p:nvPr/>
+        </p:nvSpPr>
+        <p:spPr>
+          <a:xfrm xmlns:a="http://schemas.openxmlformats.org/drawingml/2006/main">
+            <a:off x="400050" y="1066800"/>
+            <a:ext cx="10477500" cy="285750"/>
+          </a:xfrm>
+          <a:prstGeom xmlns:a="http://schemas.openxmlformats.org/drawingml/2006/main" prst="rect">
+            <a:avLst/>
+          </a:prstGeom>
+          <a:noFill xmlns:a="http://schemas.openxmlformats.org/drawingml/2006/main"/>
+          <a:ln xmlns:a="http://schemas.openxmlformats.org/drawingml/2006/main" w="0">
+            <a:noFill/>
+            <a:prstDash val="solid"/>
+          </a:ln>
+        </p:spPr>
+        <p:txBody>
+          <a:bodyPr xmlns:a="http://schemas.openxmlformats.org/drawingml/2006/main" anchor="t"/>
+          <a:lstStyle xmlns:a="http://schemas.openxmlformats.org/drawingml/2006/main"/>
+          <a:p xmlns:a="http://schemas.openxmlformats.org/drawingml/2006/main">
+            <a:pPr algn="l">
+              <a:defRPr sz="1425" b="0">
+                <a:solidFill>
+                  <a:srgbClr val="5F6675"/>
+                </a:solidFill>
+                <a:latin typeface="Arial"/>
+                <a:ea typeface="Arial"/>
+                <a:cs typeface="Arial"/>
+              </a:defRPr>
+            </a:pPr>
+            <a:r>
+              <a:rPr sz="1425" b="0">
+                <a:solidFill>
+                  <a:srgbClr val="5F6675"/>
+                </a:solidFill>
+                <a:latin typeface="Arial"/>
+                <a:ea typeface="Arial"/>
+                <a:cs typeface="Arial"/>
+              </a:rPr>
+              <a:t>Platformlar &amp; İndirme  •  Платформы и загрузка</a:t>
+            </a:r>
+          </a:p>
+        </p:txBody>
+      </p:sp>
+      <p:sp>
+        <p:nvSpPr>
+          <p:cNvPr id="3" name="platform-rule">
+            <a:extLst xmlns:a="http://schemas.openxmlformats.org/drawingml/2006/main">
+              <a:ext uri="{FF2B5EF4-FFF2-40B4-BE49-F238E27FC236}">
+                <a16:creationId xmlns:a16="http://schemas.microsoft.com/office/drawing/2014/main" id="{0C6910F4-3CBC-426A-B2DA-88D132EB381C}"/>
+              </a:ext>
+            </a:extLst>
+          </p:cNvPr>
+          <p:cNvSpPr>
+            <a:spLocks xmlns:a="http://schemas.openxmlformats.org/drawingml/2006/main" noGrp="1"/>
+          </p:cNvSpPr>
+          <p:nvPr/>
+        </p:nvSpPr>
+        <p:spPr>
+          <a:xfrm xmlns:a="http://schemas.openxmlformats.org/drawingml/2006/main">
+            <a:off x="400050" y="1866900"/>
             <a:ext cx="11391900" cy="0"/>
           </a:xfrm>
           <a:prstGeom xmlns:a="http://schemas.openxmlformats.org/drawingml/2006/main" prst="line">
@@ -6366,38 +6307,150 @@
       </p:sp>
       <p:sp>
         <p:nvSpPr>
-          <p:cNvPr id="6" name="close-action">
-            <a:extLst xmlns:a="http://schemas.openxmlformats.org/drawingml/2006/main">
-              <a:ext uri="{FF2B5EF4-FFF2-40B4-BE49-F238E27FC236}">
-                <a16:creationId xmlns:a16="http://schemas.microsoft.com/office/drawing/2014/main" id="{3C5473A6-32BE-402D-A048-3E06CBFEC5D5}"/>
-              </a:ext>
-            </a:extLst>
-          </p:cNvPr>
-          <p:cNvSpPr>
-            <a:spLocks xmlns:a="http://schemas.openxmlformats.org/drawingml/2006/main" noGrp="1"/>
-          </p:cNvSpPr>
-          <p:nvPr/>
-        </p:nvSpPr>
-        <p:spPr>
-          <a:xfrm xmlns:a="http://schemas.openxmlformats.org/drawingml/2006/main">
-            <a:off x="400050" y="5848350"/>
-            <a:ext cx="5905500" cy="266700"/>
-          </a:xfrm>
-          <a:prstGeom xmlns:a="http://schemas.openxmlformats.org/drawingml/2006/main" prst="rect">
-            <a:avLst/>
-          </a:prstGeom>
-          <a:noFill xmlns:a="http://schemas.openxmlformats.org/drawingml/2006/main"/>
-          <a:ln xmlns:a="http://schemas.openxmlformats.org/drawingml/2006/main" w="0">
-            <a:noFill/>
-            <a:prstDash val="solid"/>
-          </a:ln>
-        </p:spPr>
-        <p:txBody>
-          <a:bodyPr xmlns:a="http://schemas.openxmlformats.org/drawingml/2006/main" anchor="t"/>
-          <a:lstStyle xmlns:a="http://schemas.openxmlformats.org/drawingml/2006/main"/>
-          <a:p xmlns:a="http://schemas.openxmlformats.org/drawingml/2006/main">
-            <a:pPr algn="l">
-              <a:defRPr sz="1350" b="1">
+          <p:cNvPr id="4" name="platform-label-0">
+            <a:extLst xmlns:a="http://schemas.openxmlformats.org/drawingml/2006/main">
+              <a:ext uri="{FF2B5EF4-FFF2-40B4-BE49-F238E27FC236}">
+                <a16:creationId xmlns:a16="http://schemas.microsoft.com/office/drawing/2014/main" id="{EB4FF3CF-F7B5-4401-87A6-74CD429A0117}"/>
+              </a:ext>
+            </a:extLst>
+          </p:cNvPr>
+          <p:cNvSpPr>
+            <a:spLocks xmlns:a="http://schemas.openxmlformats.org/drawingml/2006/main" noGrp="1"/>
+          </p:cNvSpPr>
+          <p:nvPr/>
+        </p:nvSpPr>
+        <p:spPr>
+          <a:xfrm xmlns:a="http://schemas.openxmlformats.org/drawingml/2006/main">
+            <a:off x="400050" y="2209800"/>
+            <a:ext cx="2857500" cy="209550"/>
+          </a:xfrm>
+          <a:prstGeom xmlns:a="http://schemas.openxmlformats.org/drawingml/2006/main" prst="rect">
+            <a:avLst/>
+          </a:prstGeom>
+          <a:noFill xmlns:a="http://schemas.openxmlformats.org/drawingml/2006/main"/>
+          <a:ln xmlns:a="http://schemas.openxmlformats.org/drawingml/2006/main" w="0">
+            <a:noFill/>
+            <a:prstDash val="solid"/>
+          </a:ln>
+        </p:spPr>
+        <p:txBody>
+          <a:bodyPr xmlns:a="http://schemas.openxmlformats.org/drawingml/2006/main" anchor="t"/>
+          <a:lstStyle xmlns:a="http://schemas.openxmlformats.org/drawingml/2006/main"/>
+          <a:p xmlns:a="http://schemas.openxmlformats.org/drawingml/2006/main">
+            <a:pPr algn="l">
+              <a:defRPr sz="1050" b="1">
+                <a:solidFill>
+                  <a:srgbClr val="10131A"/>
+                </a:solidFill>
+                <a:latin typeface="Arial"/>
+                <a:ea typeface="Arial"/>
+                <a:cs typeface="Arial"/>
+              </a:defRPr>
+            </a:pPr>
+            <a:r>
+              <a:rPr sz="1050" b="1">
+                <a:solidFill>
+                  <a:srgbClr val="10131A"/>
+                </a:solidFill>
+                <a:latin typeface="Arial"/>
+                <a:ea typeface="Arial"/>
+                <a:cs typeface="Arial"/>
+              </a:rPr>
+              <a:t>TÜRKÇE</a:t>
+            </a:r>
+          </a:p>
+        </p:txBody>
+      </p:sp>
+      <p:sp>
+        <p:nvSpPr>
+          <p:cNvPr id="5" name="platform-body-0">
+            <a:extLst xmlns:a="http://schemas.openxmlformats.org/drawingml/2006/main">
+              <a:ext uri="{FF2B5EF4-FFF2-40B4-BE49-F238E27FC236}">
+                <a16:creationId xmlns:a16="http://schemas.microsoft.com/office/drawing/2014/main" id="{81B58CC5-C08B-4274-A156-2EB00A62864A}"/>
+              </a:ext>
+            </a:extLst>
+          </p:cNvPr>
+          <p:cNvSpPr>
+            <a:spLocks xmlns:a="http://schemas.openxmlformats.org/drawingml/2006/main" noGrp="1"/>
+          </p:cNvSpPr>
+          <p:nvPr/>
+        </p:nvSpPr>
+        <p:spPr>
+          <a:xfrm xmlns:a="http://schemas.openxmlformats.org/drawingml/2006/main">
+            <a:off x="400050" y="2476500"/>
+            <a:ext cx="11391900" cy="533400"/>
+          </a:xfrm>
+          <a:prstGeom xmlns:a="http://schemas.openxmlformats.org/drawingml/2006/main" prst="rect">
+            <a:avLst/>
+          </a:prstGeom>
+          <a:noFill xmlns:a="http://schemas.openxmlformats.org/drawingml/2006/main"/>
+          <a:ln xmlns:a="http://schemas.openxmlformats.org/drawingml/2006/main" w="0">
+            <a:noFill/>
+            <a:prstDash val="solid"/>
+          </a:ln>
+        </p:spPr>
+        <p:txBody>
+          <a:bodyPr xmlns:a="http://schemas.openxmlformats.org/drawingml/2006/main" anchor="t"/>
+          <a:lstStyle xmlns:a="http://schemas.openxmlformats.org/drawingml/2006/main"/>
+          <a:p xmlns:a="http://schemas.openxmlformats.org/drawingml/2006/main">
+            <a:pPr algn="l">
+              <a:defRPr sz="1275" b="0">
+                <a:solidFill>
+                  <a:srgbClr val="10131A"/>
+                </a:solidFill>
+                <a:latin typeface="Arial"/>
+                <a:ea typeface="Arial"/>
+                <a:cs typeface="Arial"/>
+              </a:defRPr>
+            </a:pPr>
+            <a:r>
+              <a:rPr sz="1275" b="0">
+                <a:solidFill>
+                  <a:srgbClr val="10131A"/>
+                </a:solidFill>
+                <a:latin typeface="Arial"/>
+                <a:ea typeface="Arial"/>
+                <a:cs typeface="Arial"/>
+              </a:rPr>
+              <a:t>Windows 10/11 (x64) + macOS (Apple Silicon) — İndirme: github.com/Azizsekerdil/RussianCourseAI/releases (v1.0.0) (özel repo)</a:t>
+            </a:r>
+          </a:p>
+        </p:txBody>
+      </p:sp>
+      <p:sp>
+        <p:nvSpPr>
+          <p:cNvPr id="6" name="platform-label-1">
+            <a:extLst xmlns:a="http://schemas.openxmlformats.org/drawingml/2006/main">
+              <a:ext uri="{FF2B5EF4-FFF2-40B4-BE49-F238E27FC236}">
+                <a16:creationId xmlns:a16="http://schemas.microsoft.com/office/drawing/2014/main" id="{0EBAB476-AC0C-4060-A2A9-59D3A2E0FF66}"/>
+              </a:ext>
+            </a:extLst>
+          </p:cNvPr>
+          <p:cNvSpPr>
+            <a:spLocks xmlns:a="http://schemas.openxmlformats.org/drawingml/2006/main" noGrp="1"/>
+          </p:cNvSpPr>
+          <p:nvPr/>
+        </p:nvSpPr>
+        <p:spPr>
+          <a:xfrm xmlns:a="http://schemas.openxmlformats.org/drawingml/2006/main">
+            <a:off x="400050" y="3200400"/>
+            <a:ext cx="2857500" cy="209550"/>
+          </a:xfrm>
+          <a:prstGeom xmlns:a="http://schemas.openxmlformats.org/drawingml/2006/main" prst="rect">
+            <a:avLst/>
+          </a:prstGeom>
+          <a:noFill xmlns:a="http://schemas.openxmlformats.org/drawingml/2006/main"/>
+          <a:ln xmlns:a="http://schemas.openxmlformats.org/drawingml/2006/main" w="0">
+            <a:noFill/>
+            <a:prstDash val="solid"/>
+          </a:ln>
+        </p:spPr>
+        <p:txBody>
+          <a:bodyPr xmlns:a="http://schemas.openxmlformats.org/drawingml/2006/main" anchor="t"/>
+          <a:lstStyle xmlns:a="http://schemas.openxmlformats.org/drawingml/2006/main"/>
+          <a:p xmlns:a="http://schemas.openxmlformats.org/drawingml/2006/main">
+            <a:pPr algn="l">
+              <a:defRPr sz="1050" b="1">
                 <a:solidFill>
                   <a:srgbClr val="3D8DFF"/>
                 </a:solidFill>
@@ -6407,7 +6460,7 @@
               </a:defRPr>
             </a:pPr>
             <a:r>
-              <a:rPr sz="1350" b="1">
+              <a:rPr sz="1050" b="1">
                 <a:solidFill>
                   <a:srgbClr val="3D8DFF"/>
                 </a:solidFill>
@@ -6415,73 +6468,295 @@
                 <a:ea typeface="Arial"/>
                 <a:cs typeface="Arial"/>
               </a:rPr>
-              <a:t>INSTALL  •  LEARN  •  REVIEW</a:t>
-            </a:r>
-          </a:p>
-        </p:txBody>
-      </p:sp>
-      <p:sp>
-        <p:nvSpPr>
-          <p:cNvPr id="7" name="close-meta">
-            <a:extLst xmlns:a="http://schemas.openxmlformats.org/drawingml/2006/main">
-              <a:ext uri="{FF2B5EF4-FFF2-40B4-BE49-F238E27FC236}">
-                <a16:creationId xmlns:a16="http://schemas.microsoft.com/office/drawing/2014/main" id="{17DB61F9-B82E-423F-8272-2B88C01B8F58}"/>
-              </a:ext>
-            </a:extLst>
-          </p:cNvPr>
-          <p:cNvSpPr>
-            <a:spLocks xmlns:a="http://schemas.openxmlformats.org/drawingml/2006/main" noGrp="1"/>
-          </p:cNvSpPr>
-          <p:nvPr/>
-        </p:nvSpPr>
-        <p:spPr>
-          <a:xfrm xmlns:a="http://schemas.openxmlformats.org/drawingml/2006/main">
-            <a:off x="7239000" y="5848350"/>
-            <a:ext cx="4552950" cy="266700"/>
-          </a:xfrm>
-          <a:prstGeom xmlns:a="http://schemas.openxmlformats.org/drawingml/2006/main" prst="rect">
-            <a:avLst/>
-          </a:prstGeom>
-          <a:noFill xmlns:a="http://schemas.openxmlformats.org/drawingml/2006/main"/>
-          <a:ln xmlns:a="http://schemas.openxmlformats.org/drawingml/2006/main" w="0">
-            <a:noFill/>
-            <a:prstDash val="solid"/>
-          </a:ln>
-        </p:spPr>
-        <p:txBody>
-          <a:bodyPr xmlns:a="http://schemas.openxmlformats.org/drawingml/2006/main" anchor="t"/>
-          <a:lstStyle xmlns:a="http://schemas.openxmlformats.org/drawingml/2006/main"/>
-          <a:p xmlns:a="http://schemas.openxmlformats.org/drawingml/2006/main">
-            <a:pPr algn="r">
-              <a:defRPr sz="1350" b="0">
-                <a:solidFill>
-                  <a:srgbClr val="5F6675"/>
-                </a:solidFill>
-                <a:latin typeface="Arial"/>
-                <a:ea typeface="Arial"/>
-                <a:cs typeface="Arial"/>
-              </a:defRPr>
-            </a:pPr>
-            <a:r>
-              <a:rPr sz="1350" b="0">
-                <a:solidFill>
-                  <a:srgbClr val="5F6675"/>
-                </a:solidFill>
-                <a:latin typeface="Arial"/>
-                <a:ea typeface="Arial"/>
-                <a:cs typeface="Arial"/>
-              </a:rPr>
-              <a:t>Windows  •  A1-C1  •  TR / EN / RU</a:t>
-            </a:r>
-          </a:p>
-        </p:txBody>
-      </p:sp>
-      <p:sp>
-        <p:nvSpPr>
-          <p:cNvPr id="8" name="footer-7">
-            <a:extLst xmlns:a="http://schemas.openxmlformats.org/drawingml/2006/main">
-              <a:ext uri="{FF2B5EF4-FFF2-40B4-BE49-F238E27FC236}">
-                <a16:creationId xmlns:a16="http://schemas.microsoft.com/office/drawing/2014/main" id="{4008E400-7DD0-4FB6-849C-DB0CF262177A}"/>
+              <a:t>ENGLISH</a:t>
+            </a:r>
+          </a:p>
+        </p:txBody>
+      </p:sp>
+      <p:sp>
+        <p:nvSpPr>
+          <p:cNvPr id="7" name="platform-body-1">
+            <a:extLst xmlns:a="http://schemas.openxmlformats.org/drawingml/2006/main">
+              <a:ext uri="{FF2B5EF4-FFF2-40B4-BE49-F238E27FC236}">
+                <a16:creationId xmlns:a16="http://schemas.microsoft.com/office/drawing/2014/main" id="{93AEB093-D362-41E5-9A50-14BA1C007B84}"/>
+              </a:ext>
+            </a:extLst>
+          </p:cNvPr>
+          <p:cNvSpPr>
+            <a:spLocks xmlns:a="http://schemas.openxmlformats.org/drawingml/2006/main" noGrp="1"/>
+          </p:cNvSpPr>
+          <p:nvPr/>
+        </p:nvSpPr>
+        <p:spPr>
+          <a:xfrm xmlns:a="http://schemas.openxmlformats.org/drawingml/2006/main">
+            <a:off x="400050" y="3467100"/>
+            <a:ext cx="11391900" cy="533400"/>
+          </a:xfrm>
+          <a:prstGeom xmlns:a="http://schemas.openxmlformats.org/drawingml/2006/main" prst="rect">
+            <a:avLst/>
+          </a:prstGeom>
+          <a:noFill xmlns:a="http://schemas.openxmlformats.org/drawingml/2006/main"/>
+          <a:ln xmlns:a="http://schemas.openxmlformats.org/drawingml/2006/main" w="0">
+            <a:noFill/>
+            <a:prstDash val="solid"/>
+          </a:ln>
+        </p:spPr>
+        <p:txBody>
+          <a:bodyPr xmlns:a="http://schemas.openxmlformats.org/drawingml/2006/main" anchor="t"/>
+          <a:lstStyle xmlns:a="http://schemas.openxmlformats.org/drawingml/2006/main"/>
+          <a:p xmlns:a="http://schemas.openxmlformats.org/drawingml/2006/main">
+            <a:pPr algn="l">
+              <a:defRPr sz="1275" b="0">
+                <a:solidFill>
+                  <a:srgbClr val="10131A"/>
+                </a:solidFill>
+                <a:latin typeface="Arial"/>
+                <a:ea typeface="Arial"/>
+                <a:cs typeface="Arial"/>
+              </a:defRPr>
+            </a:pPr>
+            <a:r>
+              <a:rPr sz="1275" b="0">
+                <a:solidFill>
+                  <a:srgbClr val="10131A"/>
+                </a:solidFill>
+                <a:latin typeface="Arial"/>
+                <a:ea typeface="Arial"/>
+                <a:cs typeface="Arial"/>
+              </a:rPr>
+              <a:t>Windows 10/11 (x64) &amp; macOS (Apple Silicon) — Download: GitHub Releases (v1.0.0)</a:t>
+            </a:r>
+          </a:p>
+        </p:txBody>
+      </p:sp>
+      <p:sp>
+        <p:nvSpPr>
+          <p:cNvPr id="8" name="platform-label-2">
+            <a:extLst xmlns:a="http://schemas.openxmlformats.org/drawingml/2006/main">
+              <a:ext uri="{FF2B5EF4-FFF2-40B4-BE49-F238E27FC236}">
+                <a16:creationId xmlns:a16="http://schemas.microsoft.com/office/drawing/2014/main" id="{73589859-0222-4A5A-A90F-3304981018CF}"/>
+              </a:ext>
+            </a:extLst>
+          </p:cNvPr>
+          <p:cNvSpPr>
+            <a:spLocks xmlns:a="http://schemas.openxmlformats.org/drawingml/2006/main" noGrp="1"/>
+          </p:cNvSpPr>
+          <p:nvPr/>
+        </p:nvSpPr>
+        <p:spPr>
+          <a:xfrm xmlns:a="http://schemas.openxmlformats.org/drawingml/2006/main">
+            <a:off x="400050" y="4191000"/>
+            <a:ext cx="2857500" cy="209550"/>
+          </a:xfrm>
+          <a:prstGeom xmlns:a="http://schemas.openxmlformats.org/drawingml/2006/main" prst="rect">
+            <a:avLst/>
+          </a:prstGeom>
+          <a:noFill xmlns:a="http://schemas.openxmlformats.org/drawingml/2006/main"/>
+          <a:ln xmlns:a="http://schemas.openxmlformats.org/drawingml/2006/main" w="0">
+            <a:noFill/>
+            <a:prstDash val="solid"/>
+          </a:ln>
+        </p:spPr>
+        <p:txBody>
+          <a:bodyPr xmlns:a="http://schemas.openxmlformats.org/drawingml/2006/main" anchor="t"/>
+          <a:lstStyle xmlns:a="http://schemas.openxmlformats.org/drawingml/2006/main"/>
+          <a:p xmlns:a="http://schemas.openxmlformats.org/drawingml/2006/main">
+            <a:pPr algn="l">
+              <a:defRPr sz="1050" b="1">
+                <a:solidFill>
+                  <a:srgbClr val="5F6675"/>
+                </a:solidFill>
+                <a:latin typeface="Arial"/>
+                <a:ea typeface="Arial"/>
+                <a:cs typeface="Arial"/>
+              </a:defRPr>
+            </a:pPr>
+            <a:r>
+              <a:rPr sz="1050" b="1">
+                <a:solidFill>
+                  <a:srgbClr val="5F6675"/>
+                </a:solidFill>
+                <a:latin typeface="Arial"/>
+                <a:ea typeface="Arial"/>
+                <a:cs typeface="Arial"/>
+              </a:rPr>
+              <a:t>РУССКИЙ</a:t>
+            </a:r>
+          </a:p>
+        </p:txBody>
+      </p:sp>
+      <p:sp>
+        <p:nvSpPr>
+          <p:cNvPr id="9" name="platform-body-2">
+            <a:extLst xmlns:a="http://schemas.openxmlformats.org/drawingml/2006/main">
+              <a:ext uri="{FF2B5EF4-FFF2-40B4-BE49-F238E27FC236}">
+                <a16:creationId xmlns:a16="http://schemas.microsoft.com/office/drawing/2014/main" id="{A7AFC0E0-3348-443D-A3D2-B4E3362567E5}"/>
+              </a:ext>
+            </a:extLst>
+          </p:cNvPr>
+          <p:cNvSpPr>
+            <a:spLocks xmlns:a="http://schemas.openxmlformats.org/drawingml/2006/main" noGrp="1"/>
+          </p:cNvSpPr>
+          <p:nvPr/>
+        </p:nvSpPr>
+        <p:spPr>
+          <a:xfrm xmlns:a="http://schemas.openxmlformats.org/drawingml/2006/main">
+            <a:off x="400050" y="4457700"/>
+            <a:ext cx="11391900" cy="533400"/>
+          </a:xfrm>
+          <a:prstGeom xmlns:a="http://schemas.openxmlformats.org/drawingml/2006/main" prst="rect">
+            <a:avLst/>
+          </a:prstGeom>
+          <a:noFill xmlns:a="http://schemas.openxmlformats.org/drawingml/2006/main"/>
+          <a:ln xmlns:a="http://schemas.openxmlformats.org/drawingml/2006/main" w="0">
+            <a:noFill/>
+            <a:prstDash val="solid"/>
+          </a:ln>
+        </p:spPr>
+        <p:txBody>
+          <a:bodyPr xmlns:a="http://schemas.openxmlformats.org/drawingml/2006/main" anchor="t"/>
+          <a:lstStyle xmlns:a="http://schemas.openxmlformats.org/drawingml/2006/main"/>
+          <a:p xmlns:a="http://schemas.openxmlformats.org/drawingml/2006/main">
+            <a:pPr algn="l">
+              <a:defRPr sz="1275" b="0">
+                <a:solidFill>
+                  <a:srgbClr val="10131A"/>
+                </a:solidFill>
+                <a:latin typeface="Arial"/>
+                <a:ea typeface="Arial"/>
+                <a:cs typeface="Arial"/>
+              </a:defRPr>
+            </a:pPr>
+            <a:r>
+              <a:rPr sz="1275" b="0">
+                <a:solidFill>
+                  <a:srgbClr val="10131A"/>
+                </a:solidFill>
+                <a:latin typeface="Arial"/>
+                <a:ea typeface="Arial"/>
+                <a:cs typeface="Arial"/>
+              </a:rPr>
+              <a:t>Windows 10/11 (x64) и macOS (Apple Silicon) — Загрузка: GitHub Releases (v1.0.0)</a:t>
+            </a:r>
+          </a:p>
+        </p:txBody>
+      </p:sp>
+      <p:sp>
+        <p:nvSpPr>
+          <p:cNvPr id="10" name="platform-footnote-rule">
+            <a:extLst xmlns:a="http://schemas.openxmlformats.org/drawingml/2006/main">
+              <a:ext uri="{FF2B5EF4-FFF2-40B4-BE49-F238E27FC236}">
+                <a16:creationId xmlns:a16="http://schemas.microsoft.com/office/drawing/2014/main" id="{B39B1F51-522A-423E-A569-2ECF348E5DD6}"/>
+              </a:ext>
+            </a:extLst>
+          </p:cNvPr>
+          <p:cNvSpPr>
+            <a:spLocks xmlns:a="http://schemas.openxmlformats.org/drawingml/2006/main" noGrp="1"/>
+          </p:cNvSpPr>
+          <p:nvPr/>
+        </p:nvSpPr>
+        <p:spPr>
+          <a:xfrm xmlns:a="http://schemas.openxmlformats.org/drawingml/2006/main">
+            <a:off x="400050" y="5295900"/>
+            <a:ext cx="11391900" cy="0"/>
+          </a:xfrm>
+          <a:prstGeom xmlns:a="http://schemas.openxmlformats.org/drawingml/2006/main" prst="line">
+            <a:avLst/>
+          </a:prstGeom>
+          <a:noFill xmlns:a="http://schemas.openxmlformats.org/drawingml/2006/main"/>
+          <a:ln xmlns:a="http://schemas.openxmlformats.org/drawingml/2006/main" w="9525">
+            <a:solidFill>
+              <a:srgbClr val="B8BCC4"/>
+            </a:solidFill>
+            <a:prstDash val="solid"/>
+          </a:ln>
+        </p:spPr>
+      </p:sp>
+      <p:sp>
+        <p:nvSpPr>
+          <p:cNvPr id="11" name="platform-footnote">
+            <a:extLst xmlns:a="http://schemas.openxmlformats.org/drawingml/2006/main">
+              <a:ext uri="{FF2B5EF4-FFF2-40B4-BE49-F238E27FC236}">
+                <a16:creationId xmlns:a16="http://schemas.microsoft.com/office/drawing/2014/main" id="{7019DDDB-2EC6-472E-BBBF-95442605B3C1}"/>
+              </a:ext>
+            </a:extLst>
+          </p:cNvPr>
+          <p:cNvSpPr>
+            <a:spLocks xmlns:a="http://schemas.openxmlformats.org/drawingml/2006/main" noGrp="1"/>
+          </p:cNvSpPr>
+          <p:nvPr/>
+        </p:nvSpPr>
+        <p:spPr>
+          <a:xfrm xmlns:a="http://schemas.openxmlformats.org/drawingml/2006/main">
+            <a:off x="400050" y="5486400"/>
+            <a:ext cx="10668000" cy="800100"/>
+          </a:xfrm>
+          <a:prstGeom xmlns:a="http://schemas.openxmlformats.org/drawingml/2006/main" prst="rect">
+            <a:avLst/>
+          </a:prstGeom>
+          <a:noFill xmlns:a="http://schemas.openxmlformats.org/drawingml/2006/main"/>
+          <a:ln xmlns:a="http://schemas.openxmlformats.org/drawingml/2006/main" w="0">
+            <a:noFill/>
+            <a:prstDash val="solid"/>
+          </a:ln>
+        </p:spPr>
+        <p:txBody>
+          <a:bodyPr xmlns:a="http://schemas.openxmlformats.org/drawingml/2006/main" anchor="t"/>
+          <a:lstStyle xmlns:a="http://schemas.openxmlformats.org/drawingml/2006/main"/>
+          <a:p xmlns:a="http://schemas.openxmlformats.org/drawingml/2006/main">
+            <a:pPr algn="l">
+              <a:defRPr sz="1125" b="0">
+                <a:solidFill>
+                  <a:srgbClr val="5F6675"/>
+                </a:solidFill>
+                <a:latin typeface="Arial"/>
+                <a:ea typeface="Arial"/>
+                <a:cs typeface="Arial"/>
+              </a:defRPr>
+            </a:pPr>
+            <a:r>
+              <a:rPr sz="1125" b="0">
+                <a:solidFill>
+                  <a:srgbClr val="5F6675"/>
+                </a:solidFill>
+                <a:latin typeface="Arial"/>
+                <a:ea typeface="Arial"/>
+                <a:cs typeface="Arial"/>
+              </a:rPr>
+              <a:t>Release v1.0.0 — iki paket: Windows zip + macOS zip. macOS paketi Apple Silicon (arm64) içindir ve notarize edilmemiştir; ilk açılışta sağ tık → Aç.</a:t>
+            </a:r>
+          </a:p>
+          <a:p xmlns:a="http://schemas.openxmlformats.org/drawingml/2006/main">
+            <a:pPr algn="l">
+              <a:defRPr sz="1125" b="0">
+                <a:solidFill>
+                  <a:srgbClr val="5F6675"/>
+                </a:solidFill>
+                <a:latin typeface="Arial"/>
+                <a:ea typeface="Arial"/>
+                <a:cs typeface="Arial"/>
+              </a:defRPr>
+            </a:pPr>
+            <a:r>
+              <a:rPr sz="1125" b="0">
+                <a:solidFill>
+                  <a:srgbClr val="5F6675"/>
+                </a:solidFill>
+                <a:latin typeface="Arial"/>
+                <a:ea typeface="Arial"/>
+                <a:cs typeface="Arial"/>
+              </a:rPr>
+              <a:t>Depo özel (private) — github.com/Azizsekerdil/RussianCourseAI bağlantısına yalnızca hesap sahibi erişebilir.</a:t>
+            </a:r>
+          </a:p>
+        </p:txBody>
+      </p:sp>
+      <p:sp>
+        <p:nvSpPr>
+          <p:cNvPr id="12" name="footer-7">
+            <a:extLst xmlns:a="http://schemas.openxmlformats.org/drawingml/2006/main">
+              <a:ext uri="{FF2B5EF4-FFF2-40B4-BE49-F238E27FC236}">
+                <a16:creationId xmlns:a16="http://schemas.microsoft.com/office/drawing/2014/main" id="{E84DCAAE-61F7-4686-9290-4D1777B681CC}"/>
               </a:ext>
             </a:extLst>
           </p:cNvPr>
@@ -6535,7 +6810,482 @@
     </p:spTree>
     <p:extLst>
       <p:ext uri="{BB962C8B-B14F-4D97-AF65-F5344CB8AC3E}">
-        <p14:creationId xmlns:p14="http://schemas.microsoft.com/office/powerpoint/2010/main" val="346887352"/>
+        <p14:creationId xmlns:p14="http://schemas.microsoft.com/office/powerpoint/2010/main" val="1141323186"/>
+      </p:ext>
+    </p:extLst>
+  </p:cSld>
+</p:sld>
+</file>
+
+<file path=ppt/slides/slide8.xml><?xml version="1.0" encoding="utf-8"?>
+<p:sld xmlns:p="http://schemas.openxmlformats.org/presentationml/2006/main">
+  <p:cSld>
+    <p:bg>
+      <p:bgPr>
+        <a:solidFill xmlns:a="http://schemas.openxmlformats.org/drawingml/2006/main">
+          <a:srgbClr val="FFFFFF"/>
+        </a:solidFill>
+      </p:bgPr>
+    </p:bg>
+    <p:spTree>
+      <p:nvGrpSpPr>
+        <p:cNvPr id="1" name=""/>
+        <p:cNvGrpSpPr/>
+        <p:nvPr/>
+      </p:nvGrpSpPr>
+      <p:grpSpPr>
+        <a:xfrm xmlns:a="http://schemas.openxmlformats.org/drawingml/2006/main"/>
+      </p:grpSpPr>
+      <p:sp>
+        <p:nvSpPr>
+          <p:cNvPr id="9" name="close-kicker">
+            <a:extLst xmlns:a="http://schemas.openxmlformats.org/drawingml/2006/main">
+              <a:ext uri="{FF2B5EF4-FFF2-40B4-BE49-F238E27FC236}">
+                <a16:creationId xmlns:a16="http://schemas.microsoft.com/office/drawing/2014/main" id="{816F40FD-A321-4C2A-A20F-14FF24BB4D57}"/>
+              </a:ext>
+            </a:extLst>
+          </p:cNvPr>
+          <p:cNvSpPr>
+            <a:spLocks xmlns:a="http://schemas.openxmlformats.org/drawingml/2006/main" noGrp="1"/>
+          </p:cNvSpPr>
+          <p:nvPr/>
+        </p:nvSpPr>
+        <p:spPr>
+          <a:xfrm xmlns:a="http://schemas.openxmlformats.org/drawingml/2006/main">
+            <a:off x="400050" y="400050"/>
+            <a:ext cx="4000500" cy="228600"/>
+          </a:xfrm>
+          <a:prstGeom xmlns:a="http://schemas.openxmlformats.org/drawingml/2006/main" prst="rect">
+            <a:avLst/>
+          </a:prstGeom>
+          <a:noFill xmlns:a="http://schemas.openxmlformats.org/drawingml/2006/main"/>
+          <a:ln xmlns:a="http://schemas.openxmlformats.org/drawingml/2006/main" w="0">
+            <a:noFill/>
+            <a:prstDash val="solid"/>
+          </a:ln>
+        </p:spPr>
+        <p:txBody>
+          <a:bodyPr xmlns:a="http://schemas.openxmlformats.org/drawingml/2006/main" anchor="t"/>
+          <a:lstStyle xmlns:a="http://schemas.openxmlformats.org/drawingml/2006/main"/>
+          <a:p xmlns:a="http://schemas.openxmlformats.org/drawingml/2006/main">
+            <a:pPr algn="l">
+              <a:defRPr sz="1050" b="1">
+                <a:solidFill>
+                  <a:srgbClr val="3D8DFF"/>
+                </a:solidFill>
+                <a:latin typeface="Arial"/>
+                <a:ea typeface="Arial"/>
+                <a:cs typeface="Arial"/>
+              </a:defRPr>
+            </a:pPr>
+            <a:r>
+              <a:rPr sz="1050" b="1">
+                <a:solidFill>
+                  <a:srgbClr val="3D8DFF"/>
+                </a:solidFill>
+                <a:latin typeface="Arial"/>
+                <a:ea typeface="Arial"/>
+                <a:cs typeface="Arial"/>
+              </a:rPr>
+              <a:t>START YOUR NEXT SESSION</a:t>
+            </a:r>
+          </a:p>
+        </p:txBody>
+      </p:sp>
+      <p:sp>
+        <p:nvSpPr>
+          <p:cNvPr id="2" name="close-title">
+            <a:extLst xmlns:a="http://schemas.openxmlformats.org/drawingml/2006/main">
+              <a:ext uri="{FF2B5EF4-FFF2-40B4-BE49-F238E27FC236}">
+                <a16:creationId xmlns:a16="http://schemas.microsoft.com/office/drawing/2014/main" id="{3D7F8F60-86AF-4833-8CC6-35BE1C9D1EC7}"/>
+              </a:ext>
+            </a:extLst>
+          </p:cNvPr>
+          <p:cNvSpPr>
+            <a:spLocks xmlns:a="http://schemas.openxmlformats.org/drawingml/2006/main" noGrp="1"/>
+          </p:cNvSpPr>
+          <p:nvPr/>
+        </p:nvSpPr>
+        <p:spPr>
+          <a:xfrm xmlns:a="http://schemas.openxmlformats.org/drawingml/2006/main">
+            <a:off x="400050" y="1657350"/>
+            <a:ext cx="10001250" cy="1714500"/>
+          </a:xfrm>
+          <a:prstGeom xmlns:a="http://schemas.openxmlformats.org/drawingml/2006/main" prst="rect">
+            <a:avLst/>
+          </a:prstGeom>
+          <a:noFill xmlns:a="http://schemas.openxmlformats.org/drawingml/2006/main"/>
+          <a:ln xmlns:a="http://schemas.openxmlformats.org/drawingml/2006/main" w="0">
+            <a:noFill/>
+            <a:prstDash val="solid"/>
+          </a:ln>
+        </p:spPr>
+        <p:txBody>
+          <a:bodyPr xmlns:a="http://schemas.openxmlformats.org/drawingml/2006/main" anchor="t"/>
+          <a:lstStyle xmlns:a="http://schemas.openxmlformats.org/drawingml/2006/main"/>
+          <a:p xmlns:a="http://schemas.openxmlformats.org/drawingml/2006/main">
+            <a:pPr algn="l">
+              <a:defRPr sz="4650" b="1">
+                <a:solidFill>
+                  <a:srgbClr val="10131A"/>
+                </a:solidFill>
+                <a:latin typeface="Arial"/>
+                <a:ea typeface="Arial"/>
+                <a:cs typeface="Arial"/>
+              </a:defRPr>
+            </a:pPr>
+            <a:r>
+              <a:rPr sz="4650" b="1">
+                <a:solidFill>
+                  <a:srgbClr val="10131A"/>
+                </a:solidFill>
+                <a:latin typeface="Arial"/>
+                <a:ea typeface="Arial"/>
+                <a:cs typeface="Arial"/>
+              </a:rPr>
+              <a:t>Build a Russian routine</a:t>
+            </a:r>
+          </a:p>
+          <a:p xmlns:a="http://schemas.openxmlformats.org/drawingml/2006/main">
+            <a:pPr algn="l">
+              <a:defRPr sz="4650" b="1">
+                <a:solidFill>
+                  <a:srgbClr val="10131A"/>
+                </a:solidFill>
+                <a:latin typeface="Arial"/>
+                <a:ea typeface="Arial"/>
+                <a:cs typeface="Arial"/>
+              </a:defRPr>
+            </a:pPr>
+            <a:r>
+              <a:rPr sz="4650" b="1">
+                <a:solidFill>
+                  <a:srgbClr val="10131A"/>
+                </a:solidFill>
+                <a:latin typeface="Arial"/>
+                <a:ea typeface="Arial"/>
+                <a:cs typeface="Arial"/>
+              </a:rPr>
+              <a:t>that belongs to you.</a:t>
+            </a:r>
+          </a:p>
+        </p:txBody>
+      </p:sp>
+      <p:sp>
+        <p:nvSpPr>
+          <p:cNvPr id="3" name="close-tr">
+            <a:extLst xmlns:a="http://schemas.openxmlformats.org/drawingml/2006/main">
+              <a:ext uri="{FF2B5EF4-FFF2-40B4-BE49-F238E27FC236}">
+                <a16:creationId xmlns:a16="http://schemas.microsoft.com/office/drawing/2014/main" id="{B8D33F00-B2B9-445A-83ED-200518555999}"/>
+              </a:ext>
+            </a:extLst>
+          </p:cNvPr>
+          <p:cNvSpPr>
+            <a:spLocks xmlns:a="http://schemas.openxmlformats.org/drawingml/2006/main" noGrp="1"/>
+          </p:cNvSpPr>
+          <p:nvPr/>
+        </p:nvSpPr>
+        <p:spPr>
+          <a:xfrm xmlns:a="http://schemas.openxmlformats.org/drawingml/2006/main">
+            <a:off x="400050" y="4324350"/>
+            <a:ext cx="6858000" cy="323850"/>
+          </a:xfrm>
+          <a:prstGeom xmlns:a="http://schemas.openxmlformats.org/drawingml/2006/main" prst="rect">
+            <a:avLst/>
+          </a:prstGeom>
+          <a:noFill xmlns:a="http://schemas.openxmlformats.org/drawingml/2006/main"/>
+          <a:ln xmlns:a="http://schemas.openxmlformats.org/drawingml/2006/main" w="0">
+            <a:noFill/>
+            <a:prstDash val="solid"/>
+          </a:ln>
+        </p:spPr>
+        <p:txBody>
+          <a:bodyPr xmlns:a="http://schemas.openxmlformats.org/drawingml/2006/main" anchor="t"/>
+          <a:lstStyle xmlns:a="http://schemas.openxmlformats.org/drawingml/2006/main"/>
+          <a:p xmlns:a="http://schemas.openxmlformats.org/drawingml/2006/main">
+            <a:pPr algn="l">
+              <a:defRPr sz="1725" b="1">
+                <a:solidFill>
+                  <a:srgbClr val="10131A"/>
+                </a:solidFill>
+                <a:latin typeface="Arial"/>
+                <a:ea typeface="Arial"/>
+                <a:cs typeface="Arial"/>
+              </a:defRPr>
+            </a:pPr>
+            <a:r>
+              <a:rPr sz="1725" b="1">
+                <a:solidFill>
+                  <a:srgbClr val="10131A"/>
+                </a:solidFill>
+                <a:latin typeface="Arial"/>
+                <a:ea typeface="Arial"/>
+                <a:cs typeface="Arial"/>
+              </a:rPr>
+              <a:t>Size ait bir Rusça rutini oluşturun.</a:t>
+            </a:r>
+          </a:p>
+        </p:txBody>
+      </p:sp>
+      <p:sp>
+        <p:nvSpPr>
+          <p:cNvPr id="4" name="close-ru">
+            <a:extLst xmlns:a="http://schemas.openxmlformats.org/drawingml/2006/main">
+              <a:ext uri="{FF2B5EF4-FFF2-40B4-BE49-F238E27FC236}">
+                <a16:creationId xmlns:a16="http://schemas.microsoft.com/office/drawing/2014/main" id="{C7BE8B8E-4354-454D-ADDB-61414C633558}"/>
+              </a:ext>
+            </a:extLst>
+          </p:cNvPr>
+          <p:cNvSpPr>
+            <a:spLocks xmlns:a="http://schemas.openxmlformats.org/drawingml/2006/main" noGrp="1"/>
+          </p:cNvSpPr>
+          <p:nvPr/>
+        </p:nvSpPr>
+        <p:spPr>
+          <a:xfrm xmlns:a="http://schemas.openxmlformats.org/drawingml/2006/main">
+            <a:off x="400050" y="4800600"/>
+            <a:ext cx="7239000" cy="323850"/>
+          </a:xfrm>
+          <a:prstGeom xmlns:a="http://schemas.openxmlformats.org/drawingml/2006/main" prst="rect">
+            <a:avLst/>
+          </a:prstGeom>
+          <a:noFill xmlns:a="http://schemas.openxmlformats.org/drawingml/2006/main"/>
+          <a:ln xmlns:a="http://schemas.openxmlformats.org/drawingml/2006/main" w="0">
+            <a:noFill/>
+            <a:prstDash val="solid"/>
+          </a:ln>
+        </p:spPr>
+        <p:txBody>
+          <a:bodyPr xmlns:a="http://schemas.openxmlformats.org/drawingml/2006/main" anchor="t"/>
+          <a:lstStyle xmlns:a="http://schemas.openxmlformats.org/drawingml/2006/main"/>
+          <a:p xmlns:a="http://schemas.openxmlformats.org/drawingml/2006/main">
+            <a:pPr algn="l">
+              <a:defRPr sz="1725" b="1">
+                <a:solidFill>
+                  <a:srgbClr val="5F6675"/>
+                </a:solidFill>
+                <a:latin typeface="Arial"/>
+                <a:ea typeface="Arial"/>
+                <a:cs typeface="Arial"/>
+              </a:defRPr>
+            </a:pPr>
+            <a:r>
+              <a:rPr sz="1725" b="1">
+                <a:solidFill>
+                  <a:srgbClr val="5F6675"/>
+                </a:solidFill>
+                <a:latin typeface="Arial"/>
+                <a:ea typeface="Arial"/>
+                <a:cs typeface="Arial"/>
+              </a:rPr>
+              <a:t>Создайте свой ритм изучения русского.</a:t>
+            </a:r>
+          </a:p>
+        </p:txBody>
+      </p:sp>
+      <p:sp>
+        <p:nvSpPr>
+          <p:cNvPr id="5" name="close-rule">
+            <a:extLst xmlns:a="http://schemas.openxmlformats.org/drawingml/2006/main">
+              <a:ext uri="{FF2B5EF4-FFF2-40B4-BE49-F238E27FC236}">
+                <a16:creationId xmlns:a16="http://schemas.microsoft.com/office/drawing/2014/main" id="{28792FC9-81A3-4FFA-8A5D-4B9E237CD0CB}"/>
+              </a:ext>
+            </a:extLst>
+          </p:cNvPr>
+          <p:cNvSpPr>
+            <a:spLocks xmlns:a="http://schemas.openxmlformats.org/drawingml/2006/main" noGrp="1"/>
+          </p:cNvSpPr>
+          <p:nvPr/>
+        </p:nvSpPr>
+        <p:spPr>
+          <a:xfrm xmlns:a="http://schemas.openxmlformats.org/drawingml/2006/main">
+            <a:off x="400050" y="5524500"/>
+            <a:ext cx="11391900" cy="0"/>
+          </a:xfrm>
+          <a:prstGeom xmlns:a="http://schemas.openxmlformats.org/drawingml/2006/main" prst="line">
+            <a:avLst/>
+          </a:prstGeom>
+          <a:noFill xmlns:a="http://schemas.openxmlformats.org/drawingml/2006/main"/>
+          <a:ln xmlns:a="http://schemas.openxmlformats.org/drawingml/2006/main" w="9525">
+            <a:solidFill>
+              <a:srgbClr val="B8BCC4"/>
+            </a:solidFill>
+            <a:prstDash val="solid"/>
+          </a:ln>
+        </p:spPr>
+      </p:sp>
+      <p:sp>
+        <p:nvSpPr>
+          <p:cNvPr id="6" name="close-action">
+            <a:extLst xmlns:a="http://schemas.openxmlformats.org/drawingml/2006/main">
+              <a:ext uri="{FF2B5EF4-FFF2-40B4-BE49-F238E27FC236}">
+                <a16:creationId xmlns:a16="http://schemas.microsoft.com/office/drawing/2014/main" id="{B8334B51-3DE3-4D8D-970B-F81385ADFF1B}"/>
+              </a:ext>
+            </a:extLst>
+          </p:cNvPr>
+          <p:cNvSpPr>
+            <a:spLocks xmlns:a="http://schemas.openxmlformats.org/drawingml/2006/main" noGrp="1"/>
+          </p:cNvSpPr>
+          <p:nvPr/>
+        </p:nvSpPr>
+        <p:spPr>
+          <a:xfrm xmlns:a="http://schemas.openxmlformats.org/drawingml/2006/main">
+            <a:off x="400050" y="5848350"/>
+            <a:ext cx="5905500" cy="266700"/>
+          </a:xfrm>
+          <a:prstGeom xmlns:a="http://schemas.openxmlformats.org/drawingml/2006/main" prst="rect">
+            <a:avLst/>
+          </a:prstGeom>
+          <a:noFill xmlns:a="http://schemas.openxmlformats.org/drawingml/2006/main"/>
+          <a:ln xmlns:a="http://schemas.openxmlformats.org/drawingml/2006/main" w="0">
+            <a:noFill/>
+            <a:prstDash val="solid"/>
+          </a:ln>
+        </p:spPr>
+        <p:txBody>
+          <a:bodyPr xmlns:a="http://schemas.openxmlformats.org/drawingml/2006/main" anchor="t"/>
+          <a:lstStyle xmlns:a="http://schemas.openxmlformats.org/drawingml/2006/main"/>
+          <a:p xmlns:a="http://schemas.openxmlformats.org/drawingml/2006/main">
+            <a:pPr algn="l">
+              <a:defRPr sz="1350" b="1">
+                <a:solidFill>
+                  <a:srgbClr val="3D8DFF"/>
+                </a:solidFill>
+                <a:latin typeface="Arial"/>
+                <a:ea typeface="Arial"/>
+                <a:cs typeface="Arial"/>
+              </a:defRPr>
+            </a:pPr>
+            <a:r>
+              <a:rPr sz="1350" b="1">
+                <a:solidFill>
+                  <a:srgbClr val="3D8DFF"/>
+                </a:solidFill>
+                <a:latin typeface="Arial"/>
+                <a:ea typeface="Arial"/>
+                <a:cs typeface="Arial"/>
+              </a:rPr>
+              <a:t>INSTALL  •  LEARN  •  REVIEW</a:t>
+            </a:r>
+          </a:p>
+        </p:txBody>
+      </p:sp>
+      <p:sp>
+        <p:nvSpPr>
+          <p:cNvPr id="7" name="close-meta">
+            <a:extLst xmlns:a="http://schemas.openxmlformats.org/drawingml/2006/main">
+              <a:ext uri="{FF2B5EF4-FFF2-40B4-BE49-F238E27FC236}">
+                <a16:creationId xmlns:a16="http://schemas.microsoft.com/office/drawing/2014/main" id="{F6ABEC4D-59F8-4B16-AD59-B93BD6ECACA4}"/>
+              </a:ext>
+            </a:extLst>
+          </p:cNvPr>
+          <p:cNvSpPr>
+            <a:spLocks xmlns:a="http://schemas.openxmlformats.org/drawingml/2006/main" noGrp="1"/>
+          </p:cNvSpPr>
+          <p:nvPr/>
+        </p:nvSpPr>
+        <p:spPr>
+          <a:xfrm xmlns:a="http://schemas.openxmlformats.org/drawingml/2006/main">
+            <a:off x="6667500" y="5848350"/>
+            <a:ext cx="5124450" cy="266700"/>
+          </a:xfrm>
+          <a:prstGeom xmlns:a="http://schemas.openxmlformats.org/drawingml/2006/main" prst="rect">
+            <a:avLst/>
+          </a:prstGeom>
+          <a:noFill xmlns:a="http://schemas.openxmlformats.org/drawingml/2006/main"/>
+          <a:ln xmlns:a="http://schemas.openxmlformats.org/drawingml/2006/main" w="0">
+            <a:noFill/>
+            <a:prstDash val="solid"/>
+          </a:ln>
+        </p:spPr>
+        <p:txBody>
+          <a:bodyPr xmlns:a="http://schemas.openxmlformats.org/drawingml/2006/main" anchor="t"/>
+          <a:lstStyle xmlns:a="http://schemas.openxmlformats.org/drawingml/2006/main"/>
+          <a:p xmlns:a="http://schemas.openxmlformats.org/drawingml/2006/main">
+            <a:pPr algn="r">
+              <a:defRPr sz="1275" b="0">
+                <a:solidFill>
+                  <a:srgbClr val="5F6675"/>
+                </a:solidFill>
+                <a:latin typeface="Arial"/>
+                <a:ea typeface="Arial"/>
+                <a:cs typeface="Arial"/>
+              </a:defRPr>
+            </a:pPr>
+            <a:r>
+              <a:rPr sz="1275" b="0">
+                <a:solidFill>
+                  <a:srgbClr val="5F6675"/>
+                </a:solidFill>
+                <a:latin typeface="Arial"/>
+                <a:ea typeface="Arial"/>
+                <a:cs typeface="Arial"/>
+              </a:rPr>
+              <a:t>Windows 10/11 + macOS  •  A1-C1  •  TR / EN / RU</a:t>
+            </a:r>
+          </a:p>
+        </p:txBody>
+      </p:sp>
+      <p:sp>
+        <p:nvSpPr>
+          <p:cNvPr id="8" name="footer-8">
+            <a:extLst xmlns:a="http://schemas.openxmlformats.org/drawingml/2006/main">
+              <a:ext uri="{FF2B5EF4-FFF2-40B4-BE49-F238E27FC236}">
+                <a16:creationId xmlns:a16="http://schemas.microsoft.com/office/drawing/2014/main" id="{73C18654-1981-4717-834F-50E98B2143BC}"/>
+              </a:ext>
+            </a:extLst>
+          </p:cNvPr>
+          <p:cNvSpPr>
+            <a:spLocks xmlns:a="http://schemas.openxmlformats.org/drawingml/2006/main" noGrp="1"/>
+          </p:cNvSpPr>
+          <p:nvPr/>
+        </p:nvSpPr>
+        <p:spPr>
+          <a:xfrm xmlns:a="http://schemas.openxmlformats.org/drawingml/2006/main">
+            <a:off x="11239500" y="6362700"/>
+            <a:ext cx="533400" cy="190500"/>
+          </a:xfrm>
+          <a:prstGeom xmlns:a="http://schemas.openxmlformats.org/drawingml/2006/main" prst="rect">
+            <a:avLst/>
+          </a:prstGeom>
+          <a:noFill xmlns:a="http://schemas.openxmlformats.org/drawingml/2006/main"/>
+          <a:ln xmlns:a="http://schemas.openxmlformats.org/drawingml/2006/main" w="0">
+            <a:noFill/>
+            <a:prstDash val="solid"/>
+          </a:ln>
+        </p:spPr>
+        <p:txBody>
+          <a:bodyPr xmlns:a="http://schemas.openxmlformats.org/drawingml/2006/main" anchor="t"/>
+          <a:lstStyle xmlns:a="http://schemas.openxmlformats.org/drawingml/2006/main"/>
+          <a:p xmlns:a="http://schemas.openxmlformats.org/drawingml/2006/main">
+            <a:pPr algn="r">
+              <a:defRPr sz="975" b="0">
+                <a:solidFill>
+                  <a:srgbClr val="5F6675"/>
+                </a:solidFill>
+                <a:latin typeface="Arial"/>
+                <a:ea typeface="Arial"/>
+                <a:cs typeface="Arial"/>
+              </a:defRPr>
+            </a:pPr>
+            <a:r>
+              <a:rPr sz="975" b="0">
+                <a:solidFill>
+                  <a:srgbClr val="5F6675"/>
+                </a:solidFill>
+                <a:latin typeface="Arial"/>
+                <a:ea typeface="Arial"/>
+                <a:cs typeface="Arial"/>
+              </a:rPr>
+              <a:t>08</a:t>
+            </a:r>
+          </a:p>
+        </p:txBody>
+      </p:sp>
+    </p:spTree>
+    <p:extLst>
+      <p:ext uri="{BB962C8B-B14F-4D97-AF65-F5344CB8AC3E}">
+        <p14:creationId xmlns:p14="http://schemas.microsoft.com/office/powerpoint/2010/main" val="1076121641"/>
       </p:ext>
     </p:extLst>
   </p:cSld>

</xml_diff>

<commit_message>
Sozluk RU-EN sekmesi: cift yonlu Rusca-Ingilizce sozluk
- rca/dictionary.py: gomulu + kullanici + OpenRussian katmanlarini birlestiren
  arama motoru (Kiril -> RU->EN, Latin -> EN->RU; tam/onek/icerme siralamasi)
- rca/dict_data.py: 1.360 vurgulu A1-B1 madde
- rca/tabs/dictionary_tab.py: dinle, kelime bankasina ekle, AI'a sor,
  CSV/TSV ice/disa aktar, son aramalar, OpenRussian yukle
- db: dict_entries tablosu + DictRepo; i18n: TR/EN/RU anahtarlar; kilavuz bolumu
- 13 yeni test (103 toplam), README TR/EN ve tanitim sunumu (18 alan) guncellendi

Co-Authored-By: Claude Fable 5.1 <noreply@anthropic.com>
</commit_message>
<xml_diff>
--- a/docs/presentation/Russian-Course-AI-Trilingual.pptx
+++ b/docs/presentation/Russian-Course-AI-Trilingual.pptx
@@ -2,20 +2,20 @@
 <file path=ppt/presentation.xml><?xml version="1.0" encoding="utf-8"?>
 <p:presentation xmlns:p="http://schemas.openxmlformats.org/presentationml/2006/main">
   <p:sldMasterIdLst>
-    <p:sldMasterId xmlns:r="http://schemas.openxmlformats.org/officeDocument/2006/relationships" id="2147483648" r:id="Rb1638df790e24309"/>
+    <p:sldMasterId xmlns:r="http://schemas.openxmlformats.org/officeDocument/2006/relationships" id="2147483648" r:id="R31ecbf68bc6c42a7"/>
   </p:sldMasterIdLst>
   <p:notesMasterIdLst>
-    <p:notesMasterId xmlns:r="http://schemas.openxmlformats.org/officeDocument/2006/relationships" r:id="R99115881d6d740b0"/>
+    <p:notesMasterId xmlns:r="http://schemas.openxmlformats.org/officeDocument/2006/relationships" r:id="R56a09616bb304f12"/>
   </p:notesMasterIdLst>
   <p:sldIdLst>
-    <p:sldId xmlns:r="http://schemas.openxmlformats.org/officeDocument/2006/relationships" id="256" r:id="R4dce43551a9e4ec5"/>
-    <p:sldId xmlns:r="http://schemas.openxmlformats.org/officeDocument/2006/relationships" id="257" r:id="Rd5d8eb9b4cce4859"/>
-    <p:sldId xmlns:r="http://schemas.openxmlformats.org/officeDocument/2006/relationships" id="258" r:id="Rd0c22b7f66304e00"/>
-    <p:sldId xmlns:r="http://schemas.openxmlformats.org/officeDocument/2006/relationships" id="259" r:id="R3a35e0a5d1f54d41"/>
-    <p:sldId xmlns:r="http://schemas.openxmlformats.org/officeDocument/2006/relationships" id="260" r:id="R45d394c5428a49bb"/>
-    <p:sldId xmlns:r="http://schemas.openxmlformats.org/officeDocument/2006/relationships" id="261" r:id="Re664ec9617cb45f7"/>
-    <p:sldId xmlns:r="http://schemas.openxmlformats.org/officeDocument/2006/relationships" id="262" r:id="R23f6bafabb9a467d"/>
-    <p:sldId xmlns:r="http://schemas.openxmlformats.org/officeDocument/2006/relationships" id="263" r:id="R096aaaceb2074dc9"/>
+    <p:sldId xmlns:r="http://schemas.openxmlformats.org/officeDocument/2006/relationships" id="256" r:id="Ra4ae517dbcf549ed"/>
+    <p:sldId xmlns:r="http://schemas.openxmlformats.org/officeDocument/2006/relationships" id="257" r:id="Rc6ac401bf726469e"/>
+    <p:sldId xmlns:r="http://schemas.openxmlformats.org/officeDocument/2006/relationships" id="258" r:id="R1de2a49db295424a"/>
+    <p:sldId xmlns:r="http://schemas.openxmlformats.org/officeDocument/2006/relationships" id="259" r:id="R215763e5a91940f9"/>
+    <p:sldId xmlns:r="http://schemas.openxmlformats.org/officeDocument/2006/relationships" id="260" r:id="Rbe58fdae611e4301"/>
+    <p:sldId xmlns:r="http://schemas.openxmlformats.org/officeDocument/2006/relationships" id="261" r:id="R84099b912802467f"/>
+    <p:sldId xmlns:r="http://schemas.openxmlformats.org/officeDocument/2006/relationships" id="262" r:id="R73e8a04261154310"/>
+    <p:sldId xmlns:r="http://schemas.openxmlformats.org/officeDocument/2006/relationships" id="263" r:id="R027525fc6f2b4c18"/>
   </p:sldIdLst>
   <p:sldSz cx="12192000" cy="6858000"/>
   <p:notesSz cx="6858000" cy="9144000"/>
@@ -769,7 +769,12 @@
           </a:p>
           <a:p xmlns:a="http://schemas.openxmlformats.org/drawingml/2006/main">
             <a:r>
-              <a:t>- D:/Russian/Russian_Course_AI.pyw (17 entries in TAB_SPECS)</a:t>
+              <a:t>- D:/Russian/Russian_Course_AI.pyw (18 entries in TAB_SPECS)</a:t>
+            </a:r>
+          </a:p>
+          <a:p xmlns:a="http://schemas.openxmlformats.org/drawingml/2006/main">
+            <a:r>
+              <a:t>- D:/Russian/rca/dictionary.py + rca/dict_data.py (bidirectional RU-EN dictionary, 1,360 built-in entries, OpenRussian layer)</a:t>
             </a:r>
           </a:p>
           <a:p xmlns:a="http://schemas.openxmlformats.org/drawingml/2006/main">
@@ -1072,7 +1077,7 @@
   </p:cSld>
   <p:clrMap bg1="lt1" tx1="dk1" bg2="lt2" tx2="dk2" accent1="accent1" accent2="accent2" accent3="accent3" accent4="accent4" accent5="accent5" accent6="accent6" hlink="hlink" folHlink="folHlink"/>
   <p:sldLayoutIdLst>
-    <p:sldLayoutId xmlns:r="http://schemas.openxmlformats.org/officeDocument/2006/relationships" id="2147483649" r:id="Rb55103f2539e407c"/>
+    <p:sldLayoutId xmlns:r="http://schemas.openxmlformats.org/officeDocument/2006/relationships" id="2147483649" r:id="R905ea14cbb014a05"/>
   </p:sldLayoutIdLst>
   <p:txStyles>
     <p:titleStyle>
@@ -1623,7 +1628,7 @@
           <p:cNvPr id="11" name="cover-kicker">
             <a:extLst xmlns:a="http://schemas.openxmlformats.org/drawingml/2006/main">
               <a:ext uri="{FF2B5EF4-FFF2-40B4-BE49-F238E27FC236}">
-                <a16:creationId xmlns:a16="http://schemas.microsoft.com/office/drawing/2014/main" id="{A6DAB9C9-410C-4146-9515-F1741EC913BC}"/>
+                <a16:creationId xmlns:a16="http://schemas.microsoft.com/office/drawing/2014/main" id="{F9F6D61B-1520-4269-A9C5-6D3A3496E59E}"/>
               </a:ext>
             </a:extLst>
           </p:cNvPr>
@@ -1679,7 +1684,7 @@
           <p:cNvPr id="2" name="cover-title">
             <a:extLst xmlns:a="http://schemas.openxmlformats.org/drawingml/2006/main">
               <a:ext uri="{FF2B5EF4-FFF2-40B4-BE49-F238E27FC236}">
-                <a16:creationId xmlns:a16="http://schemas.microsoft.com/office/drawing/2014/main" id="{5565546F-D62F-4953-B4CE-49782A4825FA}"/>
+                <a16:creationId xmlns:a16="http://schemas.microsoft.com/office/drawing/2014/main" id="{CCCEB083-DE62-4169-A90E-6FDC2FCE7459}"/>
               </a:ext>
             </a:extLst>
           </p:cNvPr>
@@ -1758,7 +1763,7 @@
           <p:cNvPr id="3" name="cover-rule">
             <a:extLst xmlns:a="http://schemas.openxmlformats.org/drawingml/2006/main">
               <a:ext uri="{FF2B5EF4-FFF2-40B4-BE49-F238E27FC236}">
-                <a16:creationId xmlns:a16="http://schemas.microsoft.com/office/drawing/2014/main" id="{186941BB-993C-427D-AEAF-83ACFB4BBC85}"/>
+                <a16:creationId xmlns:a16="http://schemas.microsoft.com/office/drawing/2014/main" id="{441DE338-4E5B-4D13-854D-99E25220F49D}"/>
               </a:ext>
             </a:extLst>
           </p:cNvPr>
@@ -1789,7 +1794,7 @@
           <p:cNvPr id="4" name="cover-tr">
             <a:extLst xmlns:a="http://schemas.openxmlformats.org/drawingml/2006/main">
               <a:ext uri="{FF2B5EF4-FFF2-40B4-BE49-F238E27FC236}">
-                <a16:creationId xmlns:a16="http://schemas.microsoft.com/office/drawing/2014/main" id="{F28779AF-F2E9-422A-8559-61F433701CEA}"/>
+                <a16:creationId xmlns:a16="http://schemas.microsoft.com/office/drawing/2014/main" id="{3BB32D6E-B2E6-4474-8B47-74FF68E14F30}"/>
               </a:ext>
             </a:extLst>
           </p:cNvPr>
@@ -1845,7 +1850,7 @@
           <p:cNvPr id="5" name="cover-en">
             <a:extLst xmlns:a="http://schemas.openxmlformats.org/drawingml/2006/main">
               <a:ext uri="{FF2B5EF4-FFF2-40B4-BE49-F238E27FC236}">
-                <a16:creationId xmlns:a16="http://schemas.microsoft.com/office/drawing/2014/main" id="{38BABDD1-0AC3-4BD9-B2FB-F690C163B9A0}"/>
+                <a16:creationId xmlns:a16="http://schemas.microsoft.com/office/drawing/2014/main" id="{849FE9E8-1A6C-43C5-99F9-ACE6F9FC86E2}"/>
               </a:ext>
             </a:extLst>
           </p:cNvPr>
@@ -1901,7 +1906,7 @@
           <p:cNvPr id="6" name="cover-ru">
             <a:extLst xmlns:a="http://schemas.openxmlformats.org/drawingml/2006/main">
               <a:ext uri="{FF2B5EF4-FFF2-40B4-BE49-F238E27FC236}">
-                <a16:creationId xmlns:a16="http://schemas.microsoft.com/office/drawing/2014/main" id="{1C98D64D-8C53-4D12-BC23-16CD763B612D}"/>
+                <a16:creationId xmlns:a16="http://schemas.microsoft.com/office/drawing/2014/main" id="{633C7317-3535-4467-8393-61964C259505}"/>
               </a:ext>
             </a:extLst>
           </p:cNvPr>
@@ -1957,7 +1962,7 @@
           <p:cNvPr id="7" name="cover-meta">
             <a:extLst xmlns:a="http://schemas.openxmlformats.org/drawingml/2006/main">
               <a:ext uri="{FF2B5EF4-FFF2-40B4-BE49-F238E27FC236}">
-                <a16:creationId xmlns:a16="http://schemas.microsoft.com/office/drawing/2014/main" id="{B0B32552-CA12-4D9A-A9BA-22876A2CC05E}"/>
+                <a16:creationId xmlns:a16="http://schemas.microsoft.com/office/drawing/2014/main" id="{34EB8052-D5C1-4BD1-8C01-9DCDCFDE61EB}"/>
               </a:ext>
             </a:extLst>
           </p:cNvPr>
@@ -2013,7 +2018,7 @@
           <p:cNvPr id="8" name="hero-backing">
             <a:extLst xmlns:a="http://schemas.openxmlformats.org/drawingml/2006/main">
               <a:ext uri="{FF2B5EF4-FFF2-40B4-BE49-F238E27FC236}">
-                <a16:creationId xmlns:a16="http://schemas.microsoft.com/office/drawing/2014/main" id="{AC54D068-798B-4ACF-B644-E5192879E370}"/>
+                <a16:creationId xmlns:a16="http://schemas.microsoft.com/office/drawing/2014/main" id="{A16AAC39-D834-4637-BEA3-0B6A129D6A5D}"/>
               </a:ext>
             </a:extLst>
           </p:cNvPr>
@@ -2050,7 +2055,7 @@
           <p:nvPr/>
         </p:nvPicPr>
         <p:blipFill>
-          <a:blip xmlns:r="http://schemas.openxmlformats.org/officeDocument/2006/relationships" xmlns:a="http://schemas.openxmlformats.org/drawingml/2006/main" r:embed="Rde624540c4d945a7"/>
+          <a:blip xmlns:r="http://schemas.openxmlformats.org/officeDocument/2006/relationships" xmlns:a="http://schemas.openxmlformats.org/drawingml/2006/main" r:embed="Rb59a7b61ad344c60"/>
           <a:srcRect xmlns:a="http://schemas.openxmlformats.org/drawingml/2006/main" l="510" t="0" r="510" b="0"/>
           <a:stretch xmlns:a="http://schemas.openxmlformats.org/drawingml/2006/main">
             <a:fillRect l="0" t="0" r="0" b="0"/>
@@ -2073,7 +2078,7 @@
           <p:cNvPr id="10" name="footer-1">
             <a:extLst xmlns:a="http://schemas.openxmlformats.org/drawingml/2006/main">
               <a:ext uri="{FF2B5EF4-FFF2-40B4-BE49-F238E27FC236}">
-                <a16:creationId xmlns:a16="http://schemas.microsoft.com/office/drawing/2014/main" id="{584EF786-102C-4364-976B-4C5864ED75D7}"/>
+                <a16:creationId xmlns:a16="http://schemas.microsoft.com/office/drawing/2014/main" id="{DEC6A945-8154-4123-8B4A-9A50ED0E16CB}"/>
               </a:ext>
             </a:extLst>
           </p:cNvPr>
@@ -2127,7 +2132,7 @@
     </p:spTree>
     <p:extLst>
       <p:ext uri="{BB962C8B-B14F-4D97-AF65-F5344CB8AC3E}">
-        <p14:creationId xmlns:p14="http://schemas.microsoft.com/office/powerpoint/2010/main" val="529797362"/>
+        <p14:creationId xmlns:p14="http://schemas.microsoft.com/office/powerpoint/2010/main" val="1369665739"/>
       </p:ext>
     </p:extLst>
   </p:cSld>
@@ -2158,7 +2163,7 @@
           <p:cNvPr id="6" name="screen-title">
             <a:extLst xmlns:a="http://schemas.openxmlformats.org/drawingml/2006/main">
               <a:ext uri="{FF2B5EF4-FFF2-40B4-BE49-F238E27FC236}">
-                <a16:creationId xmlns:a16="http://schemas.microsoft.com/office/drawing/2014/main" id="{8191CE98-EEE6-4765-A884-84B857E79415}"/>
+                <a16:creationId xmlns:a16="http://schemas.microsoft.com/office/drawing/2014/main" id="{6C4EF357-4E1F-4543-9E8C-48B8B746AF41}"/>
               </a:ext>
             </a:extLst>
           </p:cNvPr>
@@ -2214,7 +2219,7 @@
           <p:cNvPr id="2" name="screen-subtitle">
             <a:extLst xmlns:a="http://schemas.openxmlformats.org/drawingml/2006/main">
               <a:ext uri="{FF2B5EF4-FFF2-40B4-BE49-F238E27FC236}">
-                <a16:creationId xmlns:a16="http://schemas.microsoft.com/office/drawing/2014/main" id="{9A3B5228-AE7F-407D-8045-3253368AA3CC}"/>
+                <a16:creationId xmlns:a16="http://schemas.microsoft.com/office/drawing/2014/main" id="{008F7A36-F92A-4DC5-AD65-DDCB58D01B76}"/>
               </a:ext>
             </a:extLst>
           </p:cNvPr>
@@ -2270,7 +2275,7 @@
           <p:cNvPr id="3" name="screen-frame">
             <a:extLst xmlns:a="http://schemas.openxmlformats.org/drawingml/2006/main">
               <a:ext uri="{FF2B5EF4-FFF2-40B4-BE49-F238E27FC236}">
-                <a16:creationId xmlns:a16="http://schemas.microsoft.com/office/drawing/2014/main" id="{679B8401-2944-44E4-9DF2-939570C9C36B}"/>
+                <a16:creationId xmlns:a16="http://schemas.microsoft.com/office/drawing/2014/main" id="{38F2D874-A4F6-4D45-AAE7-41173D279C75}"/>
               </a:ext>
             </a:extLst>
           </p:cNvPr>
@@ -2307,7 +2312,7 @@
           <p:nvPr/>
         </p:nvPicPr>
         <p:blipFill>
-          <a:blip xmlns:r="http://schemas.openxmlformats.org/officeDocument/2006/relationships" xmlns:a="http://schemas.openxmlformats.org/drawingml/2006/main" r:embed="Ra9a5bd89dd8b4b12"/>
+          <a:blip xmlns:r="http://schemas.openxmlformats.org/officeDocument/2006/relationships" xmlns:a="http://schemas.openxmlformats.org/drawingml/2006/main" r:embed="R3002548f094649ec"/>
           <a:stretch xmlns:a="http://schemas.openxmlformats.org/drawingml/2006/main"/>
         </p:blipFill>
         <p:spPr>
@@ -2327,7 +2332,7 @@
           <p:cNvPr id="5" name="screen-footer">
             <a:extLst xmlns:a="http://schemas.openxmlformats.org/drawingml/2006/main">
               <a:ext uri="{FF2B5EF4-FFF2-40B4-BE49-F238E27FC236}">
-                <a16:creationId xmlns:a16="http://schemas.microsoft.com/office/drawing/2014/main" id="{4D16A4A2-E284-4139-A68D-3DC8FC9C6EDF}"/>
+                <a16:creationId xmlns:a16="http://schemas.microsoft.com/office/drawing/2014/main" id="{1DD455E9-F5BF-4E21-9B1A-162E4E6B0D06}"/>
               </a:ext>
             </a:extLst>
           </p:cNvPr>
@@ -2381,7 +2386,7 @@
     </p:spTree>
     <p:extLst>
       <p:ext uri="{BB962C8B-B14F-4D97-AF65-F5344CB8AC3E}">
-        <p14:creationId xmlns:p14="http://schemas.microsoft.com/office/powerpoint/2010/main" val="1206458966"/>
+        <p14:creationId xmlns:p14="http://schemas.microsoft.com/office/powerpoint/2010/main" val="1039323642"/>
       </p:ext>
     </p:extLst>
   </p:cSld>
@@ -2412,7 +2417,7 @@
           <p:cNvPr id="17" name="language-title">
             <a:extLst xmlns:a="http://schemas.openxmlformats.org/drawingml/2006/main">
               <a:ext uri="{FF2B5EF4-FFF2-40B4-BE49-F238E27FC236}">
-                <a16:creationId xmlns:a16="http://schemas.microsoft.com/office/drawing/2014/main" id="{E115A905-5AE8-4E59-A233-E765474B970D}"/>
+                <a16:creationId xmlns:a16="http://schemas.microsoft.com/office/drawing/2014/main" id="{6480734B-1C1F-4913-9E6D-A8424B2C723D}"/>
               </a:ext>
             </a:extLst>
           </p:cNvPr>
@@ -2468,7 +2473,7 @@
           <p:cNvPr id="2" name="language-subtitle">
             <a:extLst xmlns:a="http://schemas.openxmlformats.org/drawingml/2006/main">
               <a:ext uri="{FF2B5EF4-FFF2-40B4-BE49-F238E27FC236}">
-                <a16:creationId xmlns:a16="http://schemas.microsoft.com/office/drawing/2014/main" id="{C3A796B8-CABE-492E-982B-AB789403749D}"/>
+                <a16:creationId xmlns:a16="http://schemas.microsoft.com/office/drawing/2014/main" id="{C3A209B5-06EE-4B3B-90E3-8FE61F08279A}"/>
               </a:ext>
             </a:extLst>
           </p:cNvPr>
@@ -2524,7 +2529,7 @@
           <p:cNvPr id="3" name="language-rule">
             <a:extLst xmlns:a="http://schemas.openxmlformats.org/drawingml/2006/main">
               <a:ext uri="{FF2B5EF4-FFF2-40B4-BE49-F238E27FC236}">
-                <a16:creationId xmlns:a16="http://schemas.microsoft.com/office/drawing/2014/main" id="{543574EE-9F55-48A4-99D4-8069B54F92B3}"/>
+                <a16:creationId xmlns:a16="http://schemas.microsoft.com/office/drawing/2014/main" id="{B8619A0E-9E32-4557-B78F-B36403C38ED6}"/>
               </a:ext>
             </a:extLst>
           </p:cNvPr>
@@ -2555,7 +2560,7 @@
           <p:cNvPr id="4" name="language-label-0">
             <a:extLst xmlns:a="http://schemas.openxmlformats.org/drawingml/2006/main">
               <a:ext uri="{FF2B5EF4-FFF2-40B4-BE49-F238E27FC236}">
-                <a16:creationId xmlns:a16="http://schemas.microsoft.com/office/drawing/2014/main" id="{0B8F16DE-1D40-4990-B724-3683A00486C1}"/>
+                <a16:creationId xmlns:a16="http://schemas.microsoft.com/office/drawing/2014/main" id="{AD07BB39-E994-4330-8040-8388A2FCC8AB}"/>
               </a:ext>
             </a:extLst>
           </p:cNvPr>
@@ -2611,7 +2616,7 @@
           <p:cNvPr id="5" name="language-head-0">
             <a:extLst xmlns:a="http://schemas.openxmlformats.org/drawingml/2006/main">
               <a:ext uri="{FF2B5EF4-FFF2-40B4-BE49-F238E27FC236}">
-                <a16:creationId xmlns:a16="http://schemas.microsoft.com/office/drawing/2014/main" id="{3E144B33-D62B-4ADF-A64E-7B03EA4883F5}"/>
+                <a16:creationId xmlns:a16="http://schemas.microsoft.com/office/drawing/2014/main" id="{597FA501-70D8-4400-9350-4AD734C972A0}"/>
               </a:ext>
             </a:extLst>
           </p:cNvPr>
@@ -2667,7 +2672,7 @@
           <p:cNvPr id="6" name="language-body-0">
             <a:extLst xmlns:a="http://schemas.openxmlformats.org/drawingml/2006/main">
               <a:ext uri="{FF2B5EF4-FFF2-40B4-BE49-F238E27FC236}">
-                <a16:creationId xmlns:a16="http://schemas.microsoft.com/office/drawing/2014/main" id="{8626BC2B-4BE9-41D6-A539-C0D627C96973}"/>
+                <a16:creationId xmlns:a16="http://schemas.microsoft.com/office/drawing/2014/main" id="{68F7FC22-9450-4A0E-BEF5-8FCED1EE8B62}"/>
               </a:ext>
             </a:extLst>
           </p:cNvPr>
@@ -2723,7 +2728,7 @@
           <p:cNvPr id="7" name="language-accent-0">
             <a:extLst xmlns:a="http://schemas.openxmlformats.org/drawingml/2006/main">
               <a:ext uri="{FF2B5EF4-FFF2-40B4-BE49-F238E27FC236}">
-                <a16:creationId xmlns:a16="http://schemas.microsoft.com/office/drawing/2014/main" id="{1A44738F-ACC2-4824-80C6-9F0C445F9C16}"/>
+                <a16:creationId xmlns:a16="http://schemas.microsoft.com/office/drawing/2014/main" id="{46621889-5A35-4C51-9D57-58266EE61FE3}"/>
               </a:ext>
             </a:extLst>
           </p:cNvPr>
@@ -2754,7 +2759,7 @@
           <p:cNvPr id="8" name="language-label-1">
             <a:extLst xmlns:a="http://schemas.openxmlformats.org/drawingml/2006/main">
               <a:ext uri="{FF2B5EF4-FFF2-40B4-BE49-F238E27FC236}">
-                <a16:creationId xmlns:a16="http://schemas.microsoft.com/office/drawing/2014/main" id="{C0F9AB4E-E50E-4E6C-B8ED-D06E868E48EE}"/>
+                <a16:creationId xmlns:a16="http://schemas.microsoft.com/office/drawing/2014/main" id="{A56D52AF-0840-4ECA-8716-F6ACBBD356E3}"/>
               </a:ext>
             </a:extLst>
           </p:cNvPr>
@@ -2810,7 +2815,7 @@
           <p:cNvPr id="9" name="language-head-1">
             <a:extLst xmlns:a="http://schemas.openxmlformats.org/drawingml/2006/main">
               <a:ext uri="{FF2B5EF4-FFF2-40B4-BE49-F238E27FC236}">
-                <a16:creationId xmlns:a16="http://schemas.microsoft.com/office/drawing/2014/main" id="{52019F9D-FDFE-4891-A102-5B0487D3DD4A}"/>
+                <a16:creationId xmlns:a16="http://schemas.microsoft.com/office/drawing/2014/main" id="{B525A8DC-3F16-4604-A60F-682BBA7BD3D2}"/>
               </a:ext>
             </a:extLst>
           </p:cNvPr>
@@ -2866,7 +2871,7 @@
           <p:cNvPr id="10" name="language-body-1">
             <a:extLst xmlns:a="http://schemas.openxmlformats.org/drawingml/2006/main">
               <a:ext uri="{FF2B5EF4-FFF2-40B4-BE49-F238E27FC236}">
-                <a16:creationId xmlns:a16="http://schemas.microsoft.com/office/drawing/2014/main" id="{DC34904C-694C-458A-ACA6-7B9474D459C8}"/>
+                <a16:creationId xmlns:a16="http://schemas.microsoft.com/office/drawing/2014/main" id="{29E49180-3942-40DD-A1EF-3BDCDA02D64A}"/>
               </a:ext>
             </a:extLst>
           </p:cNvPr>
@@ -2922,7 +2927,7 @@
           <p:cNvPr id="11" name="language-accent-1">
             <a:extLst xmlns:a="http://schemas.openxmlformats.org/drawingml/2006/main">
               <a:ext uri="{FF2B5EF4-FFF2-40B4-BE49-F238E27FC236}">
-                <a16:creationId xmlns:a16="http://schemas.microsoft.com/office/drawing/2014/main" id="{4B87AD09-8E70-47A0-955B-520788DCE585}"/>
+                <a16:creationId xmlns:a16="http://schemas.microsoft.com/office/drawing/2014/main" id="{5FB7E42D-0872-4667-82A5-CE17A09E807A}"/>
               </a:ext>
             </a:extLst>
           </p:cNvPr>
@@ -2953,7 +2958,7 @@
           <p:cNvPr id="12" name="language-label-2">
             <a:extLst xmlns:a="http://schemas.openxmlformats.org/drawingml/2006/main">
               <a:ext uri="{FF2B5EF4-FFF2-40B4-BE49-F238E27FC236}">
-                <a16:creationId xmlns:a16="http://schemas.microsoft.com/office/drawing/2014/main" id="{B00AFB45-0294-4C80-A089-6A61C028814A}"/>
+                <a16:creationId xmlns:a16="http://schemas.microsoft.com/office/drawing/2014/main" id="{4E20ED44-C398-4021-B643-57CA1AE394C8}"/>
               </a:ext>
             </a:extLst>
           </p:cNvPr>
@@ -3009,7 +3014,7 @@
           <p:cNvPr id="13" name="language-head-2">
             <a:extLst xmlns:a="http://schemas.openxmlformats.org/drawingml/2006/main">
               <a:ext uri="{FF2B5EF4-FFF2-40B4-BE49-F238E27FC236}">
-                <a16:creationId xmlns:a16="http://schemas.microsoft.com/office/drawing/2014/main" id="{A9A6E262-5286-4AC0-9F83-F5FAC71A23B4}"/>
+                <a16:creationId xmlns:a16="http://schemas.microsoft.com/office/drawing/2014/main" id="{0FD12518-B0A2-4A2A-A528-C7BB780003D7}"/>
               </a:ext>
             </a:extLst>
           </p:cNvPr>
@@ -3065,7 +3070,7 @@
           <p:cNvPr id="14" name="language-body-2">
             <a:extLst xmlns:a="http://schemas.openxmlformats.org/drawingml/2006/main">
               <a:ext uri="{FF2B5EF4-FFF2-40B4-BE49-F238E27FC236}">
-                <a16:creationId xmlns:a16="http://schemas.microsoft.com/office/drawing/2014/main" id="{C10E56FC-91B1-4BD1-9B59-C89FDC64C302}"/>
+                <a16:creationId xmlns:a16="http://schemas.microsoft.com/office/drawing/2014/main" id="{739AF704-3A5B-4B1D-90BE-EFF2D24D41A9}"/>
               </a:ext>
             </a:extLst>
           </p:cNvPr>
@@ -3121,7 +3126,7 @@
           <p:cNvPr id="15" name="language-accent-2">
             <a:extLst xmlns:a="http://schemas.openxmlformats.org/drawingml/2006/main">
               <a:ext uri="{FF2B5EF4-FFF2-40B4-BE49-F238E27FC236}">
-                <a16:creationId xmlns:a16="http://schemas.microsoft.com/office/drawing/2014/main" id="{57B3DFAC-10D6-4A8A-862D-4D9A2A67F139}"/>
+                <a16:creationId xmlns:a16="http://schemas.microsoft.com/office/drawing/2014/main" id="{33C38677-ECDB-4AA4-B3BF-DF5F4A8EF033}"/>
               </a:ext>
             </a:extLst>
           </p:cNvPr>
@@ -3152,7 +3157,7 @@
           <p:cNvPr id="16" name="footer-3">
             <a:extLst xmlns:a="http://schemas.openxmlformats.org/drawingml/2006/main">
               <a:ext uri="{FF2B5EF4-FFF2-40B4-BE49-F238E27FC236}">
-                <a16:creationId xmlns:a16="http://schemas.microsoft.com/office/drawing/2014/main" id="{F47596F4-D04A-4BB4-A5C0-E8631A2E7342}"/>
+                <a16:creationId xmlns:a16="http://schemas.microsoft.com/office/drawing/2014/main" id="{03800D57-FE3B-4C08-B574-F27003DFC76A}"/>
               </a:ext>
             </a:extLst>
           </p:cNvPr>
@@ -3206,7 +3211,7 @@
     </p:spTree>
     <p:extLst>
       <p:ext uri="{BB962C8B-B14F-4D97-AF65-F5344CB8AC3E}">
-        <p14:creationId xmlns:p14="http://schemas.microsoft.com/office/powerpoint/2010/main" val="221122730"/>
+        <p14:creationId xmlns:p14="http://schemas.microsoft.com/office/powerpoint/2010/main" val="1225554762"/>
       </p:ext>
     </p:extLst>
   </p:cSld>
@@ -3237,7 +3242,7 @@
           <p:cNvPr id="23" name="loop-title">
             <a:extLst xmlns:a="http://schemas.openxmlformats.org/drawingml/2006/main">
               <a:ext uri="{FF2B5EF4-FFF2-40B4-BE49-F238E27FC236}">
-                <a16:creationId xmlns:a16="http://schemas.microsoft.com/office/drawing/2014/main" id="{255E7022-10F5-483A-BC2A-5BE86474A177}"/>
+                <a16:creationId xmlns:a16="http://schemas.microsoft.com/office/drawing/2014/main" id="{9187F4E2-19AC-44AD-AC64-93B972F9C38C}"/>
               </a:ext>
             </a:extLst>
           </p:cNvPr>
@@ -3293,7 +3298,7 @@
           <p:cNvPr id="2" name="loop-subtitle">
             <a:extLst xmlns:a="http://schemas.openxmlformats.org/drawingml/2006/main">
               <a:ext uri="{FF2B5EF4-FFF2-40B4-BE49-F238E27FC236}">
-                <a16:creationId xmlns:a16="http://schemas.microsoft.com/office/drawing/2014/main" id="{2145E1D4-F7A4-493F-A8BD-61AF4EC03AC4}"/>
+                <a16:creationId xmlns:a16="http://schemas.microsoft.com/office/drawing/2014/main" id="{ECED97E8-936E-46D8-8878-AC0FA8A9E918}"/>
               </a:ext>
             </a:extLst>
           </p:cNvPr>
@@ -3349,7 +3354,7 @@
           <p:cNvPr id="3" name="loop-track">
             <a:extLst xmlns:a="http://schemas.openxmlformats.org/drawingml/2006/main">
               <a:ext uri="{FF2B5EF4-FFF2-40B4-BE49-F238E27FC236}">
-                <a16:creationId xmlns:a16="http://schemas.microsoft.com/office/drawing/2014/main" id="{C493E2B2-28DB-482A-BCF1-D04EC8882DB6}"/>
+                <a16:creationId xmlns:a16="http://schemas.microsoft.com/office/drawing/2014/main" id="{7615B780-CFD9-492A-A593-8A098589679A}"/>
               </a:ext>
             </a:extLst>
           </p:cNvPr>
@@ -3380,7 +3385,7 @@
           <p:cNvPr id="4" name="loop-node-0">
             <a:extLst xmlns:a="http://schemas.openxmlformats.org/drawingml/2006/main">
               <a:ext uri="{FF2B5EF4-FFF2-40B4-BE49-F238E27FC236}">
-                <a16:creationId xmlns:a16="http://schemas.microsoft.com/office/drawing/2014/main" id="{9DAA1747-5F55-4FCD-BAFB-A3099AB35AE2}"/>
+                <a16:creationId xmlns:a16="http://schemas.microsoft.com/office/drawing/2014/main" id="{FDD52061-68D8-4682-9C6A-091F24727471}"/>
               </a:ext>
             </a:extLst>
           </p:cNvPr>
@@ -3413,7 +3418,7 @@
           <p:cNvPr id="5" name="loop-number-0">
             <a:extLst xmlns:a="http://schemas.openxmlformats.org/drawingml/2006/main">
               <a:ext uri="{FF2B5EF4-FFF2-40B4-BE49-F238E27FC236}">
-                <a16:creationId xmlns:a16="http://schemas.microsoft.com/office/drawing/2014/main" id="{66992E49-DC49-4E6F-ADDE-56F3BC1A42D2}"/>
+                <a16:creationId xmlns:a16="http://schemas.microsoft.com/office/drawing/2014/main" id="{3E7904A1-4EB3-4493-B903-F09B657F2EBD}"/>
               </a:ext>
             </a:extLst>
           </p:cNvPr>
@@ -3469,7 +3474,7 @@
           <p:cNvPr id="6" name="loop-en-0">
             <a:extLst xmlns:a="http://schemas.openxmlformats.org/drawingml/2006/main">
               <a:ext uri="{FF2B5EF4-FFF2-40B4-BE49-F238E27FC236}">
-                <a16:creationId xmlns:a16="http://schemas.microsoft.com/office/drawing/2014/main" id="{EF8473DB-D165-457F-AAE6-43DACA71C047}"/>
+                <a16:creationId xmlns:a16="http://schemas.microsoft.com/office/drawing/2014/main" id="{C005F00F-C6C2-4853-8313-B8071122C718}"/>
               </a:ext>
             </a:extLst>
           </p:cNvPr>
@@ -3525,7 +3530,7 @@
           <p:cNvPr id="7" name="loop-tr-0">
             <a:extLst xmlns:a="http://schemas.openxmlformats.org/drawingml/2006/main">
               <a:ext uri="{FF2B5EF4-FFF2-40B4-BE49-F238E27FC236}">
-                <a16:creationId xmlns:a16="http://schemas.microsoft.com/office/drawing/2014/main" id="{9CB65CB5-D354-4DC7-89FA-CB64887ED410}"/>
+                <a16:creationId xmlns:a16="http://schemas.microsoft.com/office/drawing/2014/main" id="{D17C7CF5-8DDD-4EE3-9104-317EF4D47EF9}"/>
               </a:ext>
             </a:extLst>
           </p:cNvPr>
@@ -3581,7 +3586,7 @@
           <p:cNvPr id="8" name="loop-ru-0">
             <a:extLst xmlns:a="http://schemas.openxmlformats.org/drawingml/2006/main">
               <a:ext uri="{FF2B5EF4-FFF2-40B4-BE49-F238E27FC236}">
-                <a16:creationId xmlns:a16="http://schemas.microsoft.com/office/drawing/2014/main" id="{20069654-FB0D-452A-8CF6-7D1F21A01469}"/>
+                <a16:creationId xmlns:a16="http://schemas.microsoft.com/office/drawing/2014/main" id="{BC16E0A0-07D1-4EA4-A44E-68AAB5DADDB9}"/>
               </a:ext>
             </a:extLst>
           </p:cNvPr>
@@ -3637,7 +3642,7 @@
           <p:cNvPr id="9" name="loop-detail-0">
             <a:extLst xmlns:a="http://schemas.openxmlformats.org/drawingml/2006/main">
               <a:ext uri="{FF2B5EF4-FFF2-40B4-BE49-F238E27FC236}">
-                <a16:creationId xmlns:a16="http://schemas.microsoft.com/office/drawing/2014/main" id="{C58DB755-EB05-4FF6-985A-BCFA835D455C}"/>
+                <a16:creationId xmlns:a16="http://schemas.microsoft.com/office/drawing/2014/main" id="{58C1AE5A-F4FD-406B-9147-FDA9752B9ECB}"/>
               </a:ext>
             </a:extLst>
           </p:cNvPr>
@@ -3683,7 +3688,7 @@
                 <a:ea typeface="Arial"/>
                 <a:cs typeface="Arial"/>
               </a:rPr>
-              <a:t>Words • Cyrillic • Grammar</a:t>
+              <a:t>Words • Dictionary • Cyrillic • Grammar</a:t>
             </a:r>
           </a:p>
         </p:txBody>
@@ -3693,7 +3698,7 @@
           <p:cNvPr id="10" name="loop-node-1">
             <a:extLst xmlns:a="http://schemas.openxmlformats.org/drawingml/2006/main">
               <a:ext uri="{FF2B5EF4-FFF2-40B4-BE49-F238E27FC236}">
-                <a16:creationId xmlns:a16="http://schemas.microsoft.com/office/drawing/2014/main" id="{55380504-F5FE-4C22-BBE9-3D8982432B00}"/>
+                <a16:creationId xmlns:a16="http://schemas.microsoft.com/office/drawing/2014/main" id="{FA1D9C04-2851-4CEA-97F2-B102879062A0}"/>
               </a:ext>
             </a:extLst>
           </p:cNvPr>
@@ -3726,7 +3731,7 @@
           <p:cNvPr id="11" name="loop-number-1">
             <a:extLst xmlns:a="http://schemas.openxmlformats.org/drawingml/2006/main">
               <a:ext uri="{FF2B5EF4-FFF2-40B4-BE49-F238E27FC236}">
-                <a16:creationId xmlns:a16="http://schemas.microsoft.com/office/drawing/2014/main" id="{082A3E46-CD91-4C97-9C10-66CC8A17FC2D}"/>
+                <a16:creationId xmlns:a16="http://schemas.microsoft.com/office/drawing/2014/main" id="{F58EA130-C526-4F39-9B67-A4AEA0C08F88}"/>
               </a:ext>
             </a:extLst>
           </p:cNvPr>
@@ -3782,7 +3787,7 @@
           <p:cNvPr id="12" name="loop-en-1">
             <a:extLst xmlns:a="http://schemas.openxmlformats.org/drawingml/2006/main">
               <a:ext uri="{FF2B5EF4-FFF2-40B4-BE49-F238E27FC236}">
-                <a16:creationId xmlns:a16="http://schemas.microsoft.com/office/drawing/2014/main" id="{C27A80AC-7270-4B59-AA7C-82C941BD722E}"/>
+                <a16:creationId xmlns:a16="http://schemas.microsoft.com/office/drawing/2014/main" id="{5EA86DC0-A757-4A04-92DE-3FA8D169C200}"/>
               </a:ext>
             </a:extLst>
           </p:cNvPr>
@@ -3838,7 +3843,7 @@
           <p:cNvPr id="13" name="loop-tr-1">
             <a:extLst xmlns:a="http://schemas.openxmlformats.org/drawingml/2006/main">
               <a:ext uri="{FF2B5EF4-FFF2-40B4-BE49-F238E27FC236}">
-                <a16:creationId xmlns:a16="http://schemas.microsoft.com/office/drawing/2014/main" id="{7647A533-AE97-4979-83E1-CB7C20483374}"/>
+                <a16:creationId xmlns:a16="http://schemas.microsoft.com/office/drawing/2014/main" id="{35AAA694-42E5-47D1-AAAC-1A34301A3C24}"/>
               </a:ext>
             </a:extLst>
           </p:cNvPr>
@@ -3894,7 +3899,7 @@
           <p:cNvPr id="14" name="loop-ru-1">
             <a:extLst xmlns:a="http://schemas.openxmlformats.org/drawingml/2006/main">
               <a:ext uri="{FF2B5EF4-FFF2-40B4-BE49-F238E27FC236}">
-                <a16:creationId xmlns:a16="http://schemas.microsoft.com/office/drawing/2014/main" id="{06410452-0AD5-4291-9DB3-204F46E0D20E}"/>
+                <a16:creationId xmlns:a16="http://schemas.microsoft.com/office/drawing/2014/main" id="{A7CF54C7-E807-44A2-AA11-FEA3E14CE521}"/>
               </a:ext>
             </a:extLst>
           </p:cNvPr>
@@ -3950,7 +3955,7 @@
           <p:cNvPr id="15" name="loop-detail-1">
             <a:extLst xmlns:a="http://schemas.openxmlformats.org/drawingml/2006/main">
               <a:ext uri="{FF2B5EF4-FFF2-40B4-BE49-F238E27FC236}">
-                <a16:creationId xmlns:a16="http://schemas.microsoft.com/office/drawing/2014/main" id="{E9CAB811-C7E7-478C-9B78-98C8DFC8D092}"/>
+                <a16:creationId xmlns:a16="http://schemas.microsoft.com/office/drawing/2014/main" id="{8CAFDF4B-4B4E-4CF0-862A-93464B98D7B6}"/>
               </a:ext>
             </a:extLst>
           </p:cNvPr>
@@ -4006,7 +4011,7 @@
           <p:cNvPr id="16" name="loop-node-2">
             <a:extLst xmlns:a="http://schemas.openxmlformats.org/drawingml/2006/main">
               <a:ext uri="{FF2B5EF4-FFF2-40B4-BE49-F238E27FC236}">
-                <a16:creationId xmlns:a16="http://schemas.microsoft.com/office/drawing/2014/main" id="{F4774B87-1662-440E-92DB-8587FEB506C6}"/>
+                <a16:creationId xmlns:a16="http://schemas.microsoft.com/office/drawing/2014/main" id="{CA56FBE4-06F6-45D3-BED6-726B8CE2CC95}"/>
               </a:ext>
             </a:extLst>
           </p:cNvPr>
@@ -4039,7 +4044,7 @@
           <p:cNvPr id="17" name="loop-number-2">
             <a:extLst xmlns:a="http://schemas.openxmlformats.org/drawingml/2006/main">
               <a:ext uri="{FF2B5EF4-FFF2-40B4-BE49-F238E27FC236}">
-                <a16:creationId xmlns:a16="http://schemas.microsoft.com/office/drawing/2014/main" id="{51B4121D-AD49-420D-BAB2-1D828383D6FB}"/>
+                <a16:creationId xmlns:a16="http://schemas.microsoft.com/office/drawing/2014/main" id="{27026BB7-D59A-4A3F-B122-D3ED50924601}"/>
               </a:ext>
             </a:extLst>
           </p:cNvPr>
@@ -4095,7 +4100,7 @@
           <p:cNvPr id="18" name="loop-en-2">
             <a:extLst xmlns:a="http://schemas.openxmlformats.org/drawingml/2006/main">
               <a:ext uri="{FF2B5EF4-FFF2-40B4-BE49-F238E27FC236}">
-                <a16:creationId xmlns:a16="http://schemas.microsoft.com/office/drawing/2014/main" id="{AFFDDA26-778A-4747-AF2B-A7E5CD80AAFD}"/>
+                <a16:creationId xmlns:a16="http://schemas.microsoft.com/office/drawing/2014/main" id="{D7F4D846-5EE1-4015-A2AD-02003A063D5C}"/>
               </a:ext>
             </a:extLst>
           </p:cNvPr>
@@ -4151,7 +4156,7 @@
           <p:cNvPr id="19" name="loop-tr-2">
             <a:extLst xmlns:a="http://schemas.openxmlformats.org/drawingml/2006/main">
               <a:ext uri="{FF2B5EF4-FFF2-40B4-BE49-F238E27FC236}">
-                <a16:creationId xmlns:a16="http://schemas.microsoft.com/office/drawing/2014/main" id="{5B5AB784-C001-42A3-97C0-29806E681782}"/>
+                <a16:creationId xmlns:a16="http://schemas.microsoft.com/office/drawing/2014/main" id="{E45C12B4-71A1-443E-8053-F802DE03D838}"/>
               </a:ext>
             </a:extLst>
           </p:cNvPr>
@@ -4207,7 +4212,7 @@
           <p:cNvPr id="20" name="loop-ru-2">
             <a:extLst xmlns:a="http://schemas.openxmlformats.org/drawingml/2006/main">
               <a:ext uri="{FF2B5EF4-FFF2-40B4-BE49-F238E27FC236}">
-                <a16:creationId xmlns:a16="http://schemas.microsoft.com/office/drawing/2014/main" id="{B1A2A4C0-9B8E-4BEE-942A-91DA8C6C6E4E}"/>
+                <a16:creationId xmlns:a16="http://schemas.microsoft.com/office/drawing/2014/main" id="{56F563CD-E512-406D-B578-FFFD64FB09B1}"/>
               </a:ext>
             </a:extLst>
           </p:cNvPr>
@@ -4263,7 +4268,7 @@
           <p:cNvPr id="21" name="loop-detail-2">
             <a:extLst xmlns:a="http://schemas.openxmlformats.org/drawingml/2006/main">
               <a:ext uri="{FF2B5EF4-FFF2-40B4-BE49-F238E27FC236}">
-                <a16:creationId xmlns:a16="http://schemas.microsoft.com/office/drawing/2014/main" id="{75B9FA2F-1D23-44B8-A008-3E99CEAEFCD2}"/>
+                <a16:creationId xmlns:a16="http://schemas.microsoft.com/office/drawing/2014/main" id="{90274ECA-156C-4147-AC56-632C4B572CED}"/>
               </a:ext>
             </a:extLst>
           </p:cNvPr>
@@ -4319,7 +4324,7 @@
           <p:cNvPr id="22" name="footer-4">
             <a:extLst xmlns:a="http://schemas.openxmlformats.org/drawingml/2006/main">
               <a:ext uri="{FF2B5EF4-FFF2-40B4-BE49-F238E27FC236}">
-                <a16:creationId xmlns:a16="http://schemas.microsoft.com/office/drawing/2014/main" id="{DAC7DEAE-DF96-4FA9-BAF1-999167B71824}"/>
+                <a16:creationId xmlns:a16="http://schemas.microsoft.com/office/drawing/2014/main" id="{50C8EA7A-1004-4507-BAE8-F5F677686160}"/>
               </a:ext>
             </a:extLst>
           </p:cNvPr>
@@ -4373,7 +4378,7 @@
     </p:spTree>
     <p:extLst>
       <p:ext uri="{BB962C8B-B14F-4D97-AF65-F5344CB8AC3E}">
-        <p14:creationId xmlns:p14="http://schemas.microsoft.com/office/powerpoint/2010/main" val="1648552272"/>
+        <p14:creationId xmlns:p14="http://schemas.microsoft.com/office/powerpoint/2010/main" val="2060093979"/>
       </p:ext>
     </p:extLst>
   </p:cSld>
@@ -4404,7 +4409,7 @@
           <p:cNvPr id="21" name="breadth-title">
             <a:extLst xmlns:a="http://schemas.openxmlformats.org/drawingml/2006/main">
               <a:ext uri="{FF2B5EF4-FFF2-40B4-BE49-F238E27FC236}">
-                <a16:creationId xmlns:a16="http://schemas.microsoft.com/office/drawing/2014/main" id="{7F6372B3-C494-4B24-A3FE-EEECDFE381FF}"/>
+                <a16:creationId xmlns:a16="http://schemas.microsoft.com/office/drawing/2014/main" id="{C813BF30-1A59-436A-83CC-0788BAA354C9}"/>
               </a:ext>
             </a:extLst>
           </p:cNvPr>
@@ -4460,7 +4465,7 @@
           <p:cNvPr id="2" name="breadth-triple">
             <a:extLst xmlns:a="http://schemas.openxmlformats.org/drawingml/2006/main">
               <a:ext uri="{FF2B5EF4-FFF2-40B4-BE49-F238E27FC236}">
-                <a16:creationId xmlns:a16="http://schemas.microsoft.com/office/drawing/2014/main" id="{74DC8C2D-0F9F-4CF9-BC6A-933F55122570}"/>
+                <a16:creationId xmlns:a16="http://schemas.microsoft.com/office/drawing/2014/main" id="{93A526CF-23E7-43DA-A587-66F33F6E5AEC}"/>
               </a:ext>
             </a:extLst>
           </p:cNvPr>
@@ -4516,7 +4521,7 @@
           <p:cNvPr id="3" name="breadth-number">
             <a:extLst xmlns:a="http://schemas.openxmlformats.org/drawingml/2006/main">
               <a:ext uri="{FF2B5EF4-FFF2-40B4-BE49-F238E27FC236}">
-                <a16:creationId xmlns:a16="http://schemas.microsoft.com/office/drawing/2014/main" id="{5FEB13A1-D785-4DAC-9D1D-1BE68E2E78AD}"/>
+                <a16:creationId xmlns:a16="http://schemas.microsoft.com/office/drawing/2014/main" id="{7D4FBA11-CE42-44BE-AAF3-C77F3D554545}"/>
               </a:ext>
             </a:extLst>
           </p:cNvPr>
@@ -4562,7 +4567,7 @@
                 <a:ea typeface="Arial"/>
                 <a:cs typeface="Arial"/>
               </a:rPr>
-              <a:t>17</a:t>
+              <a:t>18</a:t>
             </a:r>
           </a:p>
         </p:txBody>
@@ -4572,7 +4577,7 @@
           <p:cNvPr id="4" name="breadth-caption">
             <a:extLst xmlns:a="http://schemas.openxmlformats.org/drawingml/2006/main">
               <a:ext uri="{FF2B5EF4-FFF2-40B4-BE49-F238E27FC236}">
-                <a16:creationId xmlns:a16="http://schemas.microsoft.com/office/drawing/2014/main" id="{68CAF65B-3EDE-41E8-A530-A84D6A678EC3}"/>
+                <a16:creationId xmlns:a16="http://schemas.microsoft.com/office/drawing/2014/main" id="{A35008DA-FCA4-4F35-A9F5-5890AF30702B}"/>
               </a:ext>
             </a:extLst>
           </p:cNvPr>
@@ -4674,7 +4679,7 @@
           <p:cNvPr id="5" name="breadth-divider">
             <a:extLst xmlns:a="http://schemas.openxmlformats.org/drawingml/2006/main">
               <a:ext uri="{FF2B5EF4-FFF2-40B4-BE49-F238E27FC236}">
-                <a16:creationId xmlns:a16="http://schemas.microsoft.com/office/drawing/2014/main" id="{4F3ADE46-BA98-4C85-97F2-AC6DCC1C5D34}"/>
+                <a16:creationId xmlns:a16="http://schemas.microsoft.com/office/drawing/2014/main" id="{7670F6E8-D88A-4CEE-8881-62E13C02D8BD}"/>
               </a:ext>
             </a:extLst>
           </p:cNvPr>
@@ -4705,7 +4710,7 @@
           <p:cNvPr id="6" name="breadth-item-rule-0">
             <a:extLst xmlns:a="http://schemas.openxmlformats.org/drawingml/2006/main">
               <a:ext uri="{FF2B5EF4-FFF2-40B4-BE49-F238E27FC236}">
-                <a16:creationId xmlns:a16="http://schemas.microsoft.com/office/drawing/2014/main" id="{0BF48DA9-DB50-4A11-AA09-14BCEB8F3B51}"/>
+                <a16:creationId xmlns:a16="http://schemas.microsoft.com/office/drawing/2014/main" id="{A7682FA0-E2B6-49B7-BA66-AD9E5CE99EF6}"/>
               </a:ext>
             </a:extLst>
           </p:cNvPr>
@@ -4736,7 +4741,7 @@
           <p:cNvPr id="7" name="breadth-item-0">
             <a:extLst xmlns:a="http://schemas.openxmlformats.org/drawingml/2006/main">
               <a:ext uri="{FF2B5EF4-FFF2-40B4-BE49-F238E27FC236}">
-                <a16:creationId xmlns:a16="http://schemas.microsoft.com/office/drawing/2014/main" id="{4A0DDE89-6668-4D81-9F6C-60C599F0D0D5}"/>
+                <a16:creationId xmlns:a16="http://schemas.microsoft.com/office/drawing/2014/main" id="{639DC8A4-E871-48DD-8A32-F81313FC0849}"/>
               </a:ext>
             </a:extLst>
           </p:cNvPr>
@@ -4782,7 +4787,7 @@
                 <a:ea typeface="Arial"/>
                 <a:cs typeface="Arial"/>
               </a:rPr>
-              <a:t>Word bank · Kelime bankası · Словарь</a:t>
+              <a:t>RU-EN dictionary · Sözlük · Словарь RU-EN</a:t>
             </a:r>
           </a:p>
         </p:txBody>
@@ -4792,7 +4797,7 @@
           <p:cNvPr id="8" name="breadth-item-rule-1">
             <a:extLst xmlns:a="http://schemas.openxmlformats.org/drawingml/2006/main">
               <a:ext uri="{FF2B5EF4-FFF2-40B4-BE49-F238E27FC236}">
-                <a16:creationId xmlns:a16="http://schemas.microsoft.com/office/drawing/2014/main" id="{0C79F47D-575C-4306-8AFB-C7F977419981}"/>
+                <a16:creationId xmlns:a16="http://schemas.microsoft.com/office/drawing/2014/main" id="{BDC4B821-F9A8-4FAF-A49B-DC7E68DF3805}"/>
               </a:ext>
             </a:extLst>
           </p:cNvPr>
@@ -4823,7 +4828,7 @@
           <p:cNvPr id="9" name="breadth-item-1">
             <a:extLst xmlns:a="http://schemas.openxmlformats.org/drawingml/2006/main">
               <a:ext uri="{FF2B5EF4-FFF2-40B4-BE49-F238E27FC236}">
-                <a16:creationId xmlns:a16="http://schemas.microsoft.com/office/drawing/2014/main" id="{7723828C-5B62-4757-966F-B8DFFD9790A3}"/>
+                <a16:creationId xmlns:a16="http://schemas.microsoft.com/office/drawing/2014/main" id="{727F445F-3B93-43CD-A8C2-5884B0F0F506}"/>
               </a:ext>
             </a:extLst>
           </p:cNvPr>
@@ -4869,7 +4874,7 @@
                 <a:ea typeface="Arial"/>
                 <a:cs typeface="Arial"/>
               </a:rPr>
-              <a:t>Grammar labs · Dilbilgisi laboratuvarı · Грамматика</a:t>
+              <a:t>Word bank &amp; grammar · Kelime bankası · Грамматика</a:t>
             </a:r>
           </a:p>
         </p:txBody>
@@ -4879,7 +4884,7 @@
           <p:cNvPr id="10" name="breadth-item-rule-2">
             <a:extLst xmlns:a="http://schemas.openxmlformats.org/drawingml/2006/main">
               <a:ext uri="{FF2B5EF4-FFF2-40B4-BE49-F238E27FC236}">
-                <a16:creationId xmlns:a16="http://schemas.microsoft.com/office/drawing/2014/main" id="{83093D72-19B5-4CF8-9463-EF9C7BD4969B}"/>
+                <a16:creationId xmlns:a16="http://schemas.microsoft.com/office/drawing/2014/main" id="{6230A6CC-EE22-47A6-877D-8CA63F23D0C4}"/>
               </a:ext>
             </a:extLst>
           </p:cNvPr>
@@ -4910,7 +4915,7 @@
           <p:cNvPr id="11" name="breadth-item-2">
             <a:extLst xmlns:a="http://schemas.openxmlformats.org/drawingml/2006/main">
               <a:ext uri="{FF2B5EF4-FFF2-40B4-BE49-F238E27FC236}">
-                <a16:creationId xmlns:a16="http://schemas.microsoft.com/office/drawing/2014/main" id="{9C4F229C-E22D-4840-A7B8-279EF7E8D130}"/>
+                <a16:creationId xmlns:a16="http://schemas.microsoft.com/office/drawing/2014/main" id="{71403011-DA6A-409A-A3B0-139C30751A13}"/>
               </a:ext>
             </a:extLst>
           </p:cNvPr>
@@ -4966,7 +4971,7 @@
           <p:cNvPr id="12" name="breadth-item-rule-3">
             <a:extLst xmlns:a="http://schemas.openxmlformats.org/drawingml/2006/main">
               <a:ext uri="{FF2B5EF4-FFF2-40B4-BE49-F238E27FC236}">
-                <a16:creationId xmlns:a16="http://schemas.microsoft.com/office/drawing/2014/main" id="{7C53DC3E-20FB-41E7-9DCC-1C6FAB2A2BD5}"/>
+                <a16:creationId xmlns:a16="http://schemas.microsoft.com/office/drawing/2014/main" id="{1AAD309E-6930-4357-AB15-C24252AF7BCA}"/>
               </a:ext>
             </a:extLst>
           </p:cNvPr>
@@ -4997,7 +5002,7 @@
           <p:cNvPr id="13" name="breadth-item-3">
             <a:extLst xmlns:a="http://schemas.openxmlformats.org/drawingml/2006/main">
               <a:ext uri="{FF2B5EF4-FFF2-40B4-BE49-F238E27FC236}">
-                <a16:creationId xmlns:a16="http://schemas.microsoft.com/office/drawing/2014/main" id="{B99A28C3-5186-4CBA-8950-06A5E2613A0B}"/>
+                <a16:creationId xmlns:a16="http://schemas.microsoft.com/office/drawing/2014/main" id="{5CA21408-75A8-43E1-A779-514F3B059CDF}"/>
               </a:ext>
             </a:extLst>
           </p:cNvPr>
@@ -5053,7 +5058,7 @@
           <p:cNvPr id="14" name="breadth-item-rule-4">
             <a:extLst xmlns:a="http://schemas.openxmlformats.org/drawingml/2006/main">
               <a:ext uri="{FF2B5EF4-FFF2-40B4-BE49-F238E27FC236}">
-                <a16:creationId xmlns:a16="http://schemas.microsoft.com/office/drawing/2014/main" id="{718F0F8D-9350-4051-981C-2513B6066485}"/>
+                <a16:creationId xmlns:a16="http://schemas.microsoft.com/office/drawing/2014/main" id="{11022A66-FABA-4D78-846F-393C26364E94}"/>
               </a:ext>
             </a:extLst>
           </p:cNvPr>
@@ -5084,7 +5089,7 @@
           <p:cNvPr id="15" name="breadth-item-4">
             <a:extLst xmlns:a="http://schemas.openxmlformats.org/drawingml/2006/main">
               <a:ext uri="{FF2B5EF4-FFF2-40B4-BE49-F238E27FC236}">
-                <a16:creationId xmlns:a16="http://schemas.microsoft.com/office/drawing/2014/main" id="{A25B442C-ADCC-4E19-A55C-81CDB2E88C8B}"/>
+                <a16:creationId xmlns:a16="http://schemas.microsoft.com/office/drawing/2014/main" id="{6515F35F-1965-4D49-A9BD-6BF16445EBF5}"/>
               </a:ext>
             </a:extLst>
           </p:cNvPr>
@@ -5140,7 +5145,7 @@
           <p:cNvPr id="16" name="breadth-item-rule-5">
             <a:extLst xmlns:a="http://schemas.openxmlformats.org/drawingml/2006/main">
               <a:ext uri="{FF2B5EF4-FFF2-40B4-BE49-F238E27FC236}">
-                <a16:creationId xmlns:a16="http://schemas.microsoft.com/office/drawing/2014/main" id="{143AFB30-C781-466E-A65E-D9B054DB1805}"/>
+                <a16:creationId xmlns:a16="http://schemas.microsoft.com/office/drawing/2014/main" id="{EBFAEFF3-450D-4884-BDBF-2893AF7A6CD9}"/>
               </a:ext>
             </a:extLst>
           </p:cNvPr>
@@ -5171,7 +5176,7 @@
           <p:cNvPr id="17" name="breadth-item-5">
             <a:extLst xmlns:a="http://schemas.openxmlformats.org/drawingml/2006/main">
               <a:ext uri="{FF2B5EF4-FFF2-40B4-BE49-F238E27FC236}">
-                <a16:creationId xmlns:a16="http://schemas.microsoft.com/office/drawing/2014/main" id="{0F836236-7C42-4E33-A5F4-0A54B173EAB9}"/>
+                <a16:creationId xmlns:a16="http://schemas.microsoft.com/office/drawing/2014/main" id="{665461E2-4DE9-459C-AABF-FCA7D69AF89E}"/>
               </a:ext>
             </a:extLst>
           </p:cNvPr>
@@ -5227,7 +5232,7 @@
           <p:cNvPr id="18" name="breadth-item-rule-6">
             <a:extLst xmlns:a="http://schemas.openxmlformats.org/drawingml/2006/main">
               <a:ext uri="{FF2B5EF4-FFF2-40B4-BE49-F238E27FC236}">
-                <a16:creationId xmlns:a16="http://schemas.microsoft.com/office/drawing/2014/main" id="{8B8F4AE9-06CF-42A5-B384-6F8648C946A3}"/>
+                <a16:creationId xmlns:a16="http://schemas.microsoft.com/office/drawing/2014/main" id="{55A5704D-21BC-49C8-9486-730D27AB653A}"/>
               </a:ext>
             </a:extLst>
           </p:cNvPr>
@@ -5258,7 +5263,7 @@
           <p:cNvPr id="19" name="breadth-item-6">
             <a:extLst xmlns:a="http://schemas.openxmlformats.org/drawingml/2006/main">
               <a:ext uri="{FF2B5EF4-FFF2-40B4-BE49-F238E27FC236}">
-                <a16:creationId xmlns:a16="http://schemas.microsoft.com/office/drawing/2014/main" id="{D99DACF6-067E-41D4-B6AC-6521039E78CE}"/>
+                <a16:creationId xmlns:a16="http://schemas.microsoft.com/office/drawing/2014/main" id="{52DE5BFA-B85A-4FAB-B258-EB80E0244B82}"/>
               </a:ext>
             </a:extLst>
           </p:cNvPr>
@@ -5314,7 +5319,7 @@
           <p:cNvPr id="20" name="footer-5">
             <a:extLst xmlns:a="http://schemas.openxmlformats.org/drawingml/2006/main">
               <a:ext uri="{FF2B5EF4-FFF2-40B4-BE49-F238E27FC236}">
-                <a16:creationId xmlns:a16="http://schemas.microsoft.com/office/drawing/2014/main" id="{B0B2F394-0AA0-4315-B169-2A0CE2C9B9EA}"/>
+                <a16:creationId xmlns:a16="http://schemas.microsoft.com/office/drawing/2014/main" id="{12BF5B2A-A69B-4DB8-AC34-A6957DDCEB32}"/>
               </a:ext>
             </a:extLst>
           </p:cNvPr>
@@ -5368,7 +5373,7 @@
     </p:spTree>
     <p:extLst>
       <p:ext uri="{BB962C8B-B14F-4D97-AF65-F5344CB8AC3E}">
-        <p14:creationId xmlns:p14="http://schemas.microsoft.com/office/powerpoint/2010/main" val="223721156"/>
+        <p14:creationId xmlns:p14="http://schemas.microsoft.com/office/powerpoint/2010/main" val="1753064886"/>
       </p:ext>
     </p:extLst>
   </p:cSld>
@@ -5399,7 +5404,7 @@
           <p:cNvPr id="12" name="privacy-title">
             <a:extLst xmlns:a="http://schemas.openxmlformats.org/drawingml/2006/main">
               <a:ext uri="{FF2B5EF4-FFF2-40B4-BE49-F238E27FC236}">
-                <a16:creationId xmlns:a16="http://schemas.microsoft.com/office/drawing/2014/main" id="{5722DF48-0B98-4E24-B2BE-4844BD4C7E06}"/>
+                <a16:creationId xmlns:a16="http://schemas.microsoft.com/office/drawing/2014/main" id="{0C8F351D-FB11-4F13-A8BF-E158FEE001F9}"/>
               </a:ext>
             </a:extLst>
           </p:cNvPr>
@@ -5455,7 +5460,7 @@
           <p:cNvPr id="2" name="privacy-tr">
             <a:extLst xmlns:a="http://schemas.openxmlformats.org/drawingml/2006/main">
               <a:ext uri="{FF2B5EF4-FFF2-40B4-BE49-F238E27FC236}">
-                <a16:creationId xmlns:a16="http://schemas.microsoft.com/office/drawing/2014/main" id="{4DD94E00-5700-4E79-AECB-B826AB4E60A2}"/>
+                <a16:creationId xmlns:a16="http://schemas.microsoft.com/office/drawing/2014/main" id="{541BDCBC-5DE7-476B-ACF5-FB11073F675E}"/>
               </a:ext>
             </a:extLst>
           </p:cNvPr>
@@ -5511,7 +5516,7 @@
           <p:cNvPr id="3" name="privacy-ru">
             <a:extLst xmlns:a="http://schemas.openxmlformats.org/drawingml/2006/main">
               <a:ext uri="{FF2B5EF4-FFF2-40B4-BE49-F238E27FC236}">
-                <a16:creationId xmlns:a16="http://schemas.microsoft.com/office/drawing/2014/main" id="{CA2CE190-6A7C-490D-9335-9F5F6B5F02B7}"/>
+                <a16:creationId xmlns:a16="http://schemas.microsoft.com/office/drawing/2014/main" id="{2671D5BC-6CC2-471C-9439-DD29E965B12C}"/>
               </a:ext>
             </a:extLst>
           </p:cNvPr>
@@ -5567,7 +5572,7 @@
           <p:cNvPr id="4" name="privacy-divider">
             <a:extLst xmlns:a="http://schemas.openxmlformats.org/drawingml/2006/main">
               <a:ext uri="{FF2B5EF4-FFF2-40B4-BE49-F238E27FC236}">
-                <a16:creationId xmlns:a16="http://schemas.microsoft.com/office/drawing/2014/main" id="{25E236AB-756D-444F-8C04-6B2E34666350}"/>
+                <a16:creationId xmlns:a16="http://schemas.microsoft.com/office/drawing/2014/main" id="{FA82800C-7C83-4924-8055-D7CF2070C4A5}"/>
               </a:ext>
             </a:extLst>
           </p:cNvPr>
@@ -5598,7 +5603,7 @@
           <p:cNvPr id="5" name="local-label">
             <a:extLst xmlns:a="http://schemas.openxmlformats.org/drawingml/2006/main">
               <a:ext uri="{FF2B5EF4-FFF2-40B4-BE49-F238E27FC236}">
-                <a16:creationId xmlns:a16="http://schemas.microsoft.com/office/drawing/2014/main" id="{5B70D2B8-FEAA-49B1-8562-484D08840A88}"/>
+                <a16:creationId xmlns:a16="http://schemas.microsoft.com/office/drawing/2014/main" id="{F63D4422-0900-46AB-8014-B3CF9C5DD684}"/>
               </a:ext>
             </a:extLst>
           </p:cNvPr>
@@ -5654,7 +5659,7 @@
           <p:cNvPr id="6" name="local-head">
             <a:extLst xmlns:a="http://schemas.openxmlformats.org/drawingml/2006/main">
               <a:ext uri="{FF2B5EF4-FFF2-40B4-BE49-F238E27FC236}">
-                <a16:creationId xmlns:a16="http://schemas.microsoft.com/office/drawing/2014/main" id="{EFD14CD2-D0E4-4FE6-BBFB-BCDBFB91D8AD}"/>
+                <a16:creationId xmlns:a16="http://schemas.microsoft.com/office/drawing/2014/main" id="{65D81A09-964C-41C2-BA00-910BDE961B8F}"/>
               </a:ext>
             </a:extLst>
           </p:cNvPr>
@@ -5710,7 +5715,7 @@
           <p:cNvPr id="7" name="local-copy">
             <a:extLst xmlns:a="http://schemas.openxmlformats.org/drawingml/2006/main">
               <a:ext uri="{FF2B5EF4-FFF2-40B4-BE49-F238E27FC236}">
-                <a16:creationId xmlns:a16="http://schemas.microsoft.com/office/drawing/2014/main" id="{BD32B1FC-E8AA-475A-B109-A536D2434249}"/>
+                <a16:creationId xmlns:a16="http://schemas.microsoft.com/office/drawing/2014/main" id="{88279E74-F92B-4380-A833-9BE4CE9F19E2}"/>
               </a:ext>
             </a:extLst>
           </p:cNvPr>
@@ -5840,7 +5845,7 @@
           <p:cNvPr id="8" name="optional-label">
             <a:extLst xmlns:a="http://schemas.openxmlformats.org/drawingml/2006/main">
               <a:ext uri="{FF2B5EF4-FFF2-40B4-BE49-F238E27FC236}">
-                <a16:creationId xmlns:a16="http://schemas.microsoft.com/office/drawing/2014/main" id="{8E456682-CC31-4A33-95F3-70C66A3F5823}"/>
+                <a16:creationId xmlns:a16="http://schemas.microsoft.com/office/drawing/2014/main" id="{3E3A4356-DDEB-4533-974C-851F1A67DD4D}"/>
               </a:ext>
             </a:extLst>
           </p:cNvPr>
@@ -5896,7 +5901,7 @@
           <p:cNvPr id="9" name="optional-head">
             <a:extLst xmlns:a="http://schemas.openxmlformats.org/drawingml/2006/main">
               <a:ext uri="{FF2B5EF4-FFF2-40B4-BE49-F238E27FC236}">
-                <a16:creationId xmlns:a16="http://schemas.microsoft.com/office/drawing/2014/main" id="{1E854F30-7CD0-4655-B638-C1053F86E7DD}"/>
+                <a16:creationId xmlns:a16="http://schemas.microsoft.com/office/drawing/2014/main" id="{7FF2489D-102D-4731-AC7E-8E90BCEA492D}"/>
               </a:ext>
             </a:extLst>
           </p:cNvPr>
@@ -5952,7 +5957,7 @@
           <p:cNvPr id="10" name="optional-copy">
             <a:extLst xmlns:a="http://schemas.openxmlformats.org/drawingml/2006/main">
               <a:ext uri="{FF2B5EF4-FFF2-40B4-BE49-F238E27FC236}">
-                <a16:creationId xmlns:a16="http://schemas.microsoft.com/office/drawing/2014/main" id="{29FAF81E-F393-4281-97A5-3CA5462E3574}"/>
+                <a16:creationId xmlns:a16="http://schemas.microsoft.com/office/drawing/2014/main" id="{E75346C0-3D5A-4E72-A437-B70A3E12FDAB}"/>
               </a:ext>
             </a:extLst>
           </p:cNvPr>
@@ -6082,7 +6087,7 @@
           <p:cNvPr id="11" name="footer-6">
             <a:extLst xmlns:a="http://schemas.openxmlformats.org/drawingml/2006/main">
               <a:ext uri="{FF2B5EF4-FFF2-40B4-BE49-F238E27FC236}">
-                <a16:creationId xmlns:a16="http://schemas.microsoft.com/office/drawing/2014/main" id="{3F5EB684-3C35-43E9-9302-7D6958E566B9}"/>
+                <a16:creationId xmlns:a16="http://schemas.microsoft.com/office/drawing/2014/main" id="{B99A7499-C901-4815-9264-8BEC3FE29FCF}"/>
               </a:ext>
             </a:extLst>
           </p:cNvPr>
@@ -6136,7 +6141,7 @@
     </p:spTree>
     <p:extLst>
       <p:ext uri="{BB962C8B-B14F-4D97-AF65-F5344CB8AC3E}">
-        <p14:creationId xmlns:p14="http://schemas.microsoft.com/office/powerpoint/2010/main" val="283387903"/>
+        <p14:creationId xmlns:p14="http://schemas.microsoft.com/office/powerpoint/2010/main" val="10108708"/>
       </p:ext>
     </p:extLst>
   </p:cSld>
@@ -6167,7 +6172,7 @@
           <p:cNvPr id="13" name="platform-title">
             <a:extLst xmlns:a="http://schemas.openxmlformats.org/drawingml/2006/main">
               <a:ext uri="{FF2B5EF4-FFF2-40B4-BE49-F238E27FC236}">
-                <a16:creationId xmlns:a16="http://schemas.microsoft.com/office/drawing/2014/main" id="{910C6908-AC17-4190-8351-FA648495865C}"/>
+                <a16:creationId xmlns:a16="http://schemas.microsoft.com/office/drawing/2014/main" id="{F439B40F-D930-47D8-8E2B-6FDC0DE7EFBB}"/>
               </a:ext>
             </a:extLst>
           </p:cNvPr>
@@ -6223,7 +6228,7 @@
           <p:cNvPr id="2" name="platform-subtitle">
             <a:extLst xmlns:a="http://schemas.openxmlformats.org/drawingml/2006/main">
               <a:ext uri="{FF2B5EF4-FFF2-40B4-BE49-F238E27FC236}">
-                <a16:creationId xmlns:a16="http://schemas.microsoft.com/office/drawing/2014/main" id="{7B8D01AF-F43D-4A39-AD7D-41D1D642B688}"/>
+                <a16:creationId xmlns:a16="http://schemas.microsoft.com/office/drawing/2014/main" id="{923C93EC-B59C-4995-9D1D-9C3B416D66C8}"/>
               </a:ext>
             </a:extLst>
           </p:cNvPr>
@@ -6279,7 +6284,7 @@
           <p:cNvPr id="3" name="platform-rule">
             <a:extLst xmlns:a="http://schemas.openxmlformats.org/drawingml/2006/main">
               <a:ext uri="{FF2B5EF4-FFF2-40B4-BE49-F238E27FC236}">
-                <a16:creationId xmlns:a16="http://schemas.microsoft.com/office/drawing/2014/main" id="{0C6910F4-3CBC-426A-B2DA-88D132EB381C}"/>
+                <a16:creationId xmlns:a16="http://schemas.microsoft.com/office/drawing/2014/main" id="{45867CCA-F079-42D0-9281-1A018B3A5B4D}"/>
               </a:ext>
             </a:extLst>
           </p:cNvPr>
@@ -6310,7 +6315,7 @@
           <p:cNvPr id="4" name="platform-label-0">
             <a:extLst xmlns:a="http://schemas.openxmlformats.org/drawingml/2006/main">
               <a:ext uri="{FF2B5EF4-FFF2-40B4-BE49-F238E27FC236}">
-                <a16:creationId xmlns:a16="http://schemas.microsoft.com/office/drawing/2014/main" id="{EB4FF3CF-F7B5-4401-87A6-74CD429A0117}"/>
+                <a16:creationId xmlns:a16="http://schemas.microsoft.com/office/drawing/2014/main" id="{A096C791-CF7C-487A-9522-BA31839A7F74}"/>
               </a:ext>
             </a:extLst>
           </p:cNvPr>
@@ -6366,7 +6371,7 @@
           <p:cNvPr id="5" name="platform-body-0">
             <a:extLst xmlns:a="http://schemas.openxmlformats.org/drawingml/2006/main">
               <a:ext uri="{FF2B5EF4-FFF2-40B4-BE49-F238E27FC236}">
-                <a16:creationId xmlns:a16="http://schemas.microsoft.com/office/drawing/2014/main" id="{81B58CC5-C08B-4274-A156-2EB00A62864A}"/>
+                <a16:creationId xmlns:a16="http://schemas.microsoft.com/office/drawing/2014/main" id="{774120D9-BE87-4CFF-9775-555E7E4A2060}"/>
               </a:ext>
             </a:extLst>
           </p:cNvPr>
@@ -6422,7 +6427,7 @@
           <p:cNvPr id="6" name="platform-label-1">
             <a:extLst xmlns:a="http://schemas.openxmlformats.org/drawingml/2006/main">
               <a:ext uri="{FF2B5EF4-FFF2-40B4-BE49-F238E27FC236}">
-                <a16:creationId xmlns:a16="http://schemas.microsoft.com/office/drawing/2014/main" id="{0EBAB476-AC0C-4060-A2A9-59D3A2E0FF66}"/>
+                <a16:creationId xmlns:a16="http://schemas.microsoft.com/office/drawing/2014/main" id="{E9202051-37C1-4780-8B44-2D863729ED19}"/>
               </a:ext>
             </a:extLst>
           </p:cNvPr>
@@ -6478,7 +6483,7 @@
           <p:cNvPr id="7" name="platform-body-1">
             <a:extLst xmlns:a="http://schemas.openxmlformats.org/drawingml/2006/main">
               <a:ext uri="{FF2B5EF4-FFF2-40B4-BE49-F238E27FC236}">
-                <a16:creationId xmlns:a16="http://schemas.microsoft.com/office/drawing/2014/main" id="{93AEB093-D362-41E5-9A50-14BA1C007B84}"/>
+                <a16:creationId xmlns:a16="http://schemas.microsoft.com/office/drawing/2014/main" id="{06E0ECD7-BBC0-4813-A45C-3C6E5D584FE6}"/>
               </a:ext>
             </a:extLst>
           </p:cNvPr>
@@ -6534,7 +6539,7 @@
           <p:cNvPr id="8" name="platform-label-2">
             <a:extLst xmlns:a="http://schemas.openxmlformats.org/drawingml/2006/main">
               <a:ext uri="{FF2B5EF4-FFF2-40B4-BE49-F238E27FC236}">
-                <a16:creationId xmlns:a16="http://schemas.microsoft.com/office/drawing/2014/main" id="{73589859-0222-4A5A-A90F-3304981018CF}"/>
+                <a16:creationId xmlns:a16="http://schemas.microsoft.com/office/drawing/2014/main" id="{5597AC4C-5459-4B6C-9748-46DB3D92E768}"/>
               </a:ext>
             </a:extLst>
           </p:cNvPr>
@@ -6590,7 +6595,7 @@
           <p:cNvPr id="9" name="platform-body-2">
             <a:extLst xmlns:a="http://schemas.openxmlformats.org/drawingml/2006/main">
               <a:ext uri="{FF2B5EF4-FFF2-40B4-BE49-F238E27FC236}">
-                <a16:creationId xmlns:a16="http://schemas.microsoft.com/office/drawing/2014/main" id="{A7AFC0E0-3348-443D-A3D2-B4E3362567E5}"/>
+                <a16:creationId xmlns:a16="http://schemas.microsoft.com/office/drawing/2014/main" id="{408A5175-C05C-47F4-8264-07E3A7DDDF1E}"/>
               </a:ext>
             </a:extLst>
           </p:cNvPr>
@@ -6646,7 +6651,7 @@
           <p:cNvPr id="10" name="platform-footnote-rule">
             <a:extLst xmlns:a="http://schemas.openxmlformats.org/drawingml/2006/main">
               <a:ext uri="{FF2B5EF4-FFF2-40B4-BE49-F238E27FC236}">
-                <a16:creationId xmlns:a16="http://schemas.microsoft.com/office/drawing/2014/main" id="{B39B1F51-522A-423E-A569-2ECF348E5DD6}"/>
+                <a16:creationId xmlns:a16="http://schemas.microsoft.com/office/drawing/2014/main" id="{FDF23EC5-F983-4369-91C6-886CEAA34DE9}"/>
               </a:ext>
             </a:extLst>
           </p:cNvPr>
@@ -6677,7 +6682,7 @@
           <p:cNvPr id="11" name="platform-footnote">
             <a:extLst xmlns:a="http://schemas.openxmlformats.org/drawingml/2006/main">
               <a:ext uri="{FF2B5EF4-FFF2-40B4-BE49-F238E27FC236}">
-                <a16:creationId xmlns:a16="http://schemas.microsoft.com/office/drawing/2014/main" id="{7019DDDB-2EC6-472E-BBBF-95442605B3C1}"/>
+                <a16:creationId xmlns:a16="http://schemas.microsoft.com/office/drawing/2014/main" id="{963E7E1F-ACC7-4915-A35C-E5DB85121FBC}"/>
               </a:ext>
             </a:extLst>
           </p:cNvPr>
@@ -6756,7 +6761,7 @@
           <p:cNvPr id="12" name="footer-7">
             <a:extLst xmlns:a="http://schemas.openxmlformats.org/drawingml/2006/main">
               <a:ext uri="{FF2B5EF4-FFF2-40B4-BE49-F238E27FC236}">
-                <a16:creationId xmlns:a16="http://schemas.microsoft.com/office/drawing/2014/main" id="{E84DCAAE-61F7-4686-9290-4D1777B681CC}"/>
+                <a16:creationId xmlns:a16="http://schemas.microsoft.com/office/drawing/2014/main" id="{1572955D-B69E-4353-9CC0-E3713A731494}"/>
               </a:ext>
             </a:extLst>
           </p:cNvPr>
@@ -6810,7 +6815,7 @@
     </p:spTree>
     <p:extLst>
       <p:ext uri="{BB962C8B-B14F-4D97-AF65-F5344CB8AC3E}">
-        <p14:creationId xmlns:p14="http://schemas.microsoft.com/office/powerpoint/2010/main" val="1141323186"/>
+        <p14:creationId xmlns:p14="http://schemas.microsoft.com/office/powerpoint/2010/main" val="406054369"/>
       </p:ext>
     </p:extLst>
   </p:cSld>
@@ -6841,7 +6846,7 @@
           <p:cNvPr id="9" name="close-kicker">
             <a:extLst xmlns:a="http://schemas.openxmlformats.org/drawingml/2006/main">
               <a:ext uri="{FF2B5EF4-FFF2-40B4-BE49-F238E27FC236}">
-                <a16:creationId xmlns:a16="http://schemas.microsoft.com/office/drawing/2014/main" id="{816F40FD-A321-4C2A-A20F-14FF24BB4D57}"/>
+                <a16:creationId xmlns:a16="http://schemas.microsoft.com/office/drawing/2014/main" id="{69805D43-A77C-43E6-A9E5-C1C94DDBA23B}"/>
               </a:ext>
             </a:extLst>
           </p:cNvPr>
@@ -6897,7 +6902,7 @@
           <p:cNvPr id="2" name="close-title">
             <a:extLst xmlns:a="http://schemas.openxmlformats.org/drawingml/2006/main">
               <a:ext uri="{FF2B5EF4-FFF2-40B4-BE49-F238E27FC236}">
-                <a16:creationId xmlns:a16="http://schemas.microsoft.com/office/drawing/2014/main" id="{3D7F8F60-86AF-4833-8CC6-35BE1C9D1EC7}"/>
+                <a16:creationId xmlns:a16="http://schemas.microsoft.com/office/drawing/2014/main" id="{EA9755D7-D60F-4A53-8F55-82E919351949}"/>
               </a:ext>
             </a:extLst>
           </p:cNvPr>
@@ -6976,7 +6981,7 @@
           <p:cNvPr id="3" name="close-tr">
             <a:extLst xmlns:a="http://schemas.openxmlformats.org/drawingml/2006/main">
               <a:ext uri="{FF2B5EF4-FFF2-40B4-BE49-F238E27FC236}">
-                <a16:creationId xmlns:a16="http://schemas.microsoft.com/office/drawing/2014/main" id="{B8D33F00-B2B9-445A-83ED-200518555999}"/>
+                <a16:creationId xmlns:a16="http://schemas.microsoft.com/office/drawing/2014/main" id="{D398432A-77D5-45B6-968A-0DC99599910F}"/>
               </a:ext>
             </a:extLst>
           </p:cNvPr>
@@ -7032,7 +7037,7 @@
           <p:cNvPr id="4" name="close-ru">
             <a:extLst xmlns:a="http://schemas.openxmlformats.org/drawingml/2006/main">
               <a:ext uri="{FF2B5EF4-FFF2-40B4-BE49-F238E27FC236}">
-                <a16:creationId xmlns:a16="http://schemas.microsoft.com/office/drawing/2014/main" id="{C7BE8B8E-4354-454D-ADDB-61414C633558}"/>
+                <a16:creationId xmlns:a16="http://schemas.microsoft.com/office/drawing/2014/main" id="{59B7B2B4-A21C-4D53-B268-7FB6C34BF102}"/>
               </a:ext>
             </a:extLst>
           </p:cNvPr>
@@ -7088,7 +7093,7 @@
           <p:cNvPr id="5" name="close-rule">
             <a:extLst xmlns:a="http://schemas.openxmlformats.org/drawingml/2006/main">
               <a:ext uri="{FF2B5EF4-FFF2-40B4-BE49-F238E27FC236}">
-                <a16:creationId xmlns:a16="http://schemas.microsoft.com/office/drawing/2014/main" id="{28792FC9-81A3-4FFA-8A5D-4B9E237CD0CB}"/>
+                <a16:creationId xmlns:a16="http://schemas.microsoft.com/office/drawing/2014/main" id="{96CE656F-6C37-430A-BF4E-3CFE720DC550}"/>
               </a:ext>
             </a:extLst>
           </p:cNvPr>
@@ -7119,7 +7124,7 @@
           <p:cNvPr id="6" name="close-action">
             <a:extLst xmlns:a="http://schemas.openxmlformats.org/drawingml/2006/main">
               <a:ext uri="{FF2B5EF4-FFF2-40B4-BE49-F238E27FC236}">
-                <a16:creationId xmlns:a16="http://schemas.microsoft.com/office/drawing/2014/main" id="{B8334B51-3DE3-4D8D-970B-F81385ADFF1B}"/>
+                <a16:creationId xmlns:a16="http://schemas.microsoft.com/office/drawing/2014/main" id="{617DEFEF-1F66-4724-B7AE-03C950E3C940}"/>
               </a:ext>
             </a:extLst>
           </p:cNvPr>
@@ -7175,7 +7180,7 @@
           <p:cNvPr id="7" name="close-meta">
             <a:extLst xmlns:a="http://schemas.openxmlformats.org/drawingml/2006/main">
               <a:ext uri="{FF2B5EF4-FFF2-40B4-BE49-F238E27FC236}">
-                <a16:creationId xmlns:a16="http://schemas.microsoft.com/office/drawing/2014/main" id="{F6ABEC4D-59F8-4B16-AD59-B93BD6ECACA4}"/>
+                <a16:creationId xmlns:a16="http://schemas.microsoft.com/office/drawing/2014/main" id="{C1911AC5-30EA-4974-BBEA-A31D9464DF10}"/>
               </a:ext>
             </a:extLst>
           </p:cNvPr>
@@ -7231,7 +7236,7 @@
           <p:cNvPr id="8" name="footer-8">
             <a:extLst xmlns:a="http://schemas.openxmlformats.org/drawingml/2006/main">
               <a:ext uri="{FF2B5EF4-FFF2-40B4-BE49-F238E27FC236}">
-                <a16:creationId xmlns:a16="http://schemas.microsoft.com/office/drawing/2014/main" id="{73C18654-1981-4717-834F-50E98B2143BC}"/>
+                <a16:creationId xmlns:a16="http://schemas.microsoft.com/office/drawing/2014/main" id="{8F04B4B7-F174-445A-8C0D-805470CFE1D6}"/>
               </a:ext>
             </a:extLst>
           </p:cNvPr>
@@ -7285,7 +7290,7 @@
     </p:spTree>
     <p:extLst>
       <p:ext uri="{BB962C8B-B14F-4D97-AF65-F5344CB8AC3E}">
-        <p14:creationId xmlns:p14="http://schemas.microsoft.com/office/powerpoint/2010/main" val="1076121641"/>
+        <p14:creationId xmlns:p14="http://schemas.microsoft.com/office/powerpoint/2010/main" val="138779937"/>
       </p:ext>
     </p:extLst>
   </p:cSld>

</xml_diff>

<commit_message>
Sunum ve README: v1.1.0 sozluk AI baglantisi, 130 test
Co-Authored-By: Claude Fable 5.1 <noreply@anthropic.com>
</commit_message>
<xml_diff>
--- a/docs/presentation/Russian-Course-AI-Trilingual.pptx
+++ b/docs/presentation/Russian-Course-AI-Trilingual.pptx
@@ -2,20 +2,20 @@
 <file path=ppt/presentation.xml><?xml version="1.0" encoding="utf-8"?>
 <p:presentation xmlns:p="http://schemas.openxmlformats.org/presentationml/2006/main">
   <p:sldMasterIdLst>
-    <p:sldMasterId xmlns:r="http://schemas.openxmlformats.org/officeDocument/2006/relationships" id="2147483648" r:id="R31ecbf68bc6c42a7"/>
+    <p:sldMasterId xmlns:r="http://schemas.openxmlformats.org/officeDocument/2006/relationships" id="2147483648" r:id="Rdda303e1dbf34df6"/>
   </p:sldMasterIdLst>
   <p:notesMasterIdLst>
-    <p:notesMasterId xmlns:r="http://schemas.openxmlformats.org/officeDocument/2006/relationships" r:id="R56a09616bb304f12"/>
+    <p:notesMasterId xmlns:r="http://schemas.openxmlformats.org/officeDocument/2006/relationships" r:id="Rd7e18220d6624dbb"/>
   </p:notesMasterIdLst>
   <p:sldIdLst>
-    <p:sldId xmlns:r="http://schemas.openxmlformats.org/officeDocument/2006/relationships" id="256" r:id="Ra4ae517dbcf549ed"/>
-    <p:sldId xmlns:r="http://schemas.openxmlformats.org/officeDocument/2006/relationships" id="257" r:id="Rc6ac401bf726469e"/>
-    <p:sldId xmlns:r="http://schemas.openxmlformats.org/officeDocument/2006/relationships" id="258" r:id="R1de2a49db295424a"/>
-    <p:sldId xmlns:r="http://schemas.openxmlformats.org/officeDocument/2006/relationships" id="259" r:id="R215763e5a91940f9"/>
-    <p:sldId xmlns:r="http://schemas.openxmlformats.org/officeDocument/2006/relationships" id="260" r:id="Rbe58fdae611e4301"/>
-    <p:sldId xmlns:r="http://schemas.openxmlformats.org/officeDocument/2006/relationships" id="261" r:id="R84099b912802467f"/>
-    <p:sldId xmlns:r="http://schemas.openxmlformats.org/officeDocument/2006/relationships" id="262" r:id="R73e8a04261154310"/>
-    <p:sldId xmlns:r="http://schemas.openxmlformats.org/officeDocument/2006/relationships" id="263" r:id="R027525fc6f2b4c18"/>
+    <p:sldId xmlns:r="http://schemas.openxmlformats.org/officeDocument/2006/relationships" id="256" r:id="Rad83a8c79b8a44be"/>
+    <p:sldId xmlns:r="http://schemas.openxmlformats.org/officeDocument/2006/relationships" id="257" r:id="R60c4377513cf4c09"/>
+    <p:sldId xmlns:r="http://schemas.openxmlformats.org/officeDocument/2006/relationships" id="258" r:id="R092a3d10efb9457f"/>
+    <p:sldId xmlns:r="http://schemas.openxmlformats.org/officeDocument/2006/relationships" id="259" r:id="R150e2a9b199745d6"/>
+    <p:sldId xmlns:r="http://schemas.openxmlformats.org/officeDocument/2006/relationships" id="260" r:id="Rca8a551ccd134d5a"/>
+    <p:sldId xmlns:r="http://schemas.openxmlformats.org/officeDocument/2006/relationships" id="261" r:id="R51b5537ac56e4967"/>
+    <p:sldId xmlns:r="http://schemas.openxmlformats.org/officeDocument/2006/relationships" id="262" r:id="Rb20fcda8d4c24bc9"/>
+    <p:sldId xmlns:r="http://schemas.openxmlformats.org/officeDocument/2006/relationships" id="263" r:id="R8c2e13b2f0734e57"/>
   </p:sldIdLst>
   <p:sldSz cx="12192000" cy="6858000"/>
   <p:notesSz cx="6858000" cy="9144000"/>
@@ -934,7 +934,7 @@
           </a:p>
           <a:p xmlns:a="http://schemas.openxmlformats.org/drawingml/2006/main">
             <a:r>
-              <a:t>- https://github.com/Azizsekerdil/RussianCourseAI/releases/tag/v1.0.0 (v1.0.0 release with Windows and macOS zip assets; private repository)</a:t>
+              <a:t>- https://github.com/Azizsekerdil/RussianCourseAI/releases/tag/v1.1.0 (v1.1.0 release with Windows and macOS zip assets; private repository)</a:t>
             </a:r>
           </a:p>
         </p:txBody>
@@ -1077,7 +1077,7 @@
   </p:cSld>
   <p:clrMap bg1="lt1" tx1="dk1" bg2="lt2" tx2="dk2" accent1="accent1" accent2="accent2" accent3="accent3" accent4="accent4" accent5="accent5" accent6="accent6" hlink="hlink" folHlink="folHlink"/>
   <p:sldLayoutIdLst>
-    <p:sldLayoutId xmlns:r="http://schemas.openxmlformats.org/officeDocument/2006/relationships" id="2147483649" r:id="R905ea14cbb014a05"/>
+    <p:sldLayoutId xmlns:r="http://schemas.openxmlformats.org/officeDocument/2006/relationships" id="2147483649" r:id="Rd7345f9e578f4ef1"/>
   </p:sldLayoutIdLst>
   <p:txStyles>
     <p:titleStyle>
@@ -1628,7 +1628,7 @@
           <p:cNvPr id="11" name="cover-kicker">
             <a:extLst xmlns:a="http://schemas.openxmlformats.org/drawingml/2006/main">
               <a:ext uri="{FF2B5EF4-FFF2-40B4-BE49-F238E27FC236}">
-                <a16:creationId xmlns:a16="http://schemas.microsoft.com/office/drawing/2014/main" id="{F9F6D61B-1520-4269-A9C5-6D3A3496E59E}"/>
+                <a16:creationId xmlns:a16="http://schemas.microsoft.com/office/drawing/2014/main" id="{FA2E78AA-ADB0-40F3-9053-480BCE7EB7F5}"/>
               </a:ext>
             </a:extLst>
           </p:cNvPr>
@@ -1684,7 +1684,7 @@
           <p:cNvPr id="2" name="cover-title">
             <a:extLst xmlns:a="http://schemas.openxmlformats.org/drawingml/2006/main">
               <a:ext uri="{FF2B5EF4-FFF2-40B4-BE49-F238E27FC236}">
-                <a16:creationId xmlns:a16="http://schemas.microsoft.com/office/drawing/2014/main" id="{CCCEB083-DE62-4169-A90E-6FDC2FCE7459}"/>
+                <a16:creationId xmlns:a16="http://schemas.microsoft.com/office/drawing/2014/main" id="{1764604F-4CD2-4F70-849B-BA4202694FD0}"/>
               </a:ext>
             </a:extLst>
           </p:cNvPr>
@@ -1763,7 +1763,7 @@
           <p:cNvPr id="3" name="cover-rule">
             <a:extLst xmlns:a="http://schemas.openxmlformats.org/drawingml/2006/main">
               <a:ext uri="{FF2B5EF4-FFF2-40B4-BE49-F238E27FC236}">
-                <a16:creationId xmlns:a16="http://schemas.microsoft.com/office/drawing/2014/main" id="{441DE338-4E5B-4D13-854D-99E25220F49D}"/>
+                <a16:creationId xmlns:a16="http://schemas.microsoft.com/office/drawing/2014/main" id="{AAFA670F-5B0D-42CD-BD0E-23F460A7D569}"/>
               </a:ext>
             </a:extLst>
           </p:cNvPr>
@@ -1794,7 +1794,7 @@
           <p:cNvPr id="4" name="cover-tr">
             <a:extLst xmlns:a="http://schemas.openxmlformats.org/drawingml/2006/main">
               <a:ext uri="{FF2B5EF4-FFF2-40B4-BE49-F238E27FC236}">
-                <a16:creationId xmlns:a16="http://schemas.microsoft.com/office/drawing/2014/main" id="{3BB32D6E-B2E6-4474-8B47-74FF68E14F30}"/>
+                <a16:creationId xmlns:a16="http://schemas.microsoft.com/office/drawing/2014/main" id="{424D4782-21CD-4D80-B284-D5B486F692E3}"/>
               </a:ext>
             </a:extLst>
           </p:cNvPr>
@@ -1850,7 +1850,7 @@
           <p:cNvPr id="5" name="cover-en">
             <a:extLst xmlns:a="http://schemas.openxmlformats.org/drawingml/2006/main">
               <a:ext uri="{FF2B5EF4-FFF2-40B4-BE49-F238E27FC236}">
-                <a16:creationId xmlns:a16="http://schemas.microsoft.com/office/drawing/2014/main" id="{849FE9E8-1A6C-43C5-99F9-ACE6F9FC86E2}"/>
+                <a16:creationId xmlns:a16="http://schemas.microsoft.com/office/drawing/2014/main" id="{21DFFEF4-86BC-4EC6-A62D-6E6F1C350C29}"/>
               </a:ext>
             </a:extLst>
           </p:cNvPr>
@@ -1906,7 +1906,7 @@
           <p:cNvPr id="6" name="cover-ru">
             <a:extLst xmlns:a="http://schemas.openxmlformats.org/drawingml/2006/main">
               <a:ext uri="{FF2B5EF4-FFF2-40B4-BE49-F238E27FC236}">
-                <a16:creationId xmlns:a16="http://schemas.microsoft.com/office/drawing/2014/main" id="{633C7317-3535-4467-8393-61964C259505}"/>
+                <a16:creationId xmlns:a16="http://schemas.microsoft.com/office/drawing/2014/main" id="{E802D3C0-8B48-4DCC-80DE-423CD0530460}"/>
               </a:ext>
             </a:extLst>
           </p:cNvPr>
@@ -1962,7 +1962,7 @@
           <p:cNvPr id="7" name="cover-meta">
             <a:extLst xmlns:a="http://schemas.openxmlformats.org/drawingml/2006/main">
               <a:ext uri="{FF2B5EF4-FFF2-40B4-BE49-F238E27FC236}">
-                <a16:creationId xmlns:a16="http://schemas.microsoft.com/office/drawing/2014/main" id="{34EB8052-D5C1-4BD1-8C01-9DCDCFDE61EB}"/>
+                <a16:creationId xmlns:a16="http://schemas.microsoft.com/office/drawing/2014/main" id="{DAE47443-7042-4CF8-B57D-DF8650AA1F71}"/>
               </a:ext>
             </a:extLst>
           </p:cNvPr>
@@ -2018,7 +2018,7 @@
           <p:cNvPr id="8" name="hero-backing">
             <a:extLst xmlns:a="http://schemas.openxmlformats.org/drawingml/2006/main">
               <a:ext uri="{FF2B5EF4-FFF2-40B4-BE49-F238E27FC236}">
-                <a16:creationId xmlns:a16="http://schemas.microsoft.com/office/drawing/2014/main" id="{A16AAC39-D834-4637-BEA3-0B6A129D6A5D}"/>
+                <a16:creationId xmlns:a16="http://schemas.microsoft.com/office/drawing/2014/main" id="{C7D14D16-7E08-41DA-B3CF-D3455A46243A}"/>
               </a:ext>
             </a:extLst>
           </p:cNvPr>
@@ -2055,7 +2055,7 @@
           <p:nvPr/>
         </p:nvPicPr>
         <p:blipFill>
-          <a:blip xmlns:r="http://schemas.openxmlformats.org/officeDocument/2006/relationships" xmlns:a="http://schemas.openxmlformats.org/drawingml/2006/main" r:embed="Rb59a7b61ad344c60"/>
+          <a:blip xmlns:r="http://schemas.openxmlformats.org/officeDocument/2006/relationships" xmlns:a="http://schemas.openxmlformats.org/drawingml/2006/main" r:embed="R9232f60bbee249de"/>
           <a:srcRect xmlns:a="http://schemas.openxmlformats.org/drawingml/2006/main" l="510" t="0" r="510" b="0"/>
           <a:stretch xmlns:a="http://schemas.openxmlformats.org/drawingml/2006/main">
             <a:fillRect l="0" t="0" r="0" b="0"/>
@@ -2078,7 +2078,7 @@
           <p:cNvPr id="10" name="footer-1">
             <a:extLst xmlns:a="http://schemas.openxmlformats.org/drawingml/2006/main">
               <a:ext uri="{FF2B5EF4-FFF2-40B4-BE49-F238E27FC236}">
-                <a16:creationId xmlns:a16="http://schemas.microsoft.com/office/drawing/2014/main" id="{DEC6A945-8154-4123-8B4A-9A50ED0E16CB}"/>
+                <a16:creationId xmlns:a16="http://schemas.microsoft.com/office/drawing/2014/main" id="{C0CB0369-E205-4086-B574-24F6B4526A11}"/>
               </a:ext>
             </a:extLst>
           </p:cNvPr>
@@ -2132,7 +2132,7 @@
     </p:spTree>
     <p:extLst>
       <p:ext uri="{BB962C8B-B14F-4D97-AF65-F5344CB8AC3E}">
-        <p14:creationId xmlns:p14="http://schemas.microsoft.com/office/powerpoint/2010/main" val="1369665739"/>
+        <p14:creationId xmlns:p14="http://schemas.microsoft.com/office/powerpoint/2010/main" val="1337296075"/>
       </p:ext>
     </p:extLst>
   </p:cSld>
@@ -2163,7 +2163,7 @@
           <p:cNvPr id="6" name="screen-title">
             <a:extLst xmlns:a="http://schemas.openxmlformats.org/drawingml/2006/main">
               <a:ext uri="{FF2B5EF4-FFF2-40B4-BE49-F238E27FC236}">
-                <a16:creationId xmlns:a16="http://schemas.microsoft.com/office/drawing/2014/main" id="{6C4EF357-4E1F-4543-9E8C-48B8B746AF41}"/>
+                <a16:creationId xmlns:a16="http://schemas.microsoft.com/office/drawing/2014/main" id="{15AC4472-2DCB-4E08-B56A-E206CBF2167F}"/>
               </a:ext>
             </a:extLst>
           </p:cNvPr>
@@ -2219,7 +2219,7 @@
           <p:cNvPr id="2" name="screen-subtitle">
             <a:extLst xmlns:a="http://schemas.openxmlformats.org/drawingml/2006/main">
               <a:ext uri="{FF2B5EF4-FFF2-40B4-BE49-F238E27FC236}">
-                <a16:creationId xmlns:a16="http://schemas.microsoft.com/office/drawing/2014/main" id="{008F7A36-F92A-4DC5-AD65-DDCB58D01B76}"/>
+                <a16:creationId xmlns:a16="http://schemas.microsoft.com/office/drawing/2014/main" id="{E77146A9-B30F-4B6D-B534-AAF56501ECB0}"/>
               </a:ext>
             </a:extLst>
           </p:cNvPr>
@@ -2275,7 +2275,7 @@
           <p:cNvPr id="3" name="screen-frame">
             <a:extLst xmlns:a="http://schemas.openxmlformats.org/drawingml/2006/main">
               <a:ext uri="{FF2B5EF4-FFF2-40B4-BE49-F238E27FC236}">
-                <a16:creationId xmlns:a16="http://schemas.microsoft.com/office/drawing/2014/main" id="{38F2D874-A4F6-4D45-AAE7-41173D279C75}"/>
+                <a16:creationId xmlns:a16="http://schemas.microsoft.com/office/drawing/2014/main" id="{CAAE8C81-FA1E-49AC-A74E-9F4545D72B7D}"/>
               </a:ext>
             </a:extLst>
           </p:cNvPr>
@@ -2312,7 +2312,7 @@
           <p:nvPr/>
         </p:nvPicPr>
         <p:blipFill>
-          <a:blip xmlns:r="http://schemas.openxmlformats.org/officeDocument/2006/relationships" xmlns:a="http://schemas.openxmlformats.org/drawingml/2006/main" r:embed="R3002548f094649ec"/>
+          <a:blip xmlns:r="http://schemas.openxmlformats.org/officeDocument/2006/relationships" xmlns:a="http://schemas.openxmlformats.org/drawingml/2006/main" r:embed="Rf2cf2a187854410e"/>
           <a:stretch xmlns:a="http://schemas.openxmlformats.org/drawingml/2006/main"/>
         </p:blipFill>
         <p:spPr>
@@ -2332,7 +2332,7 @@
           <p:cNvPr id="5" name="screen-footer">
             <a:extLst xmlns:a="http://schemas.openxmlformats.org/drawingml/2006/main">
               <a:ext uri="{FF2B5EF4-FFF2-40B4-BE49-F238E27FC236}">
-                <a16:creationId xmlns:a16="http://schemas.microsoft.com/office/drawing/2014/main" id="{1DD455E9-F5BF-4E21-9B1A-162E4E6B0D06}"/>
+                <a16:creationId xmlns:a16="http://schemas.microsoft.com/office/drawing/2014/main" id="{49247C33-6E50-4554-8A34-C531A9043949}"/>
               </a:ext>
             </a:extLst>
           </p:cNvPr>
@@ -2386,7 +2386,7 @@
     </p:spTree>
     <p:extLst>
       <p:ext uri="{BB962C8B-B14F-4D97-AF65-F5344CB8AC3E}">
-        <p14:creationId xmlns:p14="http://schemas.microsoft.com/office/powerpoint/2010/main" val="1039323642"/>
+        <p14:creationId xmlns:p14="http://schemas.microsoft.com/office/powerpoint/2010/main" val="395450409"/>
       </p:ext>
     </p:extLst>
   </p:cSld>
@@ -2417,7 +2417,7 @@
           <p:cNvPr id="17" name="language-title">
             <a:extLst xmlns:a="http://schemas.openxmlformats.org/drawingml/2006/main">
               <a:ext uri="{FF2B5EF4-FFF2-40B4-BE49-F238E27FC236}">
-                <a16:creationId xmlns:a16="http://schemas.microsoft.com/office/drawing/2014/main" id="{6480734B-1C1F-4913-9E6D-A8424B2C723D}"/>
+                <a16:creationId xmlns:a16="http://schemas.microsoft.com/office/drawing/2014/main" id="{440093F8-AC44-455E-99AB-0F25EF273CC3}"/>
               </a:ext>
             </a:extLst>
           </p:cNvPr>
@@ -2473,7 +2473,7 @@
           <p:cNvPr id="2" name="language-subtitle">
             <a:extLst xmlns:a="http://schemas.openxmlformats.org/drawingml/2006/main">
               <a:ext uri="{FF2B5EF4-FFF2-40B4-BE49-F238E27FC236}">
-                <a16:creationId xmlns:a16="http://schemas.microsoft.com/office/drawing/2014/main" id="{C3A209B5-06EE-4B3B-90E3-8FE61F08279A}"/>
+                <a16:creationId xmlns:a16="http://schemas.microsoft.com/office/drawing/2014/main" id="{51D15597-18BD-443B-B32F-29B69CA73F9B}"/>
               </a:ext>
             </a:extLst>
           </p:cNvPr>
@@ -2529,7 +2529,7 @@
           <p:cNvPr id="3" name="language-rule">
             <a:extLst xmlns:a="http://schemas.openxmlformats.org/drawingml/2006/main">
               <a:ext uri="{FF2B5EF4-FFF2-40B4-BE49-F238E27FC236}">
-                <a16:creationId xmlns:a16="http://schemas.microsoft.com/office/drawing/2014/main" id="{B8619A0E-9E32-4557-B78F-B36403C38ED6}"/>
+                <a16:creationId xmlns:a16="http://schemas.microsoft.com/office/drawing/2014/main" id="{EBF95ED9-7D62-49C9-94F2-1243B96DF7E6}"/>
               </a:ext>
             </a:extLst>
           </p:cNvPr>
@@ -2560,7 +2560,7 @@
           <p:cNvPr id="4" name="language-label-0">
             <a:extLst xmlns:a="http://schemas.openxmlformats.org/drawingml/2006/main">
               <a:ext uri="{FF2B5EF4-FFF2-40B4-BE49-F238E27FC236}">
-                <a16:creationId xmlns:a16="http://schemas.microsoft.com/office/drawing/2014/main" id="{AD07BB39-E994-4330-8040-8388A2FCC8AB}"/>
+                <a16:creationId xmlns:a16="http://schemas.microsoft.com/office/drawing/2014/main" id="{217B55B9-3676-4804-BE3D-8F0470732AFB}"/>
               </a:ext>
             </a:extLst>
           </p:cNvPr>
@@ -2616,7 +2616,7 @@
           <p:cNvPr id="5" name="language-head-0">
             <a:extLst xmlns:a="http://schemas.openxmlformats.org/drawingml/2006/main">
               <a:ext uri="{FF2B5EF4-FFF2-40B4-BE49-F238E27FC236}">
-                <a16:creationId xmlns:a16="http://schemas.microsoft.com/office/drawing/2014/main" id="{597FA501-70D8-4400-9350-4AD734C972A0}"/>
+                <a16:creationId xmlns:a16="http://schemas.microsoft.com/office/drawing/2014/main" id="{6FC7C610-BB8A-4AE1-BFF1-79855F95893A}"/>
               </a:ext>
             </a:extLst>
           </p:cNvPr>
@@ -2672,7 +2672,7 @@
           <p:cNvPr id="6" name="language-body-0">
             <a:extLst xmlns:a="http://schemas.openxmlformats.org/drawingml/2006/main">
               <a:ext uri="{FF2B5EF4-FFF2-40B4-BE49-F238E27FC236}">
-                <a16:creationId xmlns:a16="http://schemas.microsoft.com/office/drawing/2014/main" id="{68F7FC22-9450-4A0E-BEF5-8FCED1EE8B62}"/>
+                <a16:creationId xmlns:a16="http://schemas.microsoft.com/office/drawing/2014/main" id="{2AB0DABF-528B-4D8F-BBC6-956C1C21C533}"/>
               </a:ext>
             </a:extLst>
           </p:cNvPr>
@@ -2728,7 +2728,7 @@
           <p:cNvPr id="7" name="language-accent-0">
             <a:extLst xmlns:a="http://schemas.openxmlformats.org/drawingml/2006/main">
               <a:ext uri="{FF2B5EF4-FFF2-40B4-BE49-F238E27FC236}">
-                <a16:creationId xmlns:a16="http://schemas.microsoft.com/office/drawing/2014/main" id="{46621889-5A35-4C51-9D57-58266EE61FE3}"/>
+                <a16:creationId xmlns:a16="http://schemas.microsoft.com/office/drawing/2014/main" id="{1AE6F125-7FCE-4188-8A0B-B7BCFD20DA00}"/>
               </a:ext>
             </a:extLst>
           </p:cNvPr>
@@ -2759,7 +2759,7 @@
           <p:cNvPr id="8" name="language-label-1">
             <a:extLst xmlns:a="http://schemas.openxmlformats.org/drawingml/2006/main">
               <a:ext uri="{FF2B5EF4-FFF2-40B4-BE49-F238E27FC236}">
-                <a16:creationId xmlns:a16="http://schemas.microsoft.com/office/drawing/2014/main" id="{A56D52AF-0840-4ECA-8716-F6ACBBD356E3}"/>
+                <a16:creationId xmlns:a16="http://schemas.microsoft.com/office/drawing/2014/main" id="{EEB4EBBF-60FB-4B9B-A62E-A601C783A20F}"/>
               </a:ext>
             </a:extLst>
           </p:cNvPr>
@@ -2815,7 +2815,7 @@
           <p:cNvPr id="9" name="language-head-1">
             <a:extLst xmlns:a="http://schemas.openxmlformats.org/drawingml/2006/main">
               <a:ext uri="{FF2B5EF4-FFF2-40B4-BE49-F238E27FC236}">
-                <a16:creationId xmlns:a16="http://schemas.microsoft.com/office/drawing/2014/main" id="{B525A8DC-3F16-4604-A60F-682BBA7BD3D2}"/>
+                <a16:creationId xmlns:a16="http://schemas.microsoft.com/office/drawing/2014/main" id="{C51E1E0C-0E7E-4792-931B-9A06BAF8F3AA}"/>
               </a:ext>
             </a:extLst>
           </p:cNvPr>
@@ -2871,7 +2871,7 @@
           <p:cNvPr id="10" name="language-body-1">
             <a:extLst xmlns:a="http://schemas.openxmlformats.org/drawingml/2006/main">
               <a:ext uri="{FF2B5EF4-FFF2-40B4-BE49-F238E27FC236}">
-                <a16:creationId xmlns:a16="http://schemas.microsoft.com/office/drawing/2014/main" id="{29E49180-3942-40DD-A1EF-3BDCDA02D64A}"/>
+                <a16:creationId xmlns:a16="http://schemas.microsoft.com/office/drawing/2014/main" id="{DE205E8A-973F-4422-9CA9-4BFCB2E394E7}"/>
               </a:ext>
             </a:extLst>
           </p:cNvPr>
@@ -2927,7 +2927,7 @@
           <p:cNvPr id="11" name="language-accent-1">
             <a:extLst xmlns:a="http://schemas.openxmlformats.org/drawingml/2006/main">
               <a:ext uri="{FF2B5EF4-FFF2-40B4-BE49-F238E27FC236}">
-                <a16:creationId xmlns:a16="http://schemas.microsoft.com/office/drawing/2014/main" id="{5FB7E42D-0872-4667-82A5-CE17A09E807A}"/>
+                <a16:creationId xmlns:a16="http://schemas.microsoft.com/office/drawing/2014/main" id="{D3A12B90-993C-4F3E-BA54-05131D4E4D94}"/>
               </a:ext>
             </a:extLst>
           </p:cNvPr>
@@ -2958,7 +2958,7 @@
           <p:cNvPr id="12" name="language-label-2">
             <a:extLst xmlns:a="http://schemas.openxmlformats.org/drawingml/2006/main">
               <a:ext uri="{FF2B5EF4-FFF2-40B4-BE49-F238E27FC236}">
-                <a16:creationId xmlns:a16="http://schemas.microsoft.com/office/drawing/2014/main" id="{4E20ED44-C398-4021-B643-57CA1AE394C8}"/>
+                <a16:creationId xmlns:a16="http://schemas.microsoft.com/office/drawing/2014/main" id="{CEA8DEF4-9939-4A0E-BF93-DB961F29BF7A}"/>
               </a:ext>
             </a:extLst>
           </p:cNvPr>
@@ -3014,7 +3014,7 @@
           <p:cNvPr id="13" name="language-head-2">
             <a:extLst xmlns:a="http://schemas.openxmlformats.org/drawingml/2006/main">
               <a:ext uri="{FF2B5EF4-FFF2-40B4-BE49-F238E27FC236}">
-                <a16:creationId xmlns:a16="http://schemas.microsoft.com/office/drawing/2014/main" id="{0FD12518-B0A2-4A2A-A528-C7BB780003D7}"/>
+                <a16:creationId xmlns:a16="http://schemas.microsoft.com/office/drawing/2014/main" id="{3A1BAB5C-AABE-4D02-9411-43B2A2002FCF}"/>
               </a:ext>
             </a:extLst>
           </p:cNvPr>
@@ -3070,7 +3070,7 @@
           <p:cNvPr id="14" name="language-body-2">
             <a:extLst xmlns:a="http://schemas.openxmlformats.org/drawingml/2006/main">
               <a:ext uri="{FF2B5EF4-FFF2-40B4-BE49-F238E27FC236}">
-                <a16:creationId xmlns:a16="http://schemas.microsoft.com/office/drawing/2014/main" id="{739AF704-3A5B-4B1D-90BE-EFF2D24D41A9}"/>
+                <a16:creationId xmlns:a16="http://schemas.microsoft.com/office/drawing/2014/main" id="{4003A8FB-D169-430B-8041-29DADE6B5024}"/>
               </a:ext>
             </a:extLst>
           </p:cNvPr>
@@ -3126,7 +3126,7 @@
           <p:cNvPr id="15" name="language-accent-2">
             <a:extLst xmlns:a="http://schemas.openxmlformats.org/drawingml/2006/main">
               <a:ext uri="{FF2B5EF4-FFF2-40B4-BE49-F238E27FC236}">
-                <a16:creationId xmlns:a16="http://schemas.microsoft.com/office/drawing/2014/main" id="{33C38677-ECDB-4AA4-B3BF-DF5F4A8EF033}"/>
+                <a16:creationId xmlns:a16="http://schemas.microsoft.com/office/drawing/2014/main" id="{1B0A4E81-3945-4FA9-9424-177B00A77344}"/>
               </a:ext>
             </a:extLst>
           </p:cNvPr>
@@ -3157,7 +3157,7 @@
           <p:cNvPr id="16" name="footer-3">
             <a:extLst xmlns:a="http://schemas.openxmlformats.org/drawingml/2006/main">
               <a:ext uri="{FF2B5EF4-FFF2-40B4-BE49-F238E27FC236}">
-                <a16:creationId xmlns:a16="http://schemas.microsoft.com/office/drawing/2014/main" id="{03800D57-FE3B-4C08-B574-F27003DFC76A}"/>
+                <a16:creationId xmlns:a16="http://schemas.microsoft.com/office/drawing/2014/main" id="{086EFC5B-312C-45C8-A570-91CB45728C60}"/>
               </a:ext>
             </a:extLst>
           </p:cNvPr>
@@ -3211,7 +3211,7 @@
     </p:spTree>
     <p:extLst>
       <p:ext uri="{BB962C8B-B14F-4D97-AF65-F5344CB8AC3E}">
-        <p14:creationId xmlns:p14="http://schemas.microsoft.com/office/powerpoint/2010/main" val="1225554762"/>
+        <p14:creationId xmlns:p14="http://schemas.microsoft.com/office/powerpoint/2010/main" val="2075826246"/>
       </p:ext>
     </p:extLst>
   </p:cSld>
@@ -3242,7 +3242,7 @@
           <p:cNvPr id="23" name="loop-title">
             <a:extLst xmlns:a="http://schemas.openxmlformats.org/drawingml/2006/main">
               <a:ext uri="{FF2B5EF4-FFF2-40B4-BE49-F238E27FC236}">
-                <a16:creationId xmlns:a16="http://schemas.microsoft.com/office/drawing/2014/main" id="{9187F4E2-19AC-44AD-AC64-93B972F9C38C}"/>
+                <a16:creationId xmlns:a16="http://schemas.microsoft.com/office/drawing/2014/main" id="{D7DE8AA7-ABBC-4809-B572-CE22CA30835B}"/>
               </a:ext>
             </a:extLst>
           </p:cNvPr>
@@ -3298,7 +3298,7 @@
           <p:cNvPr id="2" name="loop-subtitle">
             <a:extLst xmlns:a="http://schemas.openxmlformats.org/drawingml/2006/main">
               <a:ext uri="{FF2B5EF4-FFF2-40B4-BE49-F238E27FC236}">
-                <a16:creationId xmlns:a16="http://schemas.microsoft.com/office/drawing/2014/main" id="{ECED97E8-936E-46D8-8878-AC0FA8A9E918}"/>
+                <a16:creationId xmlns:a16="http://schemas.microsoft.com/office/drawing/2014/main" id="{5C826392-C2BA-483C-9F03-C18D9B5DCE1F}"/>
               </a:ext>
             </a:extLst>
           </p:cNvPr>
@@ -3354,7 +3354,7 @@
           <p:cNvPr id="3" name="loop-track">
             <a:extLst xmlns:a="http://schemas.openxmlformats.org/drawingml/2006/main">
               <a:ext uri="{FF2B5EF4-FFF2-40B4-BE49-F238E27FC236}">
-                <a16:creationId xmlns:a16="http://schemas.microsoft.com/office/drawing/2014/main" id="{7615B780-CFD9-492A-A593-8A098589679A}"/>
+                <a16:creationId xmlns:a16="http://schemas.microsoft.com/office/drawing/2014/main" id="{3F034F78-2248-41F4-BE25-F5EE59651562}"/>
               </a:ext>
             </a:extLst>
           </p:cNvPr>
@@ -3385,7 +3385,7 @@
           <p:cNvPr id="4" name="loop-node-0">
             <a:extLst xmlns:a="http://schemas.openxmlformats.org/drawingml/2006/main">
               <a:ext uri="{FF2B5EF4-FFF2-40B4-BE49-F238E27FC236}">
-                <a16:creationId xmlns:a16="http://schemas.microsoft.com/office/drawing/2014/main" id="{FDD52061-68D8-4682-9C6A-091F24727471}"/>
+                <a16:creationId xmlns:a16="http://schemas.microsoft.com/office/drawing/2014/main" id="{F8D64DB1-C1BB-4C80-A9CF-21C0E66AB789}"/>
               </a:ext>
             </a:extLst>
           </p:cNvPr>
@@ -3418,7 +3418,7 @@
           <p:cNvPr id="5" name="loop-number-0">
             <a:extLst xmlns:a="http://schemas.openxmlformats.org/drawingml/2006/main">
               <a:ext uri="{FF2B5EF4-FFF2-40B4-BE49-F238E27FC236}">
-                <a16:creationId xmlns:a16="http://schemas.microsoft.com/office/drawing/2014/main" id="{3E7904A1-4EB3-4493-B903-F09B657F2EBD}"/>
+                <a16:creationId xmlns:a16="http://schemas.microsoft.com/office/drawing/2014/main" id="{24CB0380-27C1-4906-ADAA-297C54DAF3B9}"/>
               </a:ext>
             </a:extLst>
           </p:cNvPr>
@@ -3474,7 +3474,7 @@
           <p:cNvPr id="6" name="loop-en-0">
             <a:extLst xmlns:a="http://schemas.openxmlformats.org/drawingml/2006/main">
               <a:ext uri="{FF2B5EF4-FFF2-40B4-BE49-F238E27FC236}">
-                <a16:creationId xmlns:a16="http://schemas.microsoft.com/office/drawing/2014/main" id="{C005F00F-C6C2-4853-8313-B8071122C718}"/>
+                <a16:creationId xmlns:a16="http://schemas.microsoft.com/office/drawing/2014/main" id="{E53134DA-B1E5-4CF5-8540-D0E65F02609C}"/>
               </a:ext>
             </a:extLst>
           </p:cNvPr>
@@ -3530,7 +3530,7 @@
           <p:cNvPr id="7" name="loop-tr-0">
             <a:extLst xmlns:a="http://schemas.openxmlformats.org/drawingml/2006/main">
               <a:ext uri="{FF2B5EF4-FFF2-40B4-BE49-F238E27FC236}">
-                <a16:creationId xmlns:a16="http://schemas.microsoft.com/office/drawing/2014/main" id="{D17C7CF5-8DDD-4EE3-9104-317EF4D47EF9}"/>
+                <a16:creationId xmlns:a16="http://schemas.microsoft.com/office/drawing/2014/main" id="{DF22190B-179E-4374-A21B-C2EDCCA5FAED}"/>
               </a:ext>
             </a:extLst>
           </p:cNvPr>
@@ -3586,7 +3586,7 @@
           <p:cNvPr id="8" name="loop-ru-0">
             <a:extLst xmlns:a="http://schemas.openxmlformats.org/drawingml/2006/main">
               <a:ext uri="{FF2B5EF4-FFF2-40B4-BE49-F238E27FC236}">
-                <a16:creationId xmlns:a16="http://schemas.microsoft.com/office/drawing/2014/main" id="{BC16E0A0-07D1-4EA4-A44E-68AAB5DADDB9}"/>
+                <a16:creationId xmlns:a16="http://schemas.microsoft.com/office/drawing/2014/main" id="{7EEB0C32-7240-4FCB-97A1-8FD2F85A6282}"/>
               </a:ext>
             </a:extLst>
           </p:cNvPr>
@@ -3642,7 +3642,7 @@
           <p:cNvPr id="9" name="loop-detail-0">
             <a:extLst xmlns:a="http://schemas.openxmlformats.org/drawingml/2006/main">
               <a:ext uri="{FF2B5EF4-FFF2-40B4-BE49-F238E27FC236}">
-                <a16:creationId xmlns:a16="http://schemas.microsoft.com/office/drawing/2014/main" id="{58C1AE5A-F4FD-406B-9147-FDA9752B9ECB}"/>
+                <a16:creationId xmlns:a16="http://schemas.microsoft.com/office/drawing/2014/main" id="{7918DA9E-4CA1-48D8-AF01-85B69DACE840}"/>
               </a:ext>
             </a:extLst>
           </p:cNvPr>
@@ -3698,7 +3698,7 @@
           <p:cNvPr id="10" name="loop-node-1">
             <a:extLst xmlns:a="http://schemas.openxmlformats.org/drawingml/2006/main">
               <a:ext uri="{FF2B5EF4-FFF2-40B4-BE49-F238E27FC236}">
-                <a16:creationId xmlns:a16="http://schemas.microsoft.com/office/drawing/2014/main" id="{FA1D9C04-2851-4CEA-97F2-B102879062A0}"/>
+                <a16:creationId xmlns:a16="http://schemas.microsoft.com/office/drawing/2014/main" id="{8610EE8A-5357-4EF0-B779-6F73FA05C763}"/>
               </a:ext>
             </a:extLst>
           </p:cNvPr>
@@ -3731,7 +3731,7 @@
           <p:cNvPr id="11" name="loop-number-1">
             <a:extLst xmlns:a="http://schemas.openxmlformats.org/drawingml/2006/main">
               <a:ext uri="{FF2B5EF4-FFF2-40B4-BE49-F238E27FC236}">
-                <a16:creationId xmlns:a16="http://schemas.microsoft.com/office/drawing/2014/main" id="{F58EA130-C526-4F39-9B67-A4AEA0C08F88}"/>
+                <a16:creationId xmlns:a16="http://schemas.microsoft.com/office/drawing/2014/main" id="{E7E1F702-0C65-477A-866F-31AFBA62C8D4}"/>
               </a:ext>
             </a:extLst>
           </p:cNvPr>
@@ -3787,7 +3787,7 @@
           <p:cNvPr id="12" name="loop-en-1">
             <a:extLst xmlns:a="http://schemas.openxmlformats.org/drawingml/2006/main">
               <a:ext uri="{FF2B5EF4-FFF2-40B4-BE49-F238E27FC236}">
-                <a16:creationId xmlns:a16="http://schemas.microsoft.com/office/drawing/2014/main" id="{5EA86DC0-A757-4A04-92DE-3FA8D169C200}"/>
+                <a16:creationId xmlns:a16="http://schemas.microsoft.com/office/drawing/2014/main" id="{83825AF1-640D-47E9-9360-16F14DAB49F2}"/>
               </a:ext>
             </a:extLst>
           </p:cNvPr>
@@ -3843,7 +3843,7 @@
           <p:cNvPr id="13" name="loop-tr-1">
             <a:extLst xmlns:a="http://schemas.openxmlformats.org/drawingml/2006/main">
               <a:ext uri="{FF2B5EF4-FFF2-40B4-BE49-F238E27FC236}">
-                <a16:creationId xmlns:a16="http://schemas.microsoft.com/office/drawing/2014/main" id="{35AAA694-42E5-47D1-AAAC-1A34301A3C24}"/>
+                <a16:creationId xmlns:a16="http://schemas.microsoft.com/office/drawing/2014/main" id="{5B03BD07-1C0A-46DB-8D3D-86660135186E}"/>
               </a:ext>
             </a:extLst>
           </p:cNvPr>
@@ -3899,7 +3899,7 @@
           <p:cNvPr id="14" name="loop-ru-1">
             <a:extLst xmlns:a="http://schemas.openxmlformats.org/drawingml/2006/main">
               <a:ext uri="{FF2B5EF4-FFF2-40B4-BE49-F238E27FC236}">
-                <a16:creationId xmlns:a16="http://schemas.microsoft.com/office/drawing/2014/main" id="{A7CF54C7-E807-44A2-AA11-FEA3E14CE521}"/>
+                <a16:creationId xmlns:a16="http://schemas.microsoft.com/office/drawing/2014/main" id="{07D3D216-5D06-44D1-93A7-8C424B9C5DA3}"/>
               </a:ext>
             </a:extLst>
           </p:cNvPr>
@@ -3955,7 +3955,7 @@
           <p:cNvPr id="15" name="loop-detail-1">
             <a:extLst xmlns:a="http://schemas.openxmlformats.org/drawingml/2006/main">
               <a:ext uri="{FF2B5EF4-FFF2-40B4-BE49-F238E27FC236}">
-                <a16:creationId xmlns:a16="http://schemas.microsoft.com/office/drawing/2014/main" id="{8CAFDF4B-4B4E-4CF0-862A-93464B98D7B6}"/>
+                <a16:creationId xmlns:a16="http://schemas.microsoft.com/office/drawing/2014/main" id="{FB1D984E-BEAD-4B05-9605-EAABBBD52D54}"/>
               </a:ext>
             </a:extLst>
           </p:cNvPr>
@@ -4011,7 +4011,7 @@
           <p:cNvPr id="16" name="loop-node-2">
             <a:extLst xmlns:a="http://schemas.openxmlformats.org/drawingml/2006/main">
               <a:ext uri="{FF2B5EF4-FFF2-40B4-BE49-F238E27FC236}">
-                <a16:creationId xmlns:a16="http://schemas.microsoft.com/office/drawing/2014/main" id="{CA56FBE4-06F6-45D3-BED6-726B8CE2CC95}"/>
+                <a16:creationId xmlns:a16="http://schemas.microsoft.com/office/drawing/2014/main" id="{3FDE15C6-39A7-40FE-9531-4F2AADF4710C}"/>
               </a:ext>
             </a:extLst>
           </p:cNvPr>
@@ -4044,7 +4044,7 @@
           <p:cNvPr id="17" name="loop-number-2">
             <a:extLst xmlns:a="http://schemas.openxmlformats.org/drawingml/2006/main">
               <a:ext uri="{FF2B5EF4-FFF2-40B4-BE49-F238E27FC236}">
-                <a16:creationId xmlns:a16="http://schemas.microsoft.com/office/drawing/2014/main" id="{27026BB7-D59A-4A3F-B122-D3ED50924601}"/>
+                <a16:creationId xmlns:a16="http://schemas.microsoft.com/office/drawing/2014/main" id="{0858015D-2B76-4C1D-AC8C-B67FBEA8417D}"/>
               </a:ext>
             </a:extLst>
           </p:cNvPr>
@@ -4100,7 +4100,7 @@
           <p:cNvPr id="18" name="loop-en-2">
             <a:extLst xmlns:a="http://schemas.openxmlformats.org/drawingml/2006/main">
               <a:ext uri="{FF2B5EF4-FFF2-40B4-BE49-F238E27FC236}">
-                <a16:creationId xmlns:a16="http://schemas.microsoft.com/office/drawing/2014/main" id="{D7F4D846-5EE1-4015-A2AD-02003A063D5C}"/>
+                <a16:creationId xmlns:a16="http://schemas.microsoft.com/office/drawing/2014/main" id="{CFCA8C51-486F-4236-940A-B9F2CA919AB2}"/>
               </a:ext>
             </a:extLst>
           </p:cNvPr>
@@ -4156,7 +4156,7 @@
           <p:cNvPr id="19" name="loop-tr-2">
             <a:extLst xmlns:a="http://schemas.openxmlformats.org/drawingml/2006/main">
               <a:ext uri="{FF2B5EF4-FFF2-40B4-BE49-F238E27FC236}">
-                <a16:creationId xmlns:a16="http://schemas.microsoft.com/office/drawing/2014/main" id="{E45C12B4-71A1-443E-8053-F802DE03D838}"/>
+                <a16:creationId xmlns:a16="http://schemas.microsoft.com/office/drawing/2014/main" id="{35010379-7F51-4355-9306-B2165846A62A}"/>
               </a:ext>
             </a:extLst>
           </p:cNvPr>
@@ -4212,7 +4212,7 @@
           <p:cNvPr id="20" name="loop-ru-2">
             <a:extLst xmlns:a="http://schemas.openxmlformats.org/drawingml/2006/main">
               <a:ext uri="{FF2B5EF4-FFF2-40B4-BE49-F238E27FC236}">
-                <a16:creationId xmlns:a16="http://schemas.microsoft.com/office/drawing/2014/main" id="{56F563CD-E512-406D-B578-FFFD64FB09B1}"/>
+                <a16:creationId xmlns:a16="http://schemas.microsoft.com/office/drawing/2014/main" id="{40E7DD6F-590E-4A1D-AD80-9611A65AD006}"/>
               </a:ext>
             </a:extLst>
           </p:cNvPr>
@@ -4268,7 +4268,7 @@
           <p:cNvPr id="21" name="loop-detail-2">
             <a:extLst xmlns:a="http://schemas.openxmlformats.org/drawingml/2006/main">
               <a:ext uri="{FF2B5EF4-FFF2-40B4-BE49-F238E27FC236}">
-                <a16:creationId xmlns:a16="http://schemas.microsoft.com/office/drawing/2014/main" id="{90274ECA-156C-4147-AC56-632C4B572CED}"/>
+                <a16:creationId xmlns:a16="http://schemas.microsoft.com/office/drawing/2014/main" id="{902B5D02-077D-487A-98D8-013ECC444D33}"/>
               </a:ext>
             </a:extLst>
           </p:cNvPr>
@@ -4324,7 +4324,7 @@
           <p:cNvPr id="22" name="footer-4">
             <a:extLst xmlns:a="http://schemas.openxmlformats.org/drawingml/2006/main">
               <a:ext uri="{FF2B5EF4-FFF2-40B4-BE49-F238E27FC236}">
-                <a16:creationId xmlns:a16="http://schemas.microsoft.com/office/drawing/2014/main" id="{50C8EA7A-1004-4507-BAE8-F5F677686160}"/>
+                <a16:creationId xmlns:a16="http://schemas.microsoft.com/office/drawing/2014/main" id="{7458734A-C79A-45AF-B429-1A8595CEE704}"/>
               </a:ext>
             </a:extLst>
           </p:cNvPr>
@@ -4378,7 +4378,7 @@
     </p:spTree>
     <p:extLst>
       <p:ext uri="{BB962C8B-B14F-4D97-AF65-F5344CB8AC3E}">
-        <p14:creationId xmlns:p14="http://schemas.microsoft.com/office/powerpoint/2010/main" val="2060093979"/>
+        <p14:creationId xmlns:p14="http://schemas.microsoft.com/office/powerpoint/2010/main" val="1556800097"/>
       </p:ext>
     </p:extLst>
   </p:cSld>
@@ -4409,7 +4409,7 @@
           <p:cNvPr id="21" name="breadth-title">
             <a:extLst xmlns:a="http://schemas.openxmlformats.org/drawingml/2006/main">
               <a:ext uri="{FF2B5EF4-FFF2-40B4-BE49-F238E27FC236}">
-                <a16:creationId xmlns:a16="http://schemas.microsoft.com/office/drawing/2014/main" id="{C813BF30-1A59-436A-83CC-0788BAA354C9}"/>
+                <a16:creationId xmlns:a16="http://schemas.microsoft.com/office/drawing/2014/main" id="{25081E3F-7F55-4F8A-9AED-ACC80087BF70}"/>
               </a:ext>
             </a:extLst>
           </p:cNvPr>
@@ -4465,7 +4465,7 @@
           <p:cNvPr id="2" name="breadth-triple">
             <a:extLst xmlns:a="http://schemas.openxmlformats.org/drawingml/2006/main">
               <a:ext uri="{FF2B5EF4-FFF2-40B4-BE49-F238E27FC236}">
-                <a16:creationId xmlns:a16="http://schemas.microsoft.com/office/drawing/2014/main" id="{93A526CF-23E7-43DA-A587-66F33F6E5AEC}"/>
+                <a16:creationId xmlns:a16="http://schemas.microsoft.com/office/drawing/2014/main" id="{1E61E640-CE8E-41CA-BF8E-DD1DE976FFCA}"/>
               </a:ext>
             </a:extLst>
           </p:cNvPr>
@@ -4521,7 +4521,7 @@
           <p:cNvPr id="3" name="breadth-number">
             <a:extLst xmlns:a="http://schemas.openxmlformats.org/drawingml/2006/main">
               <a:ext uri="{FF2B5EF4-FFF2-40B4-BE49-F238E27FC236}">
-                <a16:creationId xmlns:a16="http://schemas.microsoft.com/office/drawing/2014/main" id="{7D4FBA11-CE42-44BE-AAF3-C77F3D554545}"/>
+                <a16:creationId xmlns:a16="http://schemas.microsoft.com/office/drawing/2014/main" id="{1B9C239A-369E-45E2-A7A5-A7654EF34BA6}"/>
               </a:ext>
             </a:extLst>
           </p:cNvPr>
@@ -4577,7 +4577,7 @@
           <p:cNvPr id="4" name="breadth-caption">
             <a:extLst xmlns:a="http://schemas.openxmlformats.org/drawingml/2006/main">
               <a:ext uri="{FF2B5EF4-FFF2-40B4-BE49-F238E27FC236}">
-                <a16:creationId xmlns:a16="http://schemas.microsoft.com/office/drawing/2014/main" id="{A35008DA-FCA4-4F35-A9F5-5890AF30702B}"/>
+                <a16:creationId xmlns:a16="http://schemas.microsoft.com/office/drawing/2014/main" id="{CD0E2646-D4C6-447A-A6C5-99FC48655CB0}"/>
               </a:ext>
             </a:extLst>
           </p:cNvPr>
@@ -4679,7 +4679,7 @@
           <p:cNvPr id="5" name="breadth-divider">
             <a:extLst xmlns:a="http://schemas.openxmlformats.org/drawingml/2006/main">
               <a:ext uri="{FF2B5EF4-FFF2-40B4-BE49-F238E27FC236}">
-                <a16:creationId xmlns:a16="http://schemas.microsoft.com/office/drawing/2014/main" id="{7670F6E8-D88A-4CEE-8881-62E13C02D8BD}"/>
+                <a16:creationId xmlns:a16="http://schemas.microsoft.com/office/drawing/2014/main" id="{12BAC287-10A3-4BA7-98BF-19E33E33D537}"/>
               </a:ext>
             </a:extLst>
           </p:cNvPr>
@@ -4710,7 +4710,7 @@
           <p:cNvPr id="6" name="breadth-item-rule-0">
             <a:extLst xmlns:a="http://schemas.openxmlformats.org/drawingml/2006/main">
               <a:ext uri="{FF2B5EF4-FFF2-40B4-BE49-F238E27FC236}">
-                <a16:creationId xmlns:a16="http://schemas.microsoft.com/office/drawing/2014/main" id="{A7682FA0-E2B6-49B7-BA66-AD9E5CE99EF6}"/>
+                <a16:creationId xmlns:a16="http://schemas.microsoft.com/office/drawing/2014/main" id="{BAA7A936-E9FC-4878-A7CF-9F1551C91868}"/>
               </a:ext>
             </a:extLst>
           </p:cNvPr>
@@ -4741,7 +4741,7 @@
           <p:cNvPr id="7" name="breadth-item-0">
             <a:extLst xmlns:a="http://schemas.openxmlformats.org/drawingml/2006/main">
               <a:ext uri="{FF2B5EF4-FFF2-40B4-BE49-F238E27FC236}">
-                <a16:creationId xmlns:a16="http://schemas.microsoft.com/office/drawing/2014/main" id="{639DC8A4-E871-48DD-8A32-F81313FC0849}"/>
+                <a16:creationId xmlns:a16="http://schemas.microsoft.com/office/drawing/2014/main" id="{8926ABBA-D094-4413-A4A2-556F15128932}"/>
               </a:ext>
             </a:extLst>
           </p:cNvPr>
@@ -4797,7 +4797,7 @@
           <p:cNvPr id="8" name="breadth-item-rule-1">
             <a:extLst xmlns:a="http://schemas.openxmlformats.org/drawingml/2006/main">
               <a:ext uri="{FF2B5EF4-FFF2-40B4-BE49-F238E27FC236}">
-                <a16:creationId xmlns:a16="http://schemas.microsoft.com/office/drawing/2014/main" id="{BDC4B821-F9A8-4FAF-A49B-DC7E68DF3805}"/>
+                <a16:creationId xmlns:a16="http://schemas.microsoft.com/office/drawing/2014/main" id="{67FEAF08-045E-4C7D-BD34-A3D5228BD145}"/>
               </a:ext>
             </a:extLst>
           </p:cNvPr>
@@ -4828,7 +4828,7 @@
           <p:cNvPr id="9" name="breadth-item-1">
             <a:extLst xmlns:a="http://schemas.openxmlformats.org/drawingml/2006/main">
               <a:ext uri="{FF2B5EF4-FFF2-40B4-BE49-F238E27FC236}">
-                <a16:creationId xmlns:a16="http://schemas.microsoft.com/office/drawing/2014/main" id="{727F445F-3B93-43CD-A8C2-5884B0F0F506}"/>
+                <a16:creationId xmlns:a16="http://schemas.microsoft.com/office/drawing/2014/main" id="{BD1D3769-1F79-4F33-91C8-64F06ED9EC61}"/>
               </a:ext>
             </a:extLst>
           </p:cNvPr>
@@ -4884,7 +4884,7 @@
           <p:cNvPr id="10" name="breadth-item-rule-2">
             <a:extLst xmlns:a="http://schemas.openxmlformats.org/drawingml/2006/main">
               <a:ext uri="{FF2B5EF4-FFF2-40B4-BE49-F238E27FC236}">
-                <a16:creationId xmlns:a16="http://schemas.microsoft.com/office/drawing/2014/main" id="{6230A6CC-EE22-47A6-877D-8CA63F23D0C4}"/>
+                <a16:creationId xmlns:a16="http://schemas.microsoft.com/office/drawing/2014/main" id="{843CC44B-067F-4C31-B830-CA1685713FBE}"/>
               </a:ext>
             </a:extLst>
           </p:cNvPr>
@@ -4915,7 +4915,7 @@
           <p:cNvPr id="11" name="breadth-item-2">
             <a:extLst xmlns:a="http://schemas.openxmlformats.org/drawingml/2006/main">
               <a:ext uri="{FF2B5EF4-FFF2-40B4-BE49-F238E27FC236}">
-                <a16:creationId xmlns:a16="http://schemas.microsoft.com/office/drawing/2014/main" id="{71403011-DA6A-409A-A3B0-139C30751A13}"/>
+                <a16:creationId xmlns:a16="http://schemas.microsoft.com/office/drawing/2014/main" id="{1225F7FF-0497-4461-89E4-B83DB94D0B7F}"/>
               </a:ext>
             </a:extLst>
           </p:cNvPr>
@@ -4971,7 +4971,7 @@
           <p:cNvPr id="12" name="breadth-item-rule-3">
             <a:extLst xmlns:a="http://schemas.openxmlformats.org/drawingml/2006/main">
               <a:ext uri="{FF2B5EF4-FFF2-40B4-BE49-F238E27FC236}">
-                <a16:creationId xmlns:a16="http://schemas.microsoft.com/office/drawing/2014/main" id="{1AAD309E-6930-4357-AB15-C24252AF7BCA}"/>
+                <a16:creationId xmlns:a16="http://schemas.microsoft.com/office/drawing/2014/main" id="{A339741B-1664-4798-91D1-8C3789CCDD55}"/>
               </a:ext>
             </a:extLst>
           </p:cNvPr>
@@ -5002,7 +5002,7 @@
           <p:cNvPr id="13" name="breadth-item-3">
             <a:extLst xmlns:a="http://schemas.openxmlformats.org/drawingml/2006/main">
               <a:ext uri="{FF2B5EF4-FFF2-40B4-BE49-F238E27FC236}">
-                <a16:creationId xmlns:a16="http://schemas.microsoft.com/office/drawing/2014/main" id="{5CA21408-75A8-43E1-A779-514F3B059CDF}"/>
+                <a16:creationId xmlns:a16="http://schemas.microsoft.com/office/drawing/2014/main" id="{29CF31C5-02AC-40DF-97E4-90777C0C21B7}"/>
               </a:ext>
             </a:extLst>
           </p:cNvPr>
@@ -5058,7 +5058,7 @@
           <p:cNvPr id="14" name="breadth-item-rule-4">
             <a:extLst xmlns:a="http://schemas.openxmlformats.org/drawingml/2006/main">
               <a:ext uri="{FF2B5EF4-FFF2-40B4-BE49-F238E27FC236}">
-                <a16:creationId xmlns:a16="http://schemas.microsoft.com/office/drawing/2014/main" id="{11022A66-FABA-4D78-846F-393C26364E94}"/>
+                <a16:creationId xmlns:a16="http://schemas.microsoft.com/office/drawing/2014/main" id="{1D01FCB0-AEF3-4796-B46E-E107857CF256}"/>
               </a:ext>
             </a:extLst>
           </p:cNvPr>
@@ -5089,7 +5089,7 @@
           <p:cNvPr id="15" name="breadth-item-4">
             <a:extLst xmlns:a="http://schemas.openxmlformats.org/drawingml/2006/main">
               <a:ext uri="{FF2B5EF4-FFF2-40B4-BE49-F238E27FC236}">
-                <a16:creationId xmlns:a16="http://schemas.microsoft.com/office/drawing/2014/main" id="{6515F35F-1965-4D49-A9BD-6BF16445EBF5}"/>
+                <a16:creationId xmlns:a16="http://schemas.microsoft.com/office/drawing/2014/main" id="{A5EE3755-AAB8-4E2F-AF5A-F9F35102ECBE}"/>
               </a:ext>
             </a:extLst>
           </p:cNvPr>
@@ -5145,7 +5145,7 @@
           <p:cNvPr id="16" name="breadth-item-rule-5">
             <a:extLst xmlns:a="http://schemas.openxmlformats.org/drawingml/2006/main">
               <a:ext uri="{FF2B5EF4-FFF2-40B4-BE49-F238E27FC236}">
-                <a16:creationId xmlns:a16="http://schemas.microsoft.com/office/drawing/2014/main" id="{EBFAEFF3-450D-4884-BDBF-2893AF7A6CD9}"/>
+                <a16:creationId xmlns:a16="http://schemas.microsoft.com/office/drawing/2014/main" id="{22F8D8B7-FA24-4625-BB27-96A4FB8CE4C0}"/>
               </a:ext>
             </a:extLst>
           </p:cNvPr>
@@ -5176,7 +5176,7 @@
           <p:cNvPr id="17" name="breadth-item-5">
             <a:extLst xmlns:a="http://schemas.openxmlformats.org/drawingml/2006/main">
               <a:ext uri="{FF2B5EF4-FFF2-40B4-BE49-F238E27FC236}">
-                <a16:creationId xmlns:a16="http://schemas.microsoft.com/office/drawing/2014/main" id="{665461E2-4DE9-459C-AABF-FCA7D69AF89E}"/>
+                <a16:creationId xmlns:a16="http://schemas.microsoft.com/office/drawing/2014/main" id="{9AF3AEDC-E47F-478B-AC9B-ABED87A73486}"/>
               </a:ext>
             </a:extLst>
           </p:cNvPr>
@@ -5232,7 +5232,7 @@
           <p:cNvPr id="18" name="breadth-item-rule-6">
             <a:extLst xmlns:a="http://schemas.openxmlformats.org/drawingml/2006/main">
               <a:ext uri="{FF2B5EF4-FFF2-40B4-BE49-F238E27FC236}">
-                <a16:creationId xmlns:a16="http://schemas.microsoft.com/office/drawing/2014/main" id="{55A5704D-21BC-49C8-9486-730D27AB653A}"/>
+                <a16:creationId xmlns:a16="http://schemas.microsoft.com/office/drawing/2014/main" id="{4781C19E-152F-446B-A853-D9C6C81A5098}"/>
               </a:ext>
             </a:extLst>
           </p:cNvPr>
@@ -5263,7 +5263,7 @@
           <p:cNvPr id="19" name="breadth-item-6">
             <a:extLst xmlns:a="http://schemas.openxmlformats.org/drawingml/2006/main">
               <a:ext uri="{FF2B5EF4-FFF2-40B4-BE49-F238E27FC236}">
-                <a16:creationId xmlns:a16="http://schemas.microsoft.com/office/drawing/2014/main" id="{52DE5BFA-B85A-4FAB-B258-EB80E0244B82}"/>
+                <a16:creationId xmlns:a16="http://schemas.microsoft.com/office/drawing/2014/main" id="{36D59AC3-881A-4706-99B3-A210A12C3F91}"/>
               </a:ext>
             </a:extLst>
           </p:cNvPr>
@@ -5319,7 +5319,7 @@
           <p:cNvPr id="20" name="footer-5">
             <a:extLst xmlns:a="http://schemas.openxmlformats.org/drawingml/2006/main">
               <a:ext uri="{FF2B5EF4-FFF2-40B4-BE49-F238E27FC236}">
-                <a16:creationId xmlns:a16="http://schemas.microsoft.com/office/drawing/2014/main" id="{12BF5B2A-A69B-4DB8-AC34-A6957DDCEB32}"/>
+                <a16:creationId xmlns:a16="http://schemas.microsoft.com/office/drawing/2014/main" id="{14FEF026-3D55-405D-B4DC-52574808CCE0}"/>
               </a:ext>
             </a:extLst>
           </p:cNvPr>
@@ -5373,7 +5373,7 @@
     </p:spTree>
     <p:extLst>
       <p:ext uri="{BB962C8B-B14F-4D97-AF65-F5344CB8AC3E}">
-        <p14:creationId xmlns:p14="http://schemas.microsoft.com/office/powerpoint/2010/main" val="1753064886"/>
+        <p14:creationId xmlns:p14="http://schemas.microsoft.com/office/powerpoint/2010/main" val="571714314"/>
       </p:ext>
     </p:extLst>
   </p:cSld>
@@ -5404,7 +5404,7 @@
           <p:cNvPr id="12" name="privacy-title">
             <a:extLst xmlns:a="http://schemas.openxmlformats.org/drawingml/2006/main">
               <a:ext uri="{FF2B5EF4-FFF2-40B4-BE49-F238E27FC236}">
-                <a16:creationId xmlns:a16="http://schemas.microsoft.com/office/drawing/2014/main" id="{0C8F351D-FB11-4F13-A8BF-E158FEE001F9}"/>
+                <a16:creationId xmlns:a16="http://schemas.microsoft.com/office/drawing/2014/main" id="{F921E2C5-0D0E-44C8-8EA1-75704EFC5CE0}"/>
               </a:ext>
             </a:extLst>
           </p:cNvPr>
@@ -5460,7 +5460,7 @@
           <p:cNvPr id="2" name="privacy-tr">
             <a:extLst xmlns:a="http://schemas.openxmlformats.org/drawingml/2006/main">
               <a:ext uri="{FF2B5EF4-FFF2-40B4-BE49-F238E27FC236}">
-                <a16:creationId xmlns:a16="http://schemas.microsoft.com/office/drawing/2014/main" id="{541BDCBC-5DE7-476B-ACF5-FB11073F675E}"/>
+                <a16:creationId xmlns:a16="http://schemas.microsoft.com/office/drawing/2014/main" id="{6F6CB9A3-E0CA-466B-B026-5041FB74961D}"/>
               </a:ext>
             </a:extLst>
           </p:cNvPr>
@@ -5516,7 +5516,7 @@
           <p:cNvPr id="3" name="privacy-ru">
             <a:extLst xmlns:a="http://schemas.openxmlformats.org/drawingml/2006/main">
               <a:ext uri="{FF2B5EF4-FFF2-40B4-BE49-F238E27FC236}">
-                <a16:creationId xmlns:a16="http://schemas.microsoft.com/office/drawing/2014/main" id="{2671D5BC-6CC2-471C-9439-DD29E965B12C}"/>
+                <a16:creationId xmlns:a16="http://schemas.microsoft.com/office/drawing/2014/main" id="{FC70649D-B7A3-4B44-8C33-E9A7C5AE19CC}"/>
               </a:ext>
             </a:extLst>
           </p:cNvPr>
@@ -5572,7 +5572,7 @@
           <p:cNvPr id="4" name="privacy-divider">
             <a:extLst xmlns:a="http://schemas.openxmlformats.org/drawingml/2006/main">
               <a:ext uri="{FF2B5EF4-FFF2-40B4-BE49-F238E27FC236}">
-                <a16:creationId xmlns:a16="http://schemas.microsoft.com/office/drawing/2014/main" id="{FA82800C-7C83-4924-8055-D7CF2070C4A5}"/>
+                <a16:creationId xmlns:a16="http://schemas.microsoft.com/office/drawing/2014/main" id="{E3B68CB1-D20C-4955-B8D2-F10672B939A6}"/>
               </a:ext>
             </a:extLst>
           </p:cNvPr>
@@ -5603,7 +5603,7 @@
           <p:cNvPr id="5" name="local-label">
             <a:extLst xmlns:a="http://schemas.openxmlformats.org/drawingml/2006/main">
               <a:ext uri="{FF2B5EF4-FFF2-40B4-BE49-F238E27FC236}">
-                <a16:creationId xmlns:a16="http://schemas.microsoft.com/office/drawing/2014/main" id="{F63D4422-0900-46AB-8014-B3CF9C5DD684}"/>
+                <a16:creationId xmlns:a16="http://schemas.microsoft.com/office/drawing/2014/main" id="{1DB60458-0345-4826-B3AB-DB20887F6CAC}"/>
               </a:ext>
             </a:extLst>
           </p:cNvPr>
@@ -5659,7 +5659,7 @@
           <p:cNvPr id="6" name="local-head">
             <a:extLst xmlns:a="http://schemas.openxmlformats.org/drawingml/2006/main">
               <a:ext uri="{FF2B5EF4-FFF2-40B4-BE49-F238E27FC236}">
-                <a16:creationId xmlns:a16="http://schemas.microsoft.com/office/drawing/2014/main" id="{65D81A09-964C-41C2-BA00-910BDE961B8F}"/>
+                <a16:creationId xmlns:a16="http://schemas.microsoft.com/office/drawing/2014/main" id="{7066AC72-F891-45C4-99A9-C5944AF7369D}"/>
               </a:ext>
             </a:extLst>
           </p:cNvPr>
@@ -5715,7 +5715,7 @@
           <p:cNvPr id="7" name="local-copy">
             <a:extLst xmlns:a="http://schemas.openxmlformats.org/drawingml/2006/main">
               <a:ext uri="{FF2B5EF4-FFF2-40B4-BE49-F238E27FC236}">
-                <a16:creationId xmlns:a16="http://schemas.microsoft.com/office/drawing/2014/main" id="{88279E74-F92B-4380-A833-9BE4CE9F19E2}"/>
+                <a16:creationId xmlns:a16="http://schemas.microsoft.com/office/drawing/2014/main" id="{CC78447E-AFFC-4B72-9ADB-E2322ECCC02D}"/>
               </a:ext>
             </a:extLst>
           </p:cNvPr>
@@ -5784,7 +5784,7 @@
                 <a:ea typeface="Arial"/>
                 <a:cs typeface="Arial"/>
               </a:rPr>
-              <a:t>AI, LM Studio üzerinden yerelde çalışabilir.</a:t>
+              <a:t>Sözlük ve AI öğretmen LM Studio ile yerelde çalışır.</a:t>
             </a:r>
           </a:p>
           <a:p xmlns:a="http://schemas.openxmlformats.org/drawingml/2006/main">
@@ -5835,7 +5835,7 @@
                 <a:ea typeface="Arial"/>
                 <a:cs typeface="Arial"/>
               </a:rPr>
-              <a:t>ИИ может работать локально через LM Studio.</a:t>
+              <a:t>Словарь и ИИ работают локально через LM Studio.</a:t>
             </a:r>
           </a:p>
         </p:txBody>
@@ -5845,7 +5845,7 @@
           <p:cNvPr id="8" name="optional-label">
             <a:extLst xmlns:a="http://schemas.openxmlformats.org/drawingml/2006/main">
               <a:ext uri="{FF2B5EF4-FFF2-40B4-BE49-F238E27FC236}">
-                <a16:creationId xmlns:a16="http://schemas.microsoft.com/office/drawing/2014/main" id="{3E3A4356-DDEB-4533-974C-851F1A67DD4D}"/>
+                <a16:creationId xmlns:a16="http://schemas.microsoft.com/office/drawing/2014/main" id="{E9951BD9-7C96-4AED-BA34-F66752289CE1}"/>
               </a:ext>
             </a:extLst>
           </p:cNvPr>
@@ -5901,7 +5901,7 @@
           <p:cNvPr id="9" name="optional-head">
             <a:extLst xmlns:a="http://schemas.openxmlformats.org/drawingml/2006/main">
               <a:ext uri="{FF2B5EF4-FFF2-40B4-BE49-F238E27FC236}">
-                <a16:creationId xmlns:a16="http://schemas.microsoft.com/office/drawing/2014/main" id="{7FF2489D-102D-4731-AC7E-8E90BCEA492D}"/>
+                <a16:creationId xmlns:a16="http://schemas.microsoft.com/office/drawing/2014/main" id="{E5A13A67-2619-4C38-A231-C54C66B46457}"/>
               </a:ext>
             </a:extLst>
           </p:cNvPr>
@@ -5957,7 +5957,7 @@
           <p:cNvPr id="10" name="optional-copy">
             <a:extLst xmlns:a="http://schemas.openxmlformats.org/drawingml/2006/main">
               <a:ext uri="{FF2B5EF4-FFF2-40B4-BE49-F238E27FC236}">
-                <a16:creationId xmlns:a16="http://schemas.microsoft.com/office/drawing/2014/main" id="{E75346C0-3D5A-4E72-A437-B70A3E12FDAB}"/>
+                <a16:creationId xmlns:a16="http://schemas.microsoft.com/office/drawing/2014/main" id="{98F54DF0-2A21-4ECB-893A-2D8CDEEDF8A2}"/>
               </a:ext>
             </a:extLst>
           </p:cNvPr>
@@ -6003,7 +6003,7 @@
                 <a:ea typeface="Arial"/>
                 <a:cs typeface="Arial"/>
               </a:rPr>
-              <a:t>Kaynak indirmeleri ve NVIDIA NIM internet kullanır.</a:t>
+              <a:t>Kaynak indirmeleri ve alternatif AI ucu (NVIDIA NIM / özel OpenAI uyumlu URL) internet kullanır; anahtar Credential Manager'da.</a:t>
             </a:r>
           </a:p>
           <a:p xmlns:a="http://schemas.openxmlformats.org/drawingml/2006/main">
@@ -6054,7 +6054,7 @@
                 <a:ea typeface="Arial"/>
                 <a:cs typeface="Arial"/>
               </a:rPr>
-              <a:t>Загрузки ресурсов и NVIDIA NIM используют интернет.</a:t>
+              <a:t>Загрузки и альтернативный ИИ-узел (NVIDIA NIM) используют интернет.</a:t>
             </a:r>
           </a:p>
           <a:p xmlns:a="http://schemas.openxmlformats.org/drawingml/2006/main">
@@ -6087,7 +6087,7 @@
           <p:cNvPr id="11" name="footer-6">
             <a:extLst xmlns:a="http://schemas.openxmlformats.org/drawingml/2006/main">
               <a:ext uri="{FF2B5EF4-FFF2-40B4-BE49-F238E27FC236}">
-                <a16:creationId xmlns:a16="http://schemas.microsoft.com/office/drawing/2014/main" id="{B99A7499-C901-4815-9264-8BEC3FE29FCF}"/>
+                <a16:creationId xmlns:a16="http://schemas.microsoft.com/office/drawing/2014/main" id="{F1A3E017-A6BD-4CAA-8843-5810BA4C38A3}"/>
               </a:ext>
             </a:extLst>
           </p:cNvPr>
@@ -6141,7 +6141,7 @@
     </p:spTree>
     <p:extLst>
       <p:ext uri="{BB962C8B-B14F-4D97-AF65-F5344CB8AC3E}">
-        <p14:creationId xmlns:p14="http://schemas.microsoft.com/office/powerpoint/2010/main" val="10108708"/>
+        <p14:creationId xmlns:p14="http://schemas.microsoft.com/office/powerpoint/2010/main" val="1824593443"/>
       </p:ext>
     </p:extLst>
   </p:cSld>
@@ -6172,7 +6172,7 @@
           <p:cNvPr id="13" name="platform-title">
             <a:extLst xmlns:a="http://schemas.openxmlformats.org/drawingml/2006/main">
               <a:ext uri="{FF2B5EF4-FFF2-40B4-BE49-F238E27FC236}">
-                <a16:creationId xmlns:a16="http://schemas.microsoft.com/office/drawing/2014/main" id="{F439B40F-D930-47D8-8E2B-6FDC0DE7EFBB}"/>
+                <a16:creationId xmlns:a16="http://schemas.microsoft.com/office/drawing/2014/main" id="{611E8FC2-700C-450A-8EFB-9CAE5AEF36B2}"/>
               </a:ext>
             </a:extLst>
           </p:cNvPr>
@@ -6228,7 +6228,7 @@
           <p:cNvPr id="2" name="platform-subtitle">
             <a:extLst xmlns:a="http://schemas.openxmlformats.org/drawingml/2006/main">
               <a:ext uri="{FF2B5EF4-FFF2-40B4-BE49-F238E27FC236}">
-                <a16:creationId xmlns:a16="http://schemas.microsoft.com/office/drawing/2014/main" id="{923C93EC-B59C-4995-9D1D-9C3B416D66C8}"/>
+                <a16:creationId xmlns:a16="http://schemas.microsoft.com/office/drawing/2014/main" id="{D288FBF8-A726-4571-B9FE-C6D2406DAD24}"/>
               </a:ext>
             </a:extLst>
           </p:cNvPr>
@@ -6284,7 +6284,7 @@
           <p:cNvPr id="3" name="platform-rule">
             <a:extLst xmlns:a="http://schemas.openxmlformats.org/drawingml/2006/main">
               <a:ext uri="{FF2B5EF4-FFF2-40B4-BE49-F238E27FC236}">
-                <a16:creationId xmlns:a16="http://schemas.microsoft.com/office/drawing/2014/main" id="{45867CCA-F079-42D0-9281-1A018B3A5B4D}"/>
+                <a16:creationId xmlns:a16="http://schemas.microsoft.com/office/drawing/2014/main" id="{2E77C72E-33C4-4BF6-AC43-3AD417CAC9B4}"/>
               </a:ext>
             </a:extLst>
           </p:cNvPr>
@@ -6315,7 +6315,7 @@
           <p:cNvPr id="4" name="platform-label-0">
             <a:extLst xmlns:a="http://schemas.openxmlformats.org/drawingml/2006/main">
               <a:ext uri="{FF2B5EF4-FFF2-40B4-BE49-F238E27FC236}">
-                <a16:creationId xmlns:a16="http://schemas.microsoft.com/office/drawing/2014/main" id="{A096C791-CF7C-487A-9522-BA31839A7F74}"/>
+                <a16:creationId xmlns:a16="http://schemas.microsoft.com/office/drawing/2014/main" id="{F1B736DB-96C2-4D8D-85EC-5CCA96B270A4}"/>
               </a:ext>
             </a:extLst>
           </p:cNvPr>
@@ -6371,7 +6371,7 @@
           <p:cNvPr id="5" name="platform-body-0">
             <a:extLst xmlns:a="http://schemas.openxmlformats.org/drawingml/2006/main">
               <a:ext uri="{FF2B5EF4-FFF2-40B4-BE49-F238E27FC236}">
-                <a16:creationId xmlns:a16="http://schemas.microsoft.com/office/drawing/2014/main" id="{774120D9-BE87-4CFF-9775-555E7E4A2060}"/>
+                <a16:creationId xmlns:a16="http://schemas.microsoft.com/office/drawing/2014/main" id="{F53A0E72-51DD-4E0C-A776-71002CAEC563}"/>
               </a:ext>
             </a:extLst>
           </p:cNvPr>
@@ -6417,7 +6417,7 @@
                 <a:ea typeface="Arial"/>
                 <a:cs typeface="Arial"/>
               </a:rPr>
-              <a:t>Windows 10/11 (x64) + macOS (Apple Silicon) — İndirme: github.com/Azizsekerdil/RussianCourseAI/releases (v1.0.0) (özel repo)</a:t>
+              <a:t>Windows 10/11 (x64) + macOS (Apple Silicon) — İndirme: github.com/Azizsekerdil/RussianCourseAI/releases (v1.1.0) (özel repo)</a:t>
             </a:r>
           </a:p>
         </p:txBody>
@@ -6427,7 +6427,7 @@
           <p:cNvPr id="6" name="platform-label-1">
             <a:extLst xmlns:a="http://schemas.openxmlformats.org/drawingml/2006/main">
               <a:ext uri="{FF2B5EF4-FFF2-40B4-BE49-F238E27FC236}">
-                <a16:creationId xmlns:a16="http://schemas.microsoft.com/office/drawing/2014/main" id="{E9202051-37C1-4780-8B44-2D863729ED19}"/>
+                <a16:creationId xmlns:a16="http://schemas.microsoft.com/office/drawing/2014/main" id="{0CC0E6A2-9D54-4AD1-82EE-693608670F62}"/>
               </a:ext>
             </a:extLst>
           </p:cNvPr>
@@ -6483,7 +6483,7 @@
           <p:cNvPr id="7" name="platform-body-1">
             <a:extLst xmlns:a="http://schemas.openxmlformats.org/drawingml/2006/main">
               <a:ext uri="{FF2B5EF4-FFF2-40B4-BE49-F238E27FC236}">
-                <a16:creationId xmlns:a16="http://schemas.microsoft.com/office/drawing/2014/main" id="{06E0ECD7-BBC0-4813-A45C-3C6E5D584FE6}"/>
+                <a16:creationId xmlns:a16="http://schemas.microsoft.com/office/drawing/2014/main" id="{EBE1B081-D26F-419E-AB3F-DE09C72AA517}"/>
               </a:ext>
             </a:extLst>
           </p:cNvPr>
@@ -6529,7 +6529,7 @@
                 <a:ea typeface="Arial"/>
                 <a:cs typeface="Arial"/>
               </a:rPr>
-              <a:t>Windows 10/11 (x64) &amp; macOS (Apple Silicon) — Download: GitHub Releases (v1.0.0)</a:t>
+              <a:t>Windows 10/11 (x64) &amp; macOS (Apple Silicon) — Download: GitHub Releases (v1.1.0)</a:t>
             </a:r>
           </a:p>
         </p:txBody>
@@ -6539,7 +6539,7 @@
           <p:cNvPr id="8" name="platform-label-2">
             <a:extLst xmlns:a="http://schemas.openxmlformats.org/drawingml/2006/main">
               <a:ext uri="{FF2B5EF4-FFF2-40B4-BE49-F238E27FC236}">
-                <a16:creationId xmlns:a16="http://schemas.microsoft.com/office/drawing/2014/main" id="{5597AC4C-5459-4B6C-9748-46DB3D92E768}"/>
+                <a16:creationId xmlns:a16="http://schemas.microsoft.com/office/drawing/2014/main" id="{7847B70C-82C8-461F-958D-322B205C5E29}"/>
               </a:ext>
             </a:extLst>
           </p:cNvPr>
@@ -6595,7 +6595,7 @@
           <p:cNvPr id="9" name="platform-body-2">
             <a:extLst xmlns:a="http://schemas.openxmlformats.org/drawingml/2006/main">
               <a:ext uri="{FF2B5EF4-FFF2-40B4-BE49-F238E27FC236}">
-                <a16:creationId xmlns:a16="http://schemas.microsoft.com/office/drawing/2014/main" id="{408A5175-C05C-47F4-8264-07E3A7DDDF1E}"/>
+                <a16:creationId xmlns:a16="http://schemas.microsoft.com/office/drawing/2014/main" id="{552055B3-DA50-4690-A3DA-C476FC012418}"/>
               </a:ext>
             </a:extLst>
           </p:cNvPr>
@@ -6641,7 +6641,7 @@
                 <a:ea typeface="Arial"/>
                 <a:cs typeface="Arial"/>
               </a:rPr>
-              <a:t>Windows 10/11 (x64) и macOS (Apple Silicon) — Загрузка: GitHub Releases (v1.0.0)</a:t>
+              <a:t>Windows 10/11 (x64) и macOS (Apple Silicon) — Загрузка: GitHub Releases (v1.1.0)</a:t>
             </a:r>
           </a:p>
         </p:txBody>
@@ -6651,7 +6651,7 @@
           <p:cNvPr id="10" name="platform-footnote-rule">
             <a:extLst xmlns:a="http://schemas.openxmlformats.org/drawingml/2006/main">
               <a:ext uri="{FF2B5EF4-FFF2-40B4-BE49-F238E27FC236}">
-                <a16:creationId xmlns:a16="http://schemas.microsoft.com/office/drawing/2014/main" id="{FDF23EC5-F983-4369-91C6-886CEAA34DE9}"/>
+                <a16:creationId xmlns:a16="http://schemas.microsoft.com/office/drawing/2014/main" id="{5FF6F732-9434-402E-A630-40A928386CAE}"/>
               </a:ext>
             </a:extLst>
           </p:cNvPr>
@@ -6682,7 +6682,7 @@
           <p:cNvPr id="11" name="platform-footnote">
             <a:extLst xmlns:a="http://schemas.openxmlformats.org/drawingml/2006/main">
               <a:ext uri="{FF2B5EF4-FFF2-40B4-BE49-F238E27FC236}">
-                <a16:creationId xmlns:a16="http://schemas.microsoft.com/office/drawing/2014/main" id="{963E7E1F-ACC7-4915-A35C-E5DB85121FBC}"/>
+                <a16:creationId xmlns:a16="http://schemas.microsoft.com/office/drawing/2014/main" id="{6D758C97-B738-452E-BD3E-71AF1C6B27B2}"/>
               </a:ext>
             </a:extLst>
           </p:cNvPr>
@@ -6728,7 +6728,7 @@
                 <a:ea typeface="Arial"/>
                 <a:cs typeface="Arial"/>
               </a:rPr>
-              <a:t>Release v1.0.0 — iki paket: Windows zip + macOS zip. macOS paketi Apple Silicon (arm64) içindir ve notarize edilmemiştir; ilk açılışta sağ tık → Aç.</a:t>
+              <a:t>Release v1.1.0 — iki paket: Windows zip + macOS zip. macOS paketi Apple Silicon (arm64) içindir ve notarize edilmemiştir; ilk açılışta sağ tık → Aç.</a:t>
             </a:r>
           </a:p>
           <a:p xmlns:a="http://schemas.openxmlformats.org/drawingml/2006/main">
@@ -6761,7 +6761,7 @@
           <p:cNvPr id="12" name="footer-7">
             <a:extLst xmlns:a="http://schemas.openxmlformats.org/drawingml/2006/main">
               <a:ext uri="{FF2B5EF4-FFF2-40B4-BE49-F238E27FC236}">
-                <a16:creationId xmlns:a16="http://schemas.microsoft.com/office/drawing/2014/main" id="{1572955D-B69E-4353-9CC0-E3713A731494}"/>
+                <a16:creationId xmlns:a16="http://schemas.microsoft.com/office/drawing/2014/main" id="{D4494DCE-039B-453B-A39F-1AAEA813C467}"/>
               </a:ext>
             </a:extLst>
           </p:cNvPr>
@@ -6815,7 +6815,7 @@
     </p:spTree>
     <p:extLst>
       <p:ext uri="{BB962C8B-B14F-4D97-AF65-F5344CB8AC3E}">
-        <p14:creationId xmlns:p14="http://schemas.microsoft.com/office/powerpoint/2010/main" val="406054369"/>
+        <p14:creationId xmlns:p14="http://schemas.microsoft.com/office/powerpoint/2010/main" val="1200147730"/>
       </p:ext>
     </p:extLst>
   </p:cSld>
@@ -6846,7 +6846,7 @@
           <p:cNvPr id="9" name="close-kicker">
             <a:extLst xmlns:a="http://schemas.openxmlformats.org/drawingml/2006/main">
               <a:ext uri="{FF2B5EF4-FFF2-40B4-BE49-F238E27FC236}">
-                <a16:creationId xmlns:a16="http://schemas.microsoft.com/office/drawing/2014/main" id="{69805D43-A77C-43E6-A9E5-C1C94DDBA23B}"/>
+                <a16:creationId xmlns:a16="http://schemas.microsoft.com/office/drawing/2014/main" id="{480F25C4-97C9-46EF-AC5B-36FD37BD16C0}"/>
               </a:ext>
             </a:extLst>
           </p:cNvPr>
@@ -6902,7 +6902,7 @@
           <p:cNvPr id="2" name="close-title">
             <a:extLst xmlns:a="http://schemas.openxmlformats.org/drawingml/2006/main">
               <a:ext uri="{FF2B5EF4-FFF2-40B4-BE49-F238E27FC236}">
-                <a16:creationId xmlns:a16="http://schemas.microsoft.com/office/drawing/2014/main" id="{EA9755D7-D60F-4A53-8F55-82E919351949}"/>
+                <a16:creationId xmlns:a16="http://schemas.microsoft.com/office/drawing/2014/main" id="{D487C06F-ECB0-4E42-B341-2EEB4013DDA5}"/>
               </a:ext>
             </a:extLst>
           </p:cNvPr>
@@ -6981,7 +6981,7 @@
           <p:cNvPr id="3" name="close-tr">
             <a:extLst xmlns:a="http://schemas.openxmlformats.org/drawingml/2006/main">
               <a:ext uri="{FF2B5EF4-FFF2-40B4-BE49-F238E27FC236}">
-                <a16:creationId xmlns:a16="http://schemas.microsoft.com/office/drawing/2014/main" id="{D398432A-77D5-45B6-968A-0DC99599910F}"/>
+                <a16:creationId xmlns:a16="http://schemas.microsoft.com/office/drawing/2014/main" id="{7665D151-359C-4192-8E2B-CE2CAE291B0C}"/>
               </a:ext>
             </a:extLst>
           </p:cNvPr>
@@ -7037,7 +7037,7 @@
           <p:cNvPr id="4" name="close-ru">
             <a:extLst xmlns:a="http://schemas.openxmlformats.org/drawingml/2006/main">
               <a:ext uri="{FF2B5EF4-FFF2-40B4-BE49-F238E27FC236}">
-                <a16:creationId xmlns:a16="http://schemas.microsoft.com/office/drawing/2014/main" id="{59B7B2B4-A21C-4D53-B268-7FB6C34BF102}"/>
+                <a16:creationId xmlns:a16="http://schemas.microsoft.com/office/drawing/2014/main" id="{77BB3B4A-2BF0-4F33-AAC2-663589BCE7CD}"/>
               </a:ext>
             </a:extLst>
           </p:cNvPr>
@@ -7093,7 +7093,7 @@
           <p:cNvPr id="5" name="close-rule">
             <a:extLst xmlns:a="http://schemas.openxmlformats.org/drawingml/2006/main">
               <a:ext uri="{FF2B5EF4-FFF2-40B4-BE49-F238E27FC236}">
-                <a16:creationId xmlns:a16="http://schemas.microsoft.com/office/drawing/2014/main" id="{96CE656F-6C37-430A-BF4E-3CFE720DC550}"/>
+                <a16:creationId xmlns:a16="http://schemas.microsoft.com/office/drawing/2014/main" id="{2E0E6863-2150-4B09-9A4F-275FB8DAA58A}"/>
               </a:ext>
             </a:extLst>
           </p:cNvPr>
@@ -7124,7 +7124,7 @@
           <p:cNvPr id="6" name="close-action">
             <a:extLst xmlns:a="http://schemas.openxmlformats.org/drawingml/2006/main">
               <a:ext uri="{FF2B5EF4-FFF2-40B4-BE49-F238E27FC236}">
-                <a16:creationId xmlns:a16="http://schemas.microsoft.com/office/drawing/2014/main" id="{617DEFEF-1F66-4724-B7AE-03C950E3C940}"/>
+                <a16:creationId xmlns:a16="http://schemas.microsoft.com/office/drawing/2014/main" id="{D4783F94-AD85-46F4-973D-590BE5DD2B21}"/>
               </a:ext>
             </a:extLst>
           </p:cNvPr>
@@ -7180,7 +7180,7 @@
           <p:cNvPr id="7" name="close-meta">
             <a:extLst xmlns:a="http://schemas.openxmlformats.org/drawingml/2006/main">
               <a:ext uri="{FF2B5EF4-FFF2-40B4-BE49-F238E27FC236}">
-                <a16:creationId xmlns:a16="http://schemas.microsoft.com/office/drawing/2014/main" id="{C1911AC5-30EA-4974-BBEA-A31D9464DF10}"/>
+                <a16:creationId xmlns:a16="http://schemas.microsoft.com/office/drawing/2014/main" id="{89FF406E-04EC-4175-A984-81D392C15C22}"/>
               </a:ext>
             </a:extLst>
           </p:cNvPr>
@@ -7236,7 +7236,7 @@
           <p:cNvPr id="8" name="footer-8">
             <a:extLst xmlns:a="http://schemas.openxmlformats.org/drawingml/2006/main">
               <a:ext uri="{FF2B5EF4-FFF2-40B4-BE49-F238E27FC236}">
-                <a16:creationId xmlns:a16="http://schemas.microsoft.com/office/drawing/2014/main" id="{8F04B4B7-F174-445A-8C0D-805470CFE1D6}"/>
+                <a16:creationId xmlns:a16="http://schemas.microsoft.com/office/drawing/2014/main" id="{8D2FB1DA-09D4-4456-9303-C8EC2E5DE4DF}"/>
               </a:ext>
             </a:extLst>
           </p:cNvPr>
@@ -7290,7 +7290,7 @@
     </p:spTree>
     <p:extLst>
       <p:ext uri="{BB962C8B-B14F-4D97-AF65-F5344CB8AC3E}">
-        <p14:creationId xmlns:p14="http://schemas.microsoft.com/office/powerpoint/2010/main" val="138779937"/>
+        <p14:creationId xmlns:p14="http://schemas.microsoft.com/office/powerpoint/2010/main" val="2031665315"/>
       </p:ext>
     </p:extLst>
   </p:cSld>

</xml_diff>

<commit_message>
Sunum: v1.2.0 sözlük yön seçimi ve RU-EN-TR bilgileri
Co-Authored-By: Claude Opus 5 <noreply@anthropic.com>
</commit_message>
<xml_diff>
--- a/docs/presentation/Russian-Course-AI-Trilingual.pptx
+++ b/docs/presentation/Russian-Course-AI-Trilingual.pptx
@@ -2,20 +2,20 @@
 <file path=ppt/presentation.xml><?xml version="1.0" encoding="utf-8"?>
 <p:presentation xmlns:p="http://schemas.openxmlformats.org/presentationml/2006/main">
   <p:sldMasterIdLst>
-    <p:sldMasterId xmlns:r="http://schemas.openxmlformats.org/officeDocument/2006/relationships" id="2147483648" r:id="R0e6950686e614f83"/>
+    <p:sldMasterId xmlns:r="http://schemas.openxmlformats.org/officeDocument/2006/relationships" id="2147483648" r:id="R9243d59718c64380"/>
   </p:sldMasterIdLst>
   <p:notesMasterIdLst>
-    <p:notesMasterId xmlns:r="http://schemas.openxmlformats.org/officeDocument/2006/relationships" r:id="R462a23ffeea4425d"/>
+    <p:notesMasterId xmlns:r="http://schemas.openxmlformats.org/officeDocument/2006/relationships" r:id="Rffc1ad3513bd4a17"/>
   </p:notesMasterIdLst>
   <p:sldIdLst>
-    <p:sldId xmlns:r="http://schemas.openxmlformats.org/officeDocument/2006/relationships" id="256" r:id="R47fb806b241749ea"/>
-    <p:sldId xmlns:r="http://schemas.openxmlformats.org/officeDocument/2006/relationships" id="257" r:id="R0fa9f2908d6e44ba"/>
-    <p:sldId xmlns:r="http://schemas.openxmlformats.org/officeDocument/2006/relationships" id="258" r:id="Ra2c98a1dc64144bd"/>
-    <p:sldId xmlns:r="http://schemas.openxmlformats.org/officeDocument/2006/relationships" id="259" r:id="Rc782bcdff62d4e5b"/>
-    <p:sldId xmlns:r="http://schemas.openxmlformats.org/officeDocument/2006/relationships" id="260" r:id="R66c590aaa85e4869"/>
-    <p:sldId xmlns:r="http://schemas.openxmlformats.org/officeDocument/2006/relationships" id="261" r:id="R810d71487e524508"/>
-    <p:sldId xmlns:r="http://schemas.openxmlformats.org/officeDocument/2006/relationships" id="262" r:id="R5cc0c9c7690947b1"/>
-    <p:sldId xmlns:r="http://schemas.openxmlformats.org/officeDocument/2006/relationships" id="263" r:id="R3b05031a241c4504"/>
+    <p:sldId xmlns:r="http://schemas.openxmlformats.org/officeDocument/2006/relationships" id="256" r:id="R2d19788d0dc74543"/>
+    <p:sldId xmlns:r="http://schemas.openxmlformats.org/officeDocument/2006/relationships" id="257" r:id="R39ce3473945147b3"/>
+    <p:sldId xmlns:r="http://schemas.openxmlformats.org/officeDocument/2006/relationships" id="258" r:id="Rdc7b4bd3670d448f"/>
+    <p:sldId xmlns:r="http://schemas.openxmlformats.org/officeDocument/2006/relationships" id="259" r:id="R71089e54d85c4a71"/>
+    <p:sldId xmlns:r="http://schemas.openxmlformats.org/officeDocument/2006/relationships" id="260" r:id="R38a32eba047844e2"/>
+    <p:sldId xmlns:r="http://schemas.openxmlformats.org/officeDocument/2006/relationships" id="261" r:id="R89dd58934f0546e3"/>
+    <p:sldId xmlns:r="http://schemas.openxmlformats.org/officeDocument/2006/relationships" id="262" r:id="Rf65ccbe3a294474e"/>
+    <p:sldId xmlns:r="http://schemas.openxmlformats.org/officeDocument/2006/relationships" id="263" r:id="R130b3dc25d6f400a"/>
   </p:sldIdLst>
   <p:sldSz cx="12192000" cy="6858000"/>
   <p:notesSz cx="6858000" cy="9144000"/>
@@ -774,7 +774,7 @@
           </a:p>
           <a:p xmlns:a="http://schemas.openxmlformats.org/drawingml/2006/main">
             <a:r>
-              <a:t>- D:/Russian/rca/dictionary.py + rca/dict_data.py (bidirectional RU-EN dictionary, 1,360 built-in entries, OpenRussian layer)</a:t>
+              <a:t>- D:/Russian/rca/dictionary.py + rca/dict_data.py (RU-EN-TR dictionary with direction switch, 1,360 built-in entries with Turkish glosses, OpenRussian layer)</a:t>
             </a:r>
           </a:p>
           <a:p xmlns:a="http://schemas.openxmlformats.org/drawingml/2006/main">
@@ -934,7 +934,7 @@
           </a:p>
           <a:p xmlns:a="http://schemas.openxmlformats.org/drawingml/2006/main">
             <a:r>
-              <a:t>- https://github.com/Azizsekerdil/RussianCourseAI/releases/tag/v1.1.2 (v1.1.2 release with Windows and macOS zip assets; private repository)</a:t>
+              <a:t>- https://github.com/Azizsekerdil/RussianCourseAI/releases/tag/v1.2.0 (v1.2.0 release with Windows and macOS zip assets; private repository)</a:t>
             </a:r>
           </a:p>
         </p:txBody>
@@ -1077,7 +1077,7 @@
   </p:cSld>
   <p:clrMap bg1="lt1" tx1="dk1" bg2="lt2" tx2="dk2" accent1="accent1" accent2="accent2" accent3="accent3" accent4="accent4" accent5="accent5" accent6="accent6" hlink="hlink" folHlink="folHlink"/>
   <p:sldLayoutIdLst>
-    <p:sldLayoutId xmlns:r="http://schemas.openxmlformats.org/officeDocument/2006/relationships" id="2147483649" r:id="R63e794f281ab4ee8"/>
+    <p:sldLayoutId xmlns:r="http://schemas.openxmlformats.org/officeDocument/2006/relationships" id="2147483649" r:id="R283a1827d0604724"/>
   </p:sldLayoutIdLst>
   <p:txStyles>
     <p:titleStyle>
@@ -1628,7 +1628,7 @@
           <p:cNvPr id="11" name="cover-kicker">
             <a:extLst xmlns:a="http://schemas.openxmlformats.org/drawingml/2006/main">
               <a:ext uri="{FF2B5EF4-FFF2-40B4-BE49-F238E27FC236}">
-                <a16:creationId xmlns:a16="http://schemas.microsoft.com/office/drawing/2014/main" id="{72BE6F43-151D-49B5-9158-AE95FA665B18}"/>
+                <a16:creationId xmlns:a16="http://schemas.microsoft.com/office/drawing/2014/main" id="{229AFB08-C3EA-4BBA-B7AA-9C5289C11ED1}"/>
               </a:ext>
             </a:extLst>
           </p:cNvPr>
@@ -1684,7 +1684,7 @@
           <p:cNvPr id="2" name="cover-title">
             <a:extLst xmlns:a="http://schemas.openxmlformats.org/drawingml/2006/main">
               <a:ext uri="{FF2B5EF4-FFF2-40B4-BE49-F238E27FC236}">
-                <a16:creationId xmlns:a16="http://schemas.microsoft.com/office/drawing/2014/main" id="{C39B616E-63C8-4ADC-88E6-CB9C91984255}"/>
+                <a16:creationId xmlns:a16="http://schemas.microsoft.com/office/drawing/2014/main" id="{DCFB3B6E-669F-4405-A72B-4337E2BF25FA}"/>
               </a:ext>
             </a:extLst>
           </p:cNvPr>
@@ -1763,7 +1763,7 @@
           <p:cNvPr id="3" name="cover-rule">
             <a:extLst xmlns:a="http://schemas.openxmlformats.org/drawingml/2006/main">
               <a:ext uri="{FF2B5EF4-FFF2-40B4-BE49-F238E27FC236}">
-                <a16:creationId xmlns:a16="http://schemas.microsoft.com/office/drawing/2014/main" id="{DFC00E70-3FDD-447F-8A25-19302F7C14D7}"/>
+                <a16:creationId xmlns:a16="http://schemas.microsoft.com/office/drawing/2014/main" id="{A46D1FC0-2855-498A-A7FA-FAD59463F603}"/>
               </a:ext>
             </a:extLst>
           </p:cNvPr>
@@ -1794,7 +1794,7 @@
           <p:cNvPr id="4" name="cover-tr">
             <a:extLst xmlns:a="http://schemas.openxmlformats.org/drawingml/2006/main">
               <a:ext uri="{FF2B5EF4-FFF2-40B4-BE49-F238E27FC236}">
-                <a16:creationId xmlns:a16="http://schemas.microsoft.com/office/drawing/2014/main" id="{ADF30AE1-10B3-463F-8B34-8ED0F9A1C32B}"/>
+                <a16:creationId xmlns:a16="http://schemas.microsoft.com/office/drawing/2014/main" id="{732EB094-7ABA-4DB8-87F9-C89185B32BE0}"/>
               </a:ext>
             </a:extLst>
           </p:cNvPr>
@@ -1850,7 +1850,7 @@
           <p:cNvPr id="5" name="cover-en">
             <a:extLst xmlns:a="http://schemas.openxmlformats.org/drawingml/2006/main">
               <a:ext uri="{FF2B5EF4-FFF2-40B4-BE49-F238E27FC236}">
-                <a16:creationId xmlns:a16="http://schemas.microsoft.com/office/drawing/2014/main" id="{5210288A-7260-4997-BC7C-4A268DF8DDD6}"/>
+                <a16:creationId xmlns:a16="http://schemas.microsoft.com/office/drawing/2014/main" id="{6F131FC5-1E07-4464-AB84-36781AB532A8}"/>
               </a:ext>
             </a:extLst>
           </p:cNvPr>
@@ -1906,7 +1906,7 @@
           <p:cNvPr id="6" name="cover-ru">
             <a:extLst xmlns:a="http://schemas.openxmlformats.org/drawingml/2006/main">
               <a:ext uri="{FF2B5EF4-FFF2-40B4-BE49-F238E27FC236}">
-                <a16:creationId xmlns:a16="http://schemas.microsoft.com/office/drawing/2014/main" id="{AD8F39B1-96A0-4D73-AA0B-1A1B15926008}"/>
+                <a16:creationId xmlns:a16="http://schemas.microsoft.com/office/drawing/2014/main" id="{37D1E367-E120-4682-86B3-29D8A50644B4}"/>
               </a:ext>
             </a:extLst>
           </p:cNvPr>
@@ -1962,7 +1962,7 @@
           <p:cNvPr id="7" name="cover-meta">
             <a:extLst xmlns:a="http://schemas.openxmlformats.org/drawingml/2006/main">
               <a:ext uri="{FF2B5EF4-FFF2-40B4-BE49-F238E27FC236}">
-                <a16:creationId xmlns:a16="http://schemas.microsoft.com/office/drawing/2014/main" id="{01DAC586-E268-4147-886D-CBF8EDA86B87}"/>
+                <a16:creationId xmlns:a16="http://schemas.microsoft.com/office/drawing/2014/main" id="{159BDF93-65A4-4B70-AFED-D1A32B3BBA1E}"/>
               </a:ext>
             </a:extLst>
           </p:cNvPr>
@@ -2018,7 +2018,7 @@
           <p:cNvPr id="8" name="hero-backing">
             <a:extLst xmlns:a="http://schemas.openxmlformats.org/drawingml/2006/main">
               <a:ext uri="{FF2B5EF4-FFF2-40B4-BE49-F238E27FC236}">
-                <a16:creationId xmlns:a16="http://schemas.microsoft.com/office/drawing/2014/main" id="{84041A3A-9001-41E9-8526-8E194E3845A0}"/>
+                <a16:creationId xmlns:a16="http://schemas.microsoft.com/office/drawing/2014/main" id="{9BE51A69-6828-4395-87D0-E4A348931294}"/>
               </a:ext>
             </a:extLst>
           </p:cNvPr>
@@ -2055,7 +2055,7 @@
           <p:nvPr/>
         </p:nvPicPr>
         <p:blipFill>
-          <a:blip xmlns:r="http://schemas.openxmlformats.org/officeDocument/2006/relationships" xmlns:a="http://schemas.openxmlformats.org/drawingml/2006/main" r:embed="Rc7c50242961d4cc9"/>
+          <a:blip xmlns:r="http://schemas.openxmlformats.org/officeDocument/2006/relationships" xmlns:a="http://schemas.openxmlformats.org/drawingml/2006/main" r:embed="R1a1df4690db744be"/>
           <a:srcRect xmlns:a="http://schemas.openxmlformats.org/drawingml/2006/main" l="510" t="0" r="510" b="0"/>
           <a:stretch xmlns:a="http://schemas.openxmlformats.org/drawingml/2006/main">
             <a:fillRect l="0" t="0" r="0" b="0"/>
@@ -2078,7 +2078,7 @@
           <p:cNvPr id="10" name="footer-1">
             <a:extLst xmlns:a="http://schemas.openxmlformats.org/drawingml/2006/main">
               <a:ext uri="{FF2B5EF4-FFF2-40B4-BE49-F238E27FC236}">
-                <a16:creationId xmlns:a16="http://schemas.microsoft.com/office/drawing/2014/main" id="{E3968BC7-BEF5-4809-996F-26DD29792749}"/>
+                <a16:creationId xmlns:a16="http://schemas.microsoft.com/office/drawing/2014/main" id="{58CD8957-A08B-45C0-803B-626444B82ABB}"/>
               </a:ext>
             </a:extLst>
           </p:cNvPr>
@@ -2132,7 +2132,7 @@
     </p:spTree>
     <p:extLst>
       <p:ext uri="{BB962C8B-B14F-4D97-AF65-F5344CB8AC3E}">
-        <p14:creationId xmlns:p14="http://schemas.microsoft.com/office/powerpoint/2010/main" val="494638422"/>
+        <p14:creationId xmlns:p14="http://schemas.microsoft.com/office/powerpoint/2010/main" val="1994096018"/>
       </p:ext>
     </p:extLst>
   </p:cSld>
@@ -2163,7 +2163,7 @@
           <p:cNvPr id="6" name="screen-title">
             <a:extLst xmlns:a="http://schemas.openxmlformats.org/drawingml/2006/main">
               <a:ext uri="{FF2B5EF4-FFF2-40B4-BE49-F238E27FC236}">
-                <a16:creationId xmlns:a16="http://schemas.microsoft.com/office/drawing/2014/main" id="{A2DE3156-7140-43BD-95B4-47B7356B5A7B}"/>
+                <a16:creationId xmlns:a16="http://schemas.microsoft.com/office/drawing/2014/main" id="{24643229-ED78-464A-948D-2D00D5E96BEE}"/>
               </a:ext>
             </a:extLst>
           </p:cNvPr>
@@ -2219,7 +2219,7 @@
           <p:cNvPr id="2" name="screen-subtitle">
             <a:extLst xmlns:a="http://schemas.openxmlformats.org/drawingml/2006/main">
               <a:ext uri="{FF2B5EF4-FFF2-40B4-BE49-F238E27FC236}">
-                <a16:creationId xmlns:a16="http://schemas.microsoft.com/office/drawing/2014/main" id="{942B7966-4856-420F-B68A-FF9CFC9441EC}"/>
+                <a16:creationId xmlns:a16="http://schemas.microsoft.com/office/drawing/2014/main" id="{35513F5D-1CFF-4415-B2F6-25122FA70A52}"/>
               </a:ext>
             </a:extLst>
           </p:cNvPr>
@@ -2275,7 +2275,7 @@
           <p:cNvPr id="3" name="screen-frame">
             <a:extLst xmlns:a="http://schemas.openxmlformats.org/drawingml/2006/main">
               <a:ext uri="{FF2B5EF4-FFF2-40B4-BE49-F238E27FC236}">
-                <a16:creationId xmlns:a16="http://schemas.microsoft.com/office/drawing/2014/main" id="{8BB3F2C2-3D3C-42D9-BA94-360566E63B34}"/>
+                <a16:creationId xmlns:a16="http://schemas.microsoft.com/office/drawing/2014/main" id="{E5F0C7C8-625F-4928-A3CE-6962C03112EA}"/>
               </a:ext>
             </a:extLst>
           </p:cNvPr>
@@ -2312,7 +2312,7 @@
           <p:nvPr/>
         </p:nvPicPr>
         <p:blipFill>
-          <a:blip xmlns:r="http://schemas.openxmlformats.org/officeDocument/2006/relationships" xmlns:a="http://schemas.openxmlformats.org/drawingml/2006/main" r:embed="R581fa669e5154431"/>
+          <a:blip xmlns:r="http://schemas.openxmlformats.org/officeDocument/2006/relationships" xmlns:a="http://schemas.openxmlformats.org/drawingml/2006/main" r:embed="Rbc19aa0a9a834338"/>
           <a:stretch xmlns:a="http://schemas.openxmlformats.org/drawingml/2006/main"/>
         </p:blipFill>
         <p:spPr>
@@ -2332,7 +2332,7 @@
           <p:cNvPr id="5" name="screen-footer">
             <a:extLst xmlns:a="http://schemas.openxmlformats.org/drawingml/2006/main">
               <a:ext uri="{FF2B5EF4-FFF2-40B4-BE49-F238E27FC236}">
-                <a16:creationId xmlns:a16="http://schemas.microsoft.com/office/drawing/2014/main" id="{CBCFE3D5-A023-422E-8CAC-6DE76EC47E0F}"/>
+                <a16:creationId xmlns:a16="http://schemas.microsoft.com/office/drawing/2014/main" id="{3695F82A-3A70-4280-97F4-74034D1AED78}"/>
               </a:ext>
             </a:extLst>
           </p:cNvPr>
@@ -2386,7 +2386,7 @@
     </p:spTree>
     <p:extLst>
       <p:ext uri="{BB962C8B-B14F-4D97-AF65-F5344CB8AC3E}">
-        <p14:creationId xmlns:p14="http://schemas.microsoft.com/office/powerpoint/2010/main" val="1016196716"/>
+        <p14:creationId xmlns:p14="http://schemas.microsoft.com/office/powerpoint/2010/main" val="10307070"/>
       </p:ext>
     </p:extLst>
   </p:cSld>
@@ -2417,7 +2417,7 @@
           <p:cNvPr id="17" name="language-title">
             <a:extLst xmlns:a="http://schemas.openxmlformats.org/drawingml/2006/main">
               <a:ext uri="{FF2B5EF4-FFF2-40B4-BE49-F238E27FC236}">
-                <a16:creationId xmlns:a16="http://schemas.microsoft.com/office/drawing/2014/main" id="{274E69F3-8A25-48C6-A378-D8B9FC228D3D}"/>
+                <a16:creationId xmlns:a16="http://schemas.microsoft.com/office/drawing/2014/main" id="{C8F541AD-E941-466F-8A19-E70DDB9C15A1}"/>
               </a:ext>
             </a:extLst>
           </p:cNvPr>
@@ -2473,7 +2473,7 @@
           <p:cNvPr id="2" name="language-subtitle">
             <a:extLst xmlns:a="http://schemas.openxmlformats.org/drawingml/2006/main">
               <a:ext uri="{FF2B5EF4-FFF2-40B4-BE49-F238E27FC236}">
-                <a16:creationId xmlns:a16="http://schemas.microsoft.com/office/drawing/2014/main" id="{ECA0A163-A15E-4CE1-8BAB-F04A4D58CBC9}"/>
+                <a16:creationId xmlns:a16="http://schemas.microsoft.com/office/drawing/2014/main" id="{26D27363-EE34-477A-9BD7-7340223C367D}"/>
               </a:ext>
             </a:extLst>
           </p:cNvPr>
@@ -2529,7 +2529,7 @@
           <p:cNvPr id="3" name="language-rule">
             <a:extLst xmlns:a="http://schemas.openxmlformats.org/drawingml/2006/main">
               <a:ext uri="{FF2B5EF4-FFF2-40B4-BE49-F238E27FC236}">
-                <a16:creationId xmlns:a16="http://schemas.microsoft.com/office/drawing/2014/main" id="{A2AB4C33-7337-4298-908F-04614F609CF8}"/>
+                <a16:creationId xmlns:a16="http://schemas.microsoft.com/office/drawing/2014/main" id="{A062F3B4-417D-4F6D-8B11-BD98520C4D92}"/>
               </a:ext>
             </a:extLst>
           </p:cNvPr>
@@ -2560,7 +2560,7 @@
           <p:cNvPr id="4" name="language-label-0">
             <a:extLst xmlns:a="http://schemas.openxmlformats.org/drawingml/2006/main">
               <a:ext uri="{FF2B5EF4-FFF2-40B4-BE49-F238E27FC236}">
-                <a16:creationId xmlns:a16="http://schemas.microsoft.com/office/drawing/2014/main" id="{6C7DCB2E-F457-4DE5-AFD1-202FA14ADD4C}"/>
+                <a16:creationId xmlns:a16="http://schemas.microsoft.com/office/drawing/2014/main" id="{C5AEB42A-FC38-49F1-8A2C-936879D1FBBC}"/>
               </a:ext>
             </a:extLst>
           </p:cNvPr>
@@ -2616,7 +2616,7 @@
           <p:cNvPr id="5" name="language-head-0">
             <a:extLst xmlns:a="http://schemas.openxmlformats.org/drawingml/2006/main">
               <a:ext uri="{FF2B5EF4-FFF2-40B4-BE49-F238E27FC236}">
-                <a16:creationId xmlns:a16="http://schemas.microsoft.com/office/drawing/2014/main" id="{3829403D-B318-4984-B86D-45C44FD613D0}"/>
+                <a16:creationId xmlns:a16="http://schemas.microsoft.com/office/drawing/2014/main" id="{D0F131D4-6F83-43EE-BAF6-E764DEE08D78}"/>
               </a:ext>
             </a:extLst>
           </p:cNvPr>
@@ -2672,7 +2672,7 @@
           <p:cNvPr id="6" name="language-body-0">
             <a:extLst xmlns:a="http://schemas.openxmlformats.org/drawingml/2006/main">
               <a:ext uri="{FF2B5EF4-FFF2-40B4-BE49-F238E27FC236}">
-                <a16:creationId xmlns:a16="http://schemas.microsoft.com/office/drawing/2014/main" id="{F7F435FA-D395-465B-B0CC-545B89081F8B}"/>
+                <a16:creationId xmlns:a16="http://schemas.microsoft.com/office/drawing/2014/main" id="{2D34C88C-8C2D-4933-9A5F-ABDF74E22093}"/>
               </a:ext>
             </a:extLst>
           </p:cNvPr>
@@ -2728,7 +2728,7 @@
           <p:cNvPr id="7" name="language-accent-0">
             <a:extLst xmlns:a="http://schemas.openxmlformats.org/drawingml/2006/main">
               <a:ext uri="{FF2B5EF4-FFF2-40B4-BE49-F238E27FC236}">
-                <a16:creationId xmlns:a16="http://schemas.microsoft.com/office/drawing/2014/main" id="{63FA023B-D0BF-4DB3-9BC1-6FB9DE28DFF3}"/>
+                <a16:creationId xmlns:a16="http://schemas.microsoft.com/office/drawing/2014/main" id="{8C66BF13-7995-4F5F-8F44-E0DF42F7215D}"/>
               </a:ext>
             </a:extLst>
           </p:cNvPr>
@@ -2759,7 +2759,7 @@
           <p:cNvPr id="8" name="language-label-1">
             <a:extLst xmlns:a="http://schemas.openxmlformats.org/drawingml/2006/main">
               <a:ext uri="{FF2B5EF4-FFF2-40B4-BE49-F238E27FC236}">
-                <a16:creationId xmlns:a16="http://schemas.microsoft.com/office/drawing/2014/main" id="{F2536F4B-2DDD-468C-BF77-F2279DA1C244}"/>
+                <a16:creationId xmlns:a16="http://schemas.microsoft.com/office/drawing/2014/main" id="{9FEE6A9F-FFF9-4F59-B4CB-C610B62F0057}"/>
               </a:ext>
             </a:extLst>
           </p:cNvPr>
@@ -2815,7 +2815,7 @@
           <p:cNvPr id="9" name="language-head-1">
             <a:extLst xmlns:a="http://schemas.openxmlformats.org/drawingml/2006/main">
               <a:ext uri="{FF2B5EF4-FFF2-40B4-BE49-F238E27FC236}">
-                <a16:creationId xmlns:a16="http://schemas.microsoft.com/office/drawing/2014/main" id="{163B6C00-6304-4A21-9336-CBA9CF6A1E14}"/>
+                <a16:creationId xmlns:a16="http://schemas.microsoft.com/office/drawing/2014/main" id="{BAE1D2BA-E59B-4F28-B68E-838D2840EADF}"/>
               </a:ext>
             </a:extLst>
           </p:cNvPr>
@@ -2871,7 +2871,7 @@
           <p:cNvPr id="10" name="language-body-1">
             <a:extLst xmlns:a="http://schemas.openxmlformats.org/drawingml/2006/main">
               <a:ext uri="{FF2B5EF4-FFF2-40B4-BE49-F238E27FC236}">
-                <a16:creationId xmlns:a16="http://schemas.microsoft.com/office/drawing/2014/main" id="{8866ED22-231C-4F2C-B709-47CDBC9E7B31}"/>
+                <a16:creationId xmlns:a16="http://schemas.microsoft.com/office/drawing/2014/main" id="{818F11EF-B445-433F-8015-77B6BF74D028}"/>
               </a:ext>
             </a:extLst>
           </p:cNvPr>
@@ -2927,7 +2927,7 @@
           <p:cNvPr id="11" name="language-accent-1">
             <a:extLst xmlns:a="http://schemas.openxmlformats.org/drawingml/2006/main">
               <a:ext uri="{FF2B5EF4-FFF2-40B4-BE49-F238E27FC236}">
-                <a16:creationId xmlns:a16="http://schemas.microsoft.com/office/drawing/2014/main" id="{FF3F7CBA-2531-44AA-B5DE-C0DE04FF0B0D}"/>
+                <a16:creationId xmlns:a16="http://schemas.microsoft.com/office/drawing/2014/main" id="{0AFC85F9-543D-46F7-ABE8-949A6E2A09D5}"/>
               </a:ext>
             </a:extLst>
           </p:cNvPr>
@@ -2958,7 +2958,7 @@
           <p:cNvPr id="12" name="language-label-2">
             <a:extLst xmlns:a="http://schemas.openxmlformats.org/drawingml/2006/main">
               <a:ext uri="{FF2B5EF4-FFF2-40B4-BE49-F238E27FC236}">
-                <a16:creationId xmlns:a16="http://schemas.microsoft.com/office/drawing/2014/main" id="{48018914-E29D-4ED3-A0C3-8DF422B1FF78}"/>
+                <a16:creationId xmlns:a16="http://schemas.microsoft.com/office/drawing/2014/main" id="{0E1905D4-EE07-4FE6-AFB6-296CB05CD51F}"/>
               </a:ext>
             </a:extLst>
           </p:cNvPr>
@@ -3014,7 +3014,7 @@
           <p:cNvPr id="13" name="language-head-2">
             <a:extLst xmlns:a="http://schemas.openxmlformats.org/drawingml/2006/main">
               <a:ext uri="{FF2B5EF4-FFF2-40B4-BE49-F238E27FC236}">
-                <a16:creationId xmlns:a16="http://schemas.microsoft.com/office/drawing/2014/main" id="{1E2795D4-1816-426F-9A04-913DB40D707C}"/>
+                <a16:creationId xmlns:a16="http://schemas.microsoft.com/office/drawing/2014/main" id="{4135E8AC-8A5B-422C-8025-2DB7125F3AF0}"/>
               </a:ext>
             </a:extLst>
           </p:cNvPr>
@@ -3070,7 +3070,7 @@
           <p:cNvPr id="14" name="language-body-2">
             <a:extLst xmlns:a="http://schemas.openxmlformats.org/drawingml/2006/main">
               <a:ext uri="{FF2B5EF4-FFF2-40B4-BE49-F238E27FC236}">
-                <a16:creationId xmlns:a16="http://schemas.microsoft.com/office/drawing/2014/main" id="{C3F53394-BA94-4E5B-859A-1DF7F119B405}"/>
+                <a16:creationId xmlns:a16="http://schemas.microsoft.com/office/drawing/2014/main" id="{6C2BCE05-C3D3-4364-911E-4166664DED0F}"/>
               </a:ext>
             </a:extLst>
           </p:cNvPr>
@@ -3126,7 +3126,7 @@
           <p:cNvPr id="15" name="language-accent-2">
             <a:extLst xmlns:a="http://schemas.openxmlformats.org/drawingml/2006/main">
               <a:ext uri="{FF2B5EF4-FFF2-40B4-BE49-F238E27FC236}">
-                <a16:creationId xmlns:a16="http://schemas.microsoft.com/office/drawing/2014/main" id="{262BEB27-B19E-402B-924A-BBD914883C13}"/>
+                <a16:creationId xmlns:a16="http://schemas.microsoft.com/office/drawing/2014/main" id="{681FFC26-E345-4997-8FD5-A3573CB49D0D}"/>
               </a:ext>
             </a:extLst>
           </p:cNvPr>
@@ -3157,7 +3157,7 @@
           <p:cNvPr id="16" name="footer-3">
             <a:extLst xmlns:a="http://schemas.openxmlformats.org/drawingml/2006/main">
               <a:ext uri="{FF2B5EF4-FFF2-40B4-BE49-F238E27FC236}">
-                <a16:creationId xmlns:a16="http://schemas.microsoft.com/office/drawing/2014/main" id="{6A241A3B-43C5-4D13-9FF8-314615B3BB7B}"/>
+                <a16:creationId xmlns:a16="http://schemas.microsoft.com/office/drawing/2014/main" id="{7CC6D7D6-DAC9-4E48-868F-E69DBE06C803}"/>
               </a:ext>
             </a:extLst>
           </p:cNvPr>
@@ -3211,7 +3211,7 @@
     </p:spTree>
     <p:extLst>
       <p:ext uri="{BB962C8B-B14F-4D97-AF65-F5344CB8AC3E}">
-        <p14:creationId xmlns:p14="http://schemas.microsoft.com/office/powerpoint/2010/main" val="527863676"/>
+        <p14:creationId xmlns:p14="http://schemas.microsoft.com/office/powerpoint/2010/main" val="669638051"/>
       </p:ext>
     </p:extLst>
   </p:cSld>
@@ -3242,7 +3242,7 @@
           <p:cNvPr id="23" name="loop-title">
             <a:extLst xmlns:a="http://schemas.openxmlformats.org/drawingml/2006/main">
               <a:ext uri="{FF2B5EF4-FFF2-40B4-BE49-F238E27FC236}">
-                <a16:creationId xmlns:a16="http://schemas.microsoft.com/office/drawing/2014/main" id="{46A6EEBA-AB32-40AD-8B25-B0222E6614B4}"/>
+                <a16:creationId xmlns:a16="http://schemas.microsoft.com/office/drawing/2014/main" id="{C7DEA656-7A1C-47FE-9501-A7B5B52C5105}"/>
               </a:ext>
             </a:extLst>
           </p:cNvPr>
@@ -3298,7 +3298,7 @@
           <p:cNvPr id="2" name="loop-subtitle">
             <a:extLst xmlns:a="http://schemas.openxmlformats.org/drawingml/2006/main">
               <a:ext uri="{FF2B5EF4-FFF2-40B4-BE49-F238E27FC236}">
-                <a16:creationId xmlns:a16="http://schemas.microsoft.com/office/drawing/2014/main" id="{3F283596-21AE-45A8-A151-D31E675B4CC3}"/>
+                <a16:creationId xmlns:a16="http://schemas.microsoft.com/office/drawing/2014/main" id="{8C0817CA-E719-4EAA-875F-721EA3869007}"/>
               </a:ext>
             </a:extLst>
           </p:cNvPr>
@@ -3354,7 +3354,7 @@
           <p:cNvPr id="3" name="loop-track">
             <a:extLst xmlns:a="http://schemas.openxmlformats.org/drawingml/2006/main">
               <a:ext uri="{FF2B5EF4-FFF2-40B4-BE49-F238E27FC236}">
-                <a16:creationId xmlns:a16="http://schemas.microsoft.com/office/drawing/2014/main" id="{F5F8A142-A169-48F9-BEC4-E76F62ECBE5B}"/>
+                <a16:creationId xmlns:a16="http://schemas.microsoft.com/office/drawing/2014/main" id="{B56C3A5E-0C2E-4C8F-A840-FF7519036D66}"/>
               </a:ext>
             </a:extLst>
           </p:cNvPr>
@@ -3385,7 +3385,7 @@
           <p:cNvPr id="4" name="loop-node-0">
             <a:extLst xmlns:a="http://schemas.openxmlformats.org/drawingml/2006/main">
               <a:ext uri="{FF2B5EF4-FFF2-40B4-BE49-F238E27FC236}">
-                <a16:creationId xmlns:a16="http://schemas.microsoft.com/office/drawing/2014/main" id="{49828832-8AF0-4981-A8CA-23EF4788F788}"/>
+                <a16:creationId xmlns:a16="http://schemas.microsoft.com/office/drawing/2014/main" id="{64FBFA2E-ACEB-4C41-BE14-295189F0E7F6}"/>
               </a:ext>
             </a:extLst>
           </p:cNvPr>
@@ -3418,7 +3418,7 @@
           <p:cNvPr id="5" name="loop-number-0">
             <a:extLst xmlns:a="http://schemas.openxmlformats.org/drawingml/2006/main">
               <a:ext uri="{FF2B5EF4-FFF2-40B4-BE49-F238E27FC236}">
-                <a16:creationId xmlns:a16="http://schemas.microsoft.com/office/drawing/2014/main" id="{76585E12-A832-440D-908C-CE0F55973FBD}"/>
+                <a16:creationId xmlns:a16="http://schemas.microsoft.com/office/drawing/2014/main" id="{4701F629-7932-45E6-84D4-3495B3E6A0FE}"/>
               </a:ext>
             </a:extLst>
           </p:cNvPr>
@@ -3474,7 +3474,7 @@
           <p:cNvPr id="6" name="loop-en-0">
             <a:extLst xmlns:a="http://schemas.openxmlformats.org/drawingml/2006/main">
               <a:ext uri="{FF2B5EF4-FFF2-40B4-BE49-F238E27FC236}">
-                <a16:creationId xmlns:a16="http://schemas.microsoft.com/office/drawing/2014/main" id="{CDAD05E3-789D-4F62-96A4-8B9BE1F6E79E}"/>
+                <a16:creationId xmlns:a16="http://schemas.microsoft.com/office/drawing/2014/main" id="{7140348C-FD08-4FFB-AC1E-16E4DC47C8F0}"/>
               </a:ext>
             </a:extLst>
           </p:cNvPr>
@@ -3530,7 +3530,7 @@
           <p:cNvPr id="7" name="loop-tr-0">
             <a:extLst xmlns:a="http://schemas.openxmlformats.org/drawingml/2006/main">
               <a:ext uri="{FF2B5EF4-FFF2-40B4-BE49-F238E27FC236}">
-                <a16:creationId xmlns:a16="http://schemas.microsoft.com/office/drawing/2014/main" id="{B3246265-0CAF-4746-ABBB-C3CD8B7649D2}"/>
+                <a16:creationId xmlns:a16="http://schemas.microsoft.com/office/drawing/2014/main" id="{8F71C090-B219-4DF0-AD4E-77542EC7D075}"/>
               </a:ext>
             </a:extLst>
           </p:cNvPr>
@@ -3586,7 +3586,7 @@
           <p:cNvPr id="8" name="loop-ru-0">
             <a:extLst xmlns:a="http://schemas.openxmlformats.org/drawingml/2006/main">
               <a:ext uri="{FF2B5EF4-FFF2-40B4-BE49-F238E27FC236}">
-                <a16:creationId xmlns:a16="http://schemas.microsoft.com/office/drawing/2014/main" id="{45324295-9DE7-4040-8761-5CE9097698D6}"/>
+                <a16:creationId xmlns:a16="http://schemas.microsoft.com/office/drawing/2014/main" id="{9A2ADE5D-4757-4FF5-AB0D-17E40AD335EA}"/>
               </a:ext>
             </a:extLst>
           </p:cNvPr>
@@ -3642,7 +3642,7 @@
           <p:cNvPr id="9" name="loop-detail-0">
             <a:extLst xmlns:a="http://schemas.openxmlformats.org/drawingml/2006/main">
               <a:ext uri="{FF2B5EF4-FFF2-40B4-BE49-F238E27FC236}">
-                <a16:creationId xmlns:a16="http://schemas.microsoft.com/office/drawing/2014/main" id="{83186149-8AF1-42FE-AB11-6821C5F1D51C}"/>
+                <a16:creationId xmlns:a16="http://schemas.microsoft.com/office/drawing/2014/main" id="{0A0E55E4-CA44-405F-A0CF-200C2C1F2C3B}"/>
               </a:ext>
             </a:extLst>
           </p:cNvPr>
@@ -3698,7 +3698,7 @@
           <p:cNvPr id="10" name="loop-node-1">
             <a:extLst xmlns:a="http://schemas.openxmlformats.org/drawingml/2006/main">
               <a:ext uri="{FF2B5EF4-FFF2-40B4-BE49-F238E27FC236}">
-                <a16:creationId xmlns:a16="http://schemas.microsoft.com/office/drawing/2014/main" id="{2B0F251F-EFE1-4FE1-BEF5-95407C67E993}"/>
+                <a16:creationId xmlns:a16="http://schemas.microsoft.com/office/drawing/2014/main" id="{9E5CF83A-29A7-4177-B029-2343CA6F02CD}"/>
               </a:ext>
             </a:extLst>
           </p:cNvPr>
@@ -3731,7 +3731,7 @@
           <p:cNvPr id="11" name="loop-number-1">
             <a:extLst xmlns:a="http://schemas.openxmlformats.org/drawingml/2006/main">
               <a:ext uri="{FF2B5EF4-FFF2-40B4-BE49-F238E27FC236}">
-                <a16:creationId xmlns:a16="http://schemas.microsoft.com/office/drawing/2014/main" id="{3C381A25-FD1E-4F08-BD89-1B7B625D87AC}"/>
+                <a16:creationId xmlns:a16="http://schemas.microsoft.com/office/drawing/2014/main" id="{851ABF14-8268-464C-981D-F9CB7F604E53}"/>
               </a:ext>
             </a:extLst>
           </p:cNvPr>
@@ -3787,7 +3787,7 @@
           <p:cNvPr id="12" name="loop-en-1">
             <a:extLst xmlns:a="http://schemas.openxmlformats.org/drawingml/2006/main">
               <a:ext uri="{FF2B5EF4-FFF2-40B4-BE49-F238E27FC236}">
-                <a16:creationId xmlns:a16="http://schemas.microsoft.com/office/drawing/2014/main" id="{424198CD-885D-4AD5-B0C6-084A123F0678}"/>
+                <a16:creationId xmlns:a16="http://schemas.microsoft.com/office/drawing/2014/main" id="{AC8B7F09-7192-4C5D-8B86-AFB15178C140}"/>
               </a:ext>
             </a:extLst>
           </p:cNvPr>
@@ -3843,7 +3843,7 @@
           <p:cNvPr id="13" name="loop-tr-1">
             <a:extLst xmlns:a="http://schemas.openxmlformats.org/drawingml/2006/main">
               <a:ext uri="{FF2B5EF4-FFF2-40B4-BE49-F238E27FC236}">
-                <a16:creationId xmlns:a16="http://schemas.microsoft.com/office/drawing/2014/main" id="{66B10C27-5E60-46A5-8E8C-44B598A7513B}"/>
+                <a16:creationId xmlns:a16="http://schemas.microsoft.com/office/drawing/2014/main" id="{A2F405BF-CC9C-4D09-B642-42D62328A245}"/>
               </a:ext>
             </a:extLst>
           </p:cNvPr>
@@ -3899,7 +3899,7 @@
           <p:cNvPr id="14" name="loop-ru-1">
             <a:extLst xmlns:a="http://schemas.openxmlformats.org/drawingml/2006/main">
               <a:ext uri="{FF2B5EF4-FFF2-40B4-BE49-F238E27FC236}">
-                <a16:creationId xmlns:a16="http://schemas.microsoft.com/office/drawing/2014/main" id="{66E24831-608A-4346-B44B-1F17696F20D2}"/>
+                <a16:creationId xmlns:a16="http://schemas.microsoft.com/office/drawing/2014/main" id="{3159703A-E02F-44CE-B3AB-F6AC47079C16}"/>
               </a:ext>
             </a:extLst>
           </p:cNvPr>
@@ -3955,7 +3955,7 @@
           <p:cNvPr id="15" name="loop-detail-1">
             <a:extLst xmlns:a="http://schemas.openxmlformats.org/drawingml/2006/main">
               <a:ext uri="{FF2B5EF4-FFF2-40B4-BE49-F238E27FC236}">
-                <a16:creationId xmlns:a16="http://schemas.microsoft.com/office/drawing/2014/main" id="{24175B82-412E-46A0-AACD-A63A030F5F50}"/>
+                <a16:creationId xmlns:a16="http://schemas.microsoft.com/office/drawing/2014/main" id="{8B5F77FA-9C09-4B6B-ABCF-91A0879805BA}"/>
               </a:ext>
             </a:extLst>
           </p:cNvPr>
@@ -4011,7 +4011,7 @@
           <p:cNvPr id="16" name="loop-node-2">
             <a:extLst xmlns:a="http://schemas.openxmlformats.org/drawingml/2006/main">
               <a:ext uri="{FF2B5EF4-FFF2-40B4-BE49-F238E27FC236}">
-                <a16:creationId xmlns:a16="http://schemas.microsoft.com/office/drawing/2014/main" id="{85ED2B24-7182-4004-9710-9A9072D69A7D}"/>
+                <a16:creationId xmlns:a16="http://schemas.microsoft.com/office/drawing/2014/main" id="{04CDE943-E01D-49B1-B9D4-ECCC7B89B2F2}"/>
               </a:ext>
             </a:extLst>
           </p:cNvPr>
@@ -4044,7 +4044,7 @@
           <p:cNvPr id="17" name="loop-number-2">
             <a:extLst xmlns:a="http://schemas.openxmlformats.org/drawingml/2006/main">
               <a:ext uri="{FF2B5EF4-FFF2-40B4-BE49-F238E27FC236}">
-                <a16:creationId xmlns:a16="http://schemas.microsoft.com/office/drawing/2014/main" id="{3A787DE8-8D24-4D64-A6D4-7DCB39FFF0C4}"/>
+                <a16:creationId xmlns:a16="http://schemas.microsoft.com/office/drawing/2014/main" id="{356E6A4D-06A4-4947-8D89-A28A489434ED}"/>
               </a:ext>
             </a:extLst>
           </p:cNvPr>
@@ -4100,7 +4100,7 @@
           <p:cNvPr id="18" name="loop-en-2">
             <a:extLst xmlns:a="http://schemas.openxmlformats.org/drawingml/2006/main">
               <a:ext uri="{FF2B5EF4-FFF2-40B4-BE49-F238E27FC236}">
-                <a16:creationId xmlns:a16="http://schemas.microsoft.com/office/drawing/2014/main" id="{D66948AB-F5E9-4323-93E7-0EE2BE79075E}"/>
+                <a16:creationId xmlns:a16="http://schemas.microsoft.com/office/drawing/2014/main" id="{A0B1DA0A-0BAE-491A-A007-514C9BED4681}"/>
               </a:ext>
             </a:extLst>
           </p:cNvPr>
@@ -4156,7 +4156,7 @@
           <p:cNvPr id="19" name="loop-tr-2">
             <a:extLst xmlns:a="http://schemas.openxmlformats.org/drawingml/2006/main">
               <a:ext uri="{FF2B5EF4-FFF2-40B4-BE49-F238E27FC236}">
-                <a16:creationId xmlns:a16="http://schemas.microsoft.com/office/drawing/2014/main" id="{AF071F88-88B3-46BD-A6B3-17670650A837}"/>
+                <a16:creationId xmlns:a16="http://schemas.microsoft.com/office/drawing/2014/main" id="{2FE92587-F97C-45FB-A723-62C7B42866AA}"/>
               </a:ext>
             </a:extLst>
           </p:cNvPr>
@@ -4212,7 +4212,7 @@
           <p:cNvPr id="20" name="loop-ru-2">
             <a:extLst xmlns:a="http://schemas.openxmlformats.org/drawingml/2006/main">
               <a:ext uri="{FF2B5EF4-FFF2-40B4-BE49-F238E27FC236}">
-                <a16:creationId xmlns:a16="http://schemas.microsoft.com/office/drawing/2014/main" id="{8F704AFF-B850-4B97-8559-80A59B14A05F}"/>
+                <a16:creationId xmlns:a16="http://schemas.microsoft.com/office/drawing/2014/main" id="{DF2D2AA0-D802-4B5E-AA2C-DD3C07B76097}"/>
               </a:ext>
             </a:extLst>
           </p:cNvPr>
@@ -4268,7 +4268,7 @@
           <p:cNvPr id="21" name="loop-detail-2">
             <a:extLst xmlns:a="http://schemas.openxmlformats.org/drawingml/2006/main">
               <a:ext uri="{FF2B5EF4-FFF2-40B4-BE49-F238E27FC236}">
-                <a16:creationId xmlns:a16="http://schemas.microsoft.com/office/drawing/2014/main" id="{38790263-133D-4F93-ACD7-13D05180FEC7}"/>
+                <a16:creationId xmlns:a16="http://schemas.microsoft.com/office/drawing/2014/main" id="{D638858F-BA84-46B2-B603-CE5E0E792043}"/>
               </a:ext>
             </a:extLst>
           </p:cNvPr>
@@ -4324,7 +4324,7 @@
           <p:cNvPr id="22" name="footer-4">
             <a:extLst xmlns:a="http://schemas.openxmlformats.org/drawingml/2006/main">
               <a:ext uri="{FF2B5EF4-FFF2-40B4-BE49-F238E27FC236}">
-                <a16:creationId xmlns:a16="http://schemas.microsoft.com/office/drawing/2014/main" id="{CD2B9127-19EC-4AFE-B057-A4ADB53F7A14}"/>
+                <a16:creationId xmlns:a16="http://schemas.microsoft.com/office/drawing/2014/main" id="{D6B4671E-EA3F-4AC7-8100-62CC307F9B5A}"/>
               </a:ext>
             </a:extLst>
           </p:cNvPr>
@@ -4378,7 +4378,7 @@
     </p:spTree>
     <p:extLst>
       <p:ext uri="{BB962C8B-B14F-4D97-AF65-F5344CB8AC3E}">
-        <p14:creationId xmlns:p14="http://schemas.microsoft.com/office/powerpoint/2010/main" val="254778457"/>
+        <p14:creationId xmlns:p14="http://schemas.microsoft.com/office/powerpoint/2010/main" val="1908500908"/>
       </p:ext>
     </p:extLst>
   </p:cSld>
@@ -4409,7 +4409,7 @@
           <p:cNvPr id="21" name="breadth-title">
             <a:extLst xmlns:a="http://schemas.openxmlformats.org/drawingml/2006/main">
               <a:ext uri="{FF2B5EF4-FFF2-40B4-BE49-F238E27FC236}">
-                <a16:creationId xmlns:a16="http://schemas.microsoft.com/office/drawing/2014/main" id="{41A8A9CC-C126-459A-9795-76173D1F1A3F}"/>
+                <a16:creationId xmlns:a16="http://schemas.microsoft.com/office/drawing/2014/main" id="{38A6AAA1-5DAA-4229-A6E0-9C6AB6809897}"/>
               </a:ext>
             </a:extLst>
           </p:cNvPr>
@@ -4465,7 +4465,7 @@
           <p:cNvPr id="2" name="breadth-triple">
             <a:extLst xmlns:a="http://schemas.openxmlformats.org/drawingml/2006/main">
               <a:ext uri="{FF2B5EF4-FFF2-40B4-BE49-F238E27FC236}">
-                <a16:creationId xmlns:a16="http://schemas.microsoft.com/office/drawing/2014/main" id="{B5D4ACA3-5408-43CE-A15C-53C7262E03CF}"/>
+                <a16:creationId xmlns:a16="http://schemas.microsoft.com/office/drawing/2014/main" id="{68EE8B15-80AD-4E79-8162-8FE8EDCDE27A}"/>
               </a:ext>
             </a:extLst>
           </p:cNvPr>
@@ -4521,7 +4521,7 @@
           <p:cNvPr id="3" name="breadth-number">
             <a:extLst xmlns:a="http://schemas.openxmlformats.org/drawingml/2006/main">
               <a:ext uri="{FF2B5EF4-FFF2-40B4-BE49-F238E27FC236}">
-                <a16:creationId xmlns:a16="http://schemas.microsoft.com/office/drawing/2014/main" id="{C4B128BF-38C9-4931-A01E-A612F8E02E66}"/>
+                <a16:creationId xmlns:a16="http://schemas.microsoft.com/office/drawing/2014/main" id="{04C51819-F721-4340-836C-BC112C4F958F}"/>
               </a:ext>
             </a:extLst>
           </p:cNvPr>
@@ -4577,7 +4577,7 @@
           <p:cNvPr id="4" name="breadth-caption">
             <a:extLst xmlns:a="http://schemas.openxmlformats.org/drawingml/2006/main">
               <a:ext uri="{FF2B5EF4-FFF2-40B4-BE49-F238E27FC236}">
-                <a16:creationId xmlns:a16="http://schemas.microsoft.com/office/drawing/2014/main" id="{3FD46BCB-8D30-4C02-AF08-1588D156EF43}"/>
+                <a16:creationId xmlns:a16="http://schemas.microsoft.com/office/drawing/2014/main" id="{26C01411-2B25-4609-B108-4F3A5CAB614A}"/>
               </a:ext>
             </a:extLst>
           </p:cNvPr>
@@ -4679,7 +4679,7 @@
           <p:cNvPr id="5" name="breadth-divider">
             <a:extLst xmlns:a="http://schemas.openxmlformats.org/drawingml/2006/main">
               <a:ext uri="{FF2B5EF4-FFF2-40B4-BE49-F238E27FC236}">
-                <a16:creationId xmlns:a16="http://schemas.microsoft.com/office/drawing/2014/main" id="{2D67E61B-5EE3-4FFF-B2F0-5C4137F04985}"/>
+                <a16:creationId xmlns:a16="http://schemas.microsoft.com/office/drawing/2014/main" id="{A1AA7C38-98E5-4A64-8B39-873441107C58}"/>
               </a:ext>
             </a:extLst>
           </p:cNvPr>
@@ -4710,7 +4710,7 @@
           <p:cNvPr id="6" name="breadth-item-rule-0">
             <a:extLst xmlns:a="http://schemas.openxmlformats.org/drawingml/2006/main">
               <a:ext uri="{FF2B5EF4-FFF2-40B4-BE49-F238E27FC236}">
-                <a16:creationId xmlns:a16="http://schemas.microsoft.com/office/drawing/2014/main" id="{02D6AD79-FBAB-4010-9AC9-33AD89AE74DF}"/>
+                <a16:creationId xmlns:a16="http://schemas.microsoft.com/office/drawing/2014/main" id="{31B7202E-E44B-4F66-B216-E6B336BED04C}"/>
               </a:ext>
             </a:extLst>
           </p:cNvPr>
@@ -4741,7 +4741,7 @@
           <p:cNvPr id="7" name="breadth-item-0">
             <a:extLst xmlns:a="http://schemas.openxmlformats.org/drawingml/2006/main">
               <a:ext uri="{FF2B5EF4-FFF2-40B4-BE49-F238E27FC236}">
-                <a16:creationId xmlns:a16="http://schemas.microsoft.com/office/drawing/2014/main" id="{66122974-B85C-4E8F-8AD8-430481CF1AA1}"/>
+                <a16:creationId xmlns:a16="http://schemas.microsoft.com/office/drawing/2014/main" id="{2DE1B574-035F-4821-AEAD-E874A7683D8E}"/>
               </a:ext>
             </a:extLst>
           </p:cNvPr>
@@ -4787,7 +4787,7 @@
                 <a:ea typeface="Arial"/>
                 <a:cs typeface="Arial"/>
               </a:rPr>
-              <a:t>RU-EN dictionary · Sözlük · Словарь RU-EN</a:t>
+              <a:t>RU-EN-TR dictionary · Yön seçimli sözlük · Словарь RU-EN-TR</a:t>
             </a:r>
           </a:p>
         </p:txBody>
@@ -4797,7 +4797,7 @@
           <p:cNvPr id="8" name="breadth-item-rule-1">
             <a:extLst xmlns:a="http://schemas.openxmlformats.org/drawingml/2006/main">
               <a:ext uri="{FF2B5EF4-FFF2-40B4-BE49-F238E27FC236}">
-                <a16:creationId xmlns:a16="http://schemas.microsoft.com/office/drawing/2014/main" id="{99A0F640-068E-411E-B85C-35C1E8B6DA34}"/>
+                <a16:creationId xmlns:a16="http://schemas.microsoft.com/office/drawing/2014/main" id="{59704FAC-3718-4CEC-A278-7EE18CCBD0EE}"/>
               </a:ext>
             </a:extLst>
           </p:cNvPr>
@@ -4828,7 +4828,7 @@
           <p:cNvPr id="9" name="breadth-item-1">
             <a:extLst xmlns:a="http://schemas.openxmlformats.org/drawingml/2006/main">
               <a:ext uri="{FF2B5EF4-FFF2-40B4-BE49-F238E27FC236}">
-                <a16:creationId xmlns:a16="http://schemas.microsoft.com/office/drawing/2014/main" id="{BEEE03AE-B5E4-4965-BB5B-2DBE3454DE05}"/>
+                <a16:creationId xmlns:a16="http://schemas.microsoft.com/office/drawing/2014/main" id="{66DB8DEC-1C95-4ED8-ABBE-D9A34AC08D2E}"/>
               </a:ext>
             </a:extLst>
           </p:cNvPr>
@@ -4884,7 +4884,7 @@
           <p:cNvPr id="10" name="breadth-item-rule-2">
             <a:extLst xmlns:a="http://schemas.openxmlformats.org/drawingml/2006/main">
               <a:ext uri="{FF2B5EF4-FFF2-40B4-BE49-F238E27FC236}">
-                <a16:creationId xmlns:a16="http://schemas.microsoft.com/office/drawing/2014/main" id="{D44E6E13-B923-430B-945C-50A3AC2686EA}"/>
+                <a16:creationId xmlns:a16="http://schemas.microsoft.com/office/drawing/2014/main" id="{94D8F4B7-44AC-4ED7-B0FB-B86DF25D18FC}"/>
               </a:ext>
             </a:extLst>
           </p:cNvPr>
@@ -4915,7 +4915,7 @@
           <p:cNvPr id="11" name="breadth-item-2">
             <a:extLst xmlns:a="http://schemas.openxmlformats.org/drawingml/2006/main">
               <a:ext uri="{FF2B5EF4-FFF2-40B4-BE49-F238E27FC236}">
-                <a16:creationId xmlns:a16="http://schemas.microsoft.com/office/drawing/2014/main" id="{4252DF7E-EEA2-48D7-81BB-707ECC246183}"/>
+                <a16:creationId xmlns:a16="http://schemas.microsoft.com/office/drawing/2014/main" id="{CD5489D3-1D24-4789-84F3-F8D60B8B0079}"/>
               </a:ext>
             </a:extLst>
           </p:cNvPr>
@@ -4971,7 +4971,7 @@
           <p:cNvPr id="12" name="breadth-item-rule-3">
             <a:extLst xmlns:a="http://schemas.openxmlformats.org/drawingml/2006/main">
               <a:ext uri="{FF2B5EF4-FFF2-40B4-BE49-F238E27FC236}">
-                <a16:creationId xmlns:a16="http://schemas.microsoft.com/office/drawing/2014/main" id="{FC573B81-E07C-412F-9D2C-6AE740ADFEAB}"/>
+                <a16:creationId xmlns:a16="http://schemas.microsoft.com/office/drawing/2014/main" id="{A2692458-4D05-49F0-9678-AE41B0B7AD13}"/>
               </a:ext>
             </a:extLst>
           </p:cNvPr>
@@ -5002,7 +5002,7 @@
           <p:cNvPr id="13" name="breadth-item-3">
             <a:extLst xmlns:a="http://schemas.openxmlformats.org/drawingml/2006/main">
               <a:ext uri="{FF2B5EF4-FFF2-40B4-BE49-F238E27FC236}">
-                <a16:creationId xmlns:a16="http://schemas.microsoft.com/office/drawing/2014/main" id="{1DD8140B-A346-4DB1-BE12-C623F8762A3F}"/>
+                <a16:creationId xmlns:a16="http://schemas.microsoft.com/office/drawing/2014/main" id="{2802C671-E009-4D39-93DB-F284695FB6CA}"/>
               </a:ext>
             </a:extLst>
           </p:cNvPr>
@@ -5058,7 +5058,7 @@
           <p:cNvPr id="14" name="breadth-item-rule-4">
             <a:extLst xmlns:a="http://schemas.openxmlformats.org/drawingml/2006/main">
               <a:ext uri="{FF2B5EF4-FFF2-40B4-BE49-F238E27FC236}">
-                <a16:creationId xmlns:a16="http://schemas.microsoft.com/office/drawing/2014/main" id="{C185BD89-B80E-4B71-86E8-5E1B3281CB5F}"/>
+                <a16:creationId xmlns:a16="http://schemas.microsoft.com/office/drawing/2014/main" id="{3BF6A12E-21AD-445E-9E0D-1F750F1041B1}"/>
               </a:ext>
             </a:extLst>
           </p:cNvPr>
@@ -5089,7 +5089,7 @@
           <p:cNvPr id="15" name="breadth-item-4">
             <a:extLst xmlns:a="http://schemas.openxmlformats.org/drawingml/2006/main">
               <a:ext uri="{FF2B5EF4-FFF2-40B4-BE49-F238E27FC236}">
-                <a16:creationId xmlns:a16="http://schemas.microsoft.com/office/drawing/2014/main" id="{EAF5AB64-2B21-421F-90F5-9A28270B0D05}"/>
+                <a16:creationId xmlns:a16="http://schemas.microsoft.com/office/drawing/2014/main" id="{F58D1A26-B7D5-40A8-8009-BE677F100649}"/>
               </a:ext>
             </a:extLst>
           </p:cNvPr>
@@ -5145,7 +5145,7 @@
           <p:cNvPr id="16" name="breadth-item-rule-5">
             <a:extLst xmlns:a="http://schemas.openxmlformats.org/drawingml/2006/main">
               <a:ext uri="{FF2B5EF4-FFF2-40B4-BE49-F238E27FC236}">
-                <a16:creationId xmlns:a16="http://schemas.microsoft.com/office/drawing/2014/main" id="{E1D8A4E9-DF12-4F70-B6A8-5CF958684029}"/>
+                <a16:creationId xmlns:a16="http://schemas.microsoft.com/office/drawing/2014/main" id="{5B979B8A-4BE5-4622-A446-1312E307A450}"/>
               </a:ext>
             </a:extLst>
           </p:cNvPr>
@@ -5176,7 +5176,7 @@
           <p:cNvPr id="17" name="breadth-item-5">
             <a:extLst xmlns:a="http://schemas.openxmlformats.org/drawingml/2006/main">
               <a:ext uri="{FF2B5EF4-FFF2-40B4-BE49-F238E27FC236}">
-                <a16:creationId xmlns:a16="http://schemas.microsoft.com/office/drawing/2014/main" id="{FE8A3A62-8CFB-4E99-8DC2-F43964D81884}"/>
+                <a16:creationId xmlns:a16="http://schemas.microsoft.com/office/drawing/2014/main" id="{1F678155-3876-42EE-9CE2-136D11819CE7}"/>
               </a:ext>
             </a:extLst>
           </p:cNvPr>
@@ -5232,7 +5232,7 @@
           <p:cNvPr id="18" name="breadth-item-rule-6">
             <a:extLst xmlns:a="http://schemas.openxmlformats.org/drawingml/2006/main">
               <a:ext uri="{FF2B5EF4-FFF2-40B4-BE49-F238E27FC236}">
-                <a16:creationId xmlns:a16="http://schemas.microsoft.com/office/drawing/2014/main" id="{0379DF69-551C-4D81-B1AA-97E6CD999519}"/>
+                <a16:creationId xmlns:a16="http://schemas.microsoft.com/office/drawing/2014/main" id="{90DD7E5B-CAC4-42E4-A3DF-C1213FCF2FAF}"/>
               </a:ext>
             </a:extLst>
           </p:cNvPr>
@@ -5263,7 +5263,7 @@
           <p:cNvPr id="19" name="breadth-item-6">
             <a:extLst xmlns:a="http://schemas.openxmlformats.org/drawingml/2006/main">
               <a:ext uri="{FF2B5EF4-FFF2-40B4-BE49-F238E27FC236}">
-                <a16:creationId xmlns:a16="http://schemas.microsoft.com/office/drawing/2014/main" id="{A762B8F6-C984-4E15-8443-DA998F2A67D2}"/>
+                <a16:creationId xmlns:a16="http://schemas.microsoft.com/office/drawing/2014/main" id="{CDA10238-1B6E-4B72-9FFC-D31492521DA8}"/>
               </a:ext>
             </a:extLst>
           </p:cNvPr>
@@ -5319,7 +5319,7 @@
           <p:cNvPr id="20" name="footer-5">
             <a:extLst xmlns:a="http://schemas.openxmlformats.org/drawingml/2006/main">
               <a:ext uri="{FF2B5EF4-FFF2-40B4-BE49-F238E27FC236}">
-                <a16:creationId xmlns:a16="http://schemas.microsoft.com/office/drawing/2014/main" id="{0ABE3379-3D7E-49D8-84E2-4339F936C443}"/>
+                <a16:creationId xmlns:a16="http://schemas.microsoft.com/office/drawing/2014/main" id="{09580DBA-62C8-472A-93E6-A6EF25A3B017}"/>
               </a:ext>
             </a:extLst>
           </p:cNvPr>
@@ -5373,7 +5373,7 @@
     </p:spTree>
     <p:extLst>
       <p:ext uri="{BB962C8B-B14F-4D97-AF65-F5344CB8AC3E}">
-        <p14:creationId xmlns:p14="http://schemas.microsoft.com/office/powerpoint/2010/main" val="761217657"/>
+        <p14:creationId xmlns:p14="http://schemas.microsoft.com/office/powerpoint/2010/main" val="1508298526"/>
       </p:ext>
     </p:extLst>
   </p:cSld>
@@ -5404,7 +5404,7 @@
           <p:cNvPr id="12" name="privacy-title">
             <a:extLst xmlns:a="http://schemas.openxmlformats.org/drawingml/2006/main">
               <a:ext uri="{FF2B5EF4-FFF2-40B4-BE49-F238E27FC236}">
-                <a16:creationId xmlns:a16="http://schemas.microsoft.com/office/drawing/2014/main" id="{186230F9-6A8C-4A51-925C-93A29931E06E}"/>
+                <a16:creationId xmlns:a16="http://schemas.microsoft.com/office/drawing/2014/main" id="{7B6F448A-5201-4040-AE76-43E29F28C660}"/>
               </a:ext>
             </a:extLst>
           </p:cNvPr>
@@ -5460,7 +5460,7 @@
           <p:cNvPr id="2" name="privacy-tr">
             <a:extLst xmlns:a="http://schemas.openxmlformats.org/drawingml/2006/main">
               <a:ext uri="{FF2B5EF4-FFF2-40B4-BE49-F238E27FC236}">
-                <a16:creationId xmlns:a16="http://schemas.microsoft.com/office/drawing/2014/main" id="{23DAF60E-FD5D-4D07-8D2F-713A93816D38}"/>
+                <a16:creationId xmlns:a16="http://schemas.microsoft.com/office/drawing/2014/main" id="{53F1A4A4-2928-4293-96C6-A549EA9603B1}"/>
               </a:ext>
             </a:extLst>
           </p:cNvPr>
@@ -5516,7 +5516,7 @@
           <p:cNvPr id="3" name="privacy-ru">
             <a:extLst xmlns:a="http://schemas.openxmlformats.org/drawingml/2006/main">
               <a:ext uri="{FF2B5EF4-FFF2-40B4-BE49-F238E27FC236}">
-                <a16:creationId xmlns:a16="http://schemas.microsoft.com/office/drawing/2014/main" id="{9EA2DBC1-DE95-4B2A-8A5A-2890D63E47B8}"/>
+                <a16:creationId xmlns:a16="http://schemas.microsoft.com/office/drawing/2014/main" id="{BFDDFCD7-5AC9-46E4-91FA-2B17E763F86A}"/>
               </a:ext>
             </a:extLst>
           </p:cNvPr>
@@ -5572,7 +5572,7 @@
           <p:cNvPr id="4" name="privacy-divider">
             <a:extLst xmlns:a="http://schemas.openxmlformats.org/drawingml/2006/main">
               <a:ext uri="{FF2B5EF4-FFF2-40B4-BE49-F238E27FC236}">
-                <a16:creationId xmlns:a16="http://schemas.microsoft.com/office/drawing/2014/main" id="{2F08F910-804D-4789-BA3E-630AC1B6E7B1}"/>
+                <a16:creationId xmlns:a16="http://schemas.microsoft.com/office/drawing/2014/main" id="{6CEFF55E-D8A9-411D-BAB5-D0A15E85E4FA}"/>
               </a:ext>
             </a:extLst>
           </p:cNvPr>
@@ -5603,7 +5603,7 @@
           <p:cNvPr id="5" name="local-label">
             <a:extLst xmlns:a="http://schemas.openxmlformats.org/drawingml/2006/main">
               <a:ext uri="{FF2B5EF4-FFF2-40B4-BE49-F238E27FC236}">
-                <a16:creationId xmlns:a16="http://schemas.microsoft.com/office/drawing/2014/main" id="{D5486C58-48C2-42D4-9F34-073D5D0F935C}"/>
+                <a16:creationId xmlns:a16="http://schemas.microsoft.com/office/drawing/2014/main" id="{18B1F1CB-A78F-43EA-BAF4-A8B25364E76A}"/>
               </a:ext>
             </a:extLst>
           </p:cNvPr>
@@ -5659,7 +5659,7 @@
           <p:cNvPr id="6" name="local-head">
             <a:extLst xmlns:a="http://schemas.openxmlformats.org/drawingml/2006/main">
               <a:ext uri="{FF2B5EF4-FFF2-40B4-BE49-F238E27FC236}">
-                <a16:creationId xmlns:a16="http://schemas.microsoft.com/office/drawing/2014/main" id="{F9F6834E-C260-4B5D-BF7F-2E400F53E5B3}"/>
+                <a16:creationId xmlns:a16="http://schemas.microsoft.com/office/drawing/2014/main" id="{F3E9A2F9-7025-47A4-BB47-6171805B3801}"/>
               </a:ext>
             </a:extLst>
           </p:cNvPr>
@@ -5715,7 +5715,7 @@
           <p:cNvPr id="7" name="local-copy">
             <a:extLst xmlns:a="http://schemas.openxmlformats.org/drawingml/2006/main">
               <a:ext uri="{FF2B5EF4-FFF2-40B4-BE49-F238E27FC236}">
-                <a16:creationId xmlns:a16="http://schemas.microsoft.com/office/drawing/2014/main" id="{E4148AFF-A7A5-4762-99F5-8286E3C49D67}"/>
+                <a16:creationId xmlns:a16="http://schemas.microsoft.com/office/drawing/2014/main" id="{E0FEBCC2-B693-4B92-8132-D3260DCEB919}"/>
               </a:ext>
             </a:extLst>
           </p:cNvPr>
@@ -5845,7 +5845,7 @@
           <p:cNvPr id="8" name="optional-label">
             <a:extLst xmlns:a="http://schemas.openxmlformats.org/drawingml/2006/main">
               <a:ext uri="{FF2B5EF4-FFF2-40B4-BE49-F238E27FC236}">
-                <a16:creationId xmlns:a16="http://schemas.microsoft.com/office/drawing/2014/main" id="{80650398-6085-4173-B203-27B40AB4ED5C}"/>
+                <a16:creationId xmlns:a16="http://schemas.microsoft.com/office/drawing/2014/main" id="{CA8033C6-1134-4F4B-AABC-3A0B53A0E53B}"/>
               </a:ext>
             </a:extLst>
           </p:cNvPr>
@@ -5901,7 +5901,7 @@
           <p:cNvPr id="9" name="optional-head">
             <a:extLst xmlns:a="http://schemas.openxmlformats.org/drawingml/2006/main">
               <a:ext uri="{FF2B5EF4-FFF2-40B4-BE49-F238E27FC236}">
-                <a16:creationId xmlns:a16="http://schemas.microsoft.com/office/drawing/2014/main" id="{40E4EA46-B5D8-4AFD-9F17-6798A3B346BC}"/>
+                <a16:creationId xmlns:a16="http://schemas.microsoft.com/office/drawing/2014/main" id="{EC6D6730-293F-4D45-AFE9-657ADFDBAAAA}"/>
               </a:ext>
             </a:extLst>
           </p:cNvPr>
@@ -5957,7 +5957,7 @@
           <p:cNvPr id="10" name="optional-copy">
             <a:extLst xmlns:a="http://schemas.openxmlformats.org/drawingml/2006/main">
               <a:ext uri="{FF2B5EF4-FFF2-40B4-BE49-F238E27FC236}">
-                <a16:creationId xmlns:a16="http://schemas.microsoft.com/office/drawing/2014/main" id="{C0A613B9-8791-4AD3-A4DB-1D2C55496259}"/>
+                <a16:creationId xmlns:a16="http://schemas.microsoft.com/office/drawing/2014/main" id="{86F3189B-5A2E-40B6-B218-EE5F598ABF48}"/>
               </a:ext>
             </a:extLst>
           </p:cNvPr>
@@ -6087,7 +6087,7 @@
           <p:cNvPr id="11" name="footer-6">
             <a:extLst xmlns:a="http://schemas.openxmlformats.org/drawingml/2006/main">
               <a:ext uri="{FF2B5EF4-FFF2-40B4-BE49-F238E27FC236}">
-                <a16:creationId xmlns:a16="http://schemas.microsoft.com/office/drawing/2014/main" id="{E920FA72-E3F7-4EA5-9911-1441DEF142D2}"/>
+                <a16:creationId xmlns:a16="http://schemas.microsoft.com/office/drawing/2014/main" id="{34138668-1062-445E-9A12-A15C7CEFD9D7}"/>
               </a:ext>
             </a:extLst>
           </p:cNvPr>
@@ -6141,7 +6141,7 @@
     </p:spTree>
     <p:extLst>
       <p:ext uri="{BB962C8B-B14F-4D97-AF65-F5344CB8AC3E}">
-        <p14:creationId xmlns:p14="http://schemas.microsoft.com/office/powerpoint/2010/main" val="2128574136"/>
+        <p14:creationId xmlns:p14="http://schemas.microsoft.com/office/powerpoint/2010/main" val="1168454874"/>
       </p:ext>
     </p:extLst>
   </p:cSld>
@@ -6172,7 +6172,7 @@
           <p:cNvPr id="13" name="platform-title">
             <a:extLst xmlns:a="http://schemas.openxmlformats.org/drawingml/2006/main">
               <a:ext uri="{FF2B5EF4-FFF2-40B4-BE49-F238E27FC236}">
-                <a16:creationId xmlns:a16="http://schemas.microsoft.com/office/drawing/2014/main" id="{A09F2D5D-8E42-46F0-8CC5-A33472F9E224}"/>
+                <a16:creationId xmlns:a16="http://schemas.microsoft.com/office/drawing/2014/main" id="{124BE4C7-D8A6-4EA3-BC7E-3E308C891BD1}"/>
               </a:ext>
             </a:extLst>
           </p:cNvPr>
@@ -6228,7 +6228,7 @@
           <p:cNvPr id="2" name="platform-subtitle">
             <a:extLst xmlns:a="http://schemas.openxmlformats.org/drawingml/2006/main">
               <a:ext uri="{FF2B5EF4-FFF2-40B4-BE49-F238E27FC236}">
-                <a16:creationId xmlns:a16="http://schemas.microsoft.com/office/drawing/2014/main" id="{DE76F897-BE1B-4C73-AF5F-B534054D1DAA}"/>
+                <a16:creationId xmlns:a16="http://schemas.microsoft.com/office/drawing/2014/main" id="{C53FA8A5-70FD-464F-A0E5-EFD096BA1E28}"/>
               </a:ext>
             </a:extLst>
           </p:cNvPr>
@@ -6284,7 +6284,7 @@
           <p:cNvPr id="3" name="platform-rule">
             <a:extLst xmlns:a="http://schemas.openxmlformats.org/drawingml/2006/main">
               <a:ext uri="{FF2B5EF4-FFF2-40B4-BE49-F238E27FC236}">
-                <a16:creationId xmlns:a16="http://schemas.microsoft.com/office/drawing/2014/main" id="{C1DA347C-13D7-4BEB-8CA8-0EBFD305ADA5}"/>
+                <a16:creationId xmlns:a16="http://schemas.microsoft.com/office/drawing/2014/main" id="{5DEEBB13-08EB-4573-A204-D7BB86E03AA4}"/>
               </a:ext>
             </a:extLst>
           </p:cNvPr>
@@ -6315,7 +6315,7 @@
           <p:cNvPr id="4" name="platform-label-0">
             <a:extLst xmlns:a="http://schemas.openxmlformats.org/drawingml/2006/main">
               <a:ext uri="{FF2B5EF4-FFF2-40B4-BE49-F238E27FC236}">
-                <a16:creationId xmlns:a16="http://schemas.microsoft.com/office/drawing/2014/main" id="{29596E41-5986-47D6-BBCF-1E824C414CC6}"/>
+                <a16:creationId xmlns:a16="http://schemas.microsoft.com/office/drawing/2014/main" id="{26120135-199C-4020-851E-B7FAFE0C4896}"/>
               </a:ext>
             </a:extLst>
           </p:cNvPr>
@@ -6371,7 +6371,7 @@
           <p:cNvPr id="5" name="platform-body-0">
             <a:extLst xmlns:a="http://schemas.openxmlformats.org/drawingml/2006/main">
               <a:ext uri="{FF2B5EF4-FFF2-40B4-BE49-F238E27FC236}">
-                <a16:creationId xmlns:a16="http://schemas.microsoft.com/office/drawing/2014/main" id="{57D9446E-AC32-4D80-A1A2-065EF56537FE}"/>
+                <a16:creationId xmlns:a16="http://schemas.microsoft.com/office/drawing/2014/main" id="{EEB9CD16-A49B-46ED-8ECB-F879A6CFCCEF}"/>
               </a:ext>
             </a:extLst>
           </p:cNvPr>
@@ -6417,7 +6417,7 @@
                 <a:ea typeface="Arial"/>
                 <a:cs typeface="Arial"/>
               </a:rPr>
-              <a:t>Windows 10/11 (x64) + macOS (Apple Silicon) — İndirme: github.com/Azizsekerdil/RussianCourseAI/releases (v1.1.2) (özel repo)</a:t>
+              <a:t>Windows 10/11 (x64) + macOS (Apple Silicon) — İndirme: github.com/Azizsekerdil/RussianCourseAI/releases (v1.2.0) (özel repo)</a:t>
             </a:r>
           </a:p>
         </p:txBody>
@@ -6427,7 +6427,7 @@
           <p:cNvPr id="6" name="platform-label-1">
             <a:extLst xmlns:a="http://schemas.openxmlformats.org/drawingml/2006/main">
               <a:ext uri="{FF2B5EF4-FFF2-40B4-BE49-F238E27FC236}">
-                <a16:creationId xmlns:a16="http://schemas.microsoft.com/office/drawing/2014/main" id="{D1006491-E3DF-480D-BB2B-154294C969E3}"/>
+                <a16:creationId xmlns:a16="http://schemas.microsoft.com/office/drawing/2014/main" id="{5D66151D-08E9-479C-81E6-C18BBF5918B2}"/>
               </a:ext>
             </a:extLst>
           </p:cNvPr>
@@ -6483,7 +6483,7 @@
           <p:cNvPr id="7" name="platform-body-1">
             <a:extLst xmlns:a="http://schemas.openxmlformats.org/drawingml/2006/main">
               <a:ext uri="{FF2B5EF4-FFF2-40B4-BE49-F238E27FC236}">
-                <a16:creationId xmlns:a16="http://schemas.microsoft.com/office/drawing/2014/main" id="{55BED671-6460-4773-BEE1-F6389976C4F7}"/>
+                <a16:creationId xmlns:a16="http://schemas.microsoft.com/office/drawing/2014/main" id="{8695CF7A-E8FC-4713-8318-3ECFFB2221B4}"/>
               </a:ext>
             </a:extLst>
           </p:cNvPr>
@@ -6529,7 +6529,7 @@
                 <a:ea typeface="Arial"/>
                 <a:cs typeface="Arial"/>
               </a:rPr>
-              <a:t>Windows 10/11 (x64) &amp; macOS (Apple Silicon) — Download: GitHub Releases (v1.1.2)</a:t>
+              <a:t>Windows 10/11 (x64) &amp; macOS (Apple Silicon) — Download: GitHub Releases (v1.2.0)</a:t>
             </a:r>
           </a:p>
         </p:txBody>
@@ -6539,7 +6539,7 @@
           <p:cNvPr id="8" name="platform-label-2">
             <a:extLst xmlns:a="http://schemas.openxmlformats.org/drawingml/2006/main">
               <a:ext uri="{FF2B5EF4-FFF2-40B4-BE49-F238E27FC236}">
-                <a16:creationId xmlns:a16="http://schemas.microsoft.com/office/drawing/2014/main" id="{BDEEE98C-D1AA-4DED-A144-284ED97CF6CE}"/>
+                <a16:creationId xmlns:a16="http://schemas.microsoft.com/office/drawing/2014/main" id="{07C4D870-C741-463B-AE88-26E84F8B92F6}"/>
               </a:ext>
             </a:extLst>
           </p:cNvPr>
@@ -6595,7 +6595,7 @@
           <p:cNvPr id="9" name="platform-body-2">
             <a:extLst xmlns:a="http://schemas.openxmlformats.org/drawingml/2006/main">
               <a:ext uri="{FF2B5EF4-FFF2-40B4-BE49-F238E27FC236}">
-                <a16:creationId xmlns:a16="http://schemas.microsoft.com/office/drawing/2014/main" id="{00306626-4B81-44F0-B6ED-A307F1C3269E}"/>
+                <a16:creationId xmlns:a16="http://schemas.microsoft.com/office/drawing/2014/main" id="{E2B1D37F-AA01-44F8-BF1A-2A6A2A108E2E}"/>
               </a:ext>
             </a:extLst>
           </p:cNvPr>
@@ -6641,7 +6641,7 @@
                 <a:ea typeface="Arial"/>
                 <a:cs typeface="Arial"/>
               </a:rPr>
-              <a:t>Windows 10/11 (x64) и macOS (Apple Silicon) — Загрузка: GitHub Releases (v1.1.2)</a:t>
+              <a:t>Windows 10/11 (x64) и macOS (Apple Silicon) — Загрузка: GitHub Releases (v1.2.0)</a:t>
             </a:r>
           </a:p>
         </p:txBody>
@@ -6651,7 +6651,7 @@
           <p:cNvPr id="10" name="platform-footnote-rule">
             <a:extLst xmlns:a="http://schemas.openxmlformats.org/drawingml/2006/main">
               <a:ext uri="{FF2B5EF4-FFF2-40B4-BE49-F238E27FC236}">
-                <a16:creationId xmlns:a16="http://schemas.microsoft.com/office/drawing/2014/main" id="{222F05ED-F96E-4BB0-BBDB-C4195830A4A4}"/>
+                <a16:creationId xmlns:a16="http://schemas.microsoft.com/office/drawing/2014/main" id="{EA683EDA-4ADE-4225-8EF4-A26395292CAB}"/>
               </a:ext>
             </a:extLst>
           </p:cNvPr>
@@ -6682,7 +6682,7 @@
           <p:cNvPr id="11" name="platform-footnote">
             <a:extLst xmlns:a="http://schemas.openxmlformats.org/drawingml/2006/main">
               <a:ext uri="{FF2B5EF4-FFF2-40B4-BE49-F238E27FC236}">
-                <a16:creationId xmlns:a16="http://schemas.microsoft.com/office/drawing/2014/main" id="{A198B0C8-9C62-4D3B-9E2C-0F0CA7423F2A}"/>
+                <a16:creationId xmlns:a16="http://schemas.microsoft.com/office/drawing/2014/main" id="{7F06CA6D-1B88-47DF-B72B-2FD5C2DDC176}"/>
               </a:ext>
             </a:extLst>
           </p:cNvPr>
@@ -6728,7 +6728,7 @@
                 <a:ea typeface="Arial"/>
                 <a:cs typeface="Arial"/>
               </a:rPr>
-              <a:t>Release v1.1.2 — iki paket: Windows zip + macOS zip. macOS paketi Apple Silicon (arm64) içindir ve notarize edilmemiştir; ilk açılışta sağ tık → Aç.</a:t>
+              <a:t>Release v1.2.0 — iki paket: Windows zip + macOS zip. macOS paketi Apple Silicon (arm64) içindir ve notarize edilmemiştir; ilk açılışta sağ tık → Aç.</a:t>
             </a:r>
           </a:p>
           <a:p xmlns:a="http://schemas.openxmlformats.org/drawingml/2006/main">
@@ -6761,7 +6761,7 @@
           <p:cNvPr id="12" name="footer-7">
             <a:extLst xmlns:a="http://schemas.openxmlformats.org/drawingml/2006/main">
               <a:ext uri="{FF2B5EF4-FFF2-40B4-BE49-F238E27FC236}">
-                <a16:creationId xmlns:a16="http://schemas.microsoft.com/office/drawing/2014/main" id="{F8112F3F-AFDF-4B81-8E2E-39279D70F0AE}"/>
+                <a16:creationId xmlns:a16="http://schemas.microsoft.com/office/drawing/2014/main" id="{FA21683F-1F25-4F11-8BE1-389E6A85C4DB}"/>
               </a:ext>
             </a:extLst>
           </p:cNvPr>
@@ -6815,7 +6815,7 @@
     </p:spTree>
     <p:extLst>
       <p:ext uri="{BB962C8B-B14F-4D97-AF65-F5344CB8AC3E}">
-        <p14:creationId xmlns:p14="http://schemas.microsoft.com/office/powerpoint/2010/main" val="1195029544"/>
+        <p14:creationId xmlns:p14="http://schemas.microsoft.com/office/powerpoint/2010/main" val="274143256"/>
       </p:ext>
     </p:extLst>
   </p:cSld>
@@ -6846,7 +6846,7 @@
           <p:cNvPr id="9" name="close-kicker">
             <a:extLst xmlns:a="http://schemas.openxmlformats.org/drawingml/2006/main">
               <a:ext uri="{FF2B5EF4-FFF2-40B4-BE49-F238E27FC236}">
-                <a16:creationId xmlns:a16="http://schemas.microsoft.com/office/drawing/2014/main" id="{4269E684-F85E-463D-B98D-68292749FCD4}"/>
+                <a16:creationId xmlns:a16="http://schemas.microsoft.com/office/drawing/2014/main" id="{B80CC577-4EBF-4A37-BA6D-92F5134B3AE7}"/>
               </a:ext>
             </a:extLst>
           </p:cNvPr>
@@ -6902,7 +6902,7 @@
           <p:cNvPr id="2" name="close-title">
             <a:extLst xmlns:a="http://schemas.openxmlformats.org/drawingml/2006/main">
               <a:ext uri="{FF2B5EF4-FFF2-40B4-BE49-F238E27FC236}">
-                <a16:creationId xmlns:a16="http://schemas.microsoft.com/office/drawing/2014/main" id="{8347ADB5-140D-44E9-AC93-1435E57A7D8D}"/>
+                <a16:creationId xmlns:a16="http://schemas.microsoft.com/office/drawing/2014/main" id="{945A5272-9BEC-41EB-A2C8-86A2BA8D26D4}"/>
               </a:ext>
             </a:extLst>
           </p:cNvPr>
@@ -6981,7 +6981,7 @@
           <p:cNvPr id="3" name="close-tr">
             <a:extLst xmlns:a="http://schemas.openxmlformats.org/drawingml/2006/main">
               <a:ext uri="{FF2B5EF4-FFF2-40B4-BE49-F238E27FC236}">
-                <a16:creationId xmlns:a16="http://schemas.microsoft.com/office/drawing/2014/main" id="{662BF4F1-4B5A-4851-9F51-E6040F203884}"/>
+                <a16:creationId xmlns:a16="http://schemas.microsoft.com/office/drawing/2014/main" id="{22A0C282-D8C6-4FB5-A57F-50215D573634}"/>
               </a:ext>
             </a:extLst>
           </p:cNvPr>
@@ -7037,7 +7037,7 @@
           <p:cNvPr id="4" name="close-ru">
             <a:extLst xmlns:a="http://schemas.openxmlformats.org/drawingml/2006/main">
               <a:ext uri="{FF2B5EF4-FFF2-40B4-BE49-F238E27FC236}">
-                <a16:creationId xmlns:a16="http://schemas.microsoft.com/office/drawing/2014/main" id="{28796C36-87E5-4090-B947-F2DEABA06709}"/>
+                <a16:creationId xmlns:a16="http://schemas.microsoft.com/office/drawing/2014/main" id="{EE8E69C4-620E-4825-BBC4-0FFC6D5BE4DE}"/>
               </a:ext>
             </a:extLst>
           </p:cNvPr>
@@ -7093,7 +7093,7 @@
           <p:cNvPr id="5" name="close-rule">
             <a:extLst xmlns:a="http://schemas.openxmlformats.org/drawingml/2006/main">
               <a:ext uri="{FF2B5EF4-FFF2-40B4-BE49-F238E27FC236}">
-                <a16:creationId xmlns:a16="http://schemas.microsoft.com/office/drawing/2014/main" id="{B85C42DA-A388-44EF-B1C0-CAAC8A853A35}"/>
+                <a16:creationId xmlns:a16="http://schemas.microsoft.com/office/drawing/2014/main" id="{78DD97A4-CB46-4AD0-98B7-29A361641D22}"/>
               </a:ext>
             </a:extLst>
           </p:cNvPr>
@@ -7124,7 +7124,7 @@
           <p:cNvPr id="6" name="close-action">
             <a:extLst xmlns:a="http://schemas.openxmlformats.org/drawingml/2006/main">
               <a:ext uri="{FF2B5EF4-FFF2-40B4-BE49-F238E27FC236}">
-                <a16:creationId xmlns:a16="http://schemas.microsoft.com/office/drawing/2014/main" id="{C193058C-A633-4305-B09B-A68CA10C3202}"/>
+                <a16:creationId xmlns:a16="http://schemas.microsoft.com/office/drawing/2014/main" id="{1C15A4D2-1FE1-49B5-9E6C-E86CFCE23637}"/>
               </a:ext>
             </a:extLst>
           </p:cNvPr>
@@ -7180,7 +7180,7 @@
           <p:cNvPr id="7" name="close-meta">
             <a:extLst xmlns:a="http://schemas.openxmlformats.org/drawingml/2006/main">
               <a:ext uri="{FF2B5EF4-FFF2-40B4-BE49-F238E27FC236}">
-                <a16:creationId xmlns:a16="http://schemas.microsoft.com/office/drawing/2014/main" id="{FB43882B-46A6-414D-AD48-2093D828E835}"/>
+                <a16:creationId xmlns:a16="http://schemas.microsoft.com/office/drawing/2014/main" id="{4F5BE54E-986B-49C5-8AD4-CB70059FB594}"/>
               </a:ext>
             </a:extLst>
           </p:cNvPr>
@@ -7236,7 +7236,7 @@
           <p:cNvPr id="8" name="footer-8">
             <a:extLst xmlns:a="http://schemas.openxmlformats.org/drawingml/2006/main">
               <a:ext uri="{FF2B5EF4-FFF2-40B4-BE49-F238E27FC236}">
-                <a16:creationId xmlns:a16="http://schemas.microsoft.com/office/drawing/2014/main" id="{7CBBC832-3986-4069-8FDB-161A188CBFFD}"/>
+                <a16:creationId xmlns:a16="http://schemas.microsoft.com/office/drawing/2014/main" id="{6EB1C04F-C06F-48D4-90E8-25FC34A02949}"/>
               </a:ext>
             </a:extLst>
           </p:cNvPr>
@@ -7290,7 +7290,7 @@
     </p:spTree>
     <p:extLst>
       <p:ext uri="{BB962C8B-B14F-4D97-AF65-F5344CB8AC3E}">
-        <p14:creationId xmlns:p14="http://schemas.microsoft.com/office/powerpoint/2010/main" val="1840719015"/>
+        <p14:creationId xmlns:p14="http://schemas.microsoft.com/office/powerpoint/2010/main" val="1276436787"/>
       </p:ext>
     </p:extLst>
   </p:cSld>

</xml_diff>

<commit_message>
MIT lisansi: PyMuPDF yerine pypdfium2 + pypdf, LICENSE ve ucuncu taraf bildirimleri
- rca/pdf_backend.py: sayfa cizimi ve kelime kutulari pypdfium2 (Apache-2.0 VEYA
  BSD-3-Clause), isaretli PDF yazimi pypdf (BSD-3-Clause) ile; koordinat cevrimi
  tek yerde. AGPL lisansli PyMuPDF tamamen cikarildi (geri gelmesini engelleyen test).
- rca/tts.py: macOS icin yerlesik `say` arka ucu; pyttsx3 (GPL-3.0) istege bagli
  kaldi ve dagitilan paketlere alinmiyor (build.bat / build_macos.sh dislar).
- LICENSE (MIT) + THIRD_PARTY_NOTICES.md; README TR/EN ve kilavuzlara lisans bolumu.
- .gitignore: Resources/ altina konan ders materyali artik izlenmez.
- Sunum betiginden kullanici adi ve mutlak yollar temizlendi.
- 19 yeni test (177 toplam).

Co-Authored-By: Claude Opus 5 <noreply@anthropic.com>
</commit_message>
<xml_diff>
--- a/docs/presentation/Russian-Course-AI-Trilingual.pptx
+++ b/docs/presentation/Russian-Course-AI-Trilingual.pptx
@@ -2,20 +2,20 @@
 <file path=ppt/presentation.xml><?xml version="1.0" encoding="utf-8"?>
 <p:presentation xmlns:p="http://schemas.openxmlformats.org/presentationml/2006/main">
   <p:sldMasterIdLst>
-    <p:sldMasterId xmlns:r="http://schemas.openxmlformats.org/officeDocument/2006/relationships" id="2147483648" r:id="R9a23c79d9e4849a5"/>
+    <p:sldMasterId xmlns:r="http://schemas.openxmlformats.org/officeDocument/2006/relationships" id="2147483648" r:id="Rd6557eaa1b4c42c7"/>
   </p:sldMasterIdLst>
   <p:notesMasterIdLst>
-    <p:notesMasterId xmlns:r="http://schemas.openxmlformats.org/officeDocument/2006/relationships" r:id="R9fe7edfd01c44c2c"/>
+    <p:notesMasterId xmlns:r="http://schemas.openxmlformats.org/officeDocument/2006/relationships" r:id="R77016449c8944541"/>
   </p:notesMasterIdLst>
   <p:sldIdLst>
-    <p:sldId xmlns:r="http://schemas.openxmlformats.org/officeDocument/2006/relationships" id="256" r:id="R7f1b5dece71f4f92"/>
-    <p:sldId xmlns:r="http://schemas.openxmlformats.org/officeDocument/2006/relationships" id="257" r:id="R3b3e995d50e047b5"/>
-    <p:sldId xmlns:r="http://schemas.openxmlformats.org/officeDocument/2006/relationships" id="258" r:id="R6bc00d87cc134da1"/>
-    <p:sldId xmlns:r="http://schemas.openxmlformats.org/officeDocument/2006/relationships" id="259" r:id="R9ac878964d2e4b36"/>
-    <p:sldId xmlns:r="http://schemas.openxmlformats.org/officeDocument/2006/relationships" id="260" r:id="R1dc35d117d944879"/>
-    <p:sldId xmlns:r="http://schemas.openxmlformats.org/officeDocument/2006/relationships" id="261" r:id="R69d544187724467f"/>
-    <p:sldId xmlns:r="http://schemas.openxmlformats.org/officeDocument/2006/relationships" id="262" r:id="R56a0f4d4732b46cd"/>
-    <p:sldId xmlns:r="http://schemas.openxmlformats.org/officeDocument/2006/relationships" id="263" r:id="R9c5c6ceeaba74737"/>
+    <p:sldId xmlns:r="http://schemas.openxmlformats.org/officeDocument/2006/relationships" id="256" r:id="R54300787e149478e"/>
+    <p:sldId xmlns:r="http://schemas.openxmlformats.org/officeDocument/2006/relationships" id="257" r:id="Raafa8e337e4647b5"/>
+    <p:sldId xmlns:r="http://schemas.openxmlformats.org/officeDocument/2006/relationships" id="258" r:id="Rd90e7cc5e97d4f2c"/>
+    <p:sldId xmlns:r="http://schemas.openxmlformats.org/officeDocument/2006/relationships" id="259" r:id="R8dfab424ddd94bf0"/>
+    <p:sldId xmlns:r="http://schemas.openxmlformats.org/officeDocument/2006/relationships" id="260" r:id="R1d57af31516041d1"/>
+    <p:sldId xmlns:r="http://schemas.openxmlformats.org/officeDocument/2006/relationships" id="261" r:id="R798d4c80684b405f"/>
+    <p:sldId xmlns:r="http://schemas.openxmlformats.org/officeDocument/2006/relationships" id="262" r:id="Rd994f3d5371f498a"/>
+    <p:sldId xmlns:r="http://schemas.openxmlformats.org/officeDocument/2006/relationships" id="263" r:id="R3c1c6e6f5d5242be"/>
   </p:sldIdLst>
   <p:sldSz cx="12192000" cy="6858000"/>
   <p:notesSz cx="6858000" cy="9144000"/>
@@ -454,12 +454,12 @@
           </a:p>
           <a:p xmlns:a="http://schemas.openxmlformats.org/drawingml/2006/main">
             <a:r>
-              <a:t>- D:/Russian/README.md (product positioning and supported levels)</a:t>
-            </a:r>
-          </a:p>
-          <a:p xmlns:a="http://schemas.openxmlformats.org/drawingml/2006/main">
-            <a:r>
-              <a:t>- D:/Russian/docs/presentation/assets/russian-course-ai-hero.png (AI-generated original cover visual)</a:t>
+              <a:t>- D:\Russian\README.md (product positioning and supported levels)</a:t>
+            </a:r>
+          </a:p>
+          <a:p xmlns:a="http://schemas.openxmlformats.org/drawingml/2006/main">
+            <a:r>
+              <a:t>- D:\Russian\docs\presentation\assets\russian-course-ai-hero.png (AI-generated original cover visual)</a:t>
             </a:r>
           </a:p>
         </p:txBody>
@@ -534,7 +534,7 @@
           </a:p>
           <a:p xmlns:a="http://schemas.openxmlformats.org/drawingml/2006/main">
             <a:r>
-              <a:t>- D:/Russian/docs/presentation/assets/russian-course-ai-screenshot.png (user-supplied product screenshot)</a:t>
+              <a:t>- D:\Russian\docs\presentation\assets\russian-course-ai-screenshot.png (user-supplied product screenshot)</a:t>
             </a:r>
           </a:p>
         </p:txBody>
@@ -609,12 +609,12 @@
           </a:p>
           <a:p xmlns:a="http://schemas.openxmlformats.org/drawingml/2006/main">
             <a:r>
-              <a:t>- D:/Russian/rca/i18n.py (Turkish, English, and Russian interface catalog)</a:t>
-            </a:r>
-          </a:p>
-          <a:p xmlns:a="http://schemas.openxmlformats.org/drawingml/2006/main">
-            <a:r>
-              <a:t>- D:/Russian/Russian_Course_AI.pyw (instant and persistent language switching)</a:t>
+              <a:t>- D:\Russian\rca\i18n.py (Turkish, English, and Russian interface catalog)</a:t>
+            </a:r>
+          </a:p>
+          <a:p xmlns:a="http://schemas.openxmlformats.org/drawingml/2006/main">
+            <a:r>
+              <a:t>- D:\Russian\Russian_Course_AI.pyw (instant and persistent language switching)</a:t>
             </a:r>
           </a:p>
         </p:txBody>
@@ -689,12 +689,12 @@
           </a:p>
           <a:p xmlns:a="http://schemas.openxmlformats.org/drawingml/2006/main">
             <a:r>
-              <a:t>- D:/Russian/rca/tabs/srs_tab.py (daily review workflow and five study modes)</a:t>
-            </a:r>
-          </a:p>
-          <a:p xmlns:a="http://schemas.openxmlformats.org/drawingml/2006/main">
-            <a:r>
-              <a:t>- D:/Russian/Russian_Course_AI.pyw (learning, lab, read, practice, and system navigation groups)</a:t>
+              <a:t>- D:\Russian\rca\tabs\srs_tab.py (daily review workflow and five study modes)</a:t>
+            </a:r>
+          </a:p>
+          <a:p xmlns:a="http://schemas.openxmlformats.org/drawingml/2006/main">
+            <a:r>
+              <a:t>- D:\Russian\Russian_Course_AI.pyw (learning, lab, read, practice, and system navigation groups)</a:t>
             </a:r>
           </a:p>
         </p:txBody>
@@ -769,17 +769,17 @@
           </a:p>
           <a:p xmlns:a="http://schemas.openxmlformats.org/drawingml/2006/main">
             <a:r>
-              <a:t>- D:/Russian/Russian_Course_AI.pyw (18 entries in TAB_SPECS)</a:t>
-            </a:r>
-          </a:p>
-          <a:p xmlns:a="http://schemas.openxmlformats.org/drawingml/2006/main">
-            <a:r>
-              <a:t>- D:/Russian/rca/dictionary.py + rca/dict_data.py (RU-EN-TR dictionary with direction switch, 1,360 built-in entries with Turkish glosses, OpenRussian layer)</a:t>
-            </a:r>
-          </a:p>
-          <a:p xmlns:a="http://schemas.openxmlformats.org/drawingml/2006/main">
-            <a:r>
-              <a:t>- D:/Russian/README.md (feature descriptions)</a:t>
+              <a:t>- D:\Russian\Russian_Course_AI.pyw (18 entries in TAB_SPECS)</a:t>
+            </a:r>
+          </a:p>
+          <a:p xmlns:a="http://schemas.openxmlformats.org/drawingml/2006/main">
+            <a:r>
+              <a:t>- D:\Russian\rca\dictionary.py + rca\dict_data.py (RU-EN-TR dictionary with direction switch, 1,360 built-in entries with Turkish glosses, OpenRussian layer)</a:t>
+            </a:r>
+          </a:p>
+          <a:p xmlns:a="http://schemas.openxmlformats.org/drawingml/2006/main">
+            <a:r>
+              <a:t>- D:\Russian\README.md (feature descriptions)</a:t>
             </a:r>
           </a:p>
         </p:txBody>
@@ -854,12 +854,12 @@
           </a:p>
           <a:p xmlns:a="http://schemas.openxmlformats.org/drawingml/2006/main">
             <a:r>
-              <a:t>- D:/Russian/README.md (local LM Studio, optional NVIDIA NIM, and Resource Center network behavior)</a:t>
-            </a:r>
-          </a:p>
-          <a:p xmlns:a="http://schemas.openxmlformats.org/drawingml/2006/main">
-            <a:r>
-              <a:t>- D:/Russian/rca/db.py (SQLite persistence)</a:t>
+              <a:t>- D:\Russian\README.md (local LM Studio, optional NVIDIA NIM, and Resource Center network behavior)</a:t>
+            </a:r>
+          </a:p>
+          <a:p xmlns:a="http://schemas.openxmlformats.org/drawingml/2006/main">
+            <a:r>
+              <a:t>- D:\Russian\rca\db.py (SQLite persistence)</a:t>
             </a:r>
           </a:p>
         </p:txBody>
@@ -1009,7 +1009,7 @@
           </a:p>
           <a:p xmlns:a="http://schemas.openxmlformats.org/drawingml/2006/main">
             <a:r>
-              <a:t>- D:/Russian/README.md (installation, learning levels, and feature overview)</a:t>
+              <a:t>- D:\Russian\README.md (installation, learning levels, and feature overview)</a:t>
             </a:r>
           </a:p>
         </p:txBody>
@@ -1077,7 +1077,7 @@
   </p:cSld>
   <p:clrMap bg1="lt1" tx1="dk1" bg2="lt2" tx2="dk2" accent1="accent1" accent2="accent2" accent3="accent3" accent4="accent4" accent5="accent5" accent6="accent6" hlink="hlink" folHlink="folHlink"/>
   <p:sldLayoutIdLst>
-    <p:sldLayoutId xmlns:r="http://schemas.openxmlformats.org/officeDocument/2006/relationships" id="2147483649" r:id="R1786eea662154854"/>
+    <p:sldLayoutId xmlns:r="http://schemas.openxmlformats.org/officeDocument/2006/relationships" id="2147483649" r:id="R1b0c977fa2ae4dc7"/>
   </p:sldLayoutIdLst>
   <p:txStyles>
     <p:titleStyle>
@@ -1628,7 +1628,7 @@
           <p:cNvPr id="11" name="cover-kicker">
             <a:extLst xmlns:a="http://schemas.openxmlformats.org/drawingml/2006/main">
               <a:ext uri="{FF2B5EF4-FFF2-40B4-BE49-F238E27FC236}">
-                <a16:creationId xmlns:a16="http://schemas.microsoft.com/office/drawing/2014/main" id="{D2C04D1B-A8AF-419E-A3AD-FDF82008AAA8}"/>
+                <a16:creationId xmlns:a16="http://schemas.microsoft.com/office/drawing/2014/main" id="{57C0D56F-C3BD-407D-AA51-C43C56DF6052}"/>
               </a:ext>
             </a:extLst>
           </p:cNvPr>
@@ -1684,7 +1684,7 @@
           <p:cNvPr id="2" name="cover-title">
             <a:extLst xmlns:a="http://schemas.openxmlformats.org/drawingml/2006/main">
               <a:ext uri="{FF2B5EF4-FFF2-40B4-BE49-F238E27FC236}">
-                <a16:creationId xmlns:a16="http://schemas.microsoft.com/office/drawing/2014/main" id="{142CF151-9522-4595-BFE0-01329B502EB6}"/>
+                <a16:creationId xmlns:a16="http://schemas.microsoft.com/office/drawing/2014/main" id="{FAD35F1D-5113-48E6-A9D4-880D3221AD45}"/>
               </a:ext>
             </a:extLst>
           </p:cNvPr>
@@ -1763,7 +1763,7 @@
           <p:cNvPr id="3" name="cover-rule">
             <a:extLst xmlns:a="http://schemas.openxmlformats.org/drawingml/2006/main">
               <a:ext uri="{FF2B5EF4-FFF2-40B4-BE49-F238E27FC236}">
-                <a16:creationId xmlns:a16="http://schemas.microsoft.com/office/drawing/2014/main" id="{9E642A73-C75C-43A8-A4FB-139A8B7BA580}"/>
+                <a16:creationId xmlns:a16="http://schemas.microsoft.com/office/drawing/2014/main" id="{32460439-3821-48D1-92C5-BE5DE25CEFEE}"/>
               </a:ext>
             </a:extLst>
           </p:cNvPr>
@@ -1794,7 +1794,7 @@
           <p:cNvPr id="4" name="cover-tr">
             <a:extLst xmlns:a="http://schemas.openxmlformats.org/drawingml/2006/main">
               <a:ext uri="{FF2B5EF4-FFF2-40B4-BE49-F238E27FC236}">
-                <a16:creationId xmlns:a16="http://schemas.microsoft.com/office/drawing/2014/main" id="{B3E24BD1-19F8-4F91-992C-1C94DCBCD5D4}"/>
+                <a16:creationId xmlns:a16="http://schemas.microsoft.com/office/drawing/2014/main" id="{DA402468-81C2-46BA-9A5F-4B0710112366}"/>
               </a:ext>
             </a:extLst>
           </p:cNvPr>
@@ -1850,7 +1850,7 @@
           <p:cNvPr id="5" name="cover-en">
             <a:extLst xmlns:a="http://schemas.openxmlformats.org/drawingml/2006/main">
               <a:ext uri="{FF2B5EF4-FFF2-40B4-BE49-F238E27FC236}">
-                <a16:creationId xmlns:a16="http://schemas.microsoft.com/office/drawing/2014/main" id="{B298186E-39CF-436E-A40E-C9BAF9E25B3F}"/>
+                <a16:creationId xmlns:a16="http://schemas.microsoft.com/office/drawing/2014/main" id="{CBE10F99-2705-4C1F-9A48-3CCF3D5087D2}"/>
               </a:ext>
             </a:extLst>
           </p:cNvPr>
@@ -1906,7 +1906,7 @@
           <p:cNvPr id="6" name="cover-ru">
             <a:extLst xmlns:a="http://schemas.openxmlformats.org/drawingml/2006/main">
               <a:ext uri="{FF2B5EF4-FFF2-40B4-BE49-F238E27FC236}">
-                <a16:creationId xmlns:a16="http://schemas.microsoft.com/office/drawing/2014/main" id="{E597E31A-15AF-4B20-AAAD-B2BC25C1CBE9}"/>
+                <a16:creationId xmlns:a16="http://schemas.microsoft.com/office/drawing/2014/main" id="{B1DDA229-7281-43B9-ABEF-2D1C91AD63B5}"/>
               </a:ext>
             </a:extLst>
           </p:cNvPr>
@@ -1962,7 +1962,7 @@
           <p:cNvPr id="7" name="cover-meta">
             <a:extLst xmlns:a="http://schemas.openxmlformats.org/drawingml/2006/main">
               <a:ext uri="{FF2B5EF4-FFF2-40B4-BE49-F238E27FC236}">
-                <a16:creationId xmlns:a16="http://schemas.microsoft.com/office/drawing/2014/main" id="{9E270EBD-7FB6-4ACE-AAD5-EA278609DACC}"/>
+                <a16:creationId xmlns:a16="http://schemas.microsoft.com/office/drawing/2014/main" id="{F44C107E-B28D-415A-A230-AB2E29048F52}"/>
               </a:ext>
             </a:extLst>
           </p:cNvPr>
@@ -2018,7 +2018,7 @@
           <p:cNvPr id="8" name="hero-backing">
             <a:extLst xmlns:a="http://schemas.openxmlformats.org/drawingml/2006/main">
               <a:ext uri="{FF2B5EF4-FFF2-40B4-BE49-F238E27FC236}">
-                <a16:creationId xmlns:a16="http://schemas.microsoft.com/office/drawing/2014/main" id="{5C27B9A9-85E0-45E8-AE04-0D09079572BF}"/>
+                <a16:creationId xmlns:a16="http://schemas.microsoft.com/office/drawing/2014/main" id="{C208F246-37E4-4501-84A1-6E98983D479D}"/>
               </a:ext>
             </a:extLst>
           </p:cNvPr>
@@ -2055,7 +2055,7 @@
           <p:nvPr/>
         </p:nvPicPr>
         <p:blipFill>
-          <a:blip xmlns:r="http://schemas.openxmlformats.org/officeDocument/2006/relationships" xmlns:a="http://schemas.openxmlformats.org/drawingml/2006/main" r:embed="R8d05691df3ca4f5b"/>
+          <a:blip xmlns:r="http://schemas.openxmlformats.org/officeDocument/2006/relationships" xmlns:a="http://schemas.openxmlformats.org/drawingml/2006/main" r:embed="Ra7fe46b7ba214ae8"/>
           <a:srcRect xmlns:a="http://schemas.openxmlformats.org/drawingml/2006/main" l="510" t="0" r="510" b="0"/>
           <a:stretch xmlns:a="http://schemas.openxmlformats.org/drawingml/2006/main">
             <a:fillRect l="0" t="0" r="0" b="0"/>
@@ -2078,7 +2078,7 @@
           <p:cNvPr id="10" name="footer-1">
             <a:extLst xmlns:a="http://schemas.openxmlformats.org/drawingml/2006/main">
               <a:ext uri="{FF2B5EF4-FFF2-40B4-BE49-F238E27FC236}">
-                <a16:creationId xmlns:a16="http://schemas.microsoft.com/office/drawing/2014/main" id="{C801BFE3-D9C9-43DC-8779-AFA7B8BB4CC4}"/>
+                <a16:creationId xmlns:a16="http://schemas.microsoft.com/office/drawing/2014/main" id="{DC84DD52-C166-42BF-A2DB-9DA05C58130B}"/>
               </a:ext>
             </a:extLst>
           </p:cNvPr>
@@ -2132,7 +2132,7 @@
     </p:spTree>
     <p:extLst>
       <p:ext uri="{BB962C8B-B14F-4D97-AF65-F5344CB8AC3E}">
-        <p14:creationId xmlns:p14="http://schemas.microsoft.com/office/powerpoint/2010/main" val="2142869522"/>
+        <p14:creationId xmlns:p14="http://schemas.microsoft.com/office/powerpoint/2010/main" val="1234488235"/>
       </p:ext>
     </p:extLst>
   </p:cSld>
@@ -2163,7 +2163,7 @@
           <p:cNvPr id="6" name="screen-title">
             <a:extLst xmlns:a="http://schemas.openxmlformats.org/drawingml/2006/main">
               <a:ext uri="{FF2B5EF4-FFF2-40B4-BE49-F238E27FC236}">
-                <a16:creationId xmlns:a16="http://schemas.microsoft.com/office/drawing/2014/main" id="{07446B6D-2F30-40E7-8D32-1709DA37F60D}"/>
+                <a16:creationId xmlns:a16="http://schemas.microsoft.com/office/drawing/2014/main" id="{C13A8B36-7CE0-4713-B794-B54CAAEA3CF9}"/>
               </a:ext>
             </a:extLst>
           </p:cNvPr>
@@ -2219,7 +2219,7 @@
           <p:cNvPr id="2" name="screen-subtitle">
             <a:extLst xmlns:a="http://schemas.openxmlformats.org/drawingml/2006/main">
               <a:ext uri="{FF2B5EF4-FFF2-40B4-BE49-F238E27FC236}">
-                <a16:creationId xmlns:a16="http://schemas.microsoft.com/office/drawing/2014/main" id="{7AC0D20F-40E6-49A7-B1E2-B7F6E64D6961}"/>
+                <a16:creationId xmlns:a16="http://schemas.microsoft.com/office/drawing/2014/main" id="{BBF12F14-E476-468D-88AA-1BF989E1B627}"/>
               </a:ext>
             </a:extLst>
           </p:cNvPr>
@@ -2275,7 +2275,7 @@
           <p:cNvPr id="3" name="screen-frame">
             <a:extLst xmlns:a="http://schemas.openxmlformats.org/drawingml/2006/main">
               <a:ext uri="{FF2B5EF4-FFF2-40B4-BE49-F238E27FC236}">
-                <a16:creationId xmlns:a16="http://schemas.microsoft.com/office/drawing/2014/main" id="{0FB700FD-30B3-461F-BD40-69BB9BD770F4}"/>
+                <a16:creationId xmlns:a16="http://schemas.microsoft.com/office/drawing/2014/main" id="{DD3B96A9-0CAC-4648-8EB1-E5EB9D564CB8}"/>
               </a:ext>
             </a:extLst>
           </p:cNvPr>
@@ -2312,7 +2312,7 @@
           <p:nvPr/>
         </p:nvPicPr>
         <p:blipFill>
-          <a:blip xmlns:r="http://schemas.openxmlformats.org/officeDocument/2006/relationships" xmlns:a="http://schemas.openxmlformats.org/drawingml/2006/main" r:embed="R212ca088c432493b"/>
+          <a:blip xmlns:r="http://schemas.openxmlformats.org/officeDocument/2006/relationships" xmlns:a="http://schemas.openxmlformats.org/drawingml/2006/main" r:embed="R5a2953713dd54900"/>
           <a:stretch xmlns:a="http://schemas.openxmlformats.org/drawingml/2006/main"/>
         </p:blipFill>
         <p:spPr>
@@ -2332,7 +2332,7 @@
           <p:cNvPr id="5" name="screen-footer">
             <a:extLst xmlns:a="http://schemas.openxmlformats.org/drawingml/2006/main">
               <a:ext uri="{FF2B5EF4-FFF2-40B4-BE49-F238E27FC236}">
-                <a16:creationId xmlns:a16="http://schemas.microsoft.com/office/drawing/2014/main" id="{C39C1B64-397B-40DD-AC6C-F2B1E4D09B72}"/>
+                <a16:creationId xmlns:a16="http://schemas.microsoft.com/office/drawing/2014/main" id="{62FD8A26-56CB-468E-8D36-C767C987A905}"/>
               </a:ext>
             </a:extLst>
           </p:cNvPr>
@@ -2386,7 +2386,7 @@
     </p:spTree>
     <p:extLst>
       <p:ext uri="{BB962C8B-B14F-4D97-AF65-F5344CB8AC3E}">
-        <p14:creationId xmlns:p14="http://schemas.microsoft.com/office/powerpoint/2010/main" val="109141341"/>
+        <p14:creationId xmlns:p14="http://schemas.microsoft.com/office/powerpoint/2010/main" val="1638922992"/>
       </p:ext>
     </p:extLst>
   </p:cSld>
@@ -2417,7 +2417,7 @@
           <p:cNvPr id="17" name="language-title">
             <a:extLst xmlns:a="http://schemas.openxmlformats.org/drawingml/2006/main">
               <a:ext uri="{FF2B5EF4-FFF2-40B4-BE49-F238E27FC236}">
-                <a16:creationId xmlns:a16="http://schemas.microsoft.com/office/drawing/2014/main" id="{1697D2DA-70D7-4AAE-8058-641D76F75B19}"/>
+                <a16:creationId xmlns:a16="http://schemas.microsoft.com/office/drawing/2014/main" id="{A207F1F1-A191-4380-B317-B5D8630AB7D6}"/>
               </a:ext>
             </a:extLst>
           </p:cNvPr>
@@ -2473,7 +2473,7 @@
           <p:cNvPr id="2" name="language-subtitle">
             <a:extLst xmlns:a="http://schemas.openxmlformats.org/drawingml/2006/main">
               <a:ext uri="{FF2B5EF4-FFF2-40B4-BE49-F238E27FC236}">
-                <a16:creationId xmlns:a16="http://schemas.microsoft.com/office/drawing/2014/main" id="{348E7761-99A0-4A64-A8F0-00015BBC8146}"/>
+                <a16:creationId xmlns:a16="http://schemas.microsoft.com/office/drawing/2014/main" id="{B839A191-E037-48C7-84FB-15690141E7DB}"/>
               </a:ext>
             </a:extLst>
           </p:cNvPr>
@@ -2529,7 +2529,7 @@
           <p:cNvPr id="3" name="language-rule">
             <a:extLst xmlns:a="http://schemas.openxmlformats.org/drawingml/2006/main">
               <a:ext uri="{FF2B5EF4-FFF2-40B4-BE49-F238E27FC236}">
-                <a16:creationId xmlns:a16="http://schemas.microsoft.com/office/drawing/2014/main" id="{1F63B7AA-1E46-442E-8773-619A958CD3C3}"/>
+                <a16:creationId xmlns:a16="http://schemas.microsoft.com/office/drawing/2014/main" id="{B01232BE-4B4E-4433-AFBE-43C0ECC6487A}"/>
               </a:ext>
             </a:extLst>
           </p:cNvPr>
@@ -2560,7 +2560,7 @@
           <p:cNvPr id="4" name="language-label-0">
             <a:extLst xmlns:a="http://schemas.openxmlformats.org/drawingml/2006/main">
               <a:ext uri="{FF2B5EF4-FFF2-40B4-BE49-F238E27FC236}">
-                <a16:creationId xmlns:a16="http://schemas.microsoft.com/office/drawing/2014/main" id="{A7814F91-38A9-4AD5-9D52-AE0279E14D13}"/>
+                <a16:creationId xmlns:a16="http://schemas.microsoft.com/office/drawing/2014/main" id="{32868BEC-C82C-49AE-89EC-69EB3586C1BE}"/>
               </a:ext>
             </a:extLst>
           </p:cNvPr>
@@ -2616,7 +2616,7 @@
           <p:cNvPr id="5" name="language-head-0">
             <a:extLst xmlns:a="http://schemas.openxmlformats.org/drawingml/2006/main">
               <a:ext uri="{FF2B5EF4-FFF2-40B4-BE49-F238E27FC236}">
-                <a16:creationId xmlns:a16="http://schemas.microsoft.com/office/drawing/2014/main" id="{0D029EAD-9500-4953-BCB7-445C50120431}"/>
+                <a16:creationId xmlns:a16="http://schemas.microsoft.com/office/drawing/2014/main" id="{43A39C43-75D4-451F-980A-253396AD59B5}"/>
               </a:ext>
             </a:extLst>
           </p:cNvPr>
@@ -2672,7 +2672,7 @@
           <p:cNvPr id="6" name="language-body-0">
             <a:extLst xmlns:a="http://schemas.openxmlformats.org/drawingml/2006/main">
               <a:ext uri="{FF2B5EF4-FFF2-40B4-BE49-F238E27FC236}">
-                <a16:creationId xmlns:a16="http://schemas.microsoft.com/office/drawing/2014/main" id="{F53EEF2F-C19B-4AFB-9F86-8369A3DEEC3F}"/>
+                <a16:creationId xmlns:a16="http://schemas.microsoft.com/office/drawing/2014/main" id="{49620499-4FAA-4883-8426-2996878C32E7}"/>
               </a:ext>
             </a:extLst>
           </p:cNvPr>
@@ -2728,7 +2728,7 @@
           <p:cNvPr id="7" name="language-accent-0">
             <a:extLst xmlns:a="http://schemas.openxmlformats.org/drawingml/2006/main">
               <a:ext uri="{FF2B5EF4-FFF2-40B4-BE49-F238E27FC236}">
-                <a16:creationId xmlns:a16="http://schemas.microsoft.com/office/drawing/2014/main" id="{CB7E1724-8291-45C9-B4EA-324B3C6DD71F}"/>
+                <a16:creationId xmlns:a16="http://schemas.microsoft.com/office/drawing/2014/main" id="{AFD01959-F57C-4D93-A84C-5513524459CC}"/>
               </a:ext>
             </a:extLst>
           </p:cNvPr>
@@ -2759,7 +2759,7 @@
           <p:cNvPr id="8" name="language-label-1">
             <a:extLst xmlns:a="http://schemas.openxmlformats.org/drawingml/2006/main">
               <a:ext uri="{FF2B5EF4-FFF2-40B4-BE49-F238E27FC236}">
-                <a16:creationId xmlns:a16="http://schemas.microsoft.com/office/drawing/2014/main" id="{3599D9E0-40F3-44D5-B787-D235E1DF9717}"/>
+                <a16:creationId xmlns:a16="http://schemas.microsoft.com/office/drawing/2014/main" id="{770DE9F7-8DC0-438D-AD5A-4FEEC23164C2}"/>
               </a:ext>
             </a:extLst>
           </p:cNvPr>
@@ -2815,7 +2815,7 @@
           <p:cNvPr id="9" name="language-head-1">
             <a:extLst xmlns:a="http://schemas.openxmlformats.org/drawingml/2006/main">
               <a:ext uri="{FF2B5EF4-FFF2-40B4-BE49-F238E27FC236}">
-                <a16:creationId xmlns:a16="http://schemas.microsoft.com/office/drawing/2014/main" id="{0013DEAF-4016-48BD-B2AD-D8F653A3BC93}"/>
+                <a16:creationId xmlns:a16="http://schemas.microsoft.com/office/drawing/2014/main" id="{31ADDBE6-8C18-4064-A7A9-A91452EE5489}"/>
               </a:ext>
             </a:extLst>
           </p:cNvPr>
@@ -2871,7 +2871,7 @@
           <p:cNvPr id="10" name="language-body-1">
             <a:extLst xmlns:a="http://schemas.openxmlformats.org/drawingml/2006/main">
               <a:ext uri="{FF2B5EF4-FFF2-40B4-BE49-F238E27FC236}">
-                <a16:creationId xmlns:a16="http://schemas.microsoft.com/office/drawing/2014/main" id="{7680CB0E-B8EE-438C-91B6-8CB5FCDE61BB}"/>
+                <a16:creationId xmlns:a16="http://schemas.microsoft.com/office/drawing/2014/main" id="{ABF9BF5C-6C70-4040-A395-2D4F52E8C7D0}"/>
               </a:ext>
             </a:extLst>
           </p:cNvPr>
@@ -2927,7 +2927,7 @@
           <p:cNvPr id="11" name="language-accent-1">
             <a:extLst xmlns:a="http://schemas.openxmlformats.org/drawingml/2006/main">
               <a:ext uri="{FF2B5EF4-FFF2-40B4-BE49-F238E27FC236}">
-                <a16:creationId xmlns:a16="http://schemas.microsoft.com/office/drawing/2014/main" id="{525D7240-2A31-402D-AB74-725E944C7914}"/>
+                <a16:creationId xmlns:a16="http://schemas.microsoft.com/office/drawing/2014/main" id="{BF70DCD5-ABE6-4FCC-A0E1-5B16A2590FE4}"/>
               </a:ext>
             </a:extLst>
           </p:cNvPr>
@@ -2958,7 +2958,7 @@
           <p:cNvPr id="12" name="language-label-2">
             <a:extLst xmlns:a="http://schemas.openxmlformats.org/drawingml/2006/main">
               <a:ext uri="{FF2B5EF4-FFF2-40B4-BE49-F238E27FC236}">
-                <a16:creationId xmlns:a16="http://schemas.microsoft.com/office/drawing/2014/main" id="{2530C190-EF08-4E62-BC7E-B00FD373E723}"/>
+                <a16:creationId xmlns:a16="http://schemas.microsoft.com/office/drawing/2014/main" id="{001E6C8C-CD91-4019-A2BB-65BDB2BD8569}"/>
               </a:ext>
             </a:extLst>
           </p:cNvPr>
@@ -3014,7 +3014,7 @@
           <p:cNvPr id="13" name="language-head-2">
             <a:extLst xmlns:a="http://schemas.openxmlformats.org/drawingml/2006/main">
               <a:ext uri="{FF2B5EF4-FFF2-40B4-BE49-F238E27FC236}">
-                <a16:creationId xmlns:a16="http://schemas.microsoft.com/office/drawing/2014/main" id="{7D142714-D410-47D2-AC33-580F7F4833BA}"/>
+                <a16:creationId xmlns:a16="http://schemas.microsoft.com/office/drawing/2014/main" id="{FE8C3460-FB77-4636-8D5A-C2CE8C5F8169}"/>
               </a:ext>
             </a:extLst>
           </p:cNvPr>
@@ -3070,7 +3070,7 @@
           <p:cNvPr id="14" name="language-body-2">
             <a:extLst xmlns:a="http://schemas.openxmlformats.org/drawingml/2006/main">
               <a:ext uri="{FF2B5EF4-FFF2-40B4-BE49-F238E27FC236}">
-                <a16:creationId xmlns:a16="http://schemas.microsoft.com/office/drawing/2014/main" id="{96025A0F-5B46-4912-892C-EE5A518052DA}"/>
+                <a16:creationId xmlns:a16="http://schemas.microsoft.com/office/drawing/2014/main" id="{7D05D282-01C8-40A6-9029-49C06840C21C}"/>
               </a:ext>
             </a:extLst>
           </p:cNvPr>
@@ -3126,7 +3126,7 @@
           <p:cNvPr id="15" name="language-accent-2">
             <a:extLst xmlns:a="http://schemas.openxmlformats.org/drawingml/2006/main">
               <a:ext uri="{FF2B5EF4-FFF2-40B4-BE49-F238E27FC236}">
-                <a16:creationId xmlns:a16="http://schemas.microsoft.com/office/drawing/2014/main" id="{827CE832-5F09-41A5-BC67-557866C58581}"/>
+                <a16:creationId xmlns:a16="http://schemas.microsoft.com/office/drawing/2014/main" id="{5B49CFE8-6F60-4BC1-ABCB-C32C959142F3}"/>
               </a:ext>
             </a:extLst>
           </p:cNvPr>
@@ -3157,7 +3157,7 @@
           <p:cNvPr id="16" name="footer-3">
             <a:extLst xmlns:a="http://schemas.openxmlformats.org/drawingml/2006/main">
               <a:ext uri="{FF2B5EF4-FFF2-40B4-BE49-F238E27FC236}">
-                <a16:creationId xmlns:a16="http://schemas.microsoft.com/office/drawing/2014/main" id="{4198DA75-488C-4372-869A-E3699DCA60D8}"/>
+                <a16:creationId xmlns:a16="http://schemas.microsoft.com/office/drawing/2014/main" id="{1D28FCF2-03C0-47AA-AD5C-AA2FEAB3B721}"/>
               </a:ext>
             </a:extLst>
           </p:cNvPr>
@@ -3211,7 +3211,7 @@
     </p:spTree>
     <p:extLst>
       <p:ext uri="{BB962C8B-B14F-4D97-AF65-F5344CB8AC3E}">
-        <p14:creationId xmlns:p14="http://schemas.microsoft.com/office/powerpoint/2010/main" val="1854479918"/>
+        <p14:creationId xmlns:p14="http://schemas.microsoft.com/office/powerpoint/2010/main" val="492218474"/>
       </p:ext>
     </p:extLst>
   </p:cSld>
@@ -3242,7 +3242,7 @@
           <p:cNvPr id="23" name="loop-title">
             <a:extLst xmlns:a="http://schemas.openxmlformats.org/drawingml/2006/main">
               <a:ext uri="{FF2B5EF4-FFF2-40B4-BE49-F238E27FC236}">
-                <a16:creationId xmlns:a16="http://schemas.microsoft.com/office/drawing/2014/main" id="{100DCEDD-03B7-4663-A398-30578049C8C0}"/>
+                <a16:creationId xmlns:a16="http://schemas.microsoft.com/office/drawing/2014/main" id="{BDEA8E52-ADB0-4249-B109-B801024C0DEE}"/>
               </a:ext>
             </a:extLst>
           </p:cNvPr>
@@ -3298,7 +3298,7 @@
           <p:cNvPr id="2" name="loop-subtitle">
             <a:extLst xmlns:a="http://schemas.openxmlformats.org/drawingml/2006/main">
               <a:ext uri="{FF2B5EF4-FFF2-40B4-BE49-F238E27FC236}">
-                <a16:creationId xmlns:a16="http://schemas.microsoft.com/office/drawing/2014/main" id="{8C20832A-DDD6-43D5-AA63-E9C78CC1CFBA}"/>
+                <a16:creationId xmlns:a16="http://schemas.microsoft.com/office/drawing/2014/main" id="{A332272F-C7FD-487E-A312-A1257EE92FA8}"/>
               </a:ext>
             </a:extLst>
           </p:cNvPr>
@@ -3354,7 +3354,7 @@
           <p:cNvPr id="3" name="loop-track">
             <a:extLst xmlns:a="http://schemas.openxmlformats.org/drawingml/2006/main">
               <a:ext uri="{FF2B5EF4-FFF2-40B4-BE49-F238E27FC236}">
-                <a16:creationId xmlns:a16="http://schemas.microsoft.com/office/drawing/2014/main" id="{87C75E9F-3251-4886-AD3A-9B4FF17B7B36}"/>
+                <a16:creationId xmlns:a16="http://schemas.microsoft.com/office/drawing/2014/main" id="{C2988F6C-6843-4573-A62A-44C9A6DC9C93}"/>
               </a:ext>
             </a:extLst>
           </p:cNvPr>
@@ -3385,7 +3385,7 @@
           <p:cNvPr id="4" name="loop-node-0">
             <a:extLst xmlns:a="http://schemas.openxmlformats.org/drawingml/2006/main">
               <a:ext uri="{FF2B5EF4-FFF2-40B4-BE49-F238E27FC236}">
-                <a16:creationId xmlns:a16="http://schemas.microsoft.com/office/drawing/2014/main" id="{41763DB4-234C-4F7B-8060-EB25F4D3A522}"/>
+                <a16:creationId xmlns:a16="http://schemas.microsoft.com/office/drawing/2014/main" id="{44D2B460-7E11-437A-B727-61424F0CDF5D}"/>
               </a:ext>
             </a:extLst>
           </p:cNvPr>
@@ -3418,7 +3418,7 @@
           <p:cNvPr id="5" name="loop-number-0">
             <a:extLst xmlns:a="http://schemas.openxmlformats.org/drawingml/2006/main">
               <a:ext uri="{FF2B5EF4-FFF2-40B4-BE49-F238E27FC236}">
-                <a16:creationId xmlns:a16="http://schemas.microsoft.com/office/drawing/2014/main" id="{65D0D9CA-0471-4D77-A7EB-CE0FECF7C989}"/>
+                <a16:creationId xmlns:a16="http://schemas.microsoft.com/office/drawing/2014/main" id="{6E95C2B0-056E-4BDF-8222-E0A5B0676FA8}"/>
               </a:ext>
             </a:extLst>
           </p:cNvPr>
@@ -3474,7 +3474,7 @@
           <p:cNvPr id="6" name="loop-en-0">
             <a:extLst xmlns:a="http://schemas.openxmlformats.org/drawingml/2006/main">
               <a:ext uri="{FF2B5EF4-FFF2-40B4-BE49-F238E27FC236}">
-                <a16:creationId xmlns:a16="http://schemas.microsoft.com/office/drawing/2014/main" id="{2F86B1CD-21DF-48A6-A65D-8BF33B343492}"/>
+                <a16:creationId xmlns:a16="http://schemas.microsoft.com/office/drawing/2014/main" id="{4D94D5B0-8898-4B0A-AF44-52E0DE6A1C3D}"/>
               </a:ext>
             </a:extLst>
           </p:cNvPr>
@@ -3530,7 +3530,7 @@
           <p:cNvPr id="7" name="loop-tr-0">
             <a:extLst xmlns:a="http://schemas.openxmlformats.org/drawingml/2006/main">
               <a:ext uri="{FF2B5EF4-FFF2-40B4-BE49-F238E27FC236}">
-                <a16:creationId xmlns:a16="http://schemas.microsoft.com/office/drawing/2014/main" id="{8F7B5013-B327-48FA-8F25-6C148DFF9AB5}"/>
+                <a16:creationId xmlns:a16="http://schemas.microsoft.com/office/drawing/2014/main" id="{E6B93BDF-A7AA-49E8-B795-1C1AE1C4325A}"/>
               </a:ext>
             </a:extLst>
           </p:cNvPr>
@@ -3586,7 +3586,7 @@
           <p:cNvPr id="8" name="loop-ru-0">
             <a:extLst xmlns:a="http://schemas.openxmlformats.org/drawingml/2006/main">
               <a:ext uri="{FF2B5EF4-FFF2-40B4-BE49-F238E27FC236}">
-                <a16:creationId xmlns:a16="http://schemas.microsoft.com/office/drawing/2014/main" id="{7059A2A6-D254-47DD-A983-87AD0FD055DF}"/>
+                <a16:creationId xmlns:a16="http://schemas.microsoft.com/office/drawing/2014/main" id="{7D272DC1-4CC2-4093-A62B-4289D3E5FBCE}"/>
               </a:ext>
             </a:extLst>
           </p:cNvPr>
@@ -3642,7 +3642,7 @@
           <p:cNvPr id="9" name="loop-detail-0">
             <a:extLst xmlns:a="http://schemas.openxmlformats.org/drawingml/2006/main">
               <a:ext uri="{FF2B5EF4-FFF2-40B4-BE49-F238E27FC236}">
-                <a16:creationId xmlns:a16="http://schemas.microsoft.com/office/drawing/2014/main" id="{BBB8E762-5FA8-40CB-80B4-64EF39E67AFD}"/>
+                <a16:creationId xmlns:a16="http://schemas.microsoft.com/office/drawing/2014/main" id="{631F9297-3139-4117-9919-6B70169F126B}"/>
               </a:ext>
             </a:extLst>
           </p:cNvPr>
@@ -3698,7 +3698,7 @@
           <p:cNvPr id="10" name="loop-node-1">
             <a:extLst xmlns:a="http://schemas.openxmlformats.org/drawingml/2006/main">
               <a:ext uri="{FF2B5EF4-FFF2-40B4-BE49-F238E27FC236}">
-                <a16:creationId xmlns:a16="http://schemas.microsoft.com/office/drawing/2014/main" id="{E89AB854-716F-412B-9E09-E0B7A2BE3DBE}"/>
+                <a16:creationId xmlns:a16="http://schemas.microsoft.com/office/drawing/2014/main" id="{4A78449F-441D-4320-B552-CF481DEC497C}"/>
               </a:ext>
             </a:extLst>
           </p:cNvPr>
@@ -3731,7 +3731,7 @@
           <p:cNvPr id="11" name="loop-number-1">
             <a:extLst xmlns:a="http://schemas.openxmlformats.org/drawingml/2006/main">
               <a:ext uri="{FF2B5EF4-FFF2-40B4-BE49-F238E27FC236}">
-                <a16:creationId xmlns:a16="http://schemas.microsoft.com/office/drawing/2014/main" id="{7E697359-987F-4376-86D0-B535F44EB926}"/>
+                <a16:creationId xmlns:a16="http://schemas.microsoft.com/office/drawing/2014/main" id="{313C074E-E5DB-46F7-B858-D929E37CA4BD}"/>
               </a:ext>
             </a:extLst>
           </p:cNvPr>
@@ -3787,7 +3787,7 @@
           <p:cNvPr id="12" name="loop-en-1">
             <a:extLst xmlns:a="http://schemas.openxmlformats.org/drawingml/2006/main">
               <a:ext uri="{FF2B5EF4-FFF2-40B4-BE49-F238E27FC236}">
-                <a16:creationId xmlns:a16="http://schemas.microsoft.com/office/drawing/2014/main" id="{C62C98FC-CE06-4B9B-A2FE-2080CB7A6FFF}"/>
+                <a16:creationId xmlns:a16="http://schemas.microsoft.com/office/drawing/2014/main" id="{498009F6-F1F3-4B18-9735-0B929B9C267B}"/>
               </a:ext>
             </a:extLst>
           </p:cNvPr>
@@ -3843,7 +3843,7 @@
           <p:cNvPr id="13" name="loop-tr-1">
             <a:extLst xmlns:a="http://schemas.openxmlformats.org/drawingml/2006/main">
               <a:ext uri="{FF2B5EF4-FFF2-40B4-BE49-F238E27FC236}">
-                <a16:creationId xmlns:a16="http://schemas.microsoft.com/office/drawing/2014/main" id="{BD58D37E-D81D-4793-ADBF-F1CB472639FE}"/>
+                <a16:creationId xmlns:a16="http://schemas.microsoft.com/office/drawing/2014/main" id="{ECFB757C-115B-43B6-AB3A-26C7DCA694A6}"/>
               </a:ext>
             </a:extLst>
           </p:cNvPr>
@@ -3899,7 +3899,7 @@
           <p:cNvPr id="14" name="loop-ru-1">
             <a:extLst xmlns:a="http://schemas.openxmlformats.org/drawingml/2006/main">
               <a:ext uri="{FF2B5EF4-FFF2-40B4-BE49-F238E27FC236}">
-                <a16:creationId xmlns:a16="http://schemas.microsoft.com/office/drawing/2014/main" id="{13A6A286-8EBD-48FB-B5EA-2469271C7A6F}"/>
+                <a16:creationId xmlns:a16="http://schemas.microsoft.com/office/drawing/2014/main" id="{4177F07F-CDB0-427B-B640-53E7A3FE7208}"/>
               </a:ext>
             </a:extLst>
           </p:cNvPr>
@@ -3955,7 +3955,7 @@
           <p:cNvPr id="15" name="loop-detail-1">
             <a:extLst xmlns:a="http://schemas.openxmlformats.org/drawingml/2006/main">
               <a:ext uri="{FF2B5EF4-FFF2-40B4-BE49-F238E27FC236}">
-                <a16:creationId xmlns:a16="http://schemas.microsoft.com/office/drawing/2014/main" id="{D2C7BF89-7A5D-46FF-8CFB-EDF9E2376C15}"/>
+                <a16:creationId xmlns:a16="http://schemas.microsoft.com/office/drawing/2014/main" id="{B9A4E827-D707-4AF8-ADCC-91BD5D249D19}"/>
               </a:ext>
             </a:extLst>
           </p:cNvPr>
@@ -4011,7 +4011,7 @@
           <p:cNvPr id="16" name="loop-node-2">
             <a:extLst xmlns:a="http://schemas.openxmlformats.org/drawingml/2006/main">
               <a:ext uri="{FF2B5EF4-FFF2-40B4-BE49-F238E27FC236}">
-                <a16:creationId xmlns:a16="http://schemas.microsoft.com/office/drawing/2014/main" id="{0A60D524-148A-4A83-A837-7A69DF0FAC3A}"/>
+                <a16:creationId xmlns:a16="http://schemas.microsoft.com/office/drawing/2014/main" id="{DB59E30E-5CA8-470E-80B1-65A1DBB87672}"/>
               </a:ext>
             </a:extLst>
           </p:cNvPr>
@@ -4044,7 +4044,7 @@
           <p:cNvPr id="17" name="loop-number-2">
             <a:extLst xmlns:a="http://schemas.openxmlformats.org/drawingml/2006/main">
               <a:ext uri="{FF2B5EF4-FFF2-40B4-BE49-F238E27FC236}">
-                <a16:creationId xmlns:a16="http://schemas.microsoft.com/office/drawing/2014/main" id="{87A324F1-DAB8-4EB1-8D21-1C0A1879FD10}"/>
+                <a16:creationId xmlns:a16="http://schemas.microsoft.com/office/drawing/2014/main" id="{48AE4683-5D79-4AC3-B573-EC96CDB85948}"/>
               </a:ext>
             </a:extLst>
           </p:cNvPr>
@@ -4100,7 +4100,7 @@
           <p:cNvPr id="18" name="loop-en-2">
             <a:extLst xmlns:a="http://schemas.openxmlformats.org/drawingml/2006/main">
               <a:ext uri="{FF2B5EF4-FFF2-40B4-BE49-F238E27FC236}">
-                <a16:creationId xmlns:a16="http://schemas.microsoft.com/office/drawing/2014/main" id="{38C09F0F-3076-4F17-9F8B-E543761BA0F9}"/>
+                <a16:creationId xmlns:a16="http://schemas.microsoft.com/office/drawing/2014/main" id="{4D6E8F3E-48AF-4D08-9D5D-9A5942EC5E74}"/>
               </a:ext>
             </a:extLst>
           </p:cNvPr>
@@ -4156,7 +4156,7 @@
           <p:cNvPr id="19" name="loop-tr-2">
             <a:extLst xmlns:a="http://schemas.openxmlformats.org/drawingml/2006/main">
               <a:ext uri="{FF2B5EF4-FFF2-40B4-BE49-F238E27FC236}">
-                <a16:creationId xmlns:a16="http://schemas.microsoft.com/office/drawing/2014/main" id="{7E0CA91F-0111-4D89-9F35-C78EC40351B0}"/>
+                <a16:creationId xmlns:a16="http://schemas.microsoft.com/office/drawing/2014/main" id="{9CFF4D03-4A47-4B35-92A6-2CE5117023D3}"/>
               </a:ext>
             </a:extLst>
           </p:cNvPr>
@@ -4212,7 +4212,7 @@
           <p:cNvPr id="20" name="loop-ru-2">
             <a:extLst xmlns:a="http://schemas.openxmlformats.org/drawingml/2006/main">
               <a:ext uri="{FF2B5EF4-FFF2-40B4-BE49-F238E27FC236}">
-                <a16:creationId xmlns:a16="http://schemas.microsoft.com/office/drawing/2014/main" id="{0D4512A0-5771-4CAB-9620-A1ABA51EC7B2}"/>
+                <a16:creationId xmlns:a16="http://schemas.microsoft.com/office/drawing/2014/main" id="{89BE00E3-B931-4951-9AA2-C6E1515C60EC}"/>
               </a:ext>
             </a:extLst>
           </p:cNvPr>
@@ -4268,7 +4268,7 @@
           <p:cNvPr id="21" name="loop-detail-2">
             <a:extLst xmlns:a="http://schemas.openxmlformats.org/drawingml/2006/main">
               <a:ext uri="{FF2B5EF4-FFF2-40B4-BE49-F238E27FC236}">
-                <a16:creationId xmlns:a16="http://schemas.microsoft.com/office/drawing/2014/main" id="{618C8071-08A5-47E6-9010-E37636DB18D5}"/>
+                <a16:creationId xmlns:a16="http://schemas.microsoft.com/office/drawing/2014/main" id="{21E4DFB2-018F-400A-ACE0-30D71BCFC7F0}"/>
               </a:ext>
             </a:extLst>
           </p:cNvPr>
@@ -4324,7 +4324,7 @@
           <p:cNvPr id="22" name="footer-4">
             <a:extLst xmlns:a="http://schemas.openxmlformats.org/drawingml/2006/main">
               <a:ext uri="{FF2B5EF4-FFF2-40B4-BE49-F238E27FC236}">
-                <a16:creationId xmlns:a16="http://schemas.microsoft.com/office/drawing/2014/main" id="{035B5199-8E50-45C6-B1EE-059C79629C6E}"/>
+                <a16:creationId xmlns:a16="http://schemas.microsoft.com/office/drawing/2014/main" id="{299CA8B1-489F-4466-BDA5-5CFE1CE83279}"/>
               </a:ext>
             </a:extLst>
           </p:cNvPr>
@@ -4378,7 +4378,7 @@
     </p:spTree>
     <p:extLst>
       <p:ext uri="{BB962C8B-B14F-4D97-AF65-F5344CB8AC3E}">
-        <p14:creationId xmlns:p14="http://schemas.microsoft.com/office/powerpoint/2010/main" val="618504345"/>
+        <p14:creationId xmlns:p14="http://schemas.microsoft.com/office/powerpoint/2010/main" val="1151346544"/>
       </p:ext>
     </p:extLst>
   </p:cSld>
@@ -4409,7 +4409,7 @@
           <p:cNvPr id="21" name="breadth-title">
             <a:extLst xmlns:a="http://schemas.openxmlformats.org/drawingml/2006/main">
               <a:ext uri="{FF2B5EF4-FFF2-40B4-BE49-F238E27FC236}">
-                <a16:creationId xmlns:a16="http://schemas.microsoft.com/office/drawing/2014/main" id="{A5DD98BF-5B5A-4431-B6C5-56FA0613912D}"/>
+                <a16:creationId xmlns:a16="http://schemas.microsoft.com/office/drawing/2014/main" id="{9EE0551D-1B54-4DFC-996B-827A6AB2B96D}"/>
               </a:ext>
             </a:extLst>
           </p:cNvPr>
@@ -4465,7 +4465,7 @@
           <p:cNvPr id="2" name="breadth-triple">
             <a:extLst xmlns:a="http://schemas.openxmlformats.org/drawingml/2006/main">
               <a:ext uri="{FF2B5EF4-FFF2-40B4-BE49-F238E27FC236}">
-                <a16:creationId xmlns:a16="http://schemas.microsoft.com/office/drawing/2014/main" id="{C84DB572-801C-414C-9B8F-EBA26F802047}"/>
+                <a16:creationId xmlns:a16="http://schemas.microsoft.com/office/drawing/2014/main" id="{F54F6BBE-2EFE-4E82-ACF8-54C4CBAC44AD}"/>
               </a:ext>
             </a:extLst>
           </p:cNvPr>
@@ -4521,7 +4521,7 @@
           <p:cNvPr id="3" name="breadth-number">
             <a:extLst xmlns:a="http://schemas.openxmlformats.org/drawingml/2006/main">
               <a:ext uri="{FF2B5EF4-FFF2-40B4-BE49-F238E27FC236}">
-                <a16:creationId xmlns:a16="http://schemas.microsoft.com/office/drawing/2014/main" id="{2CBAC694-02D3-4FEA-AAC2-E367B6692711}"/>
+                <a16:creationId xmlns:a16="http://schemas.microsoft.com/office/drawing/2014/main" id="{6BA4D645-B90F-420B-97AD-98147D25F291}"/>
               </a:ext>
             </a:extLst>
           </p:cNvPr>
@@ -4577,7 +4577,7 @@
           <p:cNvPr id="4" name="breadth-caption">
             <a:extLst xmlns:a="http://schemas.openxmlformats.org/drawingml/2006/main">
               <a:ext uri="{FF2B5EF4-FFF2-40B4-BE49-F238E27FC236}">
-                <a16:creationId xmlns:a16="http://schemas.microsoft.com/office/drawing/2014/main" id="{758D066B-9E4C-4706-921C-D9DDE8EA3DAA}"/>
+                <a16:creationId xmlns:a16="http://schemas.microsoft.com/office/drawing/2014/main" id="{FA349433-9A54-4922-A067-182892A76009}"/>
               </a:ext>
             </a:extLst>
           </p:cNvPr>
@@ -4679,7 +4679,7 @@
           <p:cNvPr id="5" name="breadth-divider">
             <a:extLst xmlns:a="http://schemas.openxmlformats.org/drawingml/2006/main">
               <a:ext uri="{FF2B5EF4-FFF2-40B4-BE49-F238E27FC236}">
-                <a16:creationId xmlns:a16="http://schemas.microsoft.com/office/drawing/2014/main" id="{7196AE9B-D7C7-4DB7-A5C7-06BC3C89930A}"/>
+                <a16:creationId xmlns:a16="http://schemas.microsoft.com/office/drawing/2014/main" id="{937F2EBF-89EC-40F3-9F17-9669FCAFC69F}"/>
               </a:ext>
             </a:extLst>
           </p:cNvPr>
@@ -4710,7 +4710,7 @@
           <p:cNvPr id="6" name="breadth-item-rule-0">
             <a:extLst xmlns:a="http://schemas.openxmlformats.org/drawingml/2006/main">
               <a:ext uri="{FF2B5EF4-FFF2-40B4-BE49-F238E27FC236}">
-                <a16:creationId xmlns:a16="http://schemas.microsoft.com/office/drawing/2014/main" id="{C7749F31-87AE-4E49-AFF8-192CD688C069}"/>
+                <a16:creationId xmlns:a16="http://schemas.microsoft.com/office/drawing/2014/main" id="{BFF2F326-0838-4A31-AA15-0D6CF943D2B8}"/>
               </a:ext>
             </a:extLst>
           </p:cNvPr>
@@ -4741,7 +4741,7 @@
           <p:cNvPr id="7" name="breadth-item-0">
             <a:extLst xmlns:a="http://schemas.openxmlformats.org/drawingml/2006/main">
               <a:ext uri="{FF2B5EF4-FFF2-40B4-BE49-F238E27FC236}">
-                <a16:creationId xmlns:a16="http://schemas.microsoft.com/office/drawing/2014/main" id="{29F5F95D-720A-4D37-B72F-31145A44EFC4}"/>
+                <a16:creationId xmlns:a16="http://schemas.microsoft.com/office/drawing/2014/main" id="{C1D9EDB9-DA43-4B2A-AF54-B46825FE08C7}"/>
               </a:ext>
             </a:extLst>
           </p:cNvPr>
@@ -4797,7 +4797,7 @@
           <p:cNvPr id="8" name="breadth-item-rule-1">
             <a:extLst xmlns:a="http://schemas.openxmlformats.org/drawingml/2006/main">
               <a:ext uri="{FF2B5EF4-FFF2-40B4-BE49-F238E27FC236}">
-                <a16:creationId xmlns:a16="http://schemas.microsoft.com/office/drawing/2014/main" id="{BBD64A57-6F35-4BE9-AE87-24D9671B52D7}"/>
+                <a16:creationId xmlns:a16="http://schemas.microsoft.com/office/drawing/2014/main" id="{B8406D54-C356-424C-A632-F91624AF9E4E}"/>
               </a:ext>
             </a:extLst>
           </p:cNvPr>
@@ -4828,7 +4828,7 @@
           <p:cNvPr id="9" name="breadth-item-1">
             <a:extLst xmlns:a="http://schemas.openxmlformats.org/drawingml/2006/main">
               <a:ext uri="{FF2B5EF4-FFF2-40B4-BE49-F238E27FC236}">
-                <a16:creationId xmlns:a16="http://schemas.microsoft.com/office/drawing/2014/main" id="{C8AD2139-EF31-4D5F-AEFC-E241DD583BB9}"/>
+                <a16:creationId xmlns:a16="http://schemas.microsoft.com/office/drawing/2014/main" id="{D86A3439-1183-4B33-A4EA-1E94D9D08463}"/>
               </a:ext>
             </a:extLst>
           </p:cNvPr>
@@ -4884,7 +4884,7 @@
           <p:cNvPr id="10" name="breadth-item-rule-2">
             <a:extLst xmlns:a="http://schemas.openxmlformats.org/drawingml/2006/main">
               <a:ext uri="{FF2B5EF4-FFF2-40B4-BE49-F238E27FC236}">
-                <a16:creationId xmlns:a16="http://schemas.microsoft.com/office/drawing/2014/main" id="{7791C924-A208-4EB9-B1D3-90E1F3415A77}"/>
+                <a16:creationId xmlns:a16="http://schemas.microsoft.com/office/drawing/2014/main" id="{B7422FE0-0078-40A8-8B82-30DCFE12819A}"/>
               </a:ext>
             </a:extLst>
           </p:cNvPr>
@@ -4915,7 +4915,7 @@
           <p:cNvPr id="11" name="breadth-item-2">
             <a:extLst xmlns:a="http://schemas.openxmlformats.org/drawingml/2006/main">
               <a:ext uri="{FF2B5EF4-FFF2-40B4-BE49-F238E27FC236}">
-                <a16:creationId xmlns:a16="http://schemas.microsoft.com/office/drawing/2014/main" id="{D05F92CE-820C-44D5-9790-1E9CF7A8419E}"/>
+                <a16:creationId xmlns:a16="http://schemas.microsoft.com/office/drawing/2014/main" id="{4E1C1E0C-4E99-44C5-B3BE-59043F98C78C}"/>
               </a:ext>
             </a:extLst>
           </p:cNvPr>
@@ -4971,7 +4971,7 @@
           <p:cNvPr id="12" name="breadth-item-rule-3">
             <a:extLst xmlns:a="http://schemas.openxmlformats.org/drawingml/2006/main">
               <a:ext uri="{FF2B5EF4-FFF2-40B4-BE49-F238E27FC236}">
-                <a16:creationId xmlns:a16="http://schemas.microsoft.com/office/drawing/2014/main" id="{3F025689-89E8-4D16-B82A-E99AA9F92660}"/>
+                <a16:creationId xmlns:a16="http://schemas.microsoft.com/office/drawing/2014/main" id="{43F2BCE6-9803-45E5-B0F0-A94FAB79A530}"/>
               </a:ext>
             </a:extLst>
           </p:cNvPr>
@@ -5002,7 +5002,7 @@
           <p:cNvPr id="13" name="breadth-item-3">
             <a:extLst xmlns:a="http://schemas.openxmlformats.org/drawingml/2006/main">
               <a:ext uri="{FF2B5EF4-FFF2-40B4-BE49-F238E27FC236}">
-                <a16:creationId xmlns:a16="http://schemas.microsoft.com/office/drawing/2014/main" id="{881D6AF0-4754-4A96-93FF-D503E1F0C627}"/>
+                <a16:creationId xmlns:a16="http://schemas.microsoft.com/office/drawing/2014/main" id="{FFD6F0F2-EE45-4003-AC4F-3A394A57BBE8}"/>
               </a:ext>
             </a:extLst>
           </p:cNvPr>
@@ -5058,7 +5058,7 @@
           <p:cNvPr id="14" name="breadth-item-rule-4">
             <a:extLst xmlns:a="http://schemas.openxmlformats.org/drawingml/2006/main">
               <a:ext uri="{FF2B5EF4-FFF2-40B4-BE49-F238E27FC236}">
-                <a16:creationId xmlns:a16="http://schemas.microsoft.com/office/drawing/2014/main" id="{08A3C2C6-CF3C-460E-9BBC-9A00353E251B}"/>
+                <a16:creationId xmlns:a16="http://schemas.microsoft.com/office/drawing/2014/main" id="{16774F71-B35C-4321-97DE-6EBBB4C41024}"/>
               </a:ext>
             </a:extLst>
           </p:cNvPr>
@@ -5089,7 +5089,7 @@
           <p:cNvPr id="15" name="breadth-item-4">
             <a:extLst xmlns:a="http://schemas.openxmlformats.org/drawingml/2006/main">
               <a:ext uri="{FF2B5EF4-FFF2-40B4-BE49-F238E27FC236}">
-                <a16:creationId xmlns:a16="http://schemas.microsoft.com/office/drawing/2014/main" id="{91BC048C-F350-46E2-B8F6-FF09AA49E34D}"/>
+                <a16:creationId xmlns:a16="http://schemas.microsoft.com/office/drawing/2014/main" id="{90C89C2D-70B9-4D8E-A60A-649FD2D02695}"/>
               </a:ext>
             </a:extLst>
           </p:cNvPr>
@@ -5145,7 +5145,7 @@
           <p:cNvPr id="16" name="breadth-item-rule-5">
             <a:extLst xmlns:a="http://schemas.openxmlformats.org/drawingml/2006/main">
               <a:ext uri="{FF2B5EF4-FFF2-40B4-BE49-F238E27FC236}">
-                <a16:creationId xmlns:a16="http://schemas.microsoft.com/office/drawing/2014/main" id="{BB9A273E-0CF6-4452-B822-C26044FEFDFC}"/>
+                <a16:creationId xmlns:a16="http://schemas.microsoft.com/office/drawing/2014/main" id="{0B97508B-DDA4-4D09-A9FE-3908A41EC043}"/>
               </a:ext>
             </a:extLst>
           </p:cNvPr>
@@ -5176,7 +5176,7 @@
           <p:cNvPr id="17" name="breadth-item-5">
             <a:extLst xmlns:a="http://schemas.openxmlformats.org/drawingml/2006/main">
               <a:ext uri="{FF2B5EF4-FFF2-40B4-BE49-F238E27FC236}">
-                <a16:creationId xmlns:a16="http://schemas.microsoft.com/office/drawing/2014/main" id="{D268D113-BA44-4AE5-9E99-6241B3867304}"/>
+                <a16:creationId xmlns:a16="http://schemas.microsoft.com/office/drawing/2014/main" id="{5E0E9A48-A21C-4C01-90A2-CACBD01AD0B9}"/>
               </a:ext>
             </a:extLst>
           </p:cNvPr>
@@ -5232,7 +5232,7 @@
           <p:cNvPr id="18" name="breadth-item-rule-6">
             <a:extLst xmlns:a="http://schemas.openxmlformats.org/drawingml/2006/main">
               <a:ext uri="{FF2B5EF4-FFF2-40B4-BE49-F238E27FC236}">
-                <a16:creationId xmlns:a16="http://schemas.microsoft.com/office/drawing/2014/main" id="{88EC6AA5-2AD1-43BE-89C9-13F0FEBC9D79}"/>
+                <a16:creationId xmlns:a16="http://schemas.microsoft.com/office/drawing/2014/main" id="{3A73E46E-60B2-4B7D-BFB4-C47A6B711E07}"/>
               </a:ext>
             </a:extLst>
           </p:cNvPr>
@@ -5263,7 +5263,7 @@
           <p:cNvPr id="19" name="breadth-item-6">
             <a:extLst xmlns:a="http://schemas.openxmlformats.org/drawingml/2006/main">
               <a:ext uri="{FF2B5EF4-FFF2-40B4-BE49-F238E27FC236}">
-                <a16:creationId xmlns:a16="http://schemas.microsoft.com/office/drawing/2014/main" id="{21B5CD79-8AA3-4C8C-9D24-E0E83340EC26}"/>
+                <a16:creationId xmlns:a16="http://schemas.microsoft.com/office/drawing/2014/main" id="{188074F6-9917-4C1B-8FAD-C75ACA5B6760}"/>
               </a:ext>
             </a:extLst>
           </p:cNvPr>
@@ -5319,7 +5319,7 @@
           <p:cNvPr id="20" name="footer-5">
             <a:extLst xmlns:a="http://schemas.openxmlformats.org/drawingml/2006/main">
               <a:ext uri="{FF2B5EF4-FFF2-40B4-BE49-F238E27FC236}">
-                <a16:creationId xmlns:a16="http://schemas.microsoft.com/office/drawing/2014/main" id="{F6F41FCE-BE87-4465-AAB9-792A5C8426CF}"/>
+                <a16:creationId xmlns:a16="http://schemas.microsoft.com/office/drawing/2014/main" id="{B836DE1A-369A-413B-AFDE-73128C290E9E}"/>
               </a:ext>
             </a:extLst>
           </p:cNvPr>
@@ -5373,7 +5373,7 @@
     </p:spTree>
     <p:extLst>
       <p:ext uri="{BB962C8B-B14F-4D97-AF65-F5344CB8AC3E}">
-        <p14:creationId xmlns:p14="http://schemas.microsoft.com/office/powerpoint/2010/main" val="991746786"/>
+        <p14:creationId xmlns:p14="http://schemas.microsoft.com/office/powerpoint/2010/main" val="93527480"/>
       </p:ext>
     </p:extLst>
   </p:cSld>
@@ -5404,7 +5404,7 @@
           <p:cNvPr id="12" name="privacy-title">
             <a:extLst xmlns:a="http://schemas.openxmlformats.org/drawingml/2006/main">
               <a:ext uri="{FF2B5EF4-FFF2-40B4-BE49-F238E27FC236}">
-                <a16:creationId xmlns:a16="http://schemas.microsoft.com/office/drawing/2014/main" id="{A58615C9-798B-4BB1-B790-251372E7E6D7}"/>
+                <a16:creationId xmlns:a16="http://schemas.microsoft.com/office/drawing/2014/main" id="{B99C6A9A-7312-4275-A37F-0C3D4FC667DD}"/>
               </a:ext>
             </a:extLst>
           </p:cNvPr>
@@ -5460,7 +5460,7 @@
           <p:cNvPr id="2" name="privacy-tr">
             <a:extLst xmlns:a="http://schemas.openxmlformats.org/drawingml/2006/main">
               <a:ext uri="{FF2B5EF4-FFF2-40B4-BE49-F238E27FC236}">
-                <a16:creationId xmlns:a16="http://schemas.microsoft.com/office/drawing/2014/main" id="{394A13F2-B176-40CA-A267-63F6B3A3CED1}"/>
+                <a16:creationId xmlns:a16="http://schemas.microsoft.com/office/drawing/2014/main" id="{D09E0CC0-2596-4FA6-AD7E-5B1F5010061E}"/>
               </a:ext>
             </a:extLst>
           </p:cNvPr>
@@ -5516,7 +5516,7 @@
           <p:cNvPr id="3" name="privacy-ru">
             <a:extLst xmlns:a="http://schemas.openxmlformats.org/drawingml/2006/main">
               <a:ext uri="{FF2B5EF4-FFF2-40B4-BE49-F238E27FC236}">
-                <a16:creationId xmlns:a16="http://schemas.microsoft.com/office/drawing/2014/main" id="{AD11F256-811F-45D8-9815-670B1B8494A9}"/>
+                <a16:creationId xmlns:a16="http://schemas.microsoft.com/office/drawing/2014/main" id="{31A69B0A-4A76-4D5E-803A-99AC23E4F8CE}"/>
               </a:ext>
             </a:extLst>
           </p:cNvPr>
@@ -5572,7 +5572,7 @@
           <p:cNvPr id="4" name="privacy-divider">
             <a:extLst xmlns:a="http://schemas.openxmlformats.org/drawingml/2006/main">
               <a:ext uri="{FF2B5EF4-FFF2-40B4-BE49-F238E27FC236}">
-                <a16:creationId xmlns:a16="http://schemas.microsoft.com/office/drawing/2014/main" id="{CDD3E806-1C75-4057-9129-CBF0741FAEC4}"/>
+                <a16:creationId xmlns:a16="http://schemas.microsoft.com/office/drawing/2014/main" id="{1A02C68C-9D7F-431A-90B9-9B9ADFEE5072}"/>
               </a:ext>
             </a:extLst>
           </p:cNvPr>
@@ -5603,7 +5603,7 @@
           <p:cNvPr id="5" name="local-label">
             <a:extLst xmlns:a="http://schemas.openxmlformats.org/drawingml/2006/main">
               <a:ext uri="{FF2B5EF4-FFF2-40B4-BE49-F238E27FC236}">
-                <a16:creationId xmlns:a16="http://schemas.microsoft.com/office/drawing/2014/main" id="{66ED4BCF-7E8B-4BC2-A6BC-4711AE93DFC0}"/>
+                <a16:creationId xmlns:a16="http://schemas.microsoft.com/office/drawing/2014/main" id="{5867E621-9286-4D51-82B9-020545949593}"/>
               </a:ext>
             </a:extLst>
           </p:cNvPr>
@@ -5659,7 +5659,7 @@
           <p:cNvPr id="6" name="local-head">
             <a:extLst xmlns:a="http://schemas.openxmlformats.org/drawingml/2006/main">
               <a:ext uri="{FF2B5EF4-FFF2-40B4-BE49-F238E27FC236}">
-                <a16:creationId xmlns:a16="http://schemas.microsoft.com/office/drawing/2014/main" id="{17CDBDE6-D7B5-4AEB-838B-10EADFDFB52B}"/>
+                <a16:creationId xmlns:a16="http://schemas.microsoft.com/office/drawing/2014/main" id="{AA7F1F9D-9BF8-4323-8E85-473EC7750C66}"/>
               </a:ext>
             </a:extLst>
           </p:cNvPr>
@@ -5715,7 +5715,7 @@
           <p:cNvPr id="7" name="local-copy">
             <a:extLst xmlns:a="http://schemas.openxmlformats.org/drawingml/2006/main">
               <a:ext uri="{FF2B5EF4-FFF2-40B4-BE49-F238E27FC236}">
-                <a16:creationId xmlns:a16="http://schemas.microsoft.com/office/drawing/2014/main" id="{4102E5D6-DC8D-454D-8F1E-3A4EA0083BB0}"/>
+                <a16:creationId xmlns:a16="http://schemas.microsoft.com/office/drawing/2014/main" id="{61288030-338D-4506-9834-7B3FF588FED8}"/>
               </a:ext>
             </a:extLst>
           </p:cNvPr>
@@ -5845,7 +5845,7 @@
           <p:cNvPr id="8" name="optional-label">
             <a:extLst xmlns:a="http://schemas.openxmlformats.org/drawingml/2006/main">
               <a:ext uri="{FF2B5EF4-FFF2-40B4-BE49-F238E27FC236}">
-                <a16:creationId xmlns:a16="http://schemas.microsoft.com/office/drawing/2014/main" id="{A9F4F51A-6E7D-4206-8AAE-E64183C527A0}"/>
+                <a16:creationId xmlns:a16="http://schemas.microsoft.com/office/drawing/2014/main" id="{C04FC616-E271-429D-8F02-858EE7D791A6}"/>
               </a:ext>
             </a:extLst>
           </p:cNvPr>
@@ -5901,7 +5901,7 @@
           <p:cNvPr id="9" name="optional-head">
             <a:extLst xmlns:a="http://schemas.openxmlformats.org/drawingml/2006/main">
               <a:ext uri="{FF2B5EF4-FFF2-40B4-BE49-F238E27FC236}">
-                <a16:creationId xmlns:a16="http://schemas.microsoft.com/office/drawing/2014/main" id="{2EDC1565-5505-48AA-BA38-1D77E3A41BFC}"/>
+                <a16:creationId xmlns:a16="http://schemas.microsoft.com/office/drawing/2014/main" id="{598593ED-D6FB-47A7-8328-83174603678F}"/>
               </a:ext>
             </a:extLst>
           </p:cNvPr>
@@ -5957,7 +5957,7 @@
           <p:cNvPr id="10" name="optional-copy">
             <a:extLst xmlns:a="http://schemas.openxmlformats.org/drawingml/2006/main">
               <a:ext uri="{FF2B5EF4-FFF2-40B4-BE49-F238E27FC236}">
-                <a16:creationId xmlns:a16="http://schemas.microsoft.com/office/drawing/2014/main" id="{6B264883-B484-4C19-AF9D-53730CAF90A0}"/>
+                <a16:creationId xmlns:a16="http://schemas.microsoft.com/office/drawing/2014/main" id="{40D89780-236C-4B7E-950B-4AE6E6C359E2}"/>
               </a:ext>
             </a:extLst>
           </p:cNvPr>
@@ -6087,7 +6087,7 @@
           <p:cNvPr id="11" name="footer-6">
             <a:extLst xmlns:a="http://schemas.openxmlformats.org/drawingml/2006/main">
               <a:ext uri="{FF2B5EF4-FFF2-40B4-BE49-F238E27FC236}">
-                <a16:creationId xmlns:a16="http://schemas.microsoft.com/office/drawing/2014/main" id="{20C52DCC-20A8-4855-A754-4C57C522E3CA}"/>
+                <a16:creationId xmlns:a16="http://schemas.microsoft.com/office/drawing/2014/main" id="{8BDAFE85-3CA5-40EF-957D-52AC8198796A}"/>
               </a:ext>
             </a:extLst>
           </p:cNvPr>
@@ -6141,7 +6141,7 @@
     </p:spTree>
     <p:extLst>
       <p:ext uri="{BB962C8B-B14F-4D97-AF65-F5344CB8AC3E}">
-        <p14:creationId xmlns:p14="http://schemas.microsoft.com/office/powerpoint/2010/main" val="306044187"/>
+        <p14:creationId xmlns:p14="http://schemas.microsoft.com/office/powerpoint/2010/main" val="1285470234"/>
       </p:ext>
     </p:extLst>
   </p:cSld>
@@ -6172,7 +6172,7 @@
           <p:cNvPr id="13" name="platform-title">
             <a:extLst xmlns:a="http://schemas.openxmlformats.org/drawingml/2006/main">
               <a:ext uri="{FF2B5EF4-FFF2-40B4-BE49-F238E27FC236}">
-                <a16:creationId xmlns:a16="http://schemas.microsoft.com/office/drawing/2014/main" id="{8D7B0009-60A0-4B33-A2CF-021527B64270}"/>
+                <a16:creationId xmlns:a16="http://schemas.microsoft.com/office/drawing/2014/main" id="{0DFB9864-780F-4A88-938F-BC3D22B1F098}"/>
               </a:ext>
             </a:extLst>
           </p:cNvPr>
@@ -6228,7 +6228,7 @@
           <p:cNvPr id="2" name="platform-subtitle">
             <a:extLst xmlns:a="http://schemas.openxmlformats.org/drawingml/2006/main">
               <a:ext uri="{FF2B5EF4-FFF2-40B4-BE49-F238E27FC236}">
-                <a16:creationId xmlns:a16="http://schemas.microsoft.com/office/drawing/2014/main" id="{99FAEF76-0DC5-485D-9BB2-8E6DFB257CA3}"/>
+                <a16:creationId xmlns:a16="http://schemas.microsoft.com/office/drawing/2014/main" id="{945F6973-0631-4D0E-9FEF-ABBA179537DA}"/>
               </a:ext>
             </a:extLst>
           </p:cNvPr>
@@ -6284,7 +6284,7 @@
           <p:cNvPr id="3" name="platform-rule">
             <a:extLst xmlns:a="http://schemas.openxmlformats.org/drawingml/2006/main">
               <a:ext uri="{FF2B5EF4-FFF2-40B4-BE49-F238E27FC236}">
-                <a16:creationId xmlns:a16="http://schemas.microsoft.com/office/drawing/2014/main" id="{B0D4AB6B-7F62-43EF-85E4-41703338BE8C}"/>
+                <a16:creationId xmlns:a16="http://schemas.microsoft.com/office/drawing/2014/main" id="{D104AA2C-B079-4831-A839-30F751731B55}"/>
               </a:ext>
             </a:extLst>
           </p:cNvPr>
@@ -6315,7 +6315,7 @@
           <p:cNvPr id="4" name="platform-label-0">
             <a:extLst xmlns:a="http://schemas.openxmlformats.org/drawingml/2006/main">
               <a:ext uri="{FF2B5EF4-FFF2-40B4-BE49-F238E27FC236}">
-                <a16:creationId xmlns:a16="http://schemas.microsoft.com/office/drawing/2014/main" id="{09E1D733-8A9C-4420-B7C9-87716A1F1D54}"/>
+                <a16:creationId xmlns:a16="http://schemas.microsoft.com/office/drawing/2014/main" id="{8CAA0470-4832-45E8-B06B-FFBD9F7203B5}"/>
               </a:ext>
             </a:extLst>
           </p:cNvPr>
@@ -6371,7 +6371,7 @@
           <p:cNvPr id="5" name="platform-body-0">
             <a:extLst xmlns:a="http://schemas.openxmlformats.org/drawingml/2006/main">
               <a:ext uri="{FF2B5EF4-FFF2-40B4-BE49-F238E27FC236}">
-                <a16:creationId xmlns:a16="http://schemas.microsoft.com/office/drawing/2014/main" id="{79C357ED-216E-4695-93DB-DF74E0D5ADC8}"/>
+                <a16:creationId xmlns:a16="http://schemas.microsoft.com/office/drawing/2014/main" id="{48C92DE6-B297-4E93-B019-FD64529E9F39}"/>
               </a:ext>
             </a:extLst>
           </p:cNvPr>
@@ -6427,7 +6427,7 @@
           <p:cNvPr id="6" name="platform-label-1">
             <a:extLst xmlns:a="http://schemas.openxmlformats.org/drawingml/2006/main">
               <a:ext uri="{FF2B5EF4-FFF2-40B4-BE49-F238E27FC236}">
-                <a16:creationId xmlns:a16="http://schemas.microsoft.com/office/drawing/2014/main" id="{1119451F-46DD-43F4-A0B2-4A12CA8C9B20}"/>
+                <a16:creationId xmlns:a16="http://schemas.microsoft.com/office/drawing/2014/main" id="{5D8F1469-E14B-4A17-B9DE-B4F599A67351}"/>
               </a:ext>
             </a:extLst>
           </p:cNvPr>
@@ -6483,7 +6483,7 @@
           <p:cNvPr id="7" name="platform-body-1">
             <a:extLst xmlns:a="http://schemas.openxmlformats.org/drawingml/2006/main">
               <a:ext uri="{FF2B5EF4-FFF2-40B4-BE49-F238E27FC236}">
-                <a16:creationId xmlns:a16="http://schemas.microsoft.com/office/drawing/2014/main" id="{28ED335C-F449-4525-A2D8-1193400CC158}"/>
+                <a16:creationId xmlns:a16="http://schemas.microsoft.com/office/drawing/2014/main" id="{548F48F5-231F-4B5C-A7BA-4CB668C5C497}"/>
               </a:ext>
             </a:extLst>
           </p:cNvPr>
@@ -6539,7 +6539,7 @@
           <p:cNvPr id="8" name="platform-label-2">
             <a:extLst xmlns:a="http://schemas.openxmlformats.org/drawingml/2006/main">
               <a:ext uri="{FF2B5EF4-FFF2-40B4-BE49-F238E27FC236}">
-                <a16:creationId xmlns:a16="http://schemas.microsoft.com/office/drawing/2014/main" id="{15952640-37A9-4D70-B610-EA769D7002B0}"/>
+                <a16:creationId xmlns:a16="http://schemas.microsoft.com/office/drawing/2014/main" id="{44F92A2B-9871-4223-9E78-DB7FA90DDA3A}"/>
               </a:ext>
             </a:extLst>
           </p:cNvPr>
@@ -6595,7 +6595,7 @@
           <p:cNvPr id="9" name="platform-body-2">
             <a:extLst xmlns:a="http://schemas.openxmlformats.org/drawingml/2006/main">
               <a:ext uri="{FF2B5EF4-FFF2-40B4-BE49-F238E27FC236}">
-                <a16:creationId xmlns:a16="http://schemas.microsoft.com/office/drawing/2014/main" id="{DF612EF2-08BB-46C2-BCAB-95E96362C160}"/>
+                <a16:creationId xmlns:a16="http://schemas.microsoft.com/office/drawing/2014/main" id="{2CA5D04B-5414-4CC3-97BA-135620513D95}"/>
               </a:ext>
             </a:extLst>
           </p:cNvPr>
@@ -6651,7 +6651,7 @@
           <p:cNvPr id="10" name="platform-footnote-rule">
             <a:extLst xmlns:a="http://schemas.openxmlformats.org/drawingml/2006/main">
               <a:ext uri="{FF2B5EF4-FFF2-40B4-BE49-F238E27FC236}">
-                <a16:creationId xmlns:a16="http://schemas.microsoft.com/office/drawing/2014/main" id="{056335AB-4AAE-45F3-90C9-566241A6A5B3}"/>
+                <a16:creationId xmlns:a16="http://schemas.microsoft.com/office/drawing/2014/main" id="{681C516A-273B-4640-8098-882EB9112B6D}"/>
               </a:ext>
             </a:extLst>
           </p:cNvPr>
@@ -6682,7 +6682,7 @@
           <p:cNvPr id="11" name="platform-footnote">
             <a:extLst xmlns:a="http://schemas.openxmlformats.org/drawingml/2006/main">
               <a:ext uri="{FF2B5EF4-FFF2-40B4-BE49-F238E27FC236}">
-                <a16:creationId xmlns:a16="http://schemas.microsoft.com/office/drawing/2014/main" id="{8140EFC2-BC78-4236-A01B-F5C603145CB9}"/>
+                <a16:creationId xmlns:a16="http://schemas.microsoft.com/office/drawing/2014/main" id="{200DB95D-3787-44AC-918C-06F8F98E7803}"/>
               </a:ext>
             </a:extLst>
           </p:cNvPr>
@@ -6761,7 +6761,7 @@
           <p:cNvPr id="12" name="footer-7">
             <a:extLst xmlns:a="http://schemas.openxmlformats.org/drawingml/2006/main">
               <a:ext uri="{FF2B5EF4-FFF2-40B4-BE49-F238E27FC236}">
-                <a16:creationId xmlns:a16="http://schemas.microsoft.com/office/drawing/2014/main" id="{312E6838-DF4B-43C1-AF8D-72318678656F}"/>
+                <a16:creationId xmlns:a16="http://schemas.microsoft.com/office/drawing/2014/main" id="{4E541EDE-3215-4973-8669-47DE7D30527F}"/>
               </a:ext>
             </a:extLst>
           </p:cNvPr>
@@ -6815,7 +6815,7 @@
     </p:spTree>
     <p:extLst>
       <p:ext uri="{BB962C8B-B14F-4D97-AF65-F5344CB8AC3E}">
-        <p14:creationId xmlns:p14="http://schemas.microsoft.com/office/powerpoint/2010/main" val="520469100"/>
+        <p14:creationId xmlns:p14="http://schemas.microsoft.com/office/powerpoint/2010/main" val="485107627"/>
       </p:ext>
     </p:extLst>
   </p:cSld>
@@ -6846,7 +6846,7 @@
           <p:cNvPr id="9" name="close-kicker">
             <a:extLst xmlns:a="http://schemas.openxmlformats.org/drawingml/2006/main">
               <a:ext uri="{FF2B5EF4-FFF2-40B4-BE49-F238E27FC236}">
-                <a16:creationId xmlns:a16="http://schemas.microsoft.com/office/drawing/2014/main" id="{1D474F7D-4A82-426D-A931-34F7B1E632B3}"/>
+                <a16:creationId xmlns:a16="http://schemas.microsoft.com/office/drawing/2014/main" id="{9DAEA0CF-1A2F-4430-9A94-068D3407A4A4}"/>
               </a:ext>
             </a:extLst>
           </p:cNvPr>
@@ -6902,7 +6902,7 @@
           <p:cNvPr id="2" name="close-title">
             <a:extLst xmlns:a="http://schemas.openxmlformats.org/drawingml/2006/main">
               <a:ext uri="{FF2B5EF4-FFF2-40B4-BE49-F238E27FC236}">
-                <a16:creationId xmlns:a16="http://schemas.microsoft.com/office/drawing/2014/main" id="{1078435E-BA9F-4D4C-9A73-012446AA86DF}"/>
+                <a16:creationId xmlns:a16="http://schemas.microsoft.com/office/drawing/2014/main" id="{A2CA36C6-7FDE-43F8-B512-7BA00624F8F6}"/>
               </a:ext>
             </a:extLst>
           </p:cNvPr>
@@ -6981,7 +6981,7 @@
           <p:cNvPr id="3" name="close-tr">
             <a:extLst xmlns:a="http://schemas.openxmlformats.org/drawingml/2006/main">
               <a:ext uri="{FF2B5EF4-FFF2-40B4-BE49-F238E27FC236}">
-                <a16:creationId xmlns:a16="http://schemas.microsoft.com/office/drawing/2014/main" id="{5568147F-FD70-4619-A81E-410B9A904D04}"/>
+                <a16:creationId xmlns:a16="http://schemas.microsoft.com/office/drawing/2014/main" id="{D2F61D66-F402-4E7C-B67B-EB50F79E4692}"/>
               </a:ext>
             </a:extLst>
           </p:cNvPr>
@@ -7037,7 +7037,7 @@
           <p:cNvPr id="4" name="close-ru">
             <a:extLst xmlns:a="http://schemas.openxmlformats.org/drawingml/2006/main">
               <a:ext uri="{FF2B5EF4-FFF2-40B4-BE49-F238E27FC236}">
-                <a16:creationId xmlns:a16="http://schemas.microsoft.com/office/drawing/2014/main" id="{AC80AD40-D0BF-4049-902B-3AFB005FB1DD}"/>
+                <a16:creationId xmlns:a16="http://schemas.microsoft.com/office/drawing/2014/main" id="{B9B9320B-3933-40BF-97D3-147DA99269BA}"/>
               </a:ext>
             </a:extLst>
           </p:cNvPr>
@@ -7093,7 +7093,7 @@
           <p:cNvPr id="5" name="close-rule">
             <a:extLst xmlns:a="http://schemas.openxmlformats.org/drawingml/2006/main">
               <a:ext uri="{FF2B5EF4-FFF2-40B4-BE49-F238E27FC236}">
-                <a16:creationId xmlns:a16="http://schemas.microsoft.com/office/drawing/2014/main" id="{2CDBC1C5-5D5E-475D-BBDC-4E61B7D205E1}"/>
+                <a16:creationId xmlns:a16="http://schemas.microsoft.com/office/drawing/2014/main" id="{EC021CD1-13E4-4346-9989-4862DB7068F8}"/>
               </a:ext>
             </a:extLst>
           </p:cNvPr>
@@ -7124,7 +7124,7 @@
           <p:cNvPr id="6" name="close-action">
             <a:extLst xmlns:a="http://schemas.openxmlformats.org/drawingml/2006/main">
               <a:ext uri="{FF2B5EF4-FFF2-40B4-BE49-F238E27FC236}">
-                <a16:creationId xmlns:a16="http://schemas.microsoft.com/office/drawing/2014/main" id="{D60E7AE3-AD12-4018-9979-3AB46A6F1573}"/>
+                <a16:creationId xmlns:a16="http://schemas.microsoft.com/office/drawing/2014/main" id="{BC06E648-9455-4104-9C39-B6372A0EE718}"/>
               </a:ext>
             </a:extLst>
           </p:cNvPr>
@@ -7180,7 +7180,7 @@
           <p:cNvPr id="7" name="close-meta">
             <a:extLst xmlns:a="http://schemas.openxmlformats.org/drawingml/2006/main">
               <a:ext uri="{FF2B5EF4-FFF2-40B4-BE49-F238E27FC236}">
-                <a16:creationId xmlns:a16="http://schemas.microsoft.com/office/drawing/2014/main" id="{D129811A-BE91-4F75-A733-1CC164DC5D54}"/>
+                <a16:creationId xmlns:a16="http://schemas.microsoft.com/office/drawing/2014/main" id="{43DBF074-8E9C-43E2-B583-1CAF1DCBF3D4}"/>
               </a:ext>
             </a:extLst>
           </p:cNvPr>
@@ -7236,7 +7236,7 @@
           <p:cNvPr id="8" name="footer-8">
             <a:extLst xmlns:a="http://schemas.openxmlformats.org/drawingml/2006/main">
               <a:ext uri="{FF2B5EF4-FFF2-40B4-BE49-F238E27FC236}">
-                <a16:creationId xmlns:a16="http://schemas.microsoft.com/office/drawing/2014/main" id="{A2EBD1D6-B1CF-44D5-B249-9CC7F6006ECD}"/>
+                <a16:creationId xmlns:a16="http://schemas.microsoft.com/office/drawing/2014/main" id="{B096B21C-174E-45A0-83DF-3A6B38AEEC5F}"/>
               </a:ext>
             </a:extLst>
           </p:cNvPr>
@@ -7290,7 +7290,7 @@
     </p:spTree>
     <p:extLst>
       <p:ext uri="{BB962C8B-B14F-4D97-AF65-F5344CB8AC3E}">
-        <p14:creationId xmlns:p14="http://schemas.microsoft.com/office/powerpoint/2010/main" val="304327742"/>
+        <p14:creationId xmlns:p14="http://schemas.microsoft.com/office/powerpoint/2010/main" val="967029971"/>
       </p:ext>
     </p:extLst>
   </p:cSld>

</xml_diff>

<commit_message>
Sunum: v1.3.0 metinleriyle yeniden uretildi
Co-Authored-By: Claude Opus 5 <noreply@anthropic.com>
</commit_message>
<xml_diff>
--- a/docs/presentation/Russian-Course-AI-Trilingual.pptx
+++ b/docs/presentation/Russian-Course-AI-Trilingual.pptx
@@ -2,20 +2,20 @@
 <file path=ppt/presentation.xml><?xml version="1.0" encoding="utf-8"?>
 <p:presentation xmlns:p="http://schemas.openxmlformats.org/presentationml/2006/main">
   <p:sldMasterIdLst>
-    <p:sldMasterId xmlns:r="http://schemas.openxmlformats.org/officeDocument/2006/relationships" id="2147483648" r:id="Rd6557eaa1b4c42c7"/>
+    <p:sldMasterId xmlns:r="http://schemas.openxmlformats.org/officeDocument/2006/relationships" id="2147483648" r:id="Rf331525ca69f45a3"/>
   </p:sldMasterIdLst>
   <p:notesMasterIdLst>
-    <p:notesMasterId xmlns:r="http://schemas.openxmlformats.org/officeDocument/2006/relationships" r:id="R77016449c8944541"/>
+    <p:notesMasterId xmlns:r="http://schemas.openxmlformats.org/officeDocument/2006/relationships" r:id="R905f8c3d0d7f4a7b"/>
   </p:notesMasterIdLst>
   <p:sldIdLst>
-    <p:sldId xmlns:r="http://schemas.openxmlformats.org/officeDocument/2006/relationships" id="256" r:id="R54300787e149478e"/>
-    <p:sldId xmlns:r="http://schemas.openxmlformats.org/officeDocument/2006/relationships" id="257" r:id="Raafa8e337e4647b5"/>
-    <p:sldId xmlns:r="http://schemas.openxmlformats.org/officeDocument/2006/relationships" id="258" r:id="Rd90e7cc5e97d4f2c"/>
-    <p:sldId xmlns:r="http://schemas.openxmlformats.org/officeDocument/2006/relationships" id="259" r:id="R8dfab424ddd94bf0"/>
-    <p:sldId xmlns:r="http://schemas.openxmlformats.org/officeDocument/2006/relationships" id="260" r:id="R1d57af31516041d1"/>
-    <p:sldId xmlns:r="http://schemas.openxmlformats.org/officeDocument/2006/relationships" id="261" r:id="R798d4c80684b405f"/>
-    <p:sldId xmlns:r="http://schemas.openxmlformats.org/officeDocument/2006/relationships" id="262" r:id="Rd994f3d5371f498a"/>
-    <p:sldId xmlns:r="http://schemas.openxmlformats.org/officeDocument/2006/relationships" id="263" r:id="R3c1c6e6f5d5242be"/>
+    <p:sldId xmlns:r="http://schemas.openxmlformats.org/officeDocument/2006/relationships" id="256" r:id="Rb6845efdf8de4470"/>
+    <p:sldId xmlns:r="http://schemas.openxmlformats.org/officeDocument/2006/relationships" id="257" r:id="R22c43fad7d0f4604"/>
+    <p:sldId xmlns:r="http://schemas.openxmlformats.org/officeDocument/2006/relationships" id="258" r:id="R3c133cc873e54ed8"/>
+    <p:sldId xmlns:r="http://schemas.openxmlformats.org/officeDocument/2006/relationships" id="259" r:id="Ra54fcbf90617422b"/>
+    <p:sldId xmlns:r="http://schemas.openxmlformats.org/officeDocument/2006/relationships" id="260" r:id="R6e2daa3f99f24eba"/>
+    <p:sldId xmlns:r="http://schemas.openxmlformats.org/officeDocument/2006/relationships" id="261" r:id="Re925548124b14262"/>
+    <p:sldId xmlns:r="http://schemas.openxmlformats.org/officeDocument/2006/relationships" id="262" r:id="R48454fa62d0d4b99"/>
+    <p:sldId xmlns:r="http://schemas.openxmlformats.org/officeDocument/2006/relationships" id="263" r:id="Rbf089ad9f96c4cb1"/>
   </p:sldIdLst>
   <p:sldSz cx="12192000" cy="6858000"/>
   <p:notesSz cx="6858000" cy="9144000"/>
@@ -454,12 +454,12 @@
           </a:p>
           <a:p xmlns:a="http://schemas.openxmlformats.org/drawingml/2006/main">
             <a:r>
-              <a:t>- D:\Russian\README.md (product positioning and supported levels)</a:t>
-            </a:r>
-          </a:p>
-          <a:p xmlns:a="http://schemas.openxmlformats.org/drawingml/2006/main">
-            <a:r>
-              <a:t>- D:\Russian\docs\presentation\assets\russian-course-ai-hero.png (AI-generated original cover visual)</a:t>
+              <a:t>- README.md (product positioning and supported levels)</a:t>
+            </a:r>
+          </a:p>
+          <a:p xmlns:a="http://schemas.openxmlformats.org/drawingml/2006/main">
+            <a:r>
+              <a:t>- docs/presentation/assets/russian-course-ai-hero.png (AI-generated original cover visual)</a:t>
             </a:r>
           </a:p>
         </p:txBody>
@@ -534,7 +534,7 @@
           </a:p>
           <a:p xmlns:a="http://schemas.openxmlformats.org/drawingml/2006/main">
             <a:r>
-              <a:t>- D:\Russian\docs\presentation\assets\russian-course-ai-screenshot.png (user-supplied product screenshot)</a:t>
+              <a:t>- docs/presentation/assets/russian-course-ai-screenshot.png (user-supplied product screenshot)</a:t>
             </a:r>
           </a:p>
         </p:txBody>
@@ -609,12 +609,12 @@
           </a:p>
           <a:p xmlns:a="http://schemas.openxmlformats.org/drawingml/2006/main">
             <a:r>
-              <a:t>- D:\Russian\rca\i18n.py (Turkish, English, and Russian interface catalog)</a:t>
-            </a:r>
-          </a:p>
-          <a:p xmlns:a="http://schemas.openxmlformats.org/drawingml/2006/main">
-            <a:r>
-              <a:t>- D:\Russian\Russian_Course_AI.pyw (instant and persistent language switching)</a:t>
+              <a:t>- rca/i18n.py (Turkish, English, and Russian interface catalog)</a:t>
+            </a:r>
+          </a:p>
+          <a:p xmlns:a="http://schemas.openxmlformats.org/drawingml/2006/main">
+            <a:r>
+              <a:t>- Russian_Course_AI.pyw (instant and persistent language switching)</a:t>
             </a:r>
           </a:p>
         </p:txBody>
@@ -689,12 +689,12 @@
           </a:p>
           <a:p xmlns:a="http://schemas.openxmlformats.org/drawingml/2006/main">
             <a:r>
-              <a:t>- D:\Russian\rca\tabs\srs_tab.py (daily review workflow and five study modes)</a:t>
-            </a:r>
-          </a:p>
-          <a:p xmlns:a="http://schemas.openxmlformats.org/drawingml/2006/main">
-            <a:r>
-              <a:t>- D:\Russian\Russian_Course_AI.pyw (learning, lab, read, practice, and system navigation groups)</a:t>
+              <a:t>- rca/tabs/srs_tab.py (daily review workflow and five study modes)</a:t>
+            </a:r>
+          </a:p>
+          <a:p xmlns:a="http://schemas.openxmlformats.org/drawingml/2006/main">
+            <a:r>
+              <a:t>- Russian_Course_AI.pyw (learning, lab, read, practice, and system navigation groups)</a:t>
             </a:r>
           </a:p>
         </p:txBody>
@@ -769,17 +769,17 @@
           </a:p>
           <a:p xmlns:a="http://schemas.openxmlformats.org/drawingml/2006/main">
             <a:r>
-              <a:t>- D:\Russian\Russian_Course_AI.pyw (18 entries in TAB_SPECS)</a:t>
-            </a:r>
-          </a:p>
-          <a:p xmlns:a="http://schemas.openxmlformats.org/drawingml/2006/main">
-            <a:r>
-              <a:t>- D:\Russian\rca\dictionary.py + rca\dict_data.py (RU-EN-TR dictionary with direction switch, 1,360 built-in entries with Turkish glosses, OpenRussian layer)</a:t>
-            </a:r>
-          </a:p>
-          <a:p xmlns:a="http://schemas.openxmlformats.org/drawingml/2006/main">
-            <a:r>
-              <a:t>- D:\Russian\README.md (feature descriptions)</a:t>
+              <a:t>- Russian_Course_AI.pyw (18 entries in TAB_SPECS)</a:t>
+            </a:r>
+          </a:p>
+          <a:p xmlns:a="http://schemas.openxmlformats.org/drawingml/2006/main">
+            <a:r>
+              <a:t>- rca/dictionary.py + rca/dict_data.py (RU-EN-TR dictionary with direction switch, 1,360 built-in entries with Turkish glosses, OpenRussian layer)</a:t>
+            </a:r>
+          </a:p>
+          <a:p xmlns:a="http://schemas.openxmlformats.org/drawingml/2006/main">
+            <a:r>
+              <a:t>- README.md (feature descriptions)</a:t>
             </a:r>
           </a:p>
         </p:txBody>
@@ -854,12 +854,12 @@
           </a:p>
           <a:p xmlns:a="http://schemas.openxmlformats.org/drawingml/2006/main">
             <a:r>
-              <a:t>- D:\Russian\README.md (local LM Studio, optional NVIDIA NIM, and Resource Center network behavior)</a:t>
-            </a:r>
-          </a:p>
-          <a:p xmlns:a="http://schemas.openxmlformats.org/drawingml/2006/main">
-            <a:r>
-              <a:t>- D:\Russian\rca\db.py (SQLite persistence)</a:t>
+              <a:t>- README.md (local LM Studio, optional NVIDIA NIM, and Resource Center network behavior)</a:t>
+            </a:r>
+          </a:p>
+          <a:p xmlns:a="http://schemas.openxmlformats.org/drawingml/2006/main">
+            <a:r>
+              <a:t>- rca/db.py (SQLite persistence)</a:t>
             </a:r>
           </a:p>
         </p:txBody>
@@ -934,7 +934,7 @@
           </a:p>
           <a:p xmlns:a="http://schemas.openxmlformats.org/drawingml/2006/main">
             <a:r>
-              <a:t>- https://github.com/Azizsekerdil/RussianCourseAI/releases/tag/v1.2.1 (v1.2.1 release with Windows and macOS zip assets; private repository)</a:t>
+              <a:t>- https://github.com/Azizsekerdil/RussianCourseAI/releases/tag/v1.3.0 (v1.3.0 release with Windows and macOS zip assets; MIT licensed)</a:t>
             </a:r>
           </a:p>
         </p:txBody>
@@ -1009,7 +1009,7 @@
           </a:p>
           <a:p xmlns:a="http://schemas.openxmlformats.org/drawingml/2006/main">
             <a:r>
-              <a:t>- D:\Russian\README.md (installation, learning levels, and feature overview)</a:t>
+              <a:t>- README.md (installation, learning levels, and feature overview)</a:t>
             </a:r>
           </a:p>
         </p:txBody>
@@ -1077,7 +1077,7 @@
   </p:cSld>
   <p:clrMap bg1="lt1" tx1="dk1" bg2="lt2" tx2="dk2" accent1="accent1" accent2="accent2" accent3="accent3" accent4="accent4" accent5="accent5" accent6="accent6" hlink="hlink" folHlink="folHlink"/>
   <p:sldLayoutIdLst>
-    <p:sldLayoutId xmlns:r="http://schemas.openxmlformats.org/officeDocument/2006/relationships" id="2147483649" r:id="R1b0c977fa2ae4dc7"/>
+    <p:sldLayoutId xmlns:r="http://schemas.openxmlformats.org/officeDocument/2006/relationships" id="2147483649" r:id="R158d3525a2fc4e34"/>
   </p:sldLayoutIdLst>
   <p:txStyles>
     <p:titleStyle>
@@ -1628,7 +1628,7 @@
           <p:cNvPr id="11" name="cover-kicker">
             <a:extLst xmlns:a="http://schemas.openxmlformats.org/drawingml/2006/main">
               <a:ext uri="{FF2B5EF4-FFF2-40B4-BE49-F238E27FC236}">
-                <a16:creationId xmlns:a16="http://schemas.microsoft.com/office/drawing/2014/main" id="{57C0D56F-C3BD-407D-AA51-C43C56DF6052}"/>
+                <a16:creationId xmlns:a16="http://schemas.microsoft.com/office/drawing/2014/main" id="{F3F69A0E-7593-4DE4-B71F-6F4A0D90A8A3}"/>
               </a:ext>
             </a:extLst>
           </p:cNvPr>
@@ -1684,7 +1684,7 @@
           <p:cNvPr id="2" name="cover-title">
             <a:extLst xmlns:a="http://schemas.openxmlformats.org/drawingml/2006/main">
               <a:ext uri="{FF2B5EF4-FFF2-40B4-BE49-F238E27FC236}">
-                <a16:creationId xmlns:a16="http://schemas.microsoft.com/office/drawing/2014/main" id="{FAD35F1D-5113-48E6-A9D4-880D3221AD45}"/>
+                <a16:creationId xmlns:a16="http://schemas.microsoft.com/office/drawing/2014/main" id="{1B09B5C2-1008-4254-98F0-E6243E448C2E}"/>
               </a:ext>
             </a:extLst>
           </p:cNvPr>
@@ -1763,7 +1763,7 @@
           <p:cNvPr id="3" name="cover-rule">
             <a:extLst xmlns:a="http://schemas.openxmlformats.org/drawingml/2006/main">
               <a:ext uri="{FF2B5EF4-FFF2-40B4-BE49-F238E27FC236}">
-                <a16:creationId xmlns:a16="http://schemas.microsoft.com/office/drawing/2014/main" id="{32460439-3821-48D1-92C5-BE5DE25CEFEE}"/>
+                <a16:creationId xmlns:a16="http://schemas.microsoft.com/office/drawing/2014/main" id="{09796A5B-A07F-4AD6-9FBF-E7FD227B1F83}"/>
               </a:ext>
             </a:extLst>
           </p:cNvPr>
@@ -1794,7 +1794,7 @@
           <p:cNvPr id="4" name="cover-tr">
             <a:extLst xmlns:a="http://schemas.openxmlformats.org/drawingml/2006/main">
               <a:ext uri="{FF2B5EF4-FFF2-40B4-BE49-F238E27FC236}">
-                <a16:creationId xmlns:a16="http://schemas.microsoft.com/office/drawing/2014/main" id="{DA402468-81C2-46BA-9A5F-4B0710112366}"/>
+                <a16:creationId xmlns:a16="http://schemas.microsoft.com/office/drawing/2014/main" id="{AD746827-4929-43E9-AB13-05671AF78CA6}"/>
               </a:ext>
             </a:extLst>
           </p:cNvPr>
@@ -1850,7 +1850,7 @@
           <p:cNvPr id="5" name="cover-en">
             <a:extLst xmlns:a="http://schemas.openxmlformats.org/drawingml/2006/main">
               <a:ext uri="{FF2B5EF4-FFF2-40B4-BE49-F238E27FC236}">
-                <a16:creationId xmlns:a16="http://schemas.microsoft.com/office/drawing/2014/main" id="{CBE10F99-2705-4C1F-9A48-3CCF3D5087D2}"/>
+                <a16:creationId xmlns:a16="http://schemas.microsoft.com/office/drawing/2014/main" id="{FDBE5317-0A14-4E74-AB4B-92B12829B0A0}"/>
               </a:ext>
             </a:extLst>
           </p:cNvPr>
@@ -1906,7 +1906,7 @@
           <p:cNvPr id="6" name="cover-ru">
             <a:extLst xmlns:a="http://schemas.openxmlformats.org/drawingml/2006/main">
               <a:ext uri="{FF2B5EF4-FFF2-40B4-BE49-F238E27FC236}">
-                <a16:creationId xmlns:a16="http://schemas.microsoft.com/office/drawing/2014/main" id="{B1DDA229-7281-43B9-ABEF-2D1C91AD63B5}"/>
+                <a16:creationId xmlns:a16="http://schemas.microsoft.com/office/drawing/2014/main" id="{77DC9312-B9E7-421A-83F9-08BCB99B3331}"/>
               </a:ext>
             </a:extLst>
           </p:cNvPr>
@@ -1962,7 +1962,7 @@
           <p:cNvPr id="7" name="cover-meta">
             <a:extLst xmlns:a="http://schemas.openxmlformats.org/drawingml/2006/main">
               <a:ext uri="{FF2B5EF4-FFF2-40B4-BE49-F238E27FC236}">
-                <a16:creationId xmlns:a16="http://schemas.microsoft.com/office/drawing/2014/main" id="{F44C107E-B28D-415A-A230-AB2E29048F52}"/>
+                <a16:creationId xmlns:a16="http://schemas.microsoft.com/office/drawing/2014/main" id="{65192CAD-1FF9-4911-BF74-F0585E86A4C3}"/>
               </a:ext>
             </a:extLst>
           </p:cNvPr>
@@ -2018,7 +2018,7 @@
           <p:cNvPr id="8" name="hero-backing">
             <a:extLst xmlns:a="http://schemas.openxmlformats.org/drawingml/2006/main">
               <a:ext uri="{FF2B5EF4-FFF2-40B4-BE49-F238E27FC236}">
-                <a16:creationId xmlns:a16="http://schemas.microsoft.com/office/drawing/2014/main" id="{C208F246-37E4-4501-84A1-6E98983D479D}"/>
+                <a16:creationId xmlns:a16="http://schemas.microsoft.com/office/drawing/2014/main" id="{245D9E3C-0C46-40F7-AE0B-E7BCA2F5676A}"/>
               </a:ext>
             </a:extLst>
           </p:cNvPr>
@@ -2055,7 +2055,7 @@
           <p:nvPr/>
         </p:nvPicPr>
         <p:blipFill>
-          <a:blip xmlns:r="http://schemas.openxmlformats.org/officeDocument/2006/relationships" xmlns:a="http://schemas.openxmlformats.org/drawingml/2006/main" r:embed="Ra7fe46b7ba214ae8"/>
+          <a:blip xmlns:r="http://schemas.openxmlformats.org/officeDocument/2006/relationships" xmlns:a="http://schemas.openxmlformats.org/drawingml/2006/main" r:embed="Rbc8a2a0742514f32"/>
           <a:srcRect xmlns:a="http://schemas.openxmlformats.org/drawingml/2006/main" l="510" t="0" r="510" b="0"/>
           <a:stretch xmlns:a="http://schemas.openxmlformats.org/drawingml/2006/main">
             <a:fillRect l="0" t="0" r="0" b="0"/>
@@ -2078,7 +2078,7 @@
           <p:cNvPr id="10" name="footer-1">
             <a:extLst xmlns:a="http://schemas.openxmlformats.org/drawingml/2006/main">
               <a:ext uri="{FF2B5EF4-FFF2-40B4-BE49-F238E27FC236}">
-                <a16:creationId xmlns:a16="http://schemas.microsoft.com/office/drawing/2014/main" id="{DC84DD52-C166-42BF-A2DB-9DA05C58130B}"/>
+                <a16:creationId xmlns:a16="http://schemas.microsoft.com/office/drawing/2014/main" id="{D0E70540-DDCF-4DB3-BA32-9BB407D93FB3}"/>
               </a:ext>
             </a:extLst>
           </p:cNvPr>
@@ -2132,7 +2132,7 @@
     </p:spTree>
     <p:extLst>
       <p:ext uri="{BB962C8B-B14F-4D97-AF65-F5344CB8AC3E}">
-        <p14:creationId xmlns:p14="http://schemas.microsoft.com/office/powerpoint/2010/main" val="1234488235"/>
+        <p14:creationId xmlns:p14="http://schemas.microsoft.com/office/powerpoint/2010/main" val="696016703"/>
       </p:ext>
     </p:extLst>
   </p:cSld>
@@ -2163,7 +2163,7 @@
           <p:cNvPr id="6" name="screen-title">
             <a:extLst xmlns:a="http://schemas.openxmlformats.org/drawingml/2006/main">
               <a:ext uri="{FF2B5EF4-FFF2-40B4-BE49-F238E27FC236}">
-                <a16:creationId xmlns:a16="http://schemas.microsoft.com/office/drawing/2014/main" id="{C13A8B36-7CE0-4713-B794-B54CAAEA3CF9}"/>
+                <a16:creationId xmlns:a16="http://schemas.microsoft.com/office/drawing/2014/main" id="{9E47697D-4B67-4E04-9850-3F5973D30FB8}"/>
               </a:ext>
             </a:extLst>
           </p:cNvPr>
@@ -2219,7 +2219,7 @@
           <p:cNvPr id="2" name="screen-subtitle">
             <a:extLst xmlns:a="http://schemas.openxmlformats.org/drawingml/2006/main">
               <a:ext uri="{FF2B5EF4-FFF2-40B4-BE49-F238E27FC236}">
-                <a16:creationId xmlns:a16="http://schemas.microsoft.com/office/drawing/2014/main" id="{BBF12F14-E476-468D-88AA-1BF989E1B627}"/>
+                <a16:creationId xmlns:a16="http://schemas.microsoft.com/office/drawing/2014/main" id="{4CC5A66A-9A3D-45B6-80B0-F6F9FAFD6330}"/>
               </a:ext>
             </a:extLst>
           </p:cNvPr>
@@ -2275,7 +2275,7 @@
           <p:cNvPr id="3" name="screen-frame">
             <a:extLst xmlns:a="http://schemas.openxmlformats.org/drawingml/2006/main">
               <a:ext uri="{FF2B5EF4-FFF2-40B4-BE49-F238E27FC236}">
-                <a16:creationId xmlns:a16="http://schemas.microsoft.com/office/drawing/2014/main" id="{DD3B96A9-0CAC-4648-8EB1-E5EB9D564CB8}"/>
+                <a16:creationId xmlns:a16="http://schemas.microsoft.com/office/drawing/2014/main" id="{D18AB795-4A12-4B7A-B254-6AE05E43DF85}"/>
               </a:ext>
             </a:extLst>
           </p:cNvPr>
@@ -2312,7 +2312,7 @@
           <p:nvPr/>
         </p:nvPicPr>
         <p:blipFill>
-          <a:blip xmlns:r="http://schemas.openxmlformats.org/officeDocument/2006/relationships" xmlns:a="http://schemas.openxmlformats.org/drawingml/2006/main" r:embed="R5a2953713dd54900"/>
+          <a:blip xmlns:r="http://schemas.openxmlformats.org/officeDocument/2006/relationships" xmlns:a="http://schemas.openxmlformats.org/drawingml/2006/main" r:embed="R53140ab16da24d15"/>
           <a:stretch xmlns:a="http://schemas.openxmlformats.org/drawingml/2006/main"/>
         </p:blipFill>
         <p:spPr>
@@ -2332,7 +2332,7 @@
           <p:cNvPr id="5" name="screen-footer">
             <a:extLst xmlns:a="http://schemas.openxmlformats.org/drawingml/2006/main">
               <a:ext uri="{FF2B5EF4-FFF2-40B4-BE49-F238E27FC236}">
-                <a16:creationId xmlns:a16="http://schemas.microsoft.com/office/drawing/2014/main" id="{62FD8A26-56CB-468E-8D36-C767C987A905}"/>
+                <a16:creationId xmlns:a16="http://schemas.microsoft.com/office/drawing/2014/main" id="{16DAC262-7396-4C8D-AE27-76EA8014D8C3}"/>
               </a:ext>
             </a:extLst>
           </p:cNvPr>
@@ -2386,7 +2386,7 @@
     </p:spTree>
     <p:extLst>
       <p:ext uri="{BB962C8B-B14F-4D97-AF65-F5344CB8AC3E}">
-        <p14:creationId xmlns:p14="http://schemas.microsoft.com/office/powerpoint/2010/main" val="1638922992"/>
+        <p14:creationId xmlns:p14="http://schemas.microsoft.com/office/powerpoint/2010/main" val="907129621"/>
       </p:ext>
     </p:extLst>
   </p:cSld>
@@ -2417,7 +2417,7 @@
           <p:cNvPr id="17" name="language-title">
             <a:extLst xmlns:a="http://schemas.openxmlformats.org/drawingml/2006/main">
               <a:ext uri="{FF2B5EF4-FFF2-40B4-BE49-F238E27FC236}">
-                <a16:creationId xmlns:a16="http://schemas.microsoft.com/office/drawing/2014/main" id="{A207F1F1-A191-4380-B317-B5D8630AB7D6}"/>
+                <a16:creationId xmlns:a16="http://schemas.microsoft.com/office/drawing/2014/main" id="{3C0D6D39-F30C-4AA6-B231-5DF226C12D87}"/>
               </a:ext>
             </a:extLst>
           </p:cNvPr>
@@ -2473,7 +2473,7 @@
           <p:cNvPr id="2" name="language-subtitle">
             <a:extLst xmlns:a="http://schemas.openxmlformats.org/drawingml/2006/main">
               <a:ext uri="{FF2B5EF4-FFF2-40B4-BE49-F238E27FC236}">
-                <a16:creationId xmlns:a16="http://schemas.microsoft.com/office/drawing/2014/main" id="{B839A191-E037-48C7-84FB-15690141E7DB}"/>
+                <a16:creationId xmlns:a16="http://schemas.microsoft.com/office/drawing/2014/main" id="{E558572D-3CA5-4BFC-A5C2-4F9069BA9C78}"/>
               </a:ext>
             </a:extLst>
           </p:cNvPr>
@@ -2529,7 +2529,7 @@
           <p:cNvPr id="3" name="language-rule">
             <a:extLst xmlns:a="http://schemas.openxmlformats.org/drawingml/2006/main">
               <a:ext uri="{FF2B5EF4-FFF2-40B4-BE49-F238E27FC236}">
-                <a16:creationId xmlns:a16="http://schemas.microsoft.com/office/drawing/2014/main" id="{B01232BE-4B4E-4433-AFBE-43C0ECC6487A}"/>
+                <a16:creationId xmlns:a16="http://schemas.microsoft.com/office/drawing/2014/main" id="{94804A5D-38B7-45AF-B1D5-C4903C8C9B87}"/>
               </a:ext>
             </a:extLst>
           </p:cNvPr>
@@ -2560,7 +2560,7 @@
           <p:cNvPr id="4" name="language-label-0">
             <a:extLst xmlns:a="http://schemas.openxmlformats.org/drawingml/2006/main">
               <a:ext uri="{FF2B5EF4-FFF2-40B4-BE49-F238E27FC236}">
-                <a16:creationId xmlns:a16="http://schemas.microsoft.com/office/drawing/2014/main" id="{32868BEC-C82C-49AE-89EC-69EB3586C1BE}"/>
+                <a16:creationId xmlns:a16="http://schemas.microsoft.com/office/drawing/2014/main" id="{32F178E9-33B7-4DED-89F0-33B726F5F7C4}"/>
               </a:ext>
             </a:extLst>
           </p:cNvPr>
@@ -2616,7 +2616,7 @@
           <p:cNvPr id="5" name="language-head-0">
             <a:extLst xmlns:a="http://schemas.openxmlformats.org/drawingml/2006/main">
               <a:ext uri="{FF2B5EF4-FFF2-40B4-BE49-F238E27FC236}">
-                <a16:creationId xmlns:a16="http://schemas.microsoft.com/office/drawing/2014/main" id="{43A39C43-75D4-451F-980A-253396AD59B5}"/>
+                <a16:creationId xmlns:a16="http://schemas.microsoft.com/office/drawing/2014/main" id="{471D43DA-5A06-469C-A0BB-43718073E160}"/>
               </a:ext>
             </a:extLst>
           </p:cNvPr>
@@ -2672,7 +2672,7 @@
           <p:cNvPr id="6" name="language-body-0">
             <a:extLst xmlns:a="http://schemas.openxmlformats.org/drawingml/2006/main">
               <a:ext uri="{FF2B5EF4-FFF2-40B4-BE49-F238E27FC236}">
-                <a16:creationId xmlns:a16="http://schemas.microsoft.com/office/drawing/2014/main" id="{49620499-4FAA-4883-8426-2996878C32E7}"/>
+                <a16:creationId xmlns:a16="http://schemas.microsoft.com/office/drawing/2014/main" id="{18A08C71-F3E3-4339-9E8B-2393AB292568}"/>
               </a:ext>
             </a:extLst>
           </p:cNvPr>
@@ -2728,7 +2728,7 @@
           <p:cNvPr id="7" name="language-accent-0">
             <a:extLst xmlns:a="http://schemas.openxmlformats.org/drawingml/2006/main">
               <a:ext uri="{FF2B5EF4-FFF2-40B4-BE49-F238E27FC236}">
-                <a16:creationId xmlns:a16="http://schemas.microsoft.com/office/drawing/2014/main" id="{AFD01959-F57C-4D93-A84C-5513524459CC}"/>
+                <a16:creationId xmlns:a16="http://schemas.microsoft.com/office/drawing/2014/main" id="{5D6575EC-9B61-448B-843F-E3760FC7E6A1}"/>
               </a:ext>
             </a:extLst>
           </p:cNvPr>
@@ -2759,7 +2759,7 @@
           <p:cNvPr id="8" name="language-label-1">
             <a:extLst xmlns:a="http://schemas.openxmlformats.org/drawingml/2006/main">
               <a:ext uri="{FF2B5EF4-FFF2-40B4-BE49-F238E27FC236}">
-                <a16:creationId xmlns:a16="http://schemas.microsoft.com/office/drawing/2014/main" id="{770DE9F7-8DC0-438D-AD5A-4FEEC23164C2}"/>
+                <a16:creationId xmlns:a16="http://schemas.microsoft.com/office/drawing/2014/main" id="{12B75784-C3F6-4D15-B7D0-DBC9FE2E7C69}"/>
               </a:ext>
             </a:extLst>
           </p:cNvPr>
@@ -2815,7 +2815,7 @@
           <p:cNvPr id="9" name="language-head-1">
             <a:extLst xmlns:a="http://schemas.openxmlformats.org/drawingml/2006/main">
               <a:ext uri="{FF2B5EF4-FFF2-40B4-BE49-F238E27FC236}">
-                <a16:creationId xmlns:a16="http://schemas.microsoft.com/office/drawing/2014/main" id="{31ADDBE6-8C18-4064-A7A9-A91452EE5489}"/>
+                <a16:creationId xmlns:a16="http://schemas.microsoft.com/office/drawing/2014/main" id="{92A096AE-FE14-4A7D-92CE-A0F01EBC2034}"/>
               </a:ext>
             </a:extLst>
           </p:cNvPr>
@@ -2871,7 +2871,7 @@
           <p:cNvPr id="10" name="language-body-1">
             <a:extLst xmlns:a="http://schemas.openxmlformats.org/drawingml/2006/main">
               <a:ext uri="{FF2B5EF4-FFF2-40B4-BE49-F238E27FC236}">
-                <a16:creationId xmlns:a16="http://schemas.microsoft.com/office/drawing/2014/main" id="{ABF9BF5C-6C70-4040-A395-2D4F52E8C7D0}"/>
+                <a16:creationId xmlns:a16="http://schemas.microsoft.com/office/drawing/2014/main" id="{48C645BE-BE0C-401C-AF5A-EC98F860FC9F}"/>
               </a:ext>
             </a:extLst>
           </p:cNvPr>
@@ -2927,7 +2927,7 @@
           <p:cNvPr id="11" name="language-accent-1">
             <a:extLst xmlns:a="http://schemas.openxmlformats.org/drawingml/2006/main">
               <a:ext uri="{FF2B5EF4-FFF2-40B4-BE49-F238E27FC236}">
-                <a16:creationId xmlns:a16="http://schemas.microsoft.com/office/drawing/2014/main" id="{BF70DCD5-ABE6-4FCC-A0E1-5B16A2590FE4}"/>
+                <a16:creationId xmlns:a16="http://schemas.microsoft.com/office/drawing/2014/main" id="{00621A78-B808-46F0-B76A-0CF41FADB6C6}"/>
               </a:ext>
             </a:extLst>
           </p:cNvPr>
@@ -2958,7 +2958,7 @@
           <p:cNvPr id="12" name="language-label-2">
             <a:extLst xmlns:a="http://schemas.openxmlformats.org/drawingml/2006/main">
               <a:ext uri="{FF2B5EF4-FFF2-40B4-BE49-F238E27FC236}">
-                <a16:creationId xmlns:a16="http://schemas.microsoft.com/office/drawing/2014/main" id="{001E6C8C-CD91-4019-A2BB-65BDB2BD8569}"/>
+                <a16:creationId xmlns:a16="http://schemas.microsoft.com/office/drawing/2014/main" id="{1BA483A9-9D0E-4340-A1E1-C5DDE1EAAAC1}"/>
               </a:ext>
             </a:extLst>
           </p:cNvPr>
@@ -3014,7 +3014,7 @@
           <p:cNvPr id="13" name="language-head-2">
             <a:extLst xmlns:a="http://schemas.openxmlformats.org/drawingml/2006/main">
               <a:ext uri="{FF2B5EF4-FFF2-40B4-BE49-F238E27FC236}">
-                <a16:creationId xmlns:a16="http://schemas.microsoft.com/office/drawing/2014/main" id="{FE8C3460-FB77-4636-8D5A-C2CE8C5F8169}"/>
+                <a16:creationId xmlns:a16="http://schemas.microsoft.com/office/drawing/2014/main" id="{41B5D1E6-4D4F-462C-A24A-743AEA5A8ED8}"/>
               </a:ext>
             </a:extLst>
           </p:cNvPr>
@@ -3070,7 +3070,7 @@
           <p:cNvPr id="14" name="language-body-2">
             <a:extLst xmlns:a="http://schemas.openxmlformats.org/drawingml/2006/main">
               <a:ext uri="{FF2B5EF4-FFF2-40B4-BE49-F238E27FC236}">
-                <a16:creationId xmlns:a16="http://schemas.microsoft.com/office/drawing/2014/main" id="{7D05D282-01C8-40A6-9029-49C06840C21C}"/>
+                <a16:creationId xmlns:a16="http://schemas.microsoft.com/office/drawing/2014/main" id="{19B58886-32D3-4121-9AB0-4124F53590C5}"/>
               </a:ext>
             </a:extLst>
           </p:cNvPr>
@@ -3126,7 +3126,7 @@
           <p:cNvPr id="15" name="language-accent-2">
             <a:extLst xmlns:a="http://schemas.openxmlformats.org/drawingml/2006/main">
               <a:ext uri="{FF2B5EF4-FFF2-40B4-BE49-F238E27FC236}">
-                <a16:creationId xmlns:a16="http://schemas.microsoft.com/office/drawing/2014/main" id="{5B49CFE8-6F60-4BC1-ABCB-C32C959142F3}"/>
+                <a16:creationId xmlns:a16="http://schemas.microsoft.com/office/drawing/2014/main" id="{38F774E1-64C2-48D9-BBD8-728560AB525A}"/>
               </a:ext>
             </a:extLst>
           </p:cNvPr>
@@ -3157,7 +3157,7 @@
           <p:cNvPr id="16" name="footer-3">
             <a:extLst xmlns:a="http://schemas.openxmlformats.org/drawingml/2006/main">
               <a:ext uri="{FF2B5EF4-FFF2-40B4-BE49-F238E27FC236}">
-                <a16:creationId xmlns:a16="http://schemas.microsoft.com/office/drawing/2014/main" id="{1D28FCF2-03C0-47AA-AD5C-AA2FEAB3B721}"/>
+                <a16:creationId xmlns:a16="http://schemas.microsoft.com/office/drawing/2014/main" id="{19407ADF-515C-48C3-A9A9-76D0BDCC75CC}"/>
               </a:ext>
             </a:extLst>
           </p:cNvPr>
@@ -3211,7 +3211,7 @@
     </p:spTree>
     <p:extLst>
       <p:ext uri="{BB962C8B-B14F-4D97-AF65-F5344CB8AC3E}">
-        <p14:creationId xmlns:p14="http://schemas.microsoft.com/office/powerpoint/2010/main" val="492218474"/>
+        <p14:creationId xmlns:p14="http://schemas.microsoft.com/office/powerpoint/2010/main" val="1420195734"/>
       </p:ext>
     </p:extLst>
   </p:cSld>
@@ -3242,7 +3242,7 @@
           <p:cNvPr id="23" name="loop-title">
             <a:extLst xmlns:a="http://schemas.openxmlformats.org/drawingml/2006/main">
               <a:ext uri="{FF2B5EF4-FFF2-40B4-BE49-F238E27FC236}">
-                <a16:creationId xmlns:a16="http://schemas.microsoft.com/office/drawing/2014/main" id="{BDEA8E52-ADB0-4249-B109-B801024C0DEE}"/>
+                <a16:creationId xmlns:a16="http://schemas.microsoft.com/office/drawing/2014/main" id="{78DF29C6-E528-4430-91C4-2C1FA06BFF77}"/>
               </a:ext>
             </a:extLst>
           </p:cNvPr>
@@ -3298,7 +3298,7 @@
           <p:cNvPr id="2" name="loop-subtitle">
             <a:extLst xmlns:a="http://schemas.openxmlformats.org/drawingml/2006/main">
               <a:ext uri="{FF2B5EF4-FFF2-40B4-BE49-F238E27FC236}">
-                <a16:creationId xmlns:a16="http://schemas.microsoft.com/office/drawing/2014/main" id="{A332272F-C7FD-487E-A312-A1257EE92FA8}"/>
+                <a16:creationId xmlns:a16="http://schemas.microsoft.com/office/drawing/2014/main" id="{051A6310-2EFC-4783-9F13-985711F54C09}"/>
               </a:ext>
             </a:extLst>
           </p:cNvPr>
@@ -3354,7 +3354,7 @@
           <p:cNvPr id="3" name="loop-track">
             <a:extLst xmlns:a="http://schemas.openxmlformats.org/drawingml/2006/main">
               <a:ext uri="{FF2B5EF4-FFF2-40B4-BE49-F238E27FC236}">
-                <a16:creationId xmlns:a16="http://schemas.microsoft.com/office/drawing/2014/main" id="{C2988F6C-6843-4573-A62A-44C9A6DC9C93}"/>
+                <a16:creationId xmlns:a16="http://schemas.microsoft.com/office/drawing/2014/main" id="{41AF92AE-739E-4A67-8BCF-4F7DE81482BB}"/>
               </a:ext>
             </a:extLst>
           </p:cNvPr>
@@ -3385,7 +3385,7 @@
           <p:cNvPr id="4" name="loop-node-0">
             <a:extLst xmlns:a="http://schemas.openxmlformats.org/drawingml/2006/main">
               <a:ext uri="{FF2B5EF4-FFF2-40B4-BE49-F238E27FC236}">
-                <a16:creationId xmlns:a16="http://schemas.microsoft.com/office/drawing/2014/main" id="{44D2B460-7E11-437A-B727-61424F0CDF5D}"/>
+                <a16:creationId xmlns:a16="http://schemas.microsoft.com/office/drawing/2014/main" id="{328CA8C9-B5F1-4EBB-879D-A5F769D5992B}"/>
               </a:ext>
             </a:extLst>
           </p:cNvPr>
@@ -3418,7 +3418,7 @@
           <p:cNvPr id="5" name="loop-number-0">
             <a:extLst xmlns:a="http://schemas.openxmlformats.org/drawingml/2006/main">
               <a:ext uri="{FF2B5EF4-FFF2-40B4-BE49-F238E27FC236}">
-                <a16:creationId xmlns:a16="http://schemas.microsoft.com/office/drawing/2014/main" id="{6E95C2B0-056E-4BDF-8222-E0A5B0676FA8}"/>
+                <a16:creationId xmlns:a16="http://schemas.microsoft.com/office/drawing/2014/main" id="{10C26D9F-D3CF-4D29-A58B-259895406D45}"/>
               </a:ext>
             </a:extLst>
           </p:cNvPr>
@@ -3474,7 +3474,7 @@
           <p:cNvPr id="6" name="loop-en-0">
             <a:extLst xmlns:a="http://schemas.openxmlformats.org/drawingml/2006/main">
               <a:ext uri="{FF2B5EF4-FFF2-40B4-BE49-F238E27FC236}">
-                <a16:creationId xmlns:a16="http://schemas.microsoft.com/office/drawing/2014/main" id="{4D94D5B0-8898-4B0A-AF44-52E0DE6A1C3D}"/>
+                <a16:creationId xmlns:a16="http://schemas.microsoft.com/office/drawing/2014/main" id="{4FDAEAE6-77FD-4BA6-9185-929AEDC833C2}"/>
               </a:ext>
             </a:extLst>
           </p:cNvPr>
@@ -3530,7 +3530,7 @@
           <p:cNvPr id="7" name="loop-tr-0">
             <a:extLst xmlns:a="http://schemas.openxmlformats.org/drawingml/2006/main">
               <a:ext uri="{FF2B5EF4-FFF2-40B4-BE49-F238E27FC236}">
-                <a16:creationId xmlns:a16="http://schemas.microsoft.com/office/drawing/2014/main" id="{E6B93BDF-A7AA-49E8-B795-1C1AE1C4325A}"/>
+                <a16:creationId xmlns:a16="http://schemas.microsoft.com/office/drawing/2014/main" id="{A8E4D5F9-6744-4F35-A21D-816494D86680}"/>
               </a:ext>
             </a:extLst>
           </p:cNvPr>
@@ -3586,7 +3586,7 @@
           <p:cNvPr id="8" name="loop-ru-0">
             <a:extLst xmlns:a="http://schemas.openxmlformats.org/drawingml/2006/main">
               <a:ext uri="{FF2B5EF4-FFF2-40B4-BE49-F238E27FC236}">
-                <a16:creationId xmlns:a16="http://schemas.microsoft.com/office/drawing/2014/main" id="{7D272DC1-4CC2-4093-A62B-4289D3E5FBCE}"/>
+                <a16:creationId xmlns:a16="http://schemas.microsoft.com/office/drawing/2014/main" id="{D50420C9-96DD-4460-8475-B28594C8AAC2}"/>
               </a:ext>
             </a:extLst>
           </p:cNvPr>
@@ -3642,7 +3642,7 @@
           <p:cNvPr id="9" name="loop-detail-0">
             <a:extLst xmlns:a="http://schemas.openxmlformats.org/drawingml/2006/main">
               <a:ext uri="{FF2B5EF4-FFF2-40B4-BE49-F238E27FC236}">
-                <a16:creationId xmlns:a16="http://schemas.microsoft.com/office/drawing/2014/main" id="{631F9297-3139-4117-9919-6B70169F126B}"/>
+                <a16:creationId xmlns:a16="http://schemas.microsoft.com/office/drawing/2014/main" id="{4D98F70D-36E8-46CE-AB61-C05BBF4168AE}"/>
               </a:ext>
             </a:extLst>
           </p:cNvPr>
@@ -3698,7 +3698,7 @@
           <p:cNvPr id="10" name="loop-node-1">
             <a:extLst xmlns:a="http://schemas.openxmlformats.org/drawingml/2006/main">
               <a:ext uri="{FF2B5EF4-FFF2-40B4-BE49-F238E27FC236}">
-                <a16:creationId xmlns:a16="http://schemas.microsoft.com/office/drawing/2014/main" id="{4A78449F-441D-4320-B552-CF481DEC497C}"/>
+                <a16:creationId xmlns:a16="http://schemas.microsoft.com/office/drawing/2014/main" id="{73F9E0C6-DCF5-49B2-B79D-E54D5F4E3F7D}"/>
               </a:ext>
             </a:extLst>
           </p:cNvPr>
@@ -3731,7 +3731,7 @@
           <p:cNvPr id="11" name="loop-number-1">
             <a:extLst xmlns:a="http://schemas.openxmlformats.org/drawingml/2006/main">
               <a:ext uri="{FF2B5EF4-FFF2-40B4-BE49-F238E27FC236}">
-                <a16:creationId xmlns:a16="http://schemas.microsoft.com/office/drawing/2014/main" id="{313C074E-E5DB-46F7-B858-D929E37CA4BD}"/>
+                <a16:creationId xmlns:a16="http://schemas.microsoft.com/office/drawing/2014/main" id="{6ABEDDD7-6ABC-4CDB-BE95-953A676C203F}"/>
               </a:ext>
             </a:extLst>
           </p:cNvPr>
@@ -3787,7 +3787,7 @@
           <p:cNvPr id="12" name="loop-en-1">
             <a:extLst xmlns:a="http://schemas.openxmlformats.org/drawingml/2006/main">
               <a:ext uri="{FF2B5EF4-FFF2-40B4-BE49-F238E27FC236}">
-                <a16:creationId xmlns:a16="http://schemas.microsoft.com/office/drawing/2014/main" id="{498009F6-F1F3-4B18-9735-0B929B9C267B}"/>
+                <a16:creationId xmlns:a16="http://schemas.microsoft.com/office/drawing/2014/main" id="{2F9410C4-4790-49CD-8373-39DBF1074BCA}"/>
               </a:ext>
             </a:extLst>
           </p:cNvPr>
@@ -3843,7 +3843,7 @@
           <p:cNvPr id="13" name="loop-tr-1">
             <a:extLst xmlns:a="http://schemas.openxmlformats.org/drawingml/2006/main">
               <a:ext uri="{FF2B5EF4-FFF2-40B4-BE49-F238E27FC236}">
-                <a16:creationId xmlns:a16="http://schemas.microsoft.com/office/drawing/2014/main" id="{ECFB757C-115B-43B6-AB3A-26C7DCA694A6}"/>
+                <a16:creationId xmlns:a16="http://schemas.microsoft.com/office/drawing/2014/main" id="{D912D048-4DF8-42AA-89C4-40BD6385C57A}"/>
               </a:ext>
             </a:extLst>
           </p:cNvPr>
@@ -3899,7 +3899,7 @@
           <p:cNvPr id="14" name="loop-ru-1">
             <a:extLst xmlns:a="http://schemas.openxmlformats.org/drawingml/2006/main">
               <a:ext uri="{FF2B5EF4-FFF2-40B4-BE49-F238E27FC236}">
-                <a16:creationId xmlns:a16="http://schemas.microsoft.com/office/drawing/2014/main" id="{4177F07F-CDB0-427B-B640-53E7A3FE7208}"/>
+                <a16:creationId xmlns:a16="http://schemas.microsoft.com/office/drawing/2014/main" id="{199A4BA2-D2A6-4CC8-BA8F-AF67D3172507}"/>
               </a:ext>
             </a:extLst>
           </p:cNvPr>
@@ -3955,7 +3955,7 @@
           <p:cNvPr id="15" name="loop-detail-1">
             <a:extLst xmlns:a="http://schemas.openxmlformats.org/drawingml/2006/main">
               <a:ext uri="{FF2B5EF4-FFF2-40B4-BE49-F238E27FC236}">
-                <a16:creationId xmlns:a16="http://schemas.microsoft.com/office/drawing/2014/main" id="{B9A4E827-D707-4AF8-ADCC-91BD5D249D19}"/>
+                <a16:creationId xmlns:a16="http://schemas.microsoft.com/office/drawing/2014/main" id="{7CAD2093-B90E-4BCD-8B51-507FC38DB0D4}"/>
               </a:ext>
             </a:extLst>
           </p:cNvPr>
@@ -4011,7 +4011,7 @@
           <p:cNvPr id="16" name="loop-node-2">
             <a:extLst xmlns:a="http://schemas.openxmlformats.org/drawingml/2006/main">
               <a:ext uri="{FF2B5EF4-FFF2-40B4-BE49-F238E27FC236}">
-                <a16:creationId xmlns:a16="http://schemas.microsoft.com/office/drawing/2014/main" id="{DB59E30E-5CA8-470E-80B1-65A1DBB87672}"/>
+                <a16:creationId xmlns:a16="http://schemas.microsoft.com/office/drawing/2014/main" id="{B4C0A50F-6C67-4776-B844-A2C4B5CEB636}"/>
               </a:ext>
             </a:extLst>
           </p:cNvPr>
@@ -4044,7 +4044,7 @@
           <p:cNvPr id="17" name="loop-number-2">
             <a:extLst xmlns:a="http://schemas.openxmlformats.org/drawingml/2006/main">
               <a:ext uri="{FF2B5EF4-FFF2-40B4-BE49-F238E27FC236}">
-                <a16:creationId xmlns:a16="http://schemas.microsoft.com/office/drawing/2014/main" id="{48AE4683-5D79-4AC3-B573-EC96CDB85948}"/>
+                <a16:creationId xmlns:a16="http://schemas.microsoft.com/office/drawing/2014/main" id="{67A6C658-EB50-49A8-AFD2-5213E3A2EED0}"/>
               </a:ext>
             </a:extLst>
           </p:cNvPr>
@@ -4100,7 +4100,7 @@
           <p:cNvPr id="18" name="loop-en-2">
             <a:extLst xmlns:a="http://schemas.openxmlformats.org/drawingml/2006/main">
               <a:ext uri="{FF2B5EF4-FFF2-40B4-BE49-F238E27FC236}">
-                <a16:creationId xmlns:a16="http://schemas.microsoft.com/office/drawing/2014/main" id="{4D6E8F3E-48AF-4D08-9D5D-9A5942EC5E74}"/>
+                <a16:creationId xmlns:a16="http://schemas.microsoft.com/office/drawing/2014/main" id="{93CF2418-761D-4B40-ACD6-456220EE1BDE}"/>
               </a:ext>
             </a:extLst>
           </p:cNvPr>
@@ -4156,7 +4156,7 @@
           <p:cNvPr id="19" name="loop-tr-2">
             <a:extLst xmlns:a="http://schemas.openxmlformats.org/drawingml/2006/main">
               <a:ext uri="{FF2B5EF4-FFF2-40B4-BE49-F238E27FC236}">
-                <a16:creationId xmlns:a16="http://schemas.microsoft.com/office/drawing/2014/main" id="{9CFF4D03-4A47-4B35-92A6-2CE5117023D3}"/>
+                <a16:creationId xmlns:a16="http://schemas.microsoft.com/office/drawing/2014/main" id="{0C0E3AA2-5137-4C02-B0B5-8F9F5268008B}"/>
               </a:ext>
             </a:extLst>
           </p:cNvPr>
@@ -4212,7 +4212,7 @@
           <p:cNvPr id="20" name="loop-ru-2">
             <a:extLst xmlns:a="http://schemas.openxmlformats.org/drawingml/2006/main">
               <a:ext uri="{FF2B5EF4-FFF2-40B4-BE49-F238E27FC236}">
-                <a16:creationId xmlns:a16="http://schemas.microsoft.com/office/drawing/2014/main" id="{89BE00E3-B931-4951-9AA2-C6E1515C60EC}"/>
+                <a16:creationId xmlns:a16="http://schemas.microsoft.com/office/drawing/2014/main" id="{FE6E880C-89D9-4389-9776-79D635BABF81}"/>
               </a:ext>
             </a:extLst>
           </p:cNvPr>
@@ -4268,7 +4268,7 @@
           <p:cNvPr id="21" name="loop-detail-2">
             <a:extLst xmlns:a="http://schemas.openxmlformats.org/drawingml/2006/main">
               <a:ext uri="{FF2B5EF4-FFF2-40B4-BE49-F238E27FC236}">
-                <a16:creationId xmlns:a16="http://schemas.microsoft.com/office/drawing/2014/main" id="{21E4DFB2-018F-400A-ACE0-30D71BCFC7F0}"/>
+                <a16:creationId xmlns:a16="http://schemas.microsoft.com/office/drawing/2014/main" id="{AC3B797C-9A4C-42C3-82C0-FF51CC3E3BB4}"/>
               </a:ext>
             </a:extLst>
           </p:cNvPr>
@@ -4324,7 +4324,7 @@
           <p:cNvPr id="22" name="footer-4">
             <a:extLst xmlns:a="http://schemas.openxmlformats.org/drawingml/2006/main">
               <a:ext uri="{FF2B5EF4-FFF2-40B4-BE49-F238E27FC236}">
-                <a16:creationId xmlns:a16="http://schemas.microsoft.com/office/drawing/2014/main" id="{299CA8B1-489F-4466-BDA5-5CFE1CE83279}"/>
+                <a16:creationId xmlns:a16="http://schemas.microsoft.com/office/drawing/2014/main" id="{22A91630-83D1-4464-8D4F-FF5E46A0F56C}"/>
               </a:ext>
             </a:extLst>
           </p:cNvPr>
@@ -4378,7 +4378,7 @@
     </p:spTree>
     <p:extLst>
       <p:ext uri="{BB962C8B-B14F-4D97-AF65-F5344CB8AC3E}">
-        <p14:creationId xmlns:p14="http://schemas.microsoft.com/office/powerpoint/2010/main" val="1151346544"/>
+        <p14:creationId xmlns:p14="http://schemas.microsoft.com/office/powerpoint/2010/main" val="584464512"/>
       </p:ext>
     </p:extLst>
   </p:cSld>
@@ -4409,7 +4409,7 @@
           <p:cNvPr id="21" name="breadth-title">
             <a:extLst xmlns:a="http://schemas.openxmlformats.org/drawingml/2006/main">
               <a:ext uri="{FF2B5EF4-FFF2-40B4-BE49-F238E27FC236}">
-                <a16:creationId xmlns:a16="http://schemas.microsoft.com/office/drawing/2014/main" id="{9EE0551D-1B54-4DFC-996B-827A6AB2B96D}"/>
+                <a16:creationId xmlns:a16="http://schemas.microsoft.com/office/drawing/2014/main" id="{E7DE5AD0-C9E9-434B-9054-E8431E32210D}"/>
               </a:ext>
             </a:extLst>
           </p:cNvPr>
@@ -4465,7 +4465,7 @@
           <p:cNvPr id="2" name="breadth-triple">
             <a:extLst xmlns:a="http://schemas.openxmlformats.org/drawingml/2006/main">
               <a:ext uri="{FF2B5EF4-FFF2-40B4-BE49-F238E27FC236}">
-                <a16:creationId xmlns:a16="http://schemas.microsoft.com/office/drawing/2014/main" id="{F54F6BBE-2EFE-4E82-ACF8-54C4CBAC44AD}"/>
+                <a16:creationId xmlns:a16="http://schemas.microsoft.com/office/drawing/2014/main" id="{F177C646-B8E9-46BD-B124-2F3E93B88915}"/>
               </a:ext>
             </a:extLst>
           </p:cNvPr>
@@ -4521,7 +4521,7 @@
           <p:cNvPr id="3" name="breadth-number">
             <a:extLst xmlns:a="http://schemas.openxmlformats.org/drawingml/2006/main">
               <a:ext uri="{FF2B5EF4-FFF2-40B4-BE49-F238E27FC236}">
-                <a16:creationId xmlns:a16="http://schemas.microsoft.com/office/drawing/2014/main" id="{6BA4D645-B90F-420B-97AD-98147D25F291}"/>
+                <a16:creationId xmlns:a16="http://schemas.microsoft.com/office/drawing/2014/main" id="{6C042AEB-8813-42E1-8EF4-8345D0B6B6C8}"/>
               </a:ext>
             </a:extLst>
           </p:cNvPr>
@@ -4577,7 +4577,7 @@
           <p:cNvPr id="4" name="breadth-caption">
             <a:extLst xmlns:a="http://schemas.openxmlformats.org/drawingml/2006/main">
               <a:ext uri="{FF2B5EF4-FFF2-40B4-BE49-F238E27FC236}">
-                <a16:creationId xmlns:a16="http://schemas.microsoft.com/office/drawing/2014/main" id="{FA349433-9A54-4922-A067-182892A76009}"/>
+                <a16:creationId xmlns:a16="http://schemas.microsoft.com/office/drawing/2014/main" id="{EEB6E91C-C56C-4C29-943D-D48818D9E751}"/>
               </a:ext>
             </a:extLst>
           </p:cNvPr>
@@ -4679,7 +4679,7 @@
           <p:cNvPr id="5" name="breadth-divider">
             <a:extLst xmlns:a="http://schemas.openxmlformats.org/drawingml/2006/main">
               <a:ext uri="{FF2B5EF4-FFF2-40B4-BE49-F238E27FC236}">
-                <a16:creationId xmlns:a16="http://schemas.microsoft.com/office/drawing/2014/main" id="{937F2EBF-89EC-40F3-9F17-9669FCAFC69F}"/>
+                <a16:creationId xmlns:a16="http://schemas.microsoft.com/office/drawing/2014/main" id="{275C93CB-8993-44BA-9C6D-6F2BC0312743}"/>
               </a:ext>
             </a:extLst>
           </p:cNvPr>
@@ -4710,7 +4710,7 @@
           <p:cNvPr id="6" name="breadth-item-rule-0">
             <a:extLst xmlns:a="http://schemas.openxmlformats.org/drawingml/2006/main">
               <a:ext uri="{FF2B5EF4-FFF2-40B4-BE49-F238E27FC236}">
-                <a16:creationId xmlns:a16="http://schemas.microsoft.com/office/drawing/2014/main" id="{BFF2F326-0838-4A31-AA15-0D6CF943D2B8}"/>
+                <a16:creationId xmlns:a16="http://schemas.microsoft.com/office/drawing/2014/main" id="{783B1347-13ED-4F19-80DF-9E887DC64ECD}"/>
               </a:ext>
             </a:extLst>
           </p:cNvPr>
@@ -4741,7 +4741,7 @@
           <p:cNvPr id="7" name="breadth-item-0">
             <a:extLst xmlns:a="http://schemas.openxmlformats.org/drawingml/2006/main">
               <a:ext uri="{FF2B5EF4-FFF2-40B4-BE49-F238E27FC236}">
-                <a16:creationId xmlns:a16="http://schemas.microsoft.com/office/drawing/2014/main" id="{C1D9EDB9-DA43-4B2A-AF54-B46825FE08C7}"/>
+                <a16:creationId xmlns:a16="http://schemas.microsoft.com/office/drawing/2014/main" id="{011E58CE-75BE-44C2-8B55-085E358D1CF8}"/>
               </a:ext>
             </a:extLst>
           </p:cNvPr>
@@ -4797,7 +4797,7 @@
           <p:cNvPr id="8" name="breadth-item-rule-1">
             <a:extLst xmlns:a="http://schemas.openxmlformats.org/drawingml/2006/main">
               <a:ext uri="{FF2B5EF4-FFF2-40B4-BE49-F238E27FC236}">
-                <a16:creationId xmlns:a16="http://schemas.microsoft.com/office/drawing/2014/main" id="{B8406D54-C356-424C-A632-F91624AF9E4E}"/>
+                <a16:creationId xmlns:a16="http://schemas.microsoft.com/office/drawing/2014/main" id="{750AC45A-F97C-45E4-8485-AD6D085B0626}"/>
               </a:ext>
             </a:extLst>
           </p:cNvPr>
@@ -4828,7 +4828,7 @@
           <p:cNvPr id="9" name="breadth-item-1">
             <a:extLst xmlns:a="http://schemas.openxmlformats.org/drawingml/2006/main">
               <a:ext uri="{FF2B5EF4-FFF2-40B4-BE49-F238E27FC236}">
-                <a16:creationId xmlns:a16="http://schemas.microsoft.com/office/drawing/2014/main" id="{D86A3439-1183-4B33-A4EA-1E94D9D08463}"/>
+                <a16:creationId xmlns:a16="http://schemas.microsoft.com/office/drawing/2014/main" id="{A0E92AE3-CC32-497A-98EE-59B5077597F5}"/>
               </a:ext>
             </a:extLst>
           </p:cNvPr>
@@ -4884,7 +4884,7 @@
           <p:cNvPr id="10" name="breadth-item-rule-2">
             <a:extLst xmlns:a="http://schemas.openxmlformats.org/drawingml/2006/main">
               <a:ext uri="{FF2B5EF4-FFF2-40B4-BE49-F238E27FC236}">
-                <a16:creationId xmlns:a16="http://schemas.microsoft.com/office/drawing/2014/main" id="{B7422FE0-0078-40A8-8B82-30DCFE12819A}"/>
+                <a16:creationId xmlns:a16="http://schemas.microsoft.com/office/drawing/2014/main" id="{142C5D12-8899-4845-AB96-06C6C743E576}"/>
               </a:ext>
             </a:extLst>
           </p:cNvPr>
@@ -4915,7 +4915,7 @@
           <p:cNvPr id="11" name="breadth-item-2">
             <a:extLst xmlns:a="http://schemas.openxmlformats.org/drawingml/2006/main">
               <a:ext uri="{FF2B5EF4-FFF2-40B4-BE49-F238E27FC236}">
-                <a16:creationId xmlns:a16="http://schemas.microsoft.com/office/drawing/2014/main" id="{4E1C1E0C-4E99-44C5-B3BE-59043F98C78C}"/>
+                <a16:creationId xmlns:a16="http://schemas.microsoft.com/office/drawing/2014/main" id="{B5007ED6-8F37-4CB8-B7FA-AD47EF49B3F6}"/>
               </a:ext>
             </a:extLst>
           </p:cNvPr>
@@ -4971,7 +4971,7 @@
           <p:cNvPr id="12" name="breadth-item-rule-3">
             <a:extLst xmlns:a="http://schemas.openxmlformats.org/drawingml/2006/main">
               <a:ext uri="{FF2B5EF4-FFF2-40B4-BE49-F238E27FC236}">
-                <a16:creationId xmlns:a16="http://schemas.microsoft.com/office/drawing/2014/main" id="{43F2BCE6-9803-45E5-B0F0-A94FAB79A530}"/>
+                <a16:creationId xmlns:a16="http://schemas.microsoft.com/office/drawing/2014/main" id="{916D57C4-482C-4B0B-922D-8BFB06A51E66}"/>
               </a:ext>
             </a:extLst>
           </p:cNvPr>
@@ -5002,7 +5002,7 @@
           <p:cNvPr id="13" name="breadth-item-3">
             <a:extLst xmlns:a="http://schemas.openxmlformats.org/drawingml/2006/main">
               <a:ext uri="{FF2B5EF4-FFF2-40B4-BE49-F238E27FC236}">
-                <a16:creationId xmlns:a16="http://schemas.microsoft.com/office/drawing/2014/main" id="{FFD6F0F2-EE45-4003-AC4F-3A394A57BBE8}"/>
+                <a16:creationId xmlns:a16="http://schemas.microsoft.com/office/drawing/2014/main" id="{620466B3-7D14-4F7C-B9F7-BA89866473A1}"/>
               </a:ext>
             </a:extLst>
           </p:cNvPr>
@@ -5058,7 +5058,7 @@
           <p:cNvPr id="14" name="breadth-item-rule-4">
             <a:extLst xmlns:a="http://schemas.openxmlformats.org/drawingml/2006/main">
               <a:ext uri="{FF2B5EF4-FFF2-40B4-BE49-F238E27FC236}">
-                <a16:creationId xmlns:a16="http://schemas.microsoft.com/office/drawing/2014/main" id="{16774F71-B35C-4321-97DE-6EBBB4C41024}"/>
+                <a16:creationId xmlns:a16="http://schemas.microsoft.com/office/drawing/2014/main" id="{D57290A5-9F20-4180-91D2-9FF36F92F7ED}"/>
               </a:ext>
             </a:extLst>
           </p:cNvPr>
@@ -5089,7 +5089,7 @@
           <p:cNvPr id="15" name="breadth-item-4">
             <a:extLst xmlns:a="http://schemas.openxmlformats.org/drawingml/2006/main">
               <a:ext uri="{FF2B5EF4-FFF2-40B4-BE49-F238E27FC236}">
-                <a16:creationId xmlns:a16="http://schemas.microsoft.com/office/drawing/2014/main" id="{90C89C2D-70B9-4D8E-A60A-649FD2D02695}"/>
+                <a16:creationId xmlns:a16="http://schemas.microsoft.com/office/drawing/2014/main" id="{7C77CCAB-CD28-4A92-91C7-82AD9F3AE782}"/>
               </a:ext>
             </a:extLst>
           </p:cNvPr>
@@ -5145,7 +5145,7 @@
           <p:cNvPr id="16" name="breadth-item-rule-5">
             <a:extLst xmlns:a="http://schemas.openxmlformats.org/drawingml/2006/main">
               <a:ext uri="{FF2B5EF4-FFF2-40B4-BE49-F238E27FC236}">
-                <a16:creationId xmlns:a16="http://schemas.microsoft.com/office/drawing/2014/main" id="{0B97508B-DDA4-4D09-A9FE-3908A41EC043}"/>
+                <a16:creationId xmlns:a16="http://schemas.microsoft.com/office/drawing/2014/main" id="{02A7F13B-1F38-44E3-A437-9AE7D1FC74CF}"/>
               </a:ext>
             </a:extLst>
           </p:cNvPr>
@@ -5176,7 +5176,7 @@
           <p:cNvPr id="17" name="breadth-item-5">
             <a:extLst xmlns:a="http://schemas.openxmlformats.org/drawingml/2006/main">
               <a:ext uri="{FF2B5EF4-FFF2-40B4-BE49-F238E27FC236}">
-                <a16:creationId xmlns:a16="http://schemas.microsoft.com/office/drawing/2014/main" id="{5E0E9A48-A21C-4C01-90A2-CACBD01AD0B9}"/>
+                <a16:creationId xmlns:a16="http://schemas.microsoft.com/office/drawing/2014/main" id="{EC62A66E-4A0F-463D-93DC-39577491F4B4}"/>
               </a:ext>
             </a:extLst>
           </p:cNvPr>
@@ -5232,7 +5232,7 @@
           <p:cNvPr id="18" name="breadth-item-rule-6">
             <a:extLst xmlns:a="http://schemas.openxmlformats.org/drawingml/2006/main">
               <a:ext uri="{FF2B5EF4-FFF2-40B4-BE49-F238E27FC236}">
-                <a16:creationId xmlns:a16="http://schemas.microsoft.com/office/drawing/2014/main" id="{3A73E46E-60B2-4B7D-BFB4-C47A6B711E07}"/>
+                <a16:creationId xmlns:a16="http://schemas.microsoft.com/office/drawing/2014/main" id="{A7A469E2-601F-4E45-A27C-277715584E0E}"/>
               </a:ext>
             </a:extLst>
           </p:cNvPr>
@@ -5263,7 +5263,7 @@
           <p:cNvPr id="19" name="breadth-item-6">
             <a:extLst xmlns:a="http://schemas.openxmlformats.org/drawingml/2006/main">
               <a:ext uri="{FF2B5EF4-FFF2-40B4-BE49-F238E27FC236}">
-                <a16:creationId xmlns:a16="http://schemas.microsoft.com/office/drawing/2014/main" id="{188074F6-9917-4C1B-8FAD-C75ACA5B6760}"/>
+                <a16:creationId xmlns:a16="http://schemas.microsoft.com/office/drawing/2014/main" id="{78F4F6D7-01B3-4950-9F7A-52FA9951EEA1}"/>
               </a:ext>
             </a:extLst>
           </p:cNvPr>
@@ -5319,7 +5319,7 @@
           <p:cNvPr id="20" name="footer-5">
             <a:extLst xmlns:a="http://schemas.openxmlformats.org/drawingml/2006/main">
               <a:ext uri="{FF2B5EF4-FFF2-40B4-BE49-F238E27FC236}">
-                <a16:creationId xmlns:a16="http://schemas.microsoft.com/office/drawing/2014/main" id="{B836DE1A-369A-413B-AFDE-73128C290E9E}"/>
+                <a16:creationId xmlns:a16="http://schemas.microsoft.com/office/drawing/2014/main" id="{AAE5BDA5-222C-487B-828E-65E4CD048CD9}"/>
               </a:ext>
             </a:extLst>
           </p:cNvPr>
@@ -5373,7 +5373,7 @@
     </p:spTree>
     <p:extLst>
       <p:ext uri="{BB962C8B-B14F-4D97-AF65-F5344CB8AC3E}">
-        <p14:creationId xmlns:p14="http://schemas.microsoft.com/office/powerpoint/2010/main" val="93527480"/>
+        <p14:creationId xmlns:p14="http://schemas.microsoft.com/office/powerpoint/2010/main" val="865239947"/>
       </p:ext>
     </p:extLst>
   </p:cSld>
@@ -5404,7 +5404,7 @@
           <p:cNvPr id="12" name="privacy-title">
             <a:extLst xmlns:a="http://schemas.openxmlformats.org/drawingml/2006/main">
               <a:ext uri="{FF2B5EF4-FFF2-40B4-BE49-F238E27FC236}">
-                <a16:creationId xmlns:a16="http://schemas.microsoft.com/office/drawing/2014/main" id="{B99C6A9A-7312-4275-A37F-0C3D4FC667DD}"/>
+                <a16:creationId xmlns:a16="http://schemas.microsoft.com/office/drawing/2014/main" id="{B49D655E-3CE5-476A-A95C-C79F9CCEB5B8}"/>
               </a:ext>
             </a:extLst>
           </p:cNvPr>
@@ -5460,7 +5460,7 @@
           <p:cNvPr id="2" name="privacy-tr">
             <a:extLst xmlns:a="http://schemas.openxmlformats.org/drawingml/2006/main">
               <a:ext uri="{FF2B5EF4-FFF2-40B4-BE49-F238E27FC236}">
-                <a16:creationId xmlns:a16="http://schemas.microsoft.com/office/drawing/2014/main" id="{D09E0CC0-2596-4FA6-AD7E-5B1F5010061E}"/>
+                <a16:creationId xmlns:a16="http://schemas.microsoft.com/office/drawing/2014/main" id="{2AED3D55-1052-4E2D-976E-6B2F69FD1D9A}"/>
               </a:ext>
             </a:extLst>
           </p:cNvPr>
@@ -5516,7 +5516,7 @@
           <p:cNvPr id="3" name="privacy-ru">
             <a:extLst xmlns:a="http://schemas.openxmlformats.org/drawingml/2006/main">
               <a:ext uri="{FF2B5EF4-FFF2-40B4-BE49-F238E27FC236}">
-                <a16:creationId xmlns:a16="http://schemas.microsoft.com/office/drawing/2014/main" id="{31A69B0A-4A76-4D5E-803A-99AC23E4F8CE}"/>
+                <a16:creationId xmlns:a16="http://schemas.microsoft.com/office/drawing/2014/main" id="{17E181D8-C2FC-4E73-A15A-BEDCEF313A8F}"/>
               </a:ext>
             </a:extLst>
           </p:cNvPr>
@@ -5572,7 +5572,7 @@
           <p:cNvPr id="4" name="privacy-divider">
             <a:extLst xmlns:a="http://schemas.openxmlformats.org/drawingml/2006/main">
               <a:ext uri="{FF2B5EF4-FFF2-40B4-BE49-F238E27FC236}">
-                <a16:creationId xmlns:a16="http://schemas.microsoft.com/office/drawing/2014/main" id="{1A02C68C-9D7F-431A-90B9-9B9ADFEE5072}"/>
+                <a16:creationId xmlns:a16="http://schemas.microsoft.com/office/drawing/2014/main" id="{CE75F439-EECC-47AC-AF66-966DC7C48BD9}"/>
               </a:ext>
             </a:extLst>
           </p:cNvPr>
@@ -5603,7 +5603,7 @@
           <p:cNvPr id="5" name="local-label">
             <a:extLst xmlns:a="http://schemas.openxmlformats.org/drawingml/2006/main">
               <a:ext uri="{FF2B5EF4-FFF2-40B4-BE49-F238E27FC236}">
-                <a16:creationId xmlns:a16="http://schemas.microsoft.com/office/drawing/2014/main" id="{5867E621-9286-4D51-82B9-020545949593}"/>
+                <a16:creationId xmlns:a16="http://schemas.microsoft.com/office/drawing/2014/main" id="{D29C8FDB-A787-4B18-AF0E-D1854031B36C}"/>
               </a:ext>
             </a:extLst>
           </p:cNvPr>
@@ -5659,7 +5659,7 @@
           <p:cNvPr id="6" name="local-head">
             <a:extLst xmlns:a="http://schemas.openxmlformats.org/drawingml/2006/main">
               <a:ext uri="{FF2B5EF4-FFF2-40B4-BE49-F238E27FC236}">
-                <a16:creationId xmlns:a16="http://schemas.microsoft.com/office/drawing/2014/main" id="{AA7F1F9D-9BF8-4323-8E85-473EC7750C66}"/>
+                <a16:creationId xmlns:a16="http://schemas.microsoft.com/office/drawing/2014/main" id="{BBA0DE8D-0664-4220-AFA6-BD0302560295}"/>
               </a:ext>
             </a:extLst>
           </p:cNvPr>
@@ -5715,7 +5715,7 @@
           <p:cNvPr id="7" name="local-copy">
             <a:extLst xmlns:a="http://schemas.openxmlformats.org/drawingml/2006/main">
               <a:ext uri="{FF2B5EF4-FFF2-40B4-BE49-F238E27FC236}">
-                <a16:creationId xmlns:a16="http://schemas.microsoft.com/office/drawing/2014/main" id="{61288030-338D-4506-9834-7B3FF588FED8}"/>
+                <a16:creationId xmlns:a16="http://schemas.microsoft.com/office/drawing/2014/main" id="{E790F1DC-9709-46A1-9F28-F4AE5E2C2BF4}"/>
               </a:ext>
             </a:extLst>
           </p:cNvPr>
@@ -5845,7 +5845,7 @@
           <p:cNvPr id="8" name="optional-label">
             <a:extLst xmlns:a="http://schemas.openxmlformats.org/drawingml/2006/main">
               <a:ext uri="{FF2B5EF4-FFF2-40B4-BE49-F238E27FC236}">
-                <a16:creationId xmlns:a16="http://schemas.microsoft.com/office/drawing/2014/main" id="{C04FC616-E271-429D-8F02-858EE7D791A6}"/>
+                <a16:creationId xmlns:a16="http://schemas.microsoft.com/office/drawing/2014/main" id="{3D520B19-34BC-409F-8FAD-6F8C2A4863C6}"/>
               </a:ext>
             </a:extLst>
           </p:cNvPr>
@@ -5901,7 +5901,7 @@
           <p:cNvPr id="9" name="optional-head">
             <a:extLst xmlns:a="http://schemas.openxmlformats.org/drawingml/2006/main">
               <a:ext uri="{FF2B5EF4-FFF2-40B4-BE49-F238E27FC236}">
-                <a16:creationId xmlns:a16="http://schemas.microsoft.com/office/drawing/2014/main" id="{598593ED-D6FB-47A7-8328-83174603678F}"/>
+                <a16:creationId xmlns:a16="http://schemas.microsoft.com/office/drawing/2014/main" id="{51AE1C17-E188-4EB6-A503-7DE3F1E16B2D}"/>
               </a:ext>
             </a:extLst>
           </p:cNvPr>
@@ -5957,7 +5957,7 @@
           <p:cNvPr id="10" name="optional-copy">
             <a:extLst xmlns:a="http://schemas.openxmlformats.org/drawingml/2006/main">
               <a:ext uri="{FF2B5EF4-FFF2-40B4-BE49-F238E27FC236}">
-                <a16:creationId xmlns:a16="http://schemas.microsoft.com/office/drawing/2014/main" id="{40D89780-236C-4B7E-950B-4AE6E6C359E2}"/>
+                <a16:creationId xmlns:a16="http://schemas.microsoft.com/office/drawing/2014/main" id="{A04112A6-5B0F-43E6-96BC-DEAA0C2084B9}"/>
               </a:ext>
             </a:extLst>
           </p:cNvPr>
@@ -6087,7 +6087,7 @@
           <p:cNvPr id="11" name="footer-6">
             <a:extLst xmlns:a="http://schemas.openxmlformats.org/drawingml/2006/main">
               <a:ext uri="{FF2B5EF4-FFF2-40B4-BE49-F238E27FC236}">
-                <a16:creationId xmlns:a16="http://schemas.microsoft.com/office/drawing/2014/main" id="{8BDAFE85-3CA5-40EF-957D-52AC8198796A}"/>
+                <a16:creationId xmlns:a16="http://schemas.microsoft.com/office/drawing/2014/main" id="{9D809B61-AE57-4578-809A-D11418603D73}"/>
               </a:ext>
             </a:extLst>
           </p:cNvPr>
@@ -6141,7 +6141,7 @@
     </p:spTree>
     <p:extLst>
       <p:ext uri="{BB962C8B-B14F-4D97-AF65-F5344CB8AC3E}">
-        <p14:creationId xmlns:p14="http://schemas.microsoft.com/office/powerpoint/2010/main" val="1285470234"/>
+        <p14:creationId xmlns:p14="http://schemas.microsoft.com/office/powerpoint/2010/main" val="1033400409"/>
       </p:ext>
     </p:extLst>
   </p:cSld>
@@ -6172,7 +6172,7 @@
           <p:cNvPr id="13" name="platform-title">
             <a:extLst xmlns:a="http://schemas.openxmlformats.org/drawingml/2006/main">
               <a:ext uri="{FF2B5EF4-FFF2-40B4-BE49-F238E27FC236}">
-                <a16:creationId xmlns:a16="http://schemas.microsoft.com/office/drawing/2014/main" id="{0DFB9864-780F-4A88-938F-BC3D22B1F098}"/>
+                <a16:creationId xmlns:a16="http://schemas.microsoft.com/office/drawing/2014/main" id="{0C7F580A-F0B4-4860-AF8E-D082B8FA40E8}"/>
               </a:ext>
             </a:extLst>
           </p:cNvPr>
@@ -6228,7 +6228,7 @@
           <p:cNvPr id="2" name="platform-subtitle">
             <a:extLst xmlns:a="http://schemas.openxmlformats.org/drawingml/2006/main">
               <a:ext uri="{FF2B5EF4-FFF2-40B4-BE49-F238E27FC236}">
-                <a16:creationId xmlns:a16="http://schemas.microsoft.com/office/drawing/2014/main" id="{945F6973-0631-4D0E-9FEF-ABBA179537DA}"/>
+                <a16:creationId xmlns:a16="http://schemas.microsoft.com/office/drawing/2014/main" id="{C0658339-5ED9-4D77-A71F-6083170D63EB}"/>
               </a:ext>
             </a:extLst>
           </p:cNvPr>
@@ -6284,7 +6284,7 @@
           <p:cNvPr id="3" name="platform-rule">
             <a:extLst xmlns:a="http://schemas.openxmlformats.org/drawingml/2006/main">
               <a:ext uri="{FF2B5EF4-FFF2-40B4-BE49-F238E27FC236}">
-                <a16:creationId xmlns:a16="http://schemas.microsoft.com/office/drawing/2014/main" id="{D104AA2C-B079-4831-A839-30F751731B55}"/>
+                <a16:creationId xmlns:a16="http://schemas.microsoft.com/office/drawing/2014/main" id="{4E34B50D-89DD-4D88-B70E-9073EEF3BE3E}"/>
               </a:ext>
             </a:extLst>
           </p:cNvPr>
@@ -6315,7 +6315,7 @@
           <p:cNvPr id="4" name="platform-label-0">
             <a:extLst xmlns:a="http://schemas.openxmlformats.org/drawingml/2006/main">
               <a:ext uri="{FF2B5EF4-FFF2-40B4-BE49-F238E27FC236}">
-                <a16:creationId xmlns:a16="http://schemas.microsoft.com/office/drawing/2014/main" id="{8CAA0470-4832-45E8-B06B-FFBD9F7203B5}"/>
+                <a16:creationId xmlns:a16="http://schemas.microsoft.com/office/drawing/2014/main" id="{6CD9EB28-D697-4612-A4B4-07675EE79D00}"/>
               </a:ext>
             </a:extLst>
           </p:cNvPr>
@@ -6371,7 +6371,7 @@
           <p:cNvPr id="5" name="platform-body-0">
             <a:extLst xmlns:a="http://schemas.openxmlformats.org/drawingml/2006/main">
               <a:ext uri="{FF2B5EF4-FFF2-40B4-BE49-F238E27FC236}">
-                <a16:creationId xmlns:a16="http://schemas.microsoft.com/office/drawing/2014/main" id="{48C92DE6-B297-4E93-B019-FD64529E9F39}"/>
+                <a16:creationId xmlns:a16="http://schemas.microsoft.com/office/drawing/2014/main" id="{63BC6DF8-8C62-4C39-B588-4832BAD3F40D}"/>
               </a:ext>
             </a:extLst>
           </p:cNvPr>
@@ -6417,7 +6417,7 @@
                 <a:ea typeface="Arial"/>
                 <a:cs typeface="Arial"/>
               </a:rPr>
-              <a:t>Windows 10/11 (x64) + macOS (Apple Silicon) — İndirme: github.com/Azizsekerdil/RussianCourseAI/releases (v1.2.1) (özel repo)</a:t>
+              <a:t>Windows 10/11 (x64) + macOS (Apple Silicon) — İndirme: github.com/Azizsekerdil/RussianCourseAI/releases (v1.3.0)</a:t>
             </a:r>
           </a:p>
         </p:txBody>
@@ -6427,7 +6427,7 @@
           <p:cNvPr id="6" name="platform-label-1">
             <a:extLst xmlns:a="http://schemas.openxmlformats.org/drawingml/2006/main">
               <a:ext uri="{FF2B5EF4-FFF2-40B4-BE49-F238E27FC236}">
-                <a16:creationId xmlns:a16="http://schemas.microsoft.com/office/drawing/2014/main" id="{5D8F1469-E14B-4A17-B9DE-B4F599A67351}"/>
+                <a16:creationId xmlns:a16="http://schemas.microsoft.com/office/drawing/2014/main" id="{E81DE326-5348-47B7-975A-053DC6CC00CE}"/>
               </a:ext>
             </a:extLst>
           </p:cNvPr>
@@ -6483,7 +6483,7 @@
           <p:cNvPr id="7" name="platform-body-1">
             <a:extLst xmlns:a="http://schemas.openxmlformats.org/drawingml/2006/main">
               <a:ext uri="{FF2B5EF4-FFF2-40B4-BE49-F238E27FC236}">
-                <a16:creationId xmlns:a16="http://schemas.microsoft.com/office/drawing/2014/main" id="{548F48F5-231F-4B5C-A7BA-4CB668C5C497}"/>
+                <a16:creationId xmlns:a16="http://schemas.microsoft.com/office/drawing/2014/main" id="{74498948-A64F-47D8-82C8-0413412A3ECF}"/>
               </a:ext>
             </a:extLst>
           </p:cNvPr>
@@ -6529,7 +6529,7 @@
                 <a:ea typeface="Arial"/>
                 <a:cs typeface="Arial"/>
               </a:rPr>
-              <a:t>Windows 10/11 (x64) &amp; macOS (Apple Silicon) — Download: GitHub Releases (v1.2.1)</a:t>
+              <a:t>Windows 10/11 (x64) &amp; macOS (Apple Silicon) — Download: GitHub Releases (v1.3.0)</a:t>
             </a:r>
           </a:p>
         </p:txBody>
@@ -6539,7 +6539,7 @@
           <p:cNvPr id="8" name="platform-label-2">
             <a:extLst xmlns:a="http://schemas.openxmlformats.org/drawingml/2006/main">
               <a:ext uri="{FF2B5EF4-FFF2-40B4-BE49-F238E27FC236}">
-                <a16:creationId xmlns:a16="http://schemas.microsoft.com/office/drawing/2014/main" id="{44F92A2B-9871-4223-9E78-DB7FA90DDA3A}"/>
+                <a16:creationId xmlns:a16="http://schemas.microsoft.com/office/drawing/2014/main" id="{350906DC-495B-4EEC-9B59-BE60152DAC3B}"/>
               </a:ext>
             </a:extLst>
           </p:cNvPr>
@@ -6595,7 +6595,7 @@
           <p:cNvPr id="9" name="platform-body-2">
             <a:extLst xmlns:a="http://schemas.openxmlformats.org/drawingml/2006/main">
               <a:ext uri="{FF2B5EF4-FFF2-40B4-BE49-F238E27FC236}">
-                <a16:creationId xmlns:a16="http://schemas.microsoft.com/office/drawing/2014/main" id="{2CA5D04B-5414-4CC3-97BA-135620513D95}"/>
+                <a16:creationId xmlns:a16="http://schemas.microsoft.com/office/drawing/2014/main" id="{8061EE31-64CA-49A1-AFA0-8574F218694E}"/>
               </a:ext>
             </a:extLst>
           </p:cNvPr>
@@ -6641,7 +6641,7 @@
                 <a:ea typeface="Arial"/>
                 <a:cs typeface="Arial"/>
               </a:rPr>
-              <a:t>Windows 10/11 (x64) и macOS (Apple Silicon) — Загрузка: GitHub Releases (v1.2.1)</a:t>
+              <a:t>Windows 10/11 (x64) и macOS (Apple Silicon) — Загрузка: GitHub Releases (v1.3.0)</a:t>
             </a:r>
           </a:p>
         </p:txBody>
@@ -6651,7 +6651,7 @@
           <p:cNvPr id="10" name="platform-footnote-rule">
             <a:extLst xmlns:a="http://schemas.openxmlformats.org/drawingml/2006/main">
               <a:ext uri="{FF2B5EF4-FFF2-40B4-BE49-F238E27FC236}">
-                <a16:creationId xmlns:a16="http://schemas.microsoft.com/office/drawing/2014/main" id="{681C516A-273B-4640-8098-882EB9112B6D}"/>
+                <a16:creationId xmlns:a16="http://schemas.microsoft.com/office/drawing/2014/main" id="{0CE5BCC8-39E9-4D85-97ED-3BA5DB093310}"/>
               </a:ext>
             </a:extLst>
           </p:cNvPr>
@@ -6682,7 +6682,7 @@
           <p:cNvPr id="11" name="platform-footnote">
             <a:extLst xmlns:a="http://schemas.openxmlformats.org/drawingml/2006/main">
               <a:ext uri="{FF2B5EF4-FFF2-40B4-BE49-F238E27FC236}">
-                <a16:creationId xmlns:a16="http://schemas.microsoft.com/office/drawing/2014/main" id="{200DB95D-3787-44AC-918C-06F8F98E7803}"/>
+                <a16:creationId xmlns:a16="http://schemas.microsoft.com/office/drawing/2014/main" id="{734568D1-1BE9-4B8B-8903-EC814A95226E}"/>
               </a:ext>
             </a:extLst>
           </p:cNvPr>
@@ -6728,7 +6728,7 @@
                 <a:ea typeface="Arial"/>
                 <a:cs typeface="Arial"/>
               </a:rPr>
-              <a:t>Release v1.2.1 — iki paket: Windows zip + macOS zip. macOS paketi Apple Silicon (arm64) içindir ve notarize edilmemiştir; ilk açılışta sağ tık → Aç.</a:t>
+              <a:t>Release v1.3.0 — iki paket: Windows zip + macOS zip. macOS paketi Apple Silicon (arm64) içindir ve notarize edilmemiştir; ilk açılışta sağ tık → Aç.</a:t>
             </a:r>
           </a:p>
           <a:p xmlns:a="http://schemas.openxmlformats.org/drawingml/2006/main">
@@ -6751,7 +6751,7 @@
                 <a:ea typeface="Arial"/>
                 <a:cs typeface="Arial"/>
               </a:rPr>
-              <a:t>Depo özel (private) — github.com/Azizsekerdil/RussianCourseAI bağlantısına yalnızca hesap sahibi erişebilir.</a:t>
+              <a:t>Her iki paketin içinde LICENSE ve THIRD_PARTY_NOTICES.md bulunur; proje MIT lisanslıdır — github.com/Azizsekerdil/RussianCourseAI</a:t>
             </a:r>
           </a:p>
         </p:txBody>
@@ -6761,7 +6761,7 @@
           <p:cNvPr id="12" name="footer-7">
             <a:extLst xmlns:a="http://schemas.openxmlformats.org/drawingml/2006/main">
               <a:ext uri="{FF2B5EF4-FFF2-40B4-BE49-F238E27FC236}">
-                <a16:creationId xmlns:a16="http://schemas.microsoft.com/office/drawing/2014/main" id="{4E541EDE-3215-4973-8669-47DE7D30527F}"/>
+                <a16:creationId xmlns:a16="http://schemas.microsoft.com/office/drawing/2014/main" id="{3388BAA9-E78E-4C4E-A2C1-EC40B59DAC20}"/>
               </a:ext>
             </a:extLst>
           </p:cNvPr>
@@ -6815,7 +6815,7 @@
     </p:spTree>
     <p:extLst>
       <p:ext uri="{BB962C8B-B14F-4D97-AF65-F5344CB8AC3E}">
-        <p14:creationId xmlns:p14="http://schemas.microsoft.com/office/powerpoint/2010/main" val="485107627"/>
+        <p14:creationId xmlns:p14="http://schemas.microsoft.com/office/powerpoint/2010/main" val="1135368346"/>
       </p:ext>
     </p:extLst>
   </p:cSld>
@@ -6846,7 +6846,7 @@
           <p:cNvPr id="9" name="close-kicker">
             <a:extLst xmlns:a="http://schemas.openxmlformats.org/drawingml/2006/main">
               <a:ext uri="{FF2B5EF4-FFF2-40B4-BE49-F238E27FC236}">
-                <a16:creationId xmlns:a16="http://schemas.microsoft.com/office/drawing/2014/main" id="{9DAEA0CF-1A2F-4430-9A94-068D3407A4A4}"/>
+                <a16:creationId xmlns:a16="http://schemas.microsoft.com/office/drawing/2014/main" id="{12AA3DC4-6C78-41B9-BBBC-60F4B8B46D8A}"/>
               </a:ext>
             </a:extLst>
           </p:cNvPr>
@@ -6902,7 +6902,7 @@
           <p:cNvPr id="2" name="close-title">
             <a:extLst xmlns:a="http://schemas.openxmlformats.org/drawingml/2006/main">
               <a:ext uri="{FF2B5EF4-FFF2-40B4-BE49-F238E27FC236}">
-                <a16:creationId xmlns:a16="http://schemas.microsoft.com/office/drawing/2014/main" id="{A2CA36C6-7FDE-43F8-B512-7BA00624F8F6}"/>
+                <a16:creationId xmlns:a16="http://schemas.microsoft.com/office/drawing/2014/main" id="{B00D469B-B985-402C-B1AB-74D308CCBA6B}"/>
               </a:ext>
             </a:extLst>
           </p:cNvPr>
@@ -6981,7 +6981,7 @@
           <p:cNvPr id="3" name="close-tr">
             <a:extLst xmlns:a="http://schemas.openxmlformats.org/drawingml/2006/main">
               <a:ext uri="{FF2B5EF4-FFF2-40B4-BE49-F238E27FC236}">
-                <a16:creationId xmlns:a16="http://schemas.microsoft.com/office/drawing/2014/main" id="{D2F61D66-F402-4E7C-B67B-EB50F79E4692}"/>
+                <a16:creationId xmlns:a16="http://schemas.microsoft.com/office/drawing/2014/main" id="{BE139CA4-5969-48D1-A552-0F517B90FB63}"/>
               </a:ext>
             </a:extLst>
           </p:cNvPr>
@@ -7037,7 +7037,7 @@
           <p:cNvPr id="4" name="close-ru">
             <a:extLst xmlns:a="http://schemas.openxmlformats.org/drawingml/2006/main">
               <a:ext uri="{FF2B5EF4-FFF2-40B4-BE49-F238E27FC236}">
-                <a16:creationId xmlns:a16="http://schemas.microsoft.com/office/drawing/2014/main" id="{B9B9320B-3933-40BF-97D3-147DA99269BA}"/>
+                <a16:creationId xmlns:a16="http://schemas.microsoft.com/office/drawing/2014/main" id="{16F3D582-D3CD-493F-95D7-E700A5ADF0E3}"/>
               </a:ext>
             </a:extLst>
           </p:cNvPr>
@@ -7093,7 +7093,7 @@
           <p:cNvPr id="5" name="close-rule">
             <a:extLst xmlns:a="http://schemas.openxmlformats.org/drawingml/2006/main">
               <a:ext uri="{FF2B5EF4-FFF2-40B4-BE49-F238E27FC236}">
-                <a16:creationId xmlns:a16="http://schemas.microsoft.com/office/drawing/2014/main" id="{EC021CD1-13E4-4346-9989-4862DB7068F8}"/>
+                <a16:creationId xmlns:a16="http://schemas.microsoft.com/office/drawing/2014/main" id="{1B2472C1-04DB-4789-8D4C-8C1BBB25AEB0}"/>
               </a:ext>
             </a:extLst>
           </p:cNvPr>
@@ -7124,7 +7124,7 @@
           <p:cNvPr id="6" name="close-action">
             <a:extLst xmlns:a="http://schemas.openxmlformats.org/drawingml/2006/main">
               <a:ext uri="{FF2B5EF4-FFF2-40B4-BE49-F238E27FC236}">
-                <a16:creationId xmlns:a16="http://schemas.microsoft.com/office/drawing/2014/main" id="{BC06E648-9455-4104-9C39-B6372A0EE718}"/>
+                <a16:creationId xmlns:a16="http://schemas.microsoft.com/office/drawing/2014/main" id="{EF833B40-A80F-4C15-8A61-8938F632A775}"/>
               </a:ext>
             </a:extLst>
           </p:cNvPr>
@@ -7180,7 +7180,7 @@
           <p:cNvPr id="7" name="close-meta">
             <a:extLst xmlns:a="http://schemas.openxmlformats.org/drawingml/2006/main">
               <a:ext uri="{FF2B5EF4-FFF2-40B4-BE49-F238E27FC236}">
-                <a16:creationId xmlns:a16="http://schemas.microsoft.com/office/drawing/2014/main" id="{43DBF074-8E9C-43E2-B583-1CAF1DCBF3D4}"/>
+                <a16:creationId xmlns:a16="http://schemas.microsoft.com/office/drawing/2014/main" id="{4BD92973-3B4B-49FF-81D0-CFDEE8151B4F}"/>
               </a:ext>
             </a:extLst>
           </p:cNvPr>
@@ -7236,7 +7236,7 @@
           <p:cNvPr id="8" name="footer-8">
             <a:extLst xmlns:a="http://schemas.openxmlformats.org/drawingml/2006/main">
               <a:ext uri="{FF2B5EF4-FFF2-40B4-BE49-F238E27FC236}">
-                <a16:creationId xmlns:a16="http://schemas.microsoft.com/office/drawing/2014/main" id="{B096B21C-174E-45A0-83DF-3A6B38AEEC5F}"/>
+                <a16:creationId xmlns:a16="http://schemas.microsoft.com/office/drawing/2014/main" id="{7AE275CC-A5E6-459C-9B89-143511625ED3}"/>
               </a:ext>
             </a:extLst>
           </p:cNvPr>
@@ -7290,7 +7290,7 @@
     </p:spTree>
     <p:extLst>
       <p:ext uri="{BB962C8B-B14F-4D97-AF65-F5344CB8AC3E}">
-        <p14:creationId xmlns:p14="http://schemas.microsoft.com/office/powerpoint/2010/main" val="967029971"/>
+        <p14:creationId xmlns:p14="http://schemas.microsoft.com/office/powerpoint/2010/main" val="1318617440"/>
       </p:ext>
     </p:extLst>
   </p:cSld>

</xml_diff>